<commit_message>
feat(sih): design Slide 2 blending SIHex2 problem/solution/UVP and SIHex1 flowchart/innovation cards
</commit_message>
<xml_diff>
--- a/sih/GatiShakti_AI_SIH2026_Presentation.pptx
+++ b/sih/GatiShakti_AI_SIH2026_Presentation.pptx
@@ -6294,15 +6294,15 @@
           <a:lstStyle/>
           <a:p>
             <a:pPr algn="l">
-              <a:defRPr sz="2200" b="1">
-                <a:solidFill>
-                  <a:srgbClr val="1A365D"/>
-                </a:solidFill>
-                <a:latin typeface="Times New Roman"/>
+              <a:defRPr sz="2400" b="1">
+                <a:solidFill>
+                  <a:srgbClr val="003366"/>
+                </a:solidFill>
+                <a:latin typeface="Arial"/>
               </a:defRPr>
             </a:pPr>
             <a:r>
-              <a:t>GATISHAKTI AI: PREDICTIVE LAND ACQUISITION DELAY SYSTEM</a:t>
+              <a:t>IDEA &amp; PROPOSED SOLUTION</a:t>
             </a:r>
           </a:p>
         </p:txBody>
@@ -6410,35 +6410,24 @@
       </p:pic>
       <p:sp>
         <p:nvSpPr>
-          <p:cNvPr id="3" name="Rectangle: Rounded Corners 2">
-            <a:extLst>
-              <a:ext uri="{FF2B5EF4-FFF2-40B4-BE49-F238E27FC236}">
-                <a16:creationId xmlns:a16="http://schemas.microsoft.com/office/drawing/2014/main" id="{46D0E1B9-6A84-BA9C-A87B-74FF1721BAFE}"/>
-              </a:ext>
-            </a:extLst>
-          </p:cNvPr>
+          <p:cNvPr id="15362" name="Rounded Rectangle 15361"/>
           <p:cNvSpPr/>
           <p:nvPr/>
         </p:nvSpPr>
         <p:spPr>
           <a:xfrm>
-            <a:off x="192505" y="1368905"/>
-            <a:ext cx="7042484" cy="1188720"/>
+            <a:off x="438912" y="1051560"/>
+            <a:ext cx="2011680" cy="292608"/>
           </a:xfrm>
           <a:prstGeom prst="roundRect">
             <a:avLst/>
           </a:prstGeom>
           <a:solidFill>
-            <a:schemeClr val="bg1">
-              <a:lumMod val="95000"/>
-            </a:schemeClr>
+            <a:srgbClr val="5A6B7C"/>
           </a:solidFill>
           <a:ln>
             <a:solidFill>
-              <a:schemeClr val="tx2">
-                <a:lumMod val="40000"/>
-                <a:lumOff val="60000"/>
-              </a:schemeClr>
+              <a:srgbClr val="465564"/>
             </a:solidFill>
           </a:ln>
         </p:spPr>
@@ -6457,578 +6446,41 @@
           </a:fontRef>
         </p:style>
         <p:txBody>
-          <a:bodyPr rtlCol="0" anchor="ctr" wrap="square"/>
+          <a:bodyPr rtlCol="0" anchor="ctr" wrap="none"/>
           <a:lstStyle/>
           <a:p>
             <a:pPr algn="ctr">
-              <a:spcAft>
-                <a:spcPts val="400"/>
-              </a:spcAft>
-            </a:pPr>
-            <a:r>
-              <a:rPr sz="1000" b="1">
-                <a:solidFill>
-                  <a:srgbClr val="1E293B"/>
-                </a:solidFill>
-                <a:latin typeface="Arial"/>
-              </a:rPr>
-              <a:t>• ₹4,000+ Cr Escrow Lockup: </a:t>
-            </a:r>
-            <a:r>
-              <a:rPr sz="950" b="0">
-                <a:solidFill>
-                  <a:srgbClr val="475569"/>
-                </a:solidFill>
-                <a:latin typeface="Arial"/>
-              </a:rPr>
-              <a:t>Sub-judice litigation under Section 3H stalls corridors for 1,200+ days, accruing 9–15% statutory penal interest under Sec 34 of RFCTLARR Act 2013.</a:t>
-            </a:r>
-            <a:endParaRPr lang="en-IN" sz="1600" dirty="0">
-              <a:solidFill>
-                <a:schemeClr val="tx1"/>
-              </a:solidFill>
-            </a:endParaRPr>
-          </a:p>
-          <a:p>
-            <a:pPr>
-              <a:spcAft>
-                <a:spcPts val="400"/>
-              </a:spcAft>
-            </a:pPr>
-            <a:r>
-              <a:rPr sz="1000" b="1">
-                <a:solidFill>
-                  <a:srgbClr val="1E293B"/>
-                </a:solidFill>
-                <a:latin typeface="Arial"/>
-              </a:rPr>
-              <a:t>• Section 3D Statutory Lapse: </a:t>
-            </a:r>
-            <a:r>
-              <a:rPr sz="950" b="0">
-                <a:solidFill>
-                  <a:srgbClr val="475569"/>
-                </a:solidFill>
-                <a:latin typeface="Arial"/>
-              </a:rPr>
-              <a:t>Section 3A notifications automatically lapse at Day 365 if Sec 3D declaration is not gazetted, resetting multi-year acquisition cycles.</a:t>
-            </a:r>
-          </a:p>
-          <a:p>
-            <a:pPr>
-              <a:spcAft>
-                <a:spcPts val="400"/>
-              </a:spcAft>
-            </a:pPr>
-            <a:r>
-              <a:rPr sz="1000" b="1">
-                <a:solidFill>
-                  <a:srgbClr val="1E293B"/>
-                </a:solidFill>
-                <a:latin typeface="Arial"/>
-              </a:rPr>
-              <a:t>• Disconnected Data Silos: </a:t>
-            </a:r>
-            <a:r>
-              <a:rPr sz="950" b="0">
-                <a:solidFill>
-                  <a:srgbClr val="475569"/>
-                </a:solidFill>
-                <a:latin typeface="Arial"/>
-              </a:rPr>
-              <a:t>Gazette notices, e-Courts stay orders, cadastral Khasra maps, and EPC contractor chainages operate in completely isolated silos.</a:t>
-            </a:r>
-          </a:p>
-          <a:p>
-            <a:pPr>
-              <a:spcAft>
-                <a:spcPts val="400"/>
-              </a:spcAft>
-            </a:pPr>
-            <a:r>
-              <a:rPr sz="1000" b="1">
-                <a:solidFill>
-                  <a:srgbClr val="1E293B"/>
-                </a:solidFill>
-                <a:latin typeface="Arial"/>
-              </a:rPr>
-              <a:t>• Late Bottleneck Detection: </a:t>
-            </a:r>
-            <a:r>
-              <a:rPr sz="950" b="0">
-                <a:solidFill>
-                  <a:srgbClr val="475569"/>
-                </a:solidFill>
-                <a:latin typeface="Arial"/>
-              </a:rPr>
-              <a:t>Nodal officers manually review physical paper files, discovering judicial stay injunctions only after EPC contractors file idling claims.</a:t>
-            </a:r>
-          </a:p>
-        </p:txBody>
-      </p:sp>
-      <p:sp>
-        <p:nvSpPr>
-          <p:cNvPr id="12" name="Rectangle: Rounded Corners 11">
-            <a:extLst>
-              <a:ext uri="{FF2B5EF4-FFF2-40B4-BE49-F238E27FC236}">
-                <a16:creationId xmlns:a16="http://schemas.microsoft.com/office/drawing/2014/main" id="{4BE21E8C-12B1-11CD-33E8-71FF996AD98C}"/>
-              </a:ext>
-            </a:extLst>
-          </p:cNvPr>
+              <a:defRPr sz="1100" b="1">
+                <a:solidFill>
+                  <a:srgbClr val="FFFFFF"/>
+                </a:solidFill>
+                <a:latin typeface="Arial"/>
+              </a:defRPr>
+            </a:pPr>
+            <a:r>
+              <a:t>PROBLEM EXISTING</a:t>
+            </a:r>
+          </a:p>
+        </p:txBody>
+      </p:sp>
+      <p:sp>
+        <p:nvSpPr>
+          <p:cNvPr id="15363" name="Rounded Rectangle 15362"/>
           <p:cNvSpPr/>
           <p:nvPr/>
         </p:nvSpPr>
         <p:spPr>
           <a:xfrm>
-            <a:off x="192505" y="2697480"/>
-            <a:ext cx="7042484" cy="1188720"/>
+            <a:off x="438912" y="1371600"/>
+            <a:ext cx="5532120" cy="1371600"/>
           </a:xfrm>
           <a:prstGeom prst="roundRect">
             <a:avLst/>
           </a:prstGeom>
           <a:solidFill>
-            <a:schemeClr val="bg1">
-              <a:lumMod val="95000"/>
-            </a:schemeClr>
-          </a:solidFill>
-          <a:ln>
-            <a:solidFill>
-              <a:schemeClr val="tx2">
-                <a:lumMod val="40000"/>
-                <a:lumOff val="60000"/>
-              </a:schemeClr>
-            </a:solidFill>
-          </a:ln>
-        </p:spPr>
-        <p:style>
-          <a:lnRef idx="1">
-            <a:schemeClr val="accent1"/>
-          </a:lnRef>
-          <a:fillRef idx="3">
-            <a:schemeClr val="accent1"/>
-          </a:fillRef>
-          <a:effectRef idx="2">
-            <a:schemeClr val="accent1"/>
-          </a:effectRef>
-          <a:fontRef idx="minor">
-            <a:schemeClr val="lt1"/>
-          </a:fontRef>
-        </p:style>
-        <p:txBody>
-          <a:bodyPr rtlCol="0" anchor="ctr" wrap="square"/>
-          <a:lstStyle/>
-          <a:p>
-            <a:pPr algn="ctr">
-              <a:spcAft>
-                <a:spcPts val="400"/>
-              </a:spcAft>
-            </a:pPr>
-            <a:r>
-              <a:rPr sz="1000" b="1">
-                <a:solidFill>
-                  <a:srgbClr val="1E293B"/>
-                </a:solidFill>
-                <a:latin typeface="Arial"/>
-              </a:rPr>
-              <a:t>• Decoupled Central DB (&lt;15ms): </a:t>
-            </a:r>
-            <a:r>
-              <a:rPr sz="950" b="0">
-                <a:solidFill>
-                  <a:srgbClr val="475569"/>
-                </a:solidFill>
-                <a:latin typeface="Arial"/>
-              </a:rPr>
-              <a:t>Direct ingestion of 47 statutory parameters across civil, revenue, and environmental domains—eliminating slow PDF OCR latency.</a:t>
-            </a:r>
-            <a:endParaRPr lang="en-IN" dirty="0"/>
-          </a:p>
-          <a:p>
-            <a:pPr>
-              <a:spcAft>
-                <a:spcPts val="400"/>
-              </a:spcAft>
-            </a:pPr>
-            <a:r>
-              <a:rPr sz="1000" b="1">
-                <a:solidFill>
-                  <a:srgbClr val="1E293B"/>
-                </a:solidFill>
-                <a:latin typeface="Arial"/>
-              </a:rPr>
-              <a:t>• Dual-Track Reality Engine: </a:t>
-            </a:r>
-            <a:r>
-              <a:rPr sz="950" b="0">
-                <a:solidFill>
-                  <a:srgbClr val="475569"/>
-                </a:solidFill>
-                <a:latin typeface="Arial"/>
-              </a:rPr>
-              <a:t>Distinguishes active physical civil progress (public traffic moving) from statutory court liquidation under NH Act Section 3D(2).</a:t>
-            </a:r>
-          </a:p>
-          <a:p>
-            <a:pPr>
-              <a:spcAft>
-                <a:spcPts val="400"/>
-              </a:spcAft>
-            </a:pPr>
-            <a:r>
-              <a:rPr sz="1000" b="1">
-                <a:solidFill>
-                  <a:srgbClr val="1E293B"/>
-                </a:solidFill>
-                <a:latin typeface="Arial"/>
-              </a:rPr>
-              <a:t>• TreeSHAP Explainable XAI: </a:t>
-            </a:r>
-            <a:r>
-              <a:rPr sz="950" b="0">
-                <a:solidFill>
-                  <a:srgbClr val="475569"/>
-                </a:solidFill>
-                <a:latin typeface="Arial"/>
-              </a:rPr>
-              <a:t>Real-time factor attribution quantifying exact marginal day-impacts (+days delay / -days mitigator) for every corridor risk driver.</a:t>
-            </a:r>
-          </a:p>
-          <a:p>
-            <a:pPr>
-              <a:spcAft>
-                <a:spcPts val="400"/>
-              </a:spcAft>
-            </a:pPr>
-            <a:r>
-              <a:rPr sz="1000" b="1">
-                <a:solidFill>
-                  <a:srgbClr val="1E293B"/>
-                </a:solidFill>
-                <a:latin typeface="Arial"/>
-              </a:rPr>
-              <a:t>• Prescriptive SOP Orders (Point 9): </a:t>
-            </a:r>
-            <a:r>
-              <a:rPr sz="950" b="0">
-                <a:solidFill>
-                  <a:srgbClr val="475569"/>
-                </a:solidFill>
-                <a:latin typeface="Arial"/>
-              </a:rPr>
-              <a:t>Automates pre-drafted Draft for Approval (DFA) legal notices under NH Act § 3D, § 3G (Awards), and § 3H (Escrow).</a:t>
-            </a:r>
-          </a:p>
-        </p:txBody>
-      </p:sp>
-      <p:sp>
-        <p:nvSpPr>
-          <p:cNvPr id="14" name="Rectangle: Rounded Corners 13">
-            <a:extLst>
-              <a:ext uri="{FF2B5EF4-FFF2-40B4-BE49-F238E27FC236}">
-                <a16:creationId xmlns:a16="http://schemas.microsoft.com/office/drawing/2014/main" id="{0E28FC56-FB8D-85C4-AC7C-398B81C48EC2}"/>
-              </a:ext>
-            </a:extLst>
-          </p:cNvPr>
-          <p:cNvSpPr/>
-          <p:nvPr/>
-        </p:nvSpPr>
-        <p:spPr>
-          <a:xfrm>
-            <a:off x="192505" y="4389120"/>
-            <a:ext cx="7042485" cy="1188720"/>
-          </a:xfrm>
-          <a:prstGeom prst="roundRect">
-            <a:avLst/>
-          </a:prstGeom>
-          <a:solidFill>
-            <a:schemeClr val="bg1">
-              <a:lumMod val="95000"/>
-            </a:schemeClr>
-          </a:solidFill>
-          <a:ln>
-            <a:solidFill>
-              <a:schemeClr val="tx2">
-                <a:lumMod val="40000"/>
-                <a:lumOff val="60000"/>
-              </a:schemeClr>
-            </a:solidFill>
-          </a:ln>
-        </p:spPr>
-        <p:style>
-          <a:lnRef idx="1">
-            <a:schemeClr val="accent1"/>
-          </a:lnRef>
-          <a:fillRef idx="3">
-            <a:schemeClr val="accent1"/>
-          </a:fillRef>
-          <a:effectRef idx="2">
-            <a:schemeClr val="accent1"/>
-          </a:effectRef>
-          <a:fontRef idx="minor">
-            <a:schemeClr val="lt1"/>
-          </a:fontRef>
-        </p:style>
-        <p:txBody>
-          <a:bodyPr rtlCol="0" anchor="ctr" wrap="square"/>
-          <a:lstStyle/>
-          <a:p>
-            <a:pPr algn="ctr">
-              <a:spcAft>
-                <a:spcPts val="400"/>
-              </a:spcAft>
-            </a:pPr>
-            <a:r>
-              <a:rPr sz="1000" b="1">
-                <a:solidFill>
-                  <a:srgbClr val="1E293B"/>
-                </a:solidFill>
-                <a:latin typeface="Arial"/>
-              </a:rPr>
-              <a:t>• Constitutional HITL Architecture: </a:t>
-            </a:r>
-            <a:r>
-              <a:rPr sz="950" b="0">
-                <a:solidFill>
-                  <a:srgbClr val="475569"/>
-                </a:solidFill>
-                <a:latin typeface="Arial"/>
-              </a:rPr>
-              <a:t>Adheres to Articles 77 &amp; 166; integrates Aadhaar / Class-3 DSC e-Signing so empowered nodal officers retain full legal authority.</a:t>
-            </a:r>
-            <a:endParaRPr lang="en-IN" dirty="0"/>
-          </a:p>
-          <a:p>
-            <a:pPr>
-              <a:spcAft>
-                <a:spcPts val="400"/>
-              </a:spcAft>
-            </a:pPr>
-            <a:r>
-              <a:rPr sz="1000" b="1">
-                <a:solidFill>
-                  <a:srgbClr val="1E293B"/>
-                </a:solidFill>
-                <a:latin typeface="Arial"/>
-              </a:rPr>
-              <a:t>• Multi-Tier 340.8 km RoW GIS: </a:t>
-            </a:r>
-            <a:r>
-              <a:rPr sz="950" b="0">
-                <a:solidFill>
-                  <a:srgbClr val="475569"/>
-                </a:solidFill>
-                <a:latin typeface="Arial"/>
-              </a:rPr>
-              <a:t>Full interactive Purvanchal corridor: Macro Alignment → 8 Construction Packages → 18 Cadastral Parcel Strips with live choropleth.</a:t>
-            </a:r>
-          </a:p>
-          <a:p>
-            <a:pPr>
-              <a:spcAft>
-                <a:spcPts val="400"/>
-              </a:spcAft>
-            </a:pPr>
-            <a:r>
-              <a:rPr sz="1000" b="1">
-                <a:solidFill>
-                  <a:srgbClr val="1E293B"/>
-                </a:solidFill>
-                <a:latin typeface="Arial"/>
-              </a:rPr>
-              <a:t>• Tamper-Proof Audit Trail (Point 12): </a:t>
-            </a:r>
-            <a:r>
-              <a:rPr sz="950" b="0">
-                <a:solidFill>
-                  <a:srgbClr val="475569"/>
-                </a:solidFill>
-                <a:latin typeface="Arial"/>
-              </a:rPr>
-              <a:t>Cryptographic SHA-256 block hashing permanently seals every administrative decision, ensuring CVC &amp; CAG compliance.</a:t>
-            </a:r>
-          </a:p>
-        </p:txBody>
-      </p:sp>
-      <p:sp>
-        <p:nvSpPr>
-          <p:cNvPr id="16" name="Rectangle: Rounded Corners 15">
-            <a:extLst>
-              <a:ext uri="{FF2B5EF4-FFF2-40B4-BE49-F238E27FC236}">
-                <a16:creationId xmlns:a16="http://schemas.microsoft.com/office/drawing/2014/main" id="{60AAB1A7-E21D-E958-8562-E50040A5D015}"/>
-              </a:ext>
-            </a:extLst>
-          </p:cNvPr>
-          <p:cNvSpPr/>
-          <p:nvPr/>
-        </p:nvSpPr>
-        <p:spPr>
-          <a:xfrm>
-            <a:off x="192506" y="1011453"/>
-            <a:ext cx="1778496" cy="308810"/>
-          </a:xfrm>
-          <a:prstGeom prst="roundRect">
-            <a:avLst/>
-          </a:prstGeom>
-          <a:solidFill>
-            <a:schemeClr val="bg1">
-              <a:lumMod val="65000"/>
-            </a:schemeClr>
-          </a:solidFill>
-        </p:spPr>
-        <p:style>
-          <a:lnRef idx="1">
-            <a:schemeClr val="accent1"/>
-          </a:lnRef>
-          <a:fillRef idx="3">
-            <a:schemeClr val="accent1"/>
-          </a:fillRef>
-          <a:effectRef idx="2">
-            <a:schemeClr val="accent1"/>
-          </a:effectRef>
-          <a:fontRef idx="minor">
-            <a:schemeClr val="lt1"/>
-          </a:fontRef>
-        </p:style>
-        <p:txBody>
-          <a:bodyPr rtlCol="0" anchor="ctr"/>
-          <a:lstStyle/>
-          <a:p>
-            <a:pPr algn="ctr"/>
-            <a:r>
-              <a:rPr lang="en-IN" sz="1400" b="1" dirty="0"/>
-              <a:t>EXISTING PROBLEM</a:t>
-            </a:r>
-          </a:p>
-        </p:txBody>
-      </p:sp>
-      <p:sp>
-        <p:nvSpPr>
-          <p:cNvPr id="18" name="Rectangle: Rounded Corners 17">
-            <a:extLst>
-              <a:ext uri="{FF2B5EF4-FFF2-40B4-BE49-F238E27FC236}">
-                <a16:creationId xmlns:a16="http://schemas.microsoft.com/office/drawing/2014/main" id="{D244A848-D5EB-6A1C-5108-76D0620D5839}"/>
-              </a:ext>
-            </a:extLst>
-          </p:cNvPr>
-          <p:cNvSpPr/>
-          <p:nvPr/>
-        </p:nvSpPr>
-        <p:spPr>
-          <a:xfrm>
-            <a:off x="192506" y="2943322"/>
-            <a:ext cx="1869974" cy="308810"/>
-          </a:xfrm>
-          <a:prstGeom prst="roundRect">
-            <a:avLst/>
-          </a:prstGeom>
-          <a:solidFill>
-            <a:schemeClr val="bg1">
-              <a:lumMod val="65000"/>
-            </a:schemeClr>
-          </a:solidFill>
-        </p:spPr>
-        <p:style>
-          <a:lnRef idx="1">
-            <a:schemeClr val="accent1"/>
-          </a:lnRef>
-          <a:fillRef idx="3">
-            <a:schemeClr val="accent1"/>
-          </a:fillRef>
-          <a:effectRef idx="2">
-            <a:schemeClr val="accent1"/>
-          </a:effectRef>
-          <a:fontRef idx="minor">
-            <a:schemeClr val="lt1"/>
-          </a:fontRef>
-        </p:style>
-        <p:txBody>
-          <a:bodyPr rtlCol="0" anchor="ctr"/>
-          <a:lstStyle/>
-          <a:p>
-            <a:pPr algn="ctr"/>
-            <a:r>
-              <a:rPr lang="en-IN" sz="1400" b="1" dirty="0"/>
-              <a:t>PROPOSED SOLUTION</a:t>
-            </a:r>
-          </a:p>
-        </p:txBody>
-      </p:sp>
-      <p:sp>
-        <p:nvSpPr>
-          <p:cNvPr id="20" name="Rectangle: Rounded Corners 19">
-            <a:extLst>
-              <a:ext uri="{FF2B5EF4-FFF2-40B4-BE49-F238E27FC236}">
-                <a16:creationId xmlns:a16="http://schemas.microsoft.com/office/drawing/2014/main" id="{FCDAB89E-44BA-B9D2-C2AF-2AE0AC55DCA1}"/>
-              </a:ext>
-            </a:extLst>
-          </p:cNvPr>
-          <p:cNvSpPr/>
-          <p:nvPr/>
-        </p:nvSpPr>
-        <p:spPr>
-          <a:xfrm>
-            <a:off x="192506" y="4733576"/>
-            <a:ext cx="2601494" cy="308810"/>
-          </a:xfrm>
-          <a:prstGeom prst="roundRect">
-            <a:avLst/>
-          </a:prstGeom>
-          <a:solidFill>
-            <a:schemeClr val="bg1">
-              <a:lumMod val="65000"/>
-            </a:schemeClr>
-          </a:solidFill>
-        </p:spPr>
-        <p:style>
-          <a:lnRef idx="1">
-            <a:schemeClr val="accent1"/>
-          </a:lnRef>
-          <a:fillRef idx="3">
-            <a:schemeClr val="accent1"/>
-          </a:fillRef>
-          <a:effectRef idx="2">
-            <a:schemeClr val="accent1"/>
-          </a:effectRef>
-          <a:fontRef idx="minor">
-            <a:schemeClr val="lt1"/>
-          </a:fontRef>
-        </p:style>
-        <p:txBody>
-          <a:bodyPr rtlCol="0" anchor="ctr"/>
-          <a:lstStyle/>
-          <a:p>
-            <a:pPr algn="ctr"/>
-            <a:r>
-              <a:rPr lang="en-IN" sz="1400" b="1" dirty="0"/>
-              <a:t>UVP(Unique Value Proposition)</a:t>
-            </a:r>
-          </a:p>
-        </p:txBody>
-      </p:sp>
-      <p:sp>
-        <p:nvSpPr>
-          <p:cNvPr id="23" name="Rectangle 22">
-            <a:extLst>
-              <a:ext uri="{FF2B5EF4-FFF2-40B4-BE49-F238E27FC236}">
-                <a16:creationId xmlns:a16="http://schemas.microsoft.com/office/drawing/2014/main" id="{EBF0EE69-72A6-9359-8950-4BB3A2307110}"/>
-              </a:ext>
-            </a:extLst>
-          </p:cNvPr>
-          <p:cNvSpPr/>
-          <p:nvPr/>
-        </p:nvSpPr>
-        <p:spPr>
-          <a:xfrm>
-            <a:off x="7467600" y="1352595"/>
-            <a:ext cx="4274106" cy="4792571"/>
-          </a:xfrm>
-          <a:prstGeom prst="rect">
-            <a:avLst/>
-          </a:prstGeom>
-          <a:solidFill>
             <a:srgbClr val="F8FAFC"/>
           </a:solidFill>
-          <a:ln>
+          <a:ln w="15240">
             <a:solidFill>
               <a:srgbClr val="CBD5E1"/>
             </a:solidFill>
@@ -7049,40 +6501,143 @@
           </a:fontRef>
         </p:style>
         <p:txBody>
-          <a:bodyPr rtlCol="0" anchor="ctr"/>
+          <a:bodyPr rtlCol="0" anchor="t" wrap="square" lIns="164592" rIns="164592" tIns="109728" bIns="91440"/>
           <a:lstStyle/>
           <a:p>
-            <a:pPr algn="ctr"/>
-            <a:endParaRPr lang="en-IN" dirty="0"/>
-          </a:p>
-        </p:txBody>
-      </p:sp>
-      <p:sp>
-        <p:nvSpPr>
-          <p:cNvPr id="24" name="Rectangle: Rounded Corners 23">
-            <a:extLst>
-              <a:ext uri="{FF2B5EF4-FFF2-40B4-BE49-F238E27FC236}">
-                <a16:creationId xmlns:a16="http://schemas.microsoft.com/office/drawing/2014/main" id="{A7A7121F-3834-0B5F-2B5F-EE102B184FC1}"/>
-              </a:ext>
-            </a:extLst>
-          </p:cNvPr>
+            <a:pPr algn="ctr">
+              <a:spcBef>
+                <a:spcPts val="200"/>
+              </a:spcBef>
+              <a:spcAft>
+                <a:spcPts val="500"/>
+              </a:spcAft>
+            </a:pPr>
+            <a:r>
+              <a:rPr sz="1000" b="1">
+                <a:solidFill>
+                  <a:srgbClr val="0070C0"/>
+                </a:solidFill>
+                <a:latin typeface="Arial"/>
+              </a:rPr>
+              <a:t>➤  </a:t>
+            </a:r>
+            <a:r>
+              <a:rPr sz="1000" b="1">
+                <a:solidFill>
+                  <a:srgbClr val="0070C0"/>
+                </a:solidFill>
+                <a:latin typeface="Arial"/>
+              </a:rPr>
+              <a:t>₹4,000+ Cr Escrow Lockup : </a:t>
+            </a:r>
+            <a:r>
+              <a:rPr sz="950">
+                <a:solidFill>
+                  <a:srgbClr val="1E293B"/>
+                </a:solidFill>
+                <a:latin typeface="Arial"/>
+              </a:rPr>
+              <a:t>Sub-judice compensation under Section 3H stalls critical national corridors for 1,200+ days.</a:t>
+            </a:r>
+          </a:p>
+          <a:p>
+            <a:pPr>
+              <a:spcBef>
+                <a:spcPts val="200"/>
+              </a:spcBef>
+              <a:spcAft>
+                <a:spcPts val="500"/>
+              </a:spcAft>
+            </a:pPr>
+            <a:r>
+              <a:rPr sz="1000" b="1">
+                <a:solidFill>
+                  <a:srgbClr val="0070C0"/>
+                </a:solidFill>
+                <a:latin typeface="Arial"/>
+              </a:rPr>
+              <a:t>➤  </a:t>
+            </a:r>
+            <a:r>
+              <a:rPr sz="1000" b="1">
+                <a:solidFill>
+                  <a:srgbClr val="0070C0"/>
+                </a:solidFill>
+                <a:latin typeface="Arial"/>
+              </a:rPr>
+              <a:t>Section 3D Statutory Lapse : </a:t>
+            </a:r>
+            <a:r>
+              <a:rPr sz="950">
+                <a:solidFill>
+                  <a:srgbClr val="1E293B"/>
+                </a:solidFill>
+                <a:latin typeface="Arial"/>
+              </a:rPr>
+              <a:t>Section 3A notifications automatically lapse at Day 365 if environmental/revenue clearances stall.</a:t>
+            </a:r>
+          </a:p>
+          <a:p>
+            <a:pPr>
+              <a:spcBef>
+                <a:spcPts val="200"/>
+              </a:spcBef>
+              <a:spcAft>
+                <a:spcPts val="500"/>
+              </a:spcAft>
+            </a:pPr>
+            <a:r>
+              <a:rPr sz="1000" b="1">
+                <a:solidFill>
+                  <a:srgbClr val="0070C0"/>
+                </a:solidFill>
+                <a:latin typeface="Arial"/>
+              </a:rPr>
+              <a:t>➤  </a:t>
+            </a:r>
+            <a:r>
+              <a:rPr sz="1000" b="1">
+                <a:solidFill>
+                  <a:srgbClr val="0070C0"/>
+                </a:solidFill>
+                <a:latin typeface="Arial"/>
+              </a:rPr>
+              <a:t>Disconnected Land Silos : </a:t>
+            </a:r>
+            <a:r>
+              <a:rPr sz="950">
+                <a:solidFill>
+                  <a:srgbClr val="1E293B"/>
+                </a:solidFill>
+                <a:latin typeface="Arial"/>
+              </a:rPr>
+              <a:t>Gazette notices, e-Courts stays, cadastral Khasra maps, and civil road works operate in blind silos.</a:t>
+            </a:r>
+          </a:p>
+        </p:txBody>
+      </p:sp>
+      <p:sp>
+        <p:nvSpPr>
+          <p:cNvPr id="15364" name="Rounded Rectangle 15363"/>
           <p:cNvSpPr/>
           <p:nvPr/>
         </p:nvSpPr>
         <p:spPr>
           <a:xfrm>
-            <a:off x="7467600" y="1063548"/>
-            <a:ext cx="1647400" cy="256715"/>
+            <a:off x="438912" y="2834640"/>
+            <a:ext cx="2103120" cy="292608"/>
           </a:xfrm>
           <a:prstGeom prst="roundRect">
             <a:avLst/>
           </a:prstGeom>
           <a:solidFill>
-            <a:schemeClr val="tx1">
-              <a:lumMod val="85000"/>
-              <a:lumOff val="15000"/>
-            </a:schemeClr>
+            <a:srgbClr val="5A6B7C"/>
           </a:solidFill>
+          <a:ln>
+            <a:solidFill>
+              <a:srgbClr val="465564"/>
+            </a:solidFill>
+          </a:ln>
         </p:spPr>
         <p:style>
           <a:lnRef idx="1">
@@ -7099,27 +6654,394 @@
           </a:fontRef>
         </p:style>
         <p:txBody>
-          <a:bodyPr rtlCol="0" anchor="ctr"/>
+          <a:bodyPr rtlCol="0" anchor="ctr" wrap="none"/>
           <a:lstStyle/>
           <a:p>
-            <a:pPr algn="ctr"/>
-            <a:r>
-              <a:rPr lang="en-IN" dirty="0"/>
-              <a:t>Architecture</a:t>
-            </a:r>
-          </a:p>
-        </p:txBody>
-      </p:sp>
-      <p:sp>
-        <p:nvSpPr>
-          <p:cNvPr id="15362" name="Rounded Rectangle 15361"/>
+            <a:pPr algn="ctr">
+              <a:defRPr sz="1100" b="1">
+                <a:solidFill>
+                  <a:srgbClr val="FFFFFF"/>
+                </a:solidFill>
+                <a:latin typeface="Arial"/>
+              </a:defRPr>
+            </a:pPr>
+            <a:r>
+              <a:t>PROPOSED SOLUTION</a:t>
+            </a:r>
+          </a:p>
+        </p:txBody>
+      </p:sp>
+      <p:sp>
+        <p:nvSpPr>
+          <p:cNvPr id="15365" name="Rounded Rectangle 15364"/>
           <p:cNvSpPr/>
           <p:nvPr/>
         </p:nvSpPr>
         <p:spPr>
           <a:xfrm>
-            <a:off x="6949440" y="1325880"/>
-            <a:ext cx="3566159" cy="658368"/>
+            <a:off x="438912" y="3154680"/>
+            <a:ext cx="5532120" cy="1444752"/>
+          </a:xfrm>
+          <a:prstGeom prst="roundRect">
+            <a:avLst/>
+          </a:prstGeom>
+          <a:solidFill>
+            <a:srgbClr val="F8FAFC"/>
+          </a:solidFill>
+          <a:ln w="15240">
+            <a:solidFill>
+              <a:srgbClr val="CBD5E1"/>
+            </a:solidFill>
+          </a:ln>
+        </p:spPr>
+        <p:style>
+          <a:lnRef idx="1">
+            <a:schemeClr val="accent1"/>
+          </a:lnRef>
+          <a:fillRef idx="3">
+            <a:schemeClr val="accent1"/>
+          </a:fillRef>
+          <a:effectRef idx="2">
+            <a:schemeClr val="accent1"/>
+          </a:effectRef>
+          <a:fontRef idx="minor">
+            <a:schemeClr val="lt1"/>
+          </a:fontRef>
+        </p:style>
+        <p:txBody>
+          <a:bodyPr rtlCol="0" anchor="t" wrap="square" lIns="164592" rIns="164592" tIns="109728" bIns="91440"/>
+          <a:lstStyle/>
+          <a:p>
+            <a:pPr algn="ctr">
+              <a:spcBef>
+                <a:spcPts val="200"/>
+              </a:spcBef>
+              <a:spcAft>
+                <a:spcPts val="500"/>
+              </a:spcAft>
+            </a:pPr>
+            <a:r>
+              <a:rPr sz="1000" b="1">
+                <a:solidFill>
+                  <a:srgbClr val="0070C0"/>
+                </a:solidFill>
+                <a:latin typeface="Arial"/>
+              </a:rPr>
+              <a:t>➤  </a:t>
+            </a:r>
+            <a:r>
+              <a:rPr sz="1000" b="1">
+                <a:solidFill>
+                  <a:srgbClr val="0070C0"/>
+                </a:solidFill>
+                <a:latin typeface="Arial"/>
+              </a:rPr>
+              <a:t>Decoupled Central DB (&lt;15ms) : </a:t>
+            </a:r>
+            <a:r>
+              <a:rPr sz="950">
+                <a:solidFill>
+                  <a:srgbClr val="1E293B"/>
+                </a:solidFill>
+                <a:latin typeface="Arial"/>
+              </a:rPr>
+              <a:t>Pre-ingests 47 standardized statutory features across civil, revenue, and court databases.</a:t>
+            </a:r>
+          </a:p>
+          <a:p>
+            <a:pPr>
+              <a:spcBef>
+                <a:spcPts val="200"/>
+              </a:spcBef>
+              <a:spcAft>
+                <a:spcPts val="500"/>
+              </a:spcAft>
+            </a:pPr>
+            <a:r>
+              <a:rPr sz="1000" b="1">
+                <a:solidFill>
+                  <a:srgbClr val="0070C0"/>
+                </a:solidFill>
+                <a:latin typeface="Arial"/>
+              </a:rPr>
+              <a:t>➤  </a:t>
+            </a:r>
+            <a:r>
+              <a:rPr sz="1000" b="1">
+                <a:solidFill>
+                  <a:srgbClr val="0070C0"/>
+                </a:solidFill>
+                <a:latin typeface="Arial"/>
+              </a:rPr>
+              <a:t>Dual-Track Reality Engine : </a:t>
+            </a:r>
+            <a:r>
+              <a:rPr sz="950">
+                <a:solidFill>
+                  <a:srgbClr val="1E293B"/>
+                </a:solidFill>
+                <a:latin typeface="Arial"/>
+              </a:rPr>
+              <a:t>Decouples physical civil road construction from court escrow disputes under Section 3D(2) vesting.</a:t>
+            </a:r>
+          </a:p>
+          <a:p>
+            <a:pPr>
+              <a:spcBef>
+                <a:spcPts val="200"/>
+              </a:spcBef>
+              <a:spcAft>
+                <a:spcPts val="500"/>
+              </a:spcAft>
+            </a:pPr>
+            <a:r>
+              <a:rPr sz="1000" b="1">
+                <a:solidFill>
+                  <a:srgbClr val="0070C0"/>
+                </a:solidFill>
+                <a:latin typeface="Arial"/>
+              </a:rPr>
+              <a:t>➤  </a:t>
+            </a:r>
+            <a:r>
+              <a:rPr sz="1000" b="1">
+                <a:solidFill>
+                  <a:srgbClr val="0070C0"/>
+                </a:solidFill>
+                <a:latin typeface="Arial"/>
+              </a:rPr>
+              <a:t>TreeSHAP Statutory XAI : </a:t>
+            </a:r>
+            <a:r>
+              <a:rPr sz="950">
+                <a:solidFill>
+                  <a:srgbClr val="1E293B"/>
+                </a:solidFill>
+                <a:latin typeface="Arial"/>
+              </a:rPr>
+              <a:t>Quantifies exact additive day delays per bottleneck and automates pre-drafted DFA legal notices.</a:t>
+            </a:r>
+          </a:p>
+        </p:txBody>
+      </p:sp>
+      <p:sp>
+        <p:nvSpPr>
+          <p:cNvPr id="15366" name="Rounded Rectangle 15365"/>
+          <p:cNvSpPr/>
+          <p:nvPr/>
+        </p:nvSpPr>
+        <p:spPr>
+          <a:xfrm>
+            <a:off x="438912" y="4681728"/>
+            <a:ext cx="2926080" cy="292608"/>
+          </a:xfrm>
+          <a:prstGeom prst="roundRect">
+            <a:avLst/>
+          </a:prstGeom>
+          <a:solidFill>
+            <a:srgbClr val="5A6B7C"/>
+          </a:solidFill>
+          <a:ln>
+            <a:solidFill>
+              <a:srgbClr val="465564"/>
+            </a:solidFill>
+          </a:ln>
+        </p:spPr>
+        <p:style>
+          <a:lnRef idx="1">
+            <a:schemeClr val="accent1"/>
+          </a:lnRef>
+          <a:fillRef idx="3">
+            <a:schemeClr val="accent1"/>
+          </a:fillRef>
+          <a:effectRef idx="2">
+            <a:schemeClr val="accent1"/>
+          </a:effectRef>
+          <a:fontRef idx="minor">
+            <a:schemeClr val="lt1"/>
+          </a:fontRef>
+        </p:style>
+        <p:txBody>
+          <a:bodyPr rtlCol="0" anchor="ctr" wrap="none"/>
+          <a:lstStyle/>
+          <a:p>
+            <a:pPr algn="ctr">
+              <a:defRPr sz="1050" b="1">
+                <a:solidFill>
+                  <a:srgbClr val="FFFFFF"/>
+                </a:solidFill>
+                <a:latin typeface="Arial"/>
+              </a:defRPr>
+            </a:pPr>
+            <a:r>
+              <a:t>UVP (UNIQUE VALUE PROPOSITION)</a:t>
+            </a:r>
+          </a:p>
+        </p:txBody>
+      </p:sp>
+      <p:sp>
+        <p:nvSpPr>
+          <p:cNvPr id="15367" name="Rounded Rectangle 15366"/>
+          <p:cNvSpPr/>
+          <p:nvPr/>
+        </p:nvSpPr>
+        <p:spPr>
+          <a:xfrm>
+            <a:off x="438912" y="5001768"/>
+            <a:ext cx="5532120" cy="1417320"/>
+          </a:xfrm>
+          <a:prstGeom prst="roundRect">
+            <a:avLst/>
+          </a:prstGeom>
+          <a:solidFill>
+            <a:srgbClr val="F8FAFC"/>
+          </a:solidFill>
+          <a:ln w="15240">
+            <a:solidFill>
+              <a:srgbClr val="CBD5E1"/>
+            </a:solidFill>
+          </a:ln>
+        </p:spPr>
+        <p:style>
+          <a:lnRef idx="1">
+            <a:schemeClr val="accent1"/>
+          </a:lnRef>
+          <a:fillRef idx="3">
+            <a:schemeClr val="accent1"/>
+          </a:fillRef>
+          <a:effectRef idx="2">
+            <a:schemeClr val="accent1"/>
+          </a:effectRef>
+          <a:fontRef idx="minor">
+            <a:schemeClr val="lt1"/>
+          </a:fontRef>
+        </p:style>
+        <p:txBody>
+          <a:bodyPr rtlCol="0" anchor="t" wrap="square" lIns="164592" rIns="164592" tIns="109728" bIns="91440"/>
+          <a:lstStyle/>
+          <a:p>
+            <a:pPr algn="ctr">
+              <a:spcBef>
+                <a:spcPts val="200"/>
+              </a:spcBef>
+              <a:spcAft>
+                <a:spcPts val="500"/>
+              </a:spcAft>
+            </a:pPr>
+            <a:r>
+              <a:rPr sz="1000" b="1">
+                <a:solidFill>
+                  <a:srgbClr val="0070C0"/>
+                </a:solidFill>
+                <a:latin typeface="Arial"/>
+              </a:rPr>
+              <a:t>➤  </a:t>
+            </a:r>
+            <a:r>
+              <a:rPr sz="1000" b="1">
+                <a:solidFill>
+                  <a:srgbClr val="0070C0"/>
+                </a:solidFill>
+                <a:latin typeface="Arial"/>
+              </a:rPr>
+              <a:t>Constitutional HITL (Arts. 77 &amp; 166) : </a:t>
+            </a:r>
+            <a:r>
+              <a:rPr sz="950">
+                <a:solidFill>
+                  <a:srgbClr val="1E293B"/>
+                </a:solidFill>
+                <a:latin typeface="Arial"/>
+              </a:rPr>
+              <a:t>Strict human-in-the-loop governance; zero auto-execution without Aadhaar DSC e-Sign.</a:t>
+            </a:r>
+          </a:p>
+          <a:p>
+            <a:pPr>
+              <a:spcBef>
+                <a:spcPts val="200"/>
+              </a:spcBef>
+              <a:spcAft>
+                <a:spcPts val="500"/>
+              </a:spcAft>
+            </a:pPr>
+            <a:r>
+              <a:rPr sz="1000" b="1">
+                <a:solidFill>
+                  <a:srgbClr val="0070C0"/>
+                </a:solidFill>
+                <a:latin typeface="Arial"/>
+              </a:rPr>
+              <a:t>➤  </a:t>
+            </a:r>
+            <a:r>
+              <a:rPr sz="1000" b="1">
+                <a:solidFill>
+                  <a:srgbClr val="0070C0"/>
+                </a:solidFill>
+                <a:latin typeface="Arial"/>
+              </a:rPr>
+              <a:t>340.8 km Interactive RoW GIS : </a:t>
+            </a:r>
+            <a:r>
+              <a:rPr sz="950">
+                <a:solidFill>
+                  <a:srgbClr val="1E293B"/>
+                </a:solidFill>
+                <a:latin typeface="Arial"/>
+              </a:rPr>
+              <a:t>Hierarchical drill-down: Macro Alignment ➔ 8 Packages ➔ 156 Villages ➔ Khasra Plots.</a:t>
+            </a:r>
+          </a:p>
+          <a:p>
+            <a:pPr>
+              <a:spcBef>
+                <a:spcPts val="200"/>
+              </a:spcBef>
+              <a:spcAft>
+                <a:spcPts val="500"/>
+              </a:spcAft>
+            </a:pPr>
+            <a:r>
+              <a:rPr sz="1000" b="1">
+                <a:solidFill>
+                  <a:srgbClr val="0070C0"/>
+                </a:solidFill>
+                <a:latin typeface="Arial"/>
+              </a:rPr>
+              <a:t>➤  </a:t>
+            </a:r>
+            <a:r>
+              <a:rPr sz="1000" b="1">
+                <a:solidFill>
+                  <a:srgbClr val="0070C0"/>
+                </a:solidFill>
+                <a:latin typeface="Arial"/>
+              </a:rPr>
+              <a:t>SHA-256 Tamper-Proof Audit : </a:t>
+            </a:r>
+            <a:r>
+              <a:rPr sz="950">
+                <a:solidFill>
+                  <a:srgbClr val="1E293B"/>
+                </a:solidFill>
+                <a:latin typeface="Arial"/>
+              </a:rPr>
+              <a:t>Cryptographic block hashing permanently seals all risk scores and SOP orders for CAG/CVC scrutiny.</a:t>
+            </a:r>
+          </a:p>
+        </p:txBody>
+      </p:sp>
+      <p:sp>
+        <p:nvSpPr>
+          <p:cNvPr id="15368" name="Rounded Rectangle 15367"/>
+          <p:cNvSpPr/>
+          <p:nvPr/>
+        </p:nvSpPr>
+        <p:spPr>
+          <a:xfrm>
+            <a:off x="6126480" y="1051560"/>
+            <a:ext cx="5669280" cy="2697480"/>
           </a:xfrm>
           <a:prstGeom prst="roundRect">
             <a:avLst/>
@@ -7127,9 +7049,9 @@
           <a:solidFill>
             <a:srgbClr val="FFFFFF"/>
           </a:solidFill>
-          <a:ln w="19050">
+          <a:ln w="15240">
             <a:solidFill>
-              <a:srgbClr val="2563EB"/>
+              <a:srgbClr val="CBD5E1"/>
             </a:solidFill>
           </a:ln>
         </p:spPr>
@@ -7148,56 +7070,330 @@
           </a:fontRef>
         </p:style>
         <p:txBody>
+          <a:bodyPr rtlCol="0" anchor="ctr"/>
+          <a:lstStyle/>
+          <a:p>
+            <a:pPr algn="ctr"/>
+          </a:p>
+        </p:txBody>
+      </p:sp>
+      <p:sp>
+        <p:nvSpPr>
+          <p:cNvPr id="15369" name="TextBox 15368"/>
+          <p:cNvSpPr txBox="1"/>
+          <p:nvPr/>
+        </p:nvSpPr>
+        <p:spPr>
+          <a:xfrm>
+            <a:off x="6126480" y="1097280"/>
+            <a:ext cx="5669280" cy="274320"/>
+          </a:xfrm>
+          <a:prstGeom prst="rect">
+            <a:avLst/>
+          </a:prstGeom>
+          <a:noFill/>
+        </p:spPr>
+        <p:txBody>
+          <a:bodyPr wrap="none">
+            <a:spAutoFit/>
+          </a:bodyPr>
+          <a:lstStyle/>
+          <a:p>
+            <a:pPr algn="ctr">
+              <a:defRPr sz="1200" b="1">
+                <a:solidFill>
+                  <a:srgbClr val="0F172A"/>
+                </a:solidFill>
+                <a:latin typeface="Arial"/>
+              </a:defRPr>
+            </a:pPr>
+            <a:r>
+              <a:t>GATISHAKTI AI End-to-end workflow</a:t>
+            </a:r>
+          </a:p>
+        </p:txBody>
+      </p:sp>
+      <p:sp>
+        <p:nvSpPr>
+          <p:cNvPr id="15370" name="Rounded Rectangle 15369"/>
+          <p:cNvSpPr/>
+          <p:nvPr/>
+        </p:nvSpPr>
+        <p:spPr>
+          <a:xfrm>
+            <a:off x="6263640" y="1417320"/>
+            <a:ext cx="960120" cy="365760"/>
+          </a:xfrm>
+          <a:prstGeom prst="roundRect">
+            <a:avLst/>
+          </a:prstGeom>
+          <a:solidFill>
+            <a:srgbClr val="F8BBD0"/>
+          </a:solidFill>
+          <a:ln w="12700">
+            <a:solidFill>
+              <a:srgbClr val="C2185B"/>
+            </a:solidFill>
+          </a:ln>
+        </p:spPr>
+        <p:style>
+          <a:lnRef idx="1">
+            <a:schemeClr val="accent1"/>
+          </a:lnRef>
+          <a:fillRef idx="3">
+            <a:schemeClr val="accent1"/>
+          </a:fillRef>
+          <a:effectRef idx="2">
+            <a:schemeClr val="accent1"/>
+          </a:effectRef>
+          <a:fontRef idx="minor">
+            <a:schemeClr val="lt1"/>
+          </a:fontRef>
+        </p:style>
+        <p:txBody>
           <a:bodyPr rtlCol="0" anchor="ctr" wrap="square"/>
           <a:lstStyle/>
           <a:p>
             <a:pPr algn="ctr">
-              <a:spcAft>
-                <a:spcPts val="100"/>
-              </a:spcAft>
-            </a:pPr>
-            <a:r>
-              <a:rPr sz="1000" b="1">
-                <a:solidFill>
-                  <a:srgbClr val="2563EB"/>
-                </a:solidFill>
-                <a:latin typeface="Arial"/>
-              </a:rPr>
-              <a:t>1. Multi-Modal Data Ingestion</a:t>
-            </a:r>
-          </a:p>
-          <a:p>
-            <a:r>
-              <a:rPr sz="800">
-                <a:solidFill>
-                  <a:srgbClr val="1E293B"/>
-                </a:solidFill>
-                <a:latin typeface="Arial"/>
-              </a:rPr>
-              <a:t>Gazette PDFs • e-Courts WSDL • State Revenue (Jamabandi) • Drone DGPS</a:t>
-            </a:r>
-          </a:p>
-        </p:txBody>
-      </p:sp>
-      <p:sp>
-        <p:nvSpPr>
-          <p:cNvPr id="15363" name="Down Arrow 15362"/>
+              <a:defRPr sz="850" b="1">
+                <a:solidFill>
+                  <a:srgbClr val="880E4F"/>
+                </a:solidFill>
+              </a:defRPr>
+            </a:pPr>
+            <a:r>
+              <a:t>Start Ingestion</a:t>
+            </a:r>
+          </a:p>
+        </p:txBody>
+      </p:sp>
+      <p:sp>
+        <p:nvSpPr>
+          <p:cNvPr id="15371" name="Right Arrow 15370"/>
           <p:cNvSpPr/>
           <p:nvPr/>
         </p:nvSpPr>
         <p:spPr>
           <a:xfrm>
-            <a:off x="8641080" y="1993392"/>
-            <a:ext cx="182880" cy="164592"/>
+            <a:off x="7296912" y="1536192"/>
+            <a:ext cx="201168" cy="128016"/>
+          </a:xfrm>
+          <a:prstGeom prst="rightArrow">
+            <a:avLst/>
+          </a:prstGeom>
+          <a:solidFill>
+            <a:srgbClr val="64748B"/>
+          </a:solidFill>
+          <a:ln>
+            <a:solidFill>
+              <a:srgbClr val="64748B"/>
+            </a:solidFill>
+          </a:ln>
+        </p:spPr>
+        <p:style>
+          <a:lnRef idx="1">
+            <a:schemeClr val="accent1"/>
+          </a:lnRef>
+          <a:fillRef idx="3">
+            <a:schemeClr val="accent1"/>
+          </a:fillRef>
+          <a:effectRef idx="2">
+            <a:schemeClr val="accent1"/>
+          </a:effectRef>
+          <a:fontRef idx="minor">
+            <a:schemeClr val="lt1"/>
+          </a:fontRef>
+        </p:style>
+        <p:txBody>
+          <a:bodyPr rtlCol="0" anchor="ctr"/>
+          <a:lstStyle/>
+          <a:p>
+            <a:pPr algn="ctr"/>
+          </a:p>
+        </p:txBody>
+      </p:sp>
+      <p:sp>
+        <p:nvSpPr>
+          <p:cNvPr id="15372" name="Rounded Rectangle 15371"/>
+          <p:cNvSpPr/>
+          <p:nvPr/>
+        </p:nvSpPr>
+        <p:spPr>
+          <a:xfrm>
+            <a:off x="7543800" y="1389888"/>
+            <a:ext cx="1691640" cy="420624"/>
+          </a:xfrm>
+          <a:prstGeom prst="roundRect">
+            <a:avLst/>
+          </a:prstGeom>
+          <a:solidFill>
+            <a:srgbClr val="FFF9C4"/>
+          </a:solidFill>
+          <a:ln w="12700">
+            <a:solidFill>
+              <a:srgbClr val="FBC02D"/>
+            </a:solidFill>
+          </a:ln>
+        </p:spPr>
+        <p:style>
+          <a:lnRef idx="1">
+            <a:schemeClr val="accent1"/>
+          </a:lnRef>
+          <a:fillRef idx="3">
+            <a:schemeClr val="accent1"/>
+          </a:fillRef>
+          <a:effectRef idx="2">
+            <a:schemeClr val="accent1"/>
+          </a:effectRef>
+          <a:fontRef idx="minor">
+            <a:schemeClr val="lt1"/>
+          </a:fontRef>
+        </p:style>
+        <p:txBody>
+          <a:bodyPr rtlCol="0" anchor="ctr" wrap="square"/>
+          <a:lstStyle/>
+          <a:p>
+            <a:pPr algn="ctr">
+              <a:defRPr sz="800" b="1">
+                <a:solidFill>
+                  <a:srgbClr val="5D4037"/>
+                </a:solidFill>
+              </a:defRPr>
+            </a:pPr>
+            <a:r>
+              <a:t>Multi-Modal Ingestion</a:t>
+            </a:r>
+            <a:br/>
+            <a:r>
+              <a:t>(Gazette, e-Courts, Revenue)</a:t>
+            </a:r>
+          </a:p>
+        </p:txBody>
+      </p:sp>
+      <p:sp>
+        <p:nvSpPr>
+          <p:cNvPr id="15373" name="Right Arrow 15372"/>
+          <p:cNvSpPr/>
+          <p:nvPr/>
+        </p:nvSpPr>
+        <p:spPr>
+          <a:xfrm>
+            <a:off x="9308592" y="1536192"/>
+            <a:ext cx="201168" cy="128016"/>
+          </a:xfrm>
+          <a:prstGeom prst="rightArrow">
+            <a:avLst/>
+          </a:prstGeom>
+          <a:solidFill>
+            <a:srgbClr val="64748B"/>
+          </a:solidFill>
+          <a:ln>
+            <a:solidFill>
+              <a:srgbClr val="64748B"/>
+            </a:solidFill>
+          </a:ln>
+        </p:spPr>
+        <p:style>
+          <a:lnRef idx="1">
+            <a:schemeClr val="accent1"/>
+          </a:lnRef>
+          <a:fillRef idx="3">
+            <a:schemeClr val="accent1"/>
+          </a:fillRef>
+          <a:effectRef idx="2">
+            <a:schemeClr val="accent1"/>
+          </a:effectRef>
+          <a:fontRef idx="minor">
+            <a:schemeClr val="lt1"/>
+          </a:fontRef>
+        </p:style>
+        <p:txBody>
+          <a:bodyPr rtlCol="0" anchor="ctr"/>
+          <a:lstStyle/>
+          <a:p>
+            <a:pPr algn="ctr"/>
+          </a:p>
+        </p:txBody>
+      </p:sp>
+      <p:sp>
+        <p:nvSpPr>
+          <p:cNvPr id="15374" name="Rounded Rectangle 15373"/>
+          <p:cNvSpPr/>
+          <p:nvPr/>
+        </p:nvSpPr>
+        <p:spPr>
+          <a:xfrm>
+            <a:off x="9555480" y="1389888"/>
+            <a:ext cx="1600200" cy="420624"/>
+          </a:xfrm>
+          <a:prstGeom prst="roundRect">
+            <a:avLst/>
+          </a:prstGeom>
+          <a:solidFill>
+            <a:srgbClr val="FFE082"/>
+          </a:solidFill>
+          <a:ln w="12700">
+            <a:solidFill>
+              <a:srgbClr val="FFA000"/>
+            </a:solidFill>
+          </a:ln>
+        </p:spPr>
+        <p:style>
+          <a:lnRef idx="1">
+            <a:schemeClr val="accent1"/>
+          </a:lnRef>
+          <a:fillRef idx="3">
+            <a:schemeClr val="accent1"/>
+          </a:fillRef>
+          <a:effectRef idx="2">
+            <a:schemeClr val="accent1"/>
+          </a:effectRef>
+          <a:fontRef idx="minor">
+            <a:schemeClr val="lt1"/>
+          </a:fontRef>
+        </p:style>
+        <p:txBody>
+          <a:bodyPr rtlCol="0" anchor="ctr" wrap="square"/>
+          <a:lstStyle/>
+          <a:p>
+            <a:pPr algn="ctr">
+              <a:defRPr sz="800" b="1">
+                <a:solidFill>
+                  <a:srgbClr val="3E2723"/>
+                </a:solidFill>
+              </a:defRPr>
+            </a:pPr>
+            <a:r>
+              <a:t>Decoupled Central DB</a:t>
+            </a:r>
+            <a:br/>
+            <a:r>
+              <a:t>(47 Standardized Features)</a:t>
+            </a:r>
+          </a:p>
+        </p:txBody>
+      </p:sp>
+      <p:sp>
+        <p:nvSpPr>
+          <p:cNvPr id="15375" name="Down Arrow 15374"/>
+          <p:cNvSpPr/>
+          <p:nvPr/>
+        </p:nvSpPr>
+        <p:spPr>
+          <a:xfrm>
+            <a:off x="10287000" y="1847088"/>
+            <a:ext cx="128016" cy="164592"/>
           </a:xfrm>
           <a:prstGeom prst="downArrow">
             <a:avLst/>
           </a:prstGeom>
           <a:solidFill>
-            <a:srgbClr val="475569"/>
+            <a:srgbClr val="64748B"/>
           </a:solidFill>
           <a:ln>
-            <a:noFill/>
+            <a:solidFill>
+              <a:srgbClr val="64748B"/>
+            </a:solidFill>
           </a:ln>
         </p:spPr>
         <p:style>
@@ -7224,14 +7420,802 @@
       </p:sp>
       <p:sp>
         <p:nvSpPr>
-          <p:cNvPr id="15364" name="Rounded Rectangle 15363"/>
+          <p:cNvPr id="15376" name="Rounded Rectangle 15375"/>
           <p:cNvSpPr/>
           <p:nvPr/>
         </p:nvSpPr>
         <p:spPr>
           <a:xfrm>
-            <a:off x="6949440" y="2185415"/>
-            <a:ext cx="3566159" cy="658368"/>
+            <a:off x="9400032" y="2048256"/>
+            <a:ext cx="1828800" cy="402336"/>
+          </a:xfrm>
+          <a:prstGeom prst="roundRect">
+            <a:avLst/>
+          </a:prstGeom>
+          <a:solidFill>
+            <a:srgbClr val="FFE082"/>
+          </a:solidFill>
+          <a:ln w="12700">
+            <a:solidFill>
+              <a:srgbClr val="FFA000"/>
+            </a:solidFill>
+          </a:ln>
+        </p:spPr>
+        <p:style>
+          <a:lnRef idx="1">
+            <a:schemeClr val="accent1"/>
+          </a:lnRef>
+          <a:fillRef idx="3">
+            <a:schemeClr val="accent1"/>
+          </a:fillRef>
+          <a:effectRef idx="2">
+            <a:schemeClr val="accent1"/>
+          </a:effectRef>
+          <a:fontRef idx="minor">
+            <a:schemeClr val="lt1"/>
+          </a:fontRef>
+        </p:style>
+        <p:txBody>
+          <a:bodyPr rtlCol="0" anchor="ctr" wrap="square"/>
+          <a:lstStyle/>
+          <a:p>
+            <a:pPr algn="ctr">
+              <a:defRPr sz="750" b="1">
+                <a:solidFill>
+                  <a:srgbClr val="3E2723"/>
+                </a:solidFill>
+              </a:defRPr>
+            </a:pPr>
+            <a:r>
+              <a:t>LightGBM + XGBoost Regressor</a:t>
+            </a:r>
+            <a:br/>
+            <a:r>
+              <a:t>(Predicts Residual Delay Days)</a:t>
+            </a:r>
+          </a:p>
+        </p:txBody>
+      </p:sp>
+      <p:sp>
+        <p:nvSpPr>
+          <p:cNvPr id="15377" name="Left Arrow 15376"/>
+          <p:cNvSpPr/>
+          <p:nvPr/>
+        </p:nvSpPr>
+        <p:spPr>
+          <a:xfrm>
+            <a:off x="9162288" y="2176272"/>
+            <a:ext cx="182880" cy="128016"/>
+          </a:xfrm>
+          <a:prstGeom prst="leftArrow">
+            <a:avLst/>
+          </a:prstGeom>
+          <a:solidFill>
+            <a:srgbClr val="64748B"/>
+          </a:solidFill>
+          <a:ln>
+            <a:solidFill>
+              <a:srgbClr val="64748B"/>
+            </a:solidFill>
+          </a:ln>
+        </p:spPr>
+        <p:style>
+          <a:lnRef idx="1">
+            <a:schemeClr val="accent1"/>
+          </a:lnRef>
+          <a:fillRef idx="3">
+            <a:schemeClr val="accent1"/>
+          </a:fillRef>
+          <a:effectRef idx="2">
+            <a:schemeClr val="accent1"/>
+          </a:effectRef>
+          <a:fontRef idx="minor">
+            <a:schemeClr val="lt1"/>
+          </a:fontRef>
+        </p:style>
+        <p:txBody>
+          <a:bodyPr rtlCol="0" anchor="ctr"/>
+          <a:lstStyle/>
+          <a:p>
+            <a:pPr algn="ctr"/>
+          </a:p>
+        </p:txBody>
+      </p:sp>
+      <p:sp>
+        <p:nvSpPr>
+          <p:cNvPr id="15378" name="Diamond 15377"/>
+          <p:cNvSpPr/>
+          <p:nvPr/>
+        </p:nvSpPr>
+        <p:spPr>
+          <a:xfrm>
+            <a:off x="7818120" y="1920240"/>
+            <a:ext cx="1280160" cy="658368"/>
+          </a:xfrm>
+          <a:prstGeom prst="diamond">
+            <a:avLst/>
+          </a:prstGeom>
+          <a:solidFill>
+            <a:srgbClr val="1565C0"/>
+          </a:solidFill>
+          <a:ln>
+            <a:solidFill>
+              <a:srgbClr val="0D47A1"/>
+            </a:solidFill>
+          </a:ln>
+        </p:spPr>
+        <p:style>
+          <a:lnRef idx="1">
+            <a:schemeClr val="accent1"/>
+          </a:lnRef>
+          <a:fillRef idx="3">
+            <a:schemeClr val="accent1"/>
+          </a:fillRef>
+          <a:effectRef idx="2">
+            <a:schemeClr val="accent1"/>
+          </a:effectRef>
+          <a:fontRef idx="minor">
+            <a:schemeClr val="lt1"/>
+          </a:fontRef>
+        </p:style>
+        <p:txBody>
+          <a:bodyPr rtlCol="0" anchor="ctr" wrap="square"/>
+          <a:lstStyle/>
+          <a:p>
+            <a:pPr algn="ctr">
+              <a:defRPr sz="750" b="1">
+                <a:solidFill>
+                  <a:srgbClr val="FFFFFF"/>
+                </a:solidFill>
+              </a:defRPr>
+            </a:pPr>
+            <a:r>
+              <a:t>Delay Risk</a:t>
+            </a:r>
+            <a:br/>
+            <a:r>
+              <a:t>&gt; 60 Days?</a:t>
+            </a:r>
+          </a:p>
+        </p:txBody>
+      </p:sp>
+      <p:sp>
+        <p:nvSpPr>
+          <p:cNvPr id="15379" name="TextBox 15378"/>
+          <p:cNvSpPr txBox="1"/>
+          <p:nvPr/>
+        </p:nvSpPr>
+        <p:spPr>
+          <a:xfrm>
+            <a:off x="7452360" y="1993392"/>
+            <a:ext cx="320040" cy="182880"/>
+          </a:xfrm>
+          <a:prstGeom prst="rect">
+            <a:avLst/>
+          </a:prstGeom>
+          <a:noFill/>
+        </p:spPr>
+        <p:txBody>
+          <a:bodyPr wrap="none">
+            <a:spAutoFit/>
+          </a:bodyPr>
+          <a:lstStyle/>
+          <a:p>
+            <a:pPr>
+              <a:defRPr sz="750" b="1">
+                <a:solidFill>
+                  <a:srgbClr val="2E7D32"/>
+                </a:solidFill>
+              </a:defRPr>
+            </a:pPr>
+            <a:r>
+              <a:t>No</a:t>
+            </a:r>
+          </a:p>
+        </p:txBody>
+      </p:sp>
+      <p:sp>
+        <p:nvSpPr>
+          <p:cNvPr id="15380" name="Left Arrow 15379"/>
+          <p:cNvSpPr/>
+          <p:nvPr/>
+        </p:nvSpPr>
+        <p:spPr>
+          <a:xfrm>
+            <a:off x="7589520" y="2176272"/>
+            <a:ext cx="182880" cy="128016"/>
+          </a:xfrm>
+          <a:prstGeom prst="leftArrow">
+            <a:avLst/>
+          </a:prstGeom>
+          <a:solidFill>
+            <a:srgbClr val="2E7D32"/>
+          </a:solidFill>
+          <a:ln>
+            <a:solidFill>
+              <a:srgbClr val="2E7D32"/>
+            </a:solidFill>
+          </a:ln>
+        </p:spPr>
+        <p:style>
+          <a:lnRef idx="1">
+            <a:schemeClr val="accent1"/>
+          </a:lnRef>
+          <a:fillRef idx="3">
+            <a:schemeClr val="accent1"/>
+          </a:fillRef>
+          <a:effectRef idx="2">
+            <a:schemeClr val="accent1"/>
+          </a:effectRef>
+          <a:fontRef idx="minor">
+            <a:schemeClr val="lt1"/>
+          </a:fontRef>
+        </p:style>
+        <p:txBody>
+          <a:bodyPr rtlCol="0" anchor="ctr"/>
+          <a:lstStyle/>
+          <a:p>
+            <a:pPr algn="ctr"/>
+          </a:p>
+        </p:txBody>
+      </p:sp>
+      <p:sp>
+        <p:nvSpPr>
+          <p:cNvPr id="15381" name="Rounded Rectangle 15380"/>
+          <p:cNvSpPr/>
+          <p:nvPr/>
+        </p:nvSpPr>
+        <p:spPr>
+          <a:xfrm>
+            <a:off x="6263640" y="2048256"/>
+            <a:ext cx="1280160" cy="402336"/>
+          </a:xfrm>
+          <a:prstGeom prst="roundRect">
+            <a:avLst/>
+          </a:prstGeom>
+          <a:solidFill>
+            <a:srgbClr val="E8F5E9"/>
+          </a:solidFill>
+          <a:ln w="12700">
+            <a:solidFill>
+              <a:srgbClr val="4CAF50"/>
+            </a:solidFill>
+          </a:ln>
+        </p:spPr>
+        <p:style>
+          <a:lnRef idx="1">
+            <a:schemeClr val="accent1"/>
+          </a:lnRef>
+          <a:fillRef idx="3">
+            <a:schemeClr val="accent1"/>
+          </a:fillRef>
+          <a:effectRef idx="2">
+            <a:schemeClr val="accent1"/>
+          </a:effectRef>
+          <a:fontRef idx="minor">
+            <a:schemeClr val="lt1"/>
+          </a:fontRef>
+        </p:style>
+        <p:txBody>
+          <a:bodyPr rtlCol="0" anchor="ctr" wrap="square"/>
+          <a:lstStyle/>
+          <a:p>
+            <a:pPr algn="ctr">
+              <a:defRPr sz="750" b="1">
+                <a:solidFill>
+                  <a:srgbClr val="1B5E20"/>
+                </a:solidFill>
+              </a:defRPr>
+            </a:pPr>
+            <a:r>
+              <a:t>Fast-Track Notice</a:t>
+            </a:r>
+            <a:br/>
+            <a:r>
+              <a:t>(Sec 3A ➔ 3D)</a:t>
+            </a:r>
+          </a:p>
+        </p:txBody>
+      </p:sp>
+      <p:sp>
+        <p:nvSpPr>
+          <p:cNvPr id="15382" name="TextBox 15381"/>
+          <p:cNvSpPr txBox="1"/>
+          <p:nvPr/>
+        </p:nvSpPr>
+        <p:spPr>
+          <a:xfrm>
+            <a:off x="8485632" y="2468880"/>
+            <a:ext cx="320040" cy="182880"/>
+          </a:xfrm>
+          <a:prstGeom prst="rect">
+            <a:avLst/>
+          </a:prstGeom>
+          <a:noFill/>
+        </p:spPr>
+        <p:txBody>
+          <a:bodyPr wrap="none">
+            <a:spAutoFit/>
+          </a:bodyPr>
+          <a:lstStyle/>
+          <a:p>
+            <a:pPr>
+              <a:defRPr sz="750" b="1">
+                <a:solidFill>
+                  <a:srgbClr val="E65100"/>
+                </a:solidFill>
+              </a:defRPr>
+            </a:pPr>
+            <a:r>
+              <a:t>Yes</a:t>
+            </a:r>
+          </a:p>
+        </p:txBody>
+      </p:sp>
+      <p:sp>
+        <p:nvSpPr>
+          <p:cNvPr id="15383" name="Down Arrow 15382"/>
+          <p:cNvSpPr/>
+          <p:nvPr/>
+        </p:nvSpPr>
+        <p:spPr>
+          <a:xfrm>
+            <a:off x="8394192" y="2615184"/>
+            <a:ext cx="128016" cy="164592"/>
+          </a:xfrm>
+          <a:prstGeom prst="downArrow">
+            <a:avLst/>
+          </a:prstGeom>
+          <a:solidFill>
+            <a:srgbClr val="E65100"/>
+          </a:solidFill>
+          <a:ln>
+            <a:solidFill>
+              <a:srgbClr val="E65100"/>
+            </a:solidFill>
+          </a:ln>
+        </p:spPr>
+        <p:style>
+          <a:lnRef idx="1">
+            <a:schemeClr val="accent1"/>
+          </a:lnRef>
+          <a:fillRef idx="3">
+            <a:schemeClr val="accent1"/>
+          </a:fillRef>
+          <a:effectRef idx="2">
+            <a:schemeClr val="accent1"/>
+          </a:effectRef>
+          <a:fontRef idx="minor">
+            <a:schemeClr val="lt1"/>
+          </a:fontRef>
+        </p:style>
+        <p:txBody>
+          <a:bodyPr rtlCol="0" anchor="ctr"/>
+          <a:lstStyle/>
+          <a:p>
+            <a:pPr algn="ctr"/>
+          </a:p>
+        </p:txBody>
+      </p:sp>
+      <p:sp>
+        <p:nvSpPr>
+          <p:cNvPr id="15384" name="Rounded Rectangle 15383"/>
+          <p:cNvSpPr/>
+          <p:nvPr/>
+        </p:nvSpPr>
+        <p:spPr>
+          <a:xfrm>
+            <a:off x="6263640" y="2816352"/>
+            <a:ext cx="1719072" cy="420624"/>
+          </a:xfrm>
+          <a:prstGeom prst="roundRect">
+            <a:avLst/>
+          </a:prstGeom>
+          <a:solidFill>
+            <a:srgbClr val="FFE0B2"/>
+          </a:solidFill>
+          <a:ln w="12700">
+            <a:solidFill>
+              <a:srgbClr val="FB8C00"/>
+            </a:solidFill>
+          </a:ln>
+        </p:spPr>
+        <p:style>
+          <a:lnRef idx="1">
+            <a:schemeClr val="accent1"/>
+          </a:lnRef>
+          <a:fillRef idx="3">
+            <a:schemeClr val="accent1"/>
+          </a:fillRef>
+          <a:effectRef idx="2">
+            <a:schemeClr val="accent1"/>
+          </a:effectRef>
+          <a:fontRef idx="minor">
+            <a:schemeClr val="lt1"/>
+          </a:fontRef>
+        </p:style>
+        <p:txBody>
+          <a:bodyPr rtlCol="0" anchor="ctr" wrap="square"/>
+          <a:lstStyle/>
+          <a:p>
+            <a:pPr algn="ctr">
+              <a:defRPr sz="750" b="1">
+                <a:solidFill>
+                  <a:srgbClr val="BF360C"/>
+                </a:solidFill>
+              </a:defRPr>
+            </a:pPr>
+            <a:r>
+              <a:t>TreeSHAP Attribution</a:t>
+            </a:r>
+            <a:br/>
+            <a:r>
+              <a:t>+ Automated Legal DFA SOP</a:t>
+            </a:r>
+          </a:p>
+        </p:txBody>
+      </p:sp>
+      <p:sp>
+        <p:nvSpPr>
+          <p:cNvPr id="15385" name="Right Arrow 15384"/>
+          <p:cNvSpPr/>
+          <p:nvPr/>
+        </p:nvSpPr>
+        <p:spPr>
+          <a:xfrm>
+            <a:off x="8046720" y="2962656"/>
+            <a:ext cx="182880" cy="128016"/>
+          </a:xfrm>
+          <a:prstGeom prst="rightArrow">
+            <a:avLst/>
+          </a:prstGeom>
+          <a:solidFill>
+            <a:srgbClr val="64748B"/>
+          </a:solidFill>
+          <a:ln>
+            <a:solidFill>
+              <a:srgbClr val="64748B"/>
+            </a:solidFill>
+          </a:ln>
+        </p:spPr>
+        <p:style>
+          <a:lnRef idx="1">
+            <a:schemeClr val="accent1"/>
+          </a:lnRef>
+          <a:fillRef idx="3">
+            <a:schemeClr val="accent1"/>
+          </a:fillRef>
+          <a:effectRef idx="2">
+            <a:schemeClr val="accent1"/>
+          </a:effectRef>
+          <a:fontRef idx="minor">
+            <a:schemeClr val="lt1"/>
+          </a:fontRef>
+        </p:style>
+        <p:txBody>
+          <a:bodyPr rtlCol="0" anchor="ctr"/>
+          <a:lstStyle/>
+          <a:p>
+            <a:pPr algn="ctr"/>
+          </a:p>
+        </p:txBody>
+      </p:sp>
+      <p:sp>
+        <p:nvSpPr>
+          <p:cNvPr id="15386" name="Rounded Rectangle 15385"/>
+          <p:cNvSpPr/>
+          <p:nvPr/>
+        </p:nvSpPr>
+        <p:spPr>
+          <a:xfrm>
+            <a:off x="8275320" y="2816352"/>
+            <a:ext cx="1783080" cy="420624"/>
+          </a:xfrm>
+          <a:prstGeom prst="roundRect">
+            <a:avLst/>
+          </a:prstGeom>
+          <a:solidFill>
+            <a:srgbClr val="FFECB3"/>
+          </a:solidFill>
+          <a:ln w="12700">
+            <a:solidFill>
+              <a:srgbClr val="FFB300"/>
+            </a:solidFill>
+          </a:ln>
+        </p:spPr>
+        <p:style>
+          <a:lnRef idx="1">
+            <a:schemeClr val="accent1"/>
+          </a:lnRef>
+          <a:fillRef idx="3">
+            <a:schemeClr val="accent1"/>
+          </a:fillRef>
+          <a:effectRef idx="2">
+            <a:schemeClr val="accent1"/>
+          </a:effectRef>
+          <a:fontRef idx="minor">
+            <a:schemeClr val="lt1"/>
+          </a:fontRef>
+        </p:style>
+        <p:txBody>
+          <a:bodyPr rtlCol="0" anchor="ctr" wrap="square"/>
+          <a:lstStyle/>
+          <a:p>
+            <a:pPr algn="ctr">
+              <a:defRPr sz="750" b="1">
+                <a:solidFill>
+                  <a:srgbClr val="4E342E"/>
+                </a:solidFill>
+              </a:defRPr>
+            </a:pPr>
+            <a:r>
+              <a:t>Officer HITL Review</a:t>
+            </a:r>
+            <a:br/>
+            <a:r>
+              <a:t>+ Aadhaar DSC e-Sign</a:t>
+            </a:r>
+          </a:p>
+        </p:txBody>
+      </p:sp>
+      <p:sp>
+        <p:nvSpPr>
+          <p:cNvPr id="15387" name="Right Arrow 15386"/>
+          <p:cNvSpPr/>
+          <p:nvPr/>
+        </p:nvSpPr>
+        <p:spPr>
+          <a:xfrm>
+            <a:off x="10113264" y="2962656"/>
+            <a:ext cx="164592" cy="128016"/>
+          </a:xfrm>
+          <a:prstGeom prst="rightArrow">
+            <a:avLst/>
+          </a:prstGeom>
+          <a:solidFill>
+            <a:srgbClr val="64748B"/>
+          </a:solidFill>
+          <a:ln>
+            <a:solidFill>
+              <a:srgbClr val="64748B"/>
+            </a:solidFill>
+          </a:ln>
+        </p:spPr>
+        <p:style>
+          <a:lnRef idx="1">
+            <a:schemeClr val="accent1"/>
+          </a:lnRef>
+          <a:fillRef idx="3">
+            <a:schemeClr val="accent1"/>
+          </a:fillRef>
+          <a:effectRef idx="2">
+            <a:schemeClr val="accent1"/>
+          </a:effectRef>
+          <a:fontRef idx="minor">
+            <a:schemeClr val="lt1"/>
+          </a:fontRef>
+        </p:style>
+        <p:txBody>
+          <a:bodyPr rtlCol="0" anchor="ctr"/>
+          <a:lstStyle/>
+          <a:p>
+            <a:pPr algn="ctr"/>
+          </a:p>
+        </p:txBody>
+      </p:sp>
+      <p:sp>
+        <p:nvSpPr>
+          <p:cNvPr id="15388" name="Rounded Rectangle 15387"/>
+          <p:cNvSpPr/>
+          <p:nvPr/>
+        </p:nvSpPr>
+        <p:spPr>
+          <a:xfrm>
+            <a:off x="10332720" y="2816352"/>
+            <a:ext cx="1325880" cy="420624"/>
+          </a:xfrm>
+          <a:prstGeom prst="roundRect">
+            <a:avLst/>
+          </a:prstGeom>
+          <a:solidFill>
+            <a:srgbClr val="F8BBD0"/>
+          </a:solidFill>
+          <a:ln w="12700">
+            <a:solidFill>
+              <a:srgbClr val="C2185B"/>
+            </a:solidFill>
+          </a:ln>
+        </p:spPr>
+        <p:style>
+          <a:lnRef idx="1">
+            <a:schemeClr val="accent1"/>
+          </a:lnRef>
+          <a:fillRef idx="3">
+            <a:schemeClr val="accent1"/>
+          </a:fillRef>
+          <a:effectRef idx="2">
+            <a:schemeClr val="accent1"/>
+          </a:effectRef>
+          <a:fontRef idx="minor">
+            <a:schemeClr val="lt1"/>
+          </a:fontRef>
+        </p:style>
+        <p:txBody>
+          <a:bodyPr rtlCol="0" anchor="ctr" wrap="square"/>
+          <a:lstStyle/>
+          <a:p>
+            <a:pPr algn="ctr">
+              <a:defRPr sz="750" b="1">
+                <a:solidFill>
+                  <a:srgbClr val="880E4F"/>
+                </a:solidFill>
+              </a:defRPr>
+            </a:pPr>
+            <a:r>
+              <a:t>CAG-Ready</a:t>
+            </a:r>
+            <a:br/>
+            <a:r>
+              <a:t>SHA-256 Ledger</a:t>
+            </a:r>
+          </a:p>
+        </p:txBody>
+      </p:sp>
+      <p:sp>
+        <p:nvSpPr>
+          <p:cNvPr id="15389" name="Rounded Rectangle 15388"/>
+          <p:cNvSpPr/>
+          <p:nvPr/>
+        </p:nvSpPr>
+        <p:spPr>
+          <a:xfrm>
+            <a:off x="7589520" y="3858768"/>
+            <a:ext cx="2743200" cy="310896"/>
+          </a:xfrm>
+          <a:prstGeom prst="roundRect">
+            <a:avLst/>
+          </a:prstGeom>
+          <a:solidFill>
+            <a:srgbClr val="4B6F44"/>
+          </a:solidFill>
+          <a:ln>
+            <a:solidFill>
+              <a:srgbClr val="385533"/>
+            </a:solidFill>
+          </a:ln>
+        </p:spPr>
+        <p:style>
+          <a:lnRef idx="1">
+            <a:schemeClr val="accent1"/>
+          </a:lnRef>
+          <a:fillRef idx="3">
+            <a:schemeClr val="accent1"/>
+          </a:fillRef>
+          <a:effectRef idx="2">
+            <a:schemeClr val="accent1"/>
+          </a:effectRef>
+          <a:fontRef idx="minor">
+            <a:schemeClr val="lt1"/>
+          </a:fontRef>
+        </p:style>
+        <p:txBody>
+          <a:bodyPr rtlCol="0" anchor="ctr" wrap="none"/>
+          <a:lstStyle/>
+          <a:p>
+            <a:pPr algn="ctr">
+              <a:defRPr sz="1100" b="1">
+                <a:solidFill>
+                  <a:srgbClr val="FFFFFF"/>
+                </a:solidFill>
+                <a:latin typeface="Arial"/>
+              </a:defRPr>
+            </a:pPr>
+            <a:r>
+              <a:t>Innovation and Uniqueness</a:t>
+            </a:r>
+          </a:p>
+        </p:txBody>
+      </p:sp>
+      <p:sp>
+        <p:nvSpPr>
+          <p:cNvPr id="15390" name="Rounded Rectangle 15389"/>
+          <p:cNvSpPr/>
+          <p:nvPr/>
+        </p:nvSpPr>
+        <p:spPr>
+          <a:xfrm>
+            <a:off x="6126480" y="4224528"/>
+            <a:ext cx="1051560" cy="2194560"/>
+          </a:xfrm>
+          <a:prstGeom prst="roundRect">
+            <a:avLst/>
+          </a:prstGeom>
+          <a:solidFill>
+            <a:srgbClr val="A8443C"/>
+          </a:solidFill>
+          <a:ln w="19050">
+            <a:solidFill>
+              <a:srgbClr val="EBB4AF"/>
+            </a:solidFill>
+          </a:ln>
+        </p:spPr>
+        <p:style>
+          <a:lnRef idx="1">
+            <a:schemeClr val="accent1"/>
+          </a:lnRef>
+          <a:fillRef idx="3">
+            <a:schemeClr val="accent1"/>
+          </a:fillRef>
+          <a:effectRef idx="2">
+            <a:schemeClr val="accent1"/>
+          </a:effectRef>
+          <a:fontRef idx="minor">
+            <a:schemeClr val="lt1"/>
+          </a:fontRef>
+        </p:style>
+        <p:txBody>
+          <a:bodyPr rtlCol="0" anchor="t" wrap="square" lIns="54864" rIns="54864" tIns="73152" bIns="54864"/>
+          <a:lstStyle/>
+          <a:p>
+            <a:pPr algn="ctr">
+              <a:spcAft>
+                <a:spcPts val="200"/>
+              </a:spcAft>
+              <a:defRPr sz="850" b="1">
+                <a:solidFill>
+                  <a:srgbClr val="FFFFFF"/>
+                </a:solidFill>
+                <a:latin typeface="Arial"/>
+              </a:defRPr>
+            </a:pPr>
+            <a:r>
+              <a:t>Decoupled DB</a:t>
+            </a:r>
+          </a:p>
+          <a:p>
+            <a:pPr algn="ctr">
+              <a:spcAft>
+                <a:spcPts val="400"/>
+              </a:spcAft>
+              <a:defRPr sz="700" b="1">
+                <a:solidFill>
+                  <a:srgbClr val="FFFFC8"/>
+                </a:solidFill>
+                <a:latin typeface="Arial"/>
+              </a:defRPr>
+            </a:pPr>
+            <a:r>
+              <a:t>[&lt;15ms Direct Query]</a:t>
+            </a:r>
+          </a:p>
+          <a:p>
+            <a:pPr algn="ctr">
+              <a:spcAft>
+                <a:spcPts val="400"/>
+              </a:spcAft>
+              <a:defRPr sz="700">
+                <a:solidFill>
+                  <a:srgbClr val="F5F5F5"/>
+                </a:solidFill>
+                <a:latin typeface="Arial"/>
+              </a:defRPr>
+            </a:pPr>
+            <a:r>
+              <a:t>Direct normalized cache of 47 statutory attributes eliminates slow manual OCR bottlenecks.</a:t>
+            </a:r>
+          </a:p>
+        </p:txBody>
+      </p:sp>
+      <p:sp>
+        <p:nvSpPr>
+          <p:cNvPr id="15391" name="Rounded Rectangle 15390"/>
+          <p:cNvSpPr/>
+          <p:nvPr/>
+        </p:nvSpPr>
+        <p:spPr>
+          <a:xfrm>
+            <a:off x="6199632" y="6071616"/>
+            <a:ext cx="905256" cy="256032"/>
           </a:xfrm>
           <a:prstGeom prst="roundRect">
             <a:avLst/>
@@ -7239,9 +8223,9 @@
           <a:solidFill>
             <a:srgbClr val="FFFFFF"/>
           </a:solidFill>
-          <a:ln w="19050">
+          <a:ln w="10160">
             <a:solidFill>
-              <a:srgbClr val="1A365D"/>
+              <a:srgbClr val="EBB4AF"/>
             </a:solidFill>
           </a:ln>
         </p:spPr>
@@ -7260,56 +8244,44 @@
           </a:fontRef>
         </p:style>
         <p:txBody>
-          <a:bodyPr rtlCol="0" anchor="ctr" wrap="square"/>
+          <a:bodyPr rtlCol="0" anchor="ctr"/>
           <a:lstStyle/>
           <a:p>
             <a:pPr algn="ctr">
-              <a:spcAft>
-                <a:spcPts val="100"/>
-              </a:spcAft>
-            </a:pPr>
-            <a:r>
-              <a:rPr sz="1000" b="1">
-                <a:solidFill>
-                  <a:srgbClr val="1A365D"/>
-                </a:solidFill>
-                <a:latin typeface="Arial"/>
-              </a:rPr>
-              <a:t>2. Decoupled Central Database</a:t>
-            </a:r>
-          </a:p>
-          <a:p>
-            <a:r>
-              <a:rPr sz="800">
-                <a:solidFill>
-                  <a:srgbClr val="1E293B"/>
-                </a:solidFill>
-                <a:latin typeface="Arial"/>
-              </a:rPr>
-              <a:t>47 Standardized Statutory Features • Missing Imputation • &lt;15ms Query</a:t>
-            </a:r>
-          </a:p>
-        </p:txBody>
-      </p:sp>
-      <p:sp>
-        <p:nvSpPr>
-          <p:cNvPr id="15365" name="Down Arrow 15364"/>
+              <a:defRPr sz="700" b="1">
+                <a:solidFill>
+                  <a:srgbClr val="A8443C"/>
+                </a:solidFill>
+                <a:latin typeface="Arial"/>
+              </a:defRPr>
+            </a:pPr>
+            <a:r>
+              <a:t>⚡ Fast Cache</a:t>
+            </a:r>
+          </a:p>
+        </p:txBody>
+      </p:sp>
+      <p:sp>
+        <p:nvSpPr>
+          <p:cNvPr id="15392" name="Rounded Rectangle 15391"/>
           <p:cNvSpPr/>
           <p:nvPr/>
         </p:nvSpPr>
         <p:spPr>
           <a:xfrm>
-            <a:off x="8641080" y="2852927"/>
-            <a:ext cx="182880" cy="164592"/>
+            <a:off x="7278624" y="4224528"/>
+            <a:ext cx="1051560" cy="2194560"/>
           </a:xfrm>
-          <a:prstGeom prst="downArrow">
+          <a:prstGeom prst="roundRect">
             <a:avLst/>
           </a:prstGeom>
           <a:solidFill>
-            <a:srgbClr val="475569"/>
+            <a:srgbClr val="A66B24"/>
           </a:solidFill>
-          <a:ln>
-            <a:noFill/>
+          <a:ln w="19050">
+            <a:solidFill>
+              <a:srgbClr val="F0CDA0"/>
+            </a:solidFill>
           </a:ln>
         </p:spPr>
         <p:style>
@@ -7327,23 +8299,68 @@
           </a:fontRef>
         </p:style>
         <p:txBody>
-          <a:bodyPr rtlCol="0" anchor="ctr"/>
+          <a:bodyPr rtlCol="0" anchor="t" wrap="square" lIns="54864" rIns="54864" tIns="73152" bIns="54864"/>
           <a:lstStyle/>
           <a:p>
-            <a:pPr algn="ctr"/>
-          </a:p>
-        </p:txBody>
-      </p:sp>
-      <p:sp>
-        <p:nvSpPr>
-          <p:cNvPr id="15366" name="Rounded Rectangle 15365"/>
+            <a:pPr algn="ctr">
+              <a:spcAft>
+                <a:spcPts val="200"/>
+              </a:spcAft>
+              <a:defRPr sz="850" b="1">
+                <a:solidFill>
+                  <a:srgbClr val="FFFFFF"/>
+                </a:solidFill>
+                <a:latin typeface="Arial"/>
+              </a:defRPr>
+            </a:pPr>
+            <a:r>
+              <a:t>Dual-Track ML</a:t>
+            </a:r>
+          </a:p>
+          <a:p>
+            <a:pPr algn="ctr">
+              <a:spcAft>
+                <a:spcPts val="400"/>
+              </a:spcAft>
+              <a:defRPr sz="700" b="1">
+                <a:solidFill>
+                  <a:srgbClr val="FFFFC8"/>
+                </a:solidFill>
+                <a:latin typeface="Arial"/>
+              </a:defRPr>
+            </a:pPr>
+            <a:r>
+              <a:t>[Civil vs Legal]</a:t>
+            </a:r>
+          </a:p>
+          <a:p>
+            <a:pPr algn="ctr">
+              <a:spcAft>
+                <a:spcPts val="400"/>
+              </a:spcAft>
+              <a:defRPr sz="700">
+                <a:solidFill>
+                  <a:srgbClr val="F5F5F5"/>
+                </a:solidFill>
+                <a:latin typeface="Arial"/>
+              </a:defRPr>
+            </a:pPr>
+            <a:r>
+              <a:t>Decouples active physical road works from sub-judice court disputes under Sec 3D(2) vesting.</a:t>
+            </a:r>
+          </a:p>
+        </p:txBody>
+      </p:sp>
+      <p:sp>
+        <p:nvSpPr>
+          <p:cNvPr id="15393" name="Rounded Rectangle 15392"/>
           <p:cNvSpPr/>
           <p:nvPr/>
         </p:nvSpPr>
         <p:spPr>
           <a:xfrm>
-            <a:off x="6949440" y="3044952"/>
-            <a:ext cx="3566159" cy="658368"/>
+            <a:off x="7351776" y="6071616"/>
+            <a:ext cx="905256" cy="256032"/>
           </a:xfrm>
           <a:prstGeom prst="roundRect">
             <a:avLst/>
@@ -7351,9 +8368,9 @@
           <a:solidFill>
             <a:srgbClr val="FFFFFF"/>
           </a:solidFill>
-          <a:ln w="19050">
+          <a:ln w="10160">
             <a:solidFill>
-              <a:srgbClr val="059669"/>
+              <a:srgbClr val="F0CDA0"/>
             </a:solidFill>
           </a:ln>
         </p:spPr>
@@ -7372,56 +8389,44 @@
           </a:fontRef>
         </p:style>
         <p:txBody>
-          <a:bodyPr rtlCol="0" anchor="ctr" wrap="square"/>
+          <a:bodyPr rtlCol="0" anchor="ctr"/>
           <a:lstStyle/>
           <a:p>
             <a:pPr algn="ctr">
-              <a:spcAft>
-                <a:spcPts val="100"/>
-              </a:spcAft>
-            </a:pPr>
-            <a:r>
-              <a:rPr sz="1000" b="1">
-                <a:solidFill>
-                  <a:srgbClr val="059669"/>
-                </a:solidFill>
-                <a:latin typeface="Arial"/>
-              </a:rPr>
-              <a:t>3. Ensemble Predictive ML Core</a:t>
-            </a:r>
-          </a:p>
-          <a:p>
-            <a:r>
-              <a:rPr sz="800">
-                <a:solidFill>
-                  <a:srgbClr val="1E293B"/>
-                </a:solidFill>
-                <a:latin typeface="Arial"/>
-              </a:rPr>
-              <a:t>XGBoost 2.1 + LightGBM Regressors • Kaplan-Meier Survival Curves</a:t>
-            </a:r>
-          </a:p>
-        </p:txBody>
-      </p:sp>
-      <p:sp>
-        <p:nvSpPr>
-          <p:cNvPr id="15367" name="Down Arrow 15366"/>
+              <a:defRPr sz="700" b="1">
+                <a:solidFill>
+                  <a:srgbClr val="A66B24"/>
+                </a:solidFill>
+                <a:latin typeface="Arial"/>
+              </a:defRPr>
+            </a:pPr>
+            <a:r>
+              <a:t>⚖️ Sec 3D(2)</a:t>
+            </a:r>
+          </a:p>
+        </p:txBody>
+      </p:sp>
+      <p:sp>
+        <p:nvSpPr>
+          <p:cNvPr id="15394" name="Rounded Rectangle 15393"/>
           <p:cNvSpPr/>
           <p:nvPr/>
         </p:nvSpPr>
         <p:spPr>
           <a:xfrm>
-            <a:off x="8641080" y="3712464"/>
-            <a:ext cx="182880" cy="164592"/>
+            <a:off x="8430768" y="4224528"/>
+            <a:ext cx="1051560" cy="2194560"/>
           </a:xfrm>
-          <a:prstGeom prst="downArrow">
+          <a:prstGeom prst="roundRect">
             <a:avLst/>
           </a:prstGeom>
           <a:solidFill>
-            <a:srgbClr val="475569"/>
+            <a:srgbClr val="767E34"/>
           </a:solidFill>
-          <a:ln>
-            <a:noFill/>
+          <a:ln w="19050">
+            <a:solidFill>
+              <a:srgbClr val="D7DCAA"/>
+            </a:solidFill>
           </a:ln>
         </p:spPr>
         <p:style>
@@ -7439,23 +8444,68 @@
           </a:fontRef>
         </p:style>
         <p:txBody>
-          <a:bodyPr rtlCol="0" anchor="ctr"/>
+          <a:bodyPr rtlCol="0" anchor="t" wrap="square" lIns="54864" rIns="54864" tIns="73152" bIns="54864"/>
           <a:lstStyle/>
           <a:p>
-            <a:pPr algn="ctr"/>
-          </a:p>
-        </p:txBody>
-      </p:sp>
-      <p:sp>
-        <p:nvSpPr>
-          <p:cNvPr id="15368" name="Rounded Rectangle 15367"/>
+            <a:pPr algn="ctr">
+              <a:spcAft>
+                <a:spcPts val="200"/>
+              </a:spcAft>
+              <a:defRPr sz="850" b="1">
+                <a:solidFill>
+                  <a:srgbClr val="FFFFFF"/>
+                </a:solidFill>
+                <a:latin typeface="Arial"/>
+              </a:defRPr>
+            </a:pPr>
+            <a:r>
+              <a:t>TreeSHAP XAI</a:t>
+            </a:r>
+          </a:p>
+          <a:p>
+            <a:pPr algn="ctr">
+              <a:spcAft>
+                <a:spcPts val="400"/>
+              </a:spcAft>
+              <a:defRPr sz="700" b="1">
+                <a:solidFill>
+                  <a:srgbClr val="FFFFC8"/>
+                </a:solidFill>
+                <a:latin typeface="Arial"/>
+              </a:defRPr>
+            </a:pPr>
+            <a:r>
+              <a:t>[Statutory Attribution]</a:t>
+            </a:r>
+          </a:p>
+          <a:p>
+            <a:pPr algn="ctr">
+              <a:spcAft>
+                <a:spcPts val="400"/>
+              </a:spcAft>
+              <a:defRPr sz="700">
+                <a:solidFill>
+                  <a:srgbClr val="F5F5F5"/>
+                </a:solidFill>
+                <a:latin typeface="Arial"/>
+              </a:defRPr>
+            </a:pPr>
+            <a:r>
+              <a:t>Quantifies exact additive day delays per bottleneck and automates pre-drafted legal DFA SOPs.</a:t>
+            </a:r>
+          </a:p>
+        </p:txBody>
+      </p:sp>
+      <p:sp>
+        <p:nvSpPr>
+          <p:cNvPr id="15395" name="Rounded Rectangle 15394"/>
           <p:cNvSpPr/>
           <p:nvPr/>
         </p:nvSpPr>
         <p:spPr>
           <a:xfrm>
-            <a:off x="6949440" y="3904487"/>
-            <a:ext cx="3566159" cy="658368"/>
+            <a:off x="8503920" y="6071616"/>
+            <a:ext cx="905256" cy="256032"/>
           </a:xfrm>
           <a:prstGeom prst="roundRect">
             <a:avLst/>
@@ -7463,9 +8513,9 @@
           <a:solidFill>
             <a:srgbClr val="FFFFFF"/>
           </a:solidFill>
-          <a:ln w="19050">
+          <a:ln w="10160">
             <a:solidFill>
-              <a:srgbClr val="D97706"/>
+              <a:srgbClr val="D7DCAA"/>
             </a:solidFill>
           </a:ln>
         </p:spPr>
@@ -7484,56 +8534,44 @@
           </a:fontRef>
         </p:style>
         <p:txBody>
-          <a:bodyPr rtlCol="0" anchor="ctr" wrap="square"/>
+          <a:bodyPr rtlCol="0" anchor="ctr"/>
           <a:lstStyle/>
           <a:p>
             <a:pPr algn="ctr">
-              <a:spcAft>
-                <a:spcPts val="100"/>
-              </a:spcAft>
-            </a:pPr>
-            <a:r>
-              <a:rPr sz="1000" b="1">
-                <a:solidFill>
-                  <a:srgbClr val="D97706"/>
-                </a:solidFill>
-                <a:latin typeface="Arial"/>
-              </a:rPr>
-              <a:t>4. Explainable AI &amp; Prescriptions</a:t>
-            </a:r>
-          </a:p>
-          <a:p>
-            <a:r>
-              <a:rPr sz="800">
-                <a:solidFill>
-                  <a:srgbClr val="1E293B"/>
-                </a:solidFill>
-                <a:latin typeface="Arial"/>
-              </a:rPr>
-              <a:t>TreeSHAP Attribution Waterfall • Prescriptive Statutory SOP Orders</a:t>
-            </a:r>
-          </a:p>
-        </p:txBody>
-      </p:sp>
-      <p:sp>
-        <p:nvSpPr>
-          <p:cNvPr id="15369" name="Down Arrow 15368"/>
+              <a:defRPr sz="700" b="1">
+                <a:solidFill>
+                  <a:srgbClr val="767E34"/>
+                </a:solidFill>
+                <a:latin typeface="Arial"/>
+              </a:defRPr>
+            </a:pPr>
+            <a:r>
+              <a:t>🔍 Factor XAI</a:t>
+            </a:r>
+          </a:p>
+        </p:txBody>
+      </p:sp>
+      <p:sp>
+        <p:nvSpPr>
+          <p:cNvPr id="15396" name="Rounded Rectangle 15395"/>
           <p:cNvSpPr/>
           <p:nvPr/>
         </p:nvSpPr>
         <p:spPr>
           <a:xfrm>
-            <a:off x="8641080" y="4571999"/>
-            <a:ext cx="182880" cy="164592"/>
+            <a:off x="9582912" y="4224528"/>
+            <a:ext cx="1051560" cy="2194560"/>
           </a:xfrm>
-          <a:prstGeom prst="downArrow">
+          <a:prstGeom prst="roundRect">
             <a:avLst/>
           </a:prstGeom>
           <a:solidFill>
-            <a:srgbClr val="475569"/>
+            <a:srgbClr val="C45537"/>
           </a:solidFill>
-          <a:ln>
-            <a:noFill/>
+          <a:ln w="19050">
+            <a:solidFill>
+              <a:srgbClr val="F5BEAF"/>
+            </a:solidFill>
           </a:ln>
         </p:spPr>
         <p:style>
@@ -7551,23 +8589,68 @@
           </a:fontRef>
         </p:style>
         <p:txBody>
-          <a:bodyPr rtlCol="0" anchor="ctr"/>
+          <a:bodyPr rtlCol="0" anchor="t" wrap="square" lIns="54864" rIns="54864" tIns="73152" bIns="54864"/>
           <a:lstStyle/>
           <a:p>
-            <a:pPr algn="ctr"/>
-          </a:p>
-        </p:txBody>
-      </p:sp>
-      <p:sp>
-        <p:nvSpPr>
-          <p:cNvPr id="15370" name="Rounded Rectangle 15369"/>
+            <a:pPr algn="ctr">
+              <a:spcAft>
+                <a:spcPts val="200"/>
+              </a:spcAft>
+              <a:defRPr sz="850" b="1">
+                <a:solidFill>
+                  <a:srgbClr val="FFFFFF"/>
+                </a:solidFill>
+                <a:latin typeface="Arial"/>
+              </a:defRPr>
+            </a:pPr>
+            <a:r>
+              <a:t>340.8km GIS</a:t>
+            </a:r>
+          </a:p>
+          <a:p>
+            <a:pPr algn="ctr">
+              <a:spcAft>
+                <a:spcPts val="400"/>
+              </a:spcAft>
+              <a:defRPr sz="700" b="1">
+                <a:solidFill>
+                  <a:srgbClr val="FFFFC8"/>
+                </a:solidFill>
+                <a:latin typeface="Arial"/>
+              </a:defRPr>
+            </a:pPr>
+            <a:r>
+              <a:t>[Corridor Telemetry]</a:t>
+            </a:r>
+          </a:p>
+          <a:p>
+            <a:pPr algn="ctr">
+              <a:spcAft>
+                <a:spcPts val="400"/>
+              </a:spcAft>
+              <a:defRPr sz="700">
+                <a:solidFill>
+                  <a:srgbClr val="F5F5F5"/>
+                </a:solidFill>
+                <a:latin typeface="Arial"/>
+              </a:defRPr>
+            </a:pPr>
+            <a:r>
+              <a:t>Hierarchical drill-down: 8 Packages, 156 Villages, and Khasra plots with chainage telemetry.</a:t>
+            </a:r>
+          </a:p>
+        </p:txBody>
+      </p:sp>
+      <p:sp>
+        <p:nvSpPr>
+          <p:cNvPr id="15397" name="Rounded Rectangle 15396"/>
           <p:cNvSpPr/>
           <p:nvPr/>
         </p:nvSpPr>
         <p:spPr>
           <a:xfrm>
-            <a:off x="6949440" y="4764024"/>
-            <a:ext cx="3566159" cy="658368"/>
+            <a:off x="9656064" y="6071616"/>
+            <a:ext cx="905256" cy="256032"/>
           </a:xfrm>
           <a:prstGeom prst="roundRect">
             <a:avLst/>
@@ -7575,9 +8658,9 @@
           <a:solidFill>
             <a:srgbClr val="FFFFFF"/>
           </a:solidFill>
-          <a:ln w="19050">
+          <a:ln w="10160">
             <a:solidFill>
-              <a:srgbClr val="DC2626"/>
+              <a:srgbClr val="F5BEAF"/>
             </a:solidFill>
           </a:ln>
         </p:spPr>
@@ -7596,33 +8679,164 @@
           </a:fontRef>
         </p:style>
         <p:txBody>
-          <a:bodyPr rtlCol="0" anchor="ctr" wrap="square"/>
+          <a:bodyPr rtlCol="0" anchor="ctr"/>
+          <a:lstStyle/>
+          <a:p>
+            <a:pPr algn="ctr">
+              <a:defRPr sz="700" b="1">
+                <a:solidFill>
+                  <a:srgbClr val="C45537"/>
+                </a:solidFill>
+                <a:latin typeface="Arial"/>
+              </a:defRPr>
+            </a:pPr>
+            <a:r>
+              <a:t>🗺️ RoW GIS</a:t>
+            </a:r>
+          </a:p>
+        </p:txBody>
+      </p:sp>
+      <p:sp>
+        <p:nvSpPr>
+          <p:cNvPr id="15398" name="Rounded Rectangle 15397"/>
+          <p:cNvSpPr/>
+          <p:nvPr/>
+        </p:nvSpPr>
+        <p:spPr>
+          <a:xfrm>
+            <a:off x="10735056" y="4224528"/>
+            <a:ext cx="1051560" cy="2194560"/>
+          </a:xfrm>
+          <a:prstGeom prst="roundRect">
+            <a:avLst/>
+          </a:prstGeom>
+          <a:solidFill>
+            <a:srgbClr val="546E7A"/>
+          </a:solidFill>
+          <a:ln w="19050">
+            <a:solidFill>
+              <a:srgbClr val="BECDD7"/>
+            </a:solidFill>
+          </a:ln>
+        </p:spPr>
+        <p:style>
+          <a:lnRef idx="1">
+            <a:schemeClr val="accent1"/>
+          </a:lnRef>
+          <a:fillRef idx="3">
+            <a:schemeClr val="accent1"/>
+          </a:fillRef>
+          <a:effectRef idx="2">
+            <a:schemeClr val="accent1"/>
+          </a:effectRef>
+          <a:fontRef idx="minor">
+            <a:schemeClr val="lt1"/>
+          </a:fontRef>
+        </p:style>
+        <p:txBody>
+          <a:bodyPr rtlCol="0" anchor="t" wrap="square" lIns="54864" rIns="54864" tIns="73152" bIns="54864"/>
           <a:lstStyle/>
           <a:p>
             <a:pPr algn="ctr">
               <a:spcAft>
-                <a:spcPts val="100"/>
+                <a:spcPts val="200"/>
               </a:spcAft>
-            </a:pPr>
-            <a:r>
-              <a:rPr sz="1000" b="1">
-                <a:solidFill>
-                  <a:srgbClr val="DC2626"/>
-                </a:solidFill>
-                <a:latin typeface="Arial"/>
-              </a:rPr>
-              <a:t>5. 4-Tier Role RBAC &amp; e-Sign</a:t>
-            </a:r>
-          </a:p>
-          <a:p>
-            <a:r>
-              <a:rPr sz="800">
-                <a:solidFill>
-                  <a:srgbClr val="1E293B"/>
-                </a:solidFill>
-                <a:latin typeface="Arial"/>
-              </a:rPr>
-              <a:t>Lekhpal → CALA → NHAI PD → Ministry • Aadhaar DSC • SHA-256 Ledger</a:t>
+              <a:defRPr sz="850" b="1">
+                <a:solidFill>
+                  <a:srgbClr val="FFFFFF"/>
+                </a:solidFill>
+                <a:latin typeface="Arial"/>
+              </a:defRPr>
+            </a:pPr>
+            <a:r>
+              <a:t>Const. HITL</a:t>
+            </a:r>
+          </a:p>
+          <a:p>
+            <a:pPr algn="ctr">
+              <a:spcAft>
+                <a:spcPts val="400"/>
+              </a:spcAft>
+              <a:defRPr sz="700" b="1">
+                <a:solidFill>
+                  <a:srgbClr val="FFFFC8"/>
+                </a:solidFill>
+                <a:latin typeface="Arial"/>
+              </a:defRPr>
+            </a:pPr>
+            <a:r>
+              <a:t>[Arts. 77 &amp; 166]</a:t>
+            </a:r>
+          </a:p>
+          <a:p>
+            <a:pPr algn="ctr">
+              <a:spcAft>
+                <a:spcPts val="400"/>
+              </a:spcAft>
+              <a:defRPr sz="700">
+                <a:solidFill>
+                  <a:srgbClr val="F5F5F5"/>
+                </a:solidFill>
+                <a:latin typeface="Arial"/>
+              </a:defRPr>
+            </a:pPr>
+            <a:r>
+              <a:t>Aadhaar DSC e-Sign validation with immutable SHA-256 cryptographic audit trails for CAG.</a:t>
+            </a:r>
+          </a:p>
+        </p:txBody>
+      </p:sp>
+      <p:sp>
+        <p:nvSpPr>
+          <p:cNvPr id="15399" name="Rounded Rectangle 15398"/>
+          <p:cNvSpPr/>
+          <p:nvPr/>
+        </p:nvSpPr>
+        <p:spPr>
+          <a:xfrm>
+            <a:off x="10808208" y="6071616"/>
+            <a:ext cx="905256" cy="256032"/>
+          </a:xfrm>
+          <a:prstGeom prst="roundRect">
+            <a:avLst/>
+          </a:prstGeom>
+          <a:solidFill>
+            <a:srgbClr val="FFFFFF"/>
+          </a:solidFill>
+          <a:ln w="10160">
+            <a:solidFill>
+              <a:srgbClr val="BECDD7"/>
+            </a:solidFill>
+          </a:ln>
+        </p:spPr>
+        <p:style>
+          <a:lnRef idx="1">
+            <a:schemeClr val="accent1"/>
+          </a:lnRef>
+          <a:fillRef idx="3">
+            <a:schemeClr val="accent1"/>
+          </a:fillRef>
+          <a:effectRef idx="2">
+            <a:schemeClr val="accent1"/>
+          </a:effectRef>
+          <a:fontRef idx="minor">
+            <a:schemeClr val="lt1"/>
+          </a:fontRef>
+        </p:style>
+        <p:txBody>
+          <a:bodyPr rtlCol="0" anchor="ctr"/>
+          <a:lstStyle/>
+          <a:p>
+            <a:pPr algn="ctr">
+              <a:defRPr sz="700" b="1">
+                <a:solidFill>
+                  <a:srgbClr val="546E7A"/>
+                </a:solidFill>
+                <a:latin typeface="Arial"/>
+              </a:defRPr>
+            </a:pPr>
+            <a:r>
+              <a:t>🛡️ SHA-256</a:t>
             </a:r>
           </a:p>
         </p:txBody>

</xml_diff>

<commit_message>
feat(sih): design Slide 3 matching SIHex1 Technical Approach 4-zone architecture and implementation timeline
</commit_message>
<xml_diff>
--- a/sih/GatiShakti_AI_SIH2026_Presentation.pptx
+++ b/sih/GatiShakti_AI_SIH2026_Presentation.pptx
@@ -8946,15 +8946,15 @@
           <a:lstStyle/>
           <a:p>
             <a:pPr algn="l">
-              <a:defRPr sz="2200" b="1">
-                <a:solidFill>
-                  <a:srgbClr val="1A365D"/>
-                </a:solidFill>
-                <a:latin typeface="Times New Roman"/>
+              <a:defRPr sz="2400" b="1">
+                <a:solidFill>
+                  <a:srgbClr val="003366"/>
+                </a:solidFill>
+                <a:latin typeface="Arial"/>
               </a:defRPr>
             </a:pPr>
             <a:r>
-              <a:t>TECHNICAL APPROACH: DECOUPLED ML &amp; STATUTORY XAI STACK</a:t>
+              <a:t>TECHNICAL APPROACH</a:t>
             </a:r>
           </a:p>
         </p:txBody>
@@ -9068,8 +9068,1927 @@
         </p:nvSpPr>
         <p:spPr>
           <a:xfrm>
+            <a:off x="411480" y="1024128"/>
+            <a:ext cx="8641080" cy="4160520"/>
+          </a:xfrm>
+          <a:prstGeom prst="roundRect">
+            <a:avLst/>
+          </a:prstGeom>
+          <a:solidFill>
+            <a:srgbClr val="FFFFFF"/>
+          </a:solidFill>
+          <a:ln w="15240">
+            <a:solidFill>
+              <a:srgbClr val="CBD5E1"/>
+            </a:solidFill>
+          </a:ln>
+        </p:spPr>
+        <p:style>
+          <a:lnRef idx="1">
+            <a:schemeClr val="accent1"/>
+          </a:lnRef>
+          <a:fillRef idx="3">
+            <a:schemeClr val="accent1"/>
+          </a:fillRef>
+          <a:effectRef idx="2">
+            <a:schemeClr val="accent1"/>
+          </a:effectRef>
+          <a:fontRef idx="minor">
+            <a:schemeClr val="lt1"/>
+          </a:fontRef>
+        </p:style>
+        <p:txBody>
+          <a:bodyPr rtlCol="0" anchor="ctr"/>
+          <a:lstStyle/>
+          <a:p>
+            <a:pPr algn="ctr"/>
+          </a:p>
+        </p:txBody>
+      </p:sp>
+      <p:sp>
+        <p:nvSpPr>
+          <p:cNvPr id="17411" name="Rounded Rectangle 17410"/>
+          <p:cNvSpPr/>
+          <p:nvPr/>
+        </p:nvSpPr>
+        <p:spPr>
+          <a:xfrm>
             <a:off x="457200" y="1097280"/>
-            <a:ext cx="5120640" cy="4754880"/>
+            <a:ext cx="1874519" cy="384048"/>
+          </a:xfrm>
+          <a:prstGeom prst="roundRect">
+            <a:avLst/>
+          </a:prstGeom>
+          <a:solidFill>
+            <a:srgbClr val="E3F2FD"/>
+          </a:solidFill>
+          <a:ln>
+            <a:solidFill>
+              <a:srgbClr val="90CAF9"/>
+            </a:solidFill>
+          </a:ln>
+        </p:spPr>
+        <p:style>
+          <a:lnRef idx="1">
+            <a:schemeClr val="accent1"/>
+          </a:lnRef>
+          <a:fillRef idx="3">
+            <a:schemeClr val="accent1"/>
+          </a:fillRef>
+          <a:effectRef idx="2">
+            <a:schemeClr val="accent1"/>
+          </a:effectRef>
+          <a:fontRef idx="minor">
+            <a:schemeClr val="lt1"/>
+          </a:fontRef>
+        </p:style>
+        <p:txBody>
+          <a:bodyPr rtlCol="0" anchor="ctr" wrap="square"/>
+          <a:lstStyle/>
+          <a:p>
+            <a:pPr algn="ctr">
+              <a:defRPr sz="850" b="1">
+                <a:solidFill>
+                  <a:srgbClr val="0D47A1"/>
+                </a:solidFill>
+              </a:defRPr>
+            </a:pPr>
+            <a:r>
+              <a:t>Zone 1: Users &amp; External</a:t>
+            </a:r>
+          </a:p>
+        </p:txBody>
+      </p:sp>
+      <p:sp>
+        <p:nvSpPr>
+          <p:cNvPr id="17412" name="Rounded Rectangle 17411"/>
+          <p:cNvSpPr/>
+          <p:nvPr/>
+        </p:nvSpPr>
+        <p:spPr>
+          <a:xfrm>
+            <a:off x="457200" y="1572768"/>
+            <a:ext cx="1874519" cy="1554480"/>
+          </a:xfrm>
+          <a:prstGeom prst="roundRect">
+            <a:avLst/>
+          </a:prstGeom>
+          <a:solidFill>
+            <a:srgbClr val="F0F7FF"/>
+          </a:solidFill>
+          <a:ln>
+            <a:solidFill>
+              <a:srgbClr val="90CAF9"/>
+            </a:solidFill>
+          </a:ln>
+        </p:spPr>
+        <p:style>
+          <a:lnRef idx="1">
+            <a:schemeClr val="accent1"/>
+          </a:lnRef>
+          <a:fillRef idx="3">
+            <a:schemeClr val="accent1"/>
+          </a:fillRef>
+          <a:effectRef idx="2">
+            <a:schemeClr val="accent1"/>
+          </a:effectRef>
+          <a:fontRef idx="minor">
+            <a:schemeClr val="lt1"/>
+          </a:fontRef>
+        </p:style>
+        <p:txBody>
+          <a:bodyPr rtlCol="0" anchor="t" wrap="square" tIns="73152" lIns="73152" rIns="73152"/>
+          <a:lstStyle/>
+          <a:p>
+            <a:pPr algn="ctr">
+              <a:spcAft>
+                <a:spcPts val="400"/>
+              </a:spcAft>
+              <a:defRPr sz="800" b="1">
+                <a:solidFill>
+                  <a:srgbClr val="1976D2"/>
+                </a:solidFill>
+              </a:defRPr>
+            </a:pPr>
+            <a:r>
+              <a:t>☁️ External Services &amp; Portals</a:t>
+            </a:r>
+          </a:p>
+          <a:p>
+            <a:pPr>
+              <a:spcAft>
+                <a:spcPts val="200"/>
+              </a:spcAft>
+              <a:defRPr sz="700">
+                <a:solidFill>
+                  <a:srgbClr val="334155"/>
+                </a:solidFill>
+              </a:defRPr>
+            </a:pPr>
+            <a:r>
+              <a:t>• e-Courts WSDL &amp; Judgments</a:t>
+            </a:r>
+          </a:p>
+          <a:p>
+            <a:pPr>
+              <a:spcAft>
+                <a:spcPts val="200"/>
+              </a:spcAft>
+              <a:defRPr sz="700">
+                <a:solidFill>
+                  <a:srgbClr val="334155"/>
+                </a:solidFill>
+              </a:defRPr>
+            </a:pPr>
+            <a:r>
+              <a:t>• BhoomiRashi MoRTH Portal</a:t>
+            </a:r>
+          </a:p>
+          <a:p>
+            <a:pPr>
+              <a:spcAft>
+                <a:spcPts val="200"/>
+              </a:spcAft>
+              <a:defRPr sz="700">
+                <a:solidFill>
+                  <a:srgbClr val="334155"/>
+                </a:solidFill>
+              </a:defRPr>
+            </a:pPr>
+            <a:r>
+              <a:t>• State Jamabandi Cadastral</a:t>
+            </a:r>
+          </a:p>
+          <a:p>
+            <a:pPr>
+              <a:spcAft>
+                <a:spcPts val="200"/>
+              </a:spcAft>
+              <a:defRPr sz="700">
+                <a:solidFill>
+                  <a:srgbClr val="334155"/>
+                </a:solidFill>
+              </a:defRPr>
+            </a:pPr>
+            <a:r>
+              <a:t>• PM GatiShakti NMP Layers</a:t>
+            </a:r>
+          </a:p>
+        </p:txBody>
+      </p:sp>
+      <p:sp>
+        <p:nvSpPr>
+          <p:cNvPr id="17413" name="Rounded Rectangle 17412"/>
+          <p:cNvSpPr/>
+          <p:nvPr/>
+        </p:nvSpPr>
+        <p:spPr>
+          <a:xfrm>
+            <a:off x="457200" y="3264408"/>
+            <a:ext cx="1874519" cy="1691640"/>
+          </a:xfrm>
+          <a:prstGeom prst="roundRect">
+            <a:avLst/>
+          </a:prstGeom>
+          <a:solidFill>
+            <a:srgbClr val="F0F7FF"/>
+          </a:solidFill>
+          <a:ln>
+            <a:solidFill>
+              <a:srgbClr val="90CAF9"/>
+            </a:solidFill>
+          </a:ln>
+        </p:spPr>
+        <p:style>
+          <a:lnRef idx="1">
+            <a:schemeClr val="accent1"/>
+          </a:lnRef>
+          <a:fillRef idx="3">
+            <a:schemeClr val="accent1"/>
+          </a:fillRef>
+          <a:effectRef idx="2">
+            <a:schemeClr val="accent1"/>
+          </a:effectRef>
+          <a:fontRef idx="minor">
+            <a:schemeClr val="lt1"/>
+          </a:fontRef>
+        </p:style>
+        <p:txBody>
+          <a:bodyPr rtlCol="0" anchor="t" wrap="square" tIns="73152" lIns="73152" rIns="73152"/>
+          <a:lstStyle/>
+          <a:p>
+            <a:pPr algn="ctr">
+              <a:spcAft>
+                <a:spcPts val="400"/>
+              </a:spcAft>
+              <a:defRPr sz="800" b="1">
+                <a:solidFill>
+                  <a:srgbClr val="1976D2"/>
+                </a:solidFill>
+              </a:defRPr>
+            </a:pPr>
+            <a:r>
+              <a:t>👥 Administrative Roles (RBAC)</a:t>
+            </a:r>
+          </a:p>
+          <a:p>
+            <a:pPr>
+              <a:spcAft>
+                <a:spcPts val="200"/>
+              </a:spcAft>
+              <a:defRPr sz="700">
+                <a:solidFill>
+                  <a:srgbClr val="334155"/>
+                </a:solidFill>
+              </a:defRPr>
+            </a:pPr>
+            <a:r>
+              <a:t>• MoRTH / NPG Leadership</a:t>
+            </a:r>
+          </a:p>
+          <a:p>
+            <a:pPr>
+              <a:spcAft>
+                <a:spcPts val="200"/>
+              </a:spcAft>
+              <a:defRPr sz="700">
+                <a:solidFill>
+                  <a:srgbClr val="334155"/>
+                </a:solidFill>
+              </a:defRPr>
+            </a:pPr>
+            <a:r>
+              <a:t>• NHAI Project Directors (PD)</a:t>
+            </a:r>
+          </a:p>
+          <a:p>
+            <a:pPr>
+              <a:spcAft>
+                <a:spcPts val="200"/>
+              </a:spcAft>
+              <a:defRPr sz="700">
+                <a:solidFill>
+                  <a:srgbClr val="334155"/>
+                </a:solidFill>
+              </a:defRPr>
+            </a:pPr>
+            <a:r>
+              <a:t>• CALA (Competent Authority)</a:t>
+            </a:r>
+          </a:p>
+          <a:p>
+            <a:pPr>
+              <a:spcAft>
+                <a:spcPts val="200"/>
+              </a:spcAft>
+              <a:defRPr sz="700">
+                <a:solidFill>
+                  <a:srgbClr val="334155"/>
+                </a:solidFill>
+              </a:defRPr>
+            </a:pPr>
+            <a:r>
+              <a:t>• Lekhpal &amp; Field Tehsildars</a:t>
+            </a:r>
+          </a:p>
+          <a:p>
+            <a:pPr>
+              <a:spcAft>
+                <a:spcPts val="200"/>
+              </a:spcAft>
+              <a:defRPr sz="700">
+                <a:solidFill>
+                  <a:srgbClr val="334155"/>
+                </a:solidFill>
+              </a:defRPr>
+            </a:pPr>
+            <a:r>
+              <a:t>• Affected Landowner Farmers</a:t>
+            </a:r>
+          </a:p>
+        </p:txBody>
+      </p:sp>
+      <p:sp>
+        <p:nvSpPr>
+          <p:cNvPr id="17414" name="Right Arrow 17413"/>
+          <p:cNvSpPr/>
+          <p:nvPr/>
+        </p:nvSpPr>
+        <p:spPr>
+          <a:xfrm>
+            <a:off x="2359152" y="3310128"/>
+            <a:ext cx="164592" cy="128016"/>
+          </a:xfrm>
+          <a:prstGeom prst="rightArrow">
+            <a:avLst/>
+          </a:prstGeom>
+          <a:solidFill>
+            <a:srgbClr val="64748B"/>
+          </a:solidFill>
+          <a:ln>
+            <a:solidFill>
+              <a:srgbClr val="64748B"/>
+            </a:solidFill>
+          </a:ln>
+        </p:spPr>
+        <p:style>
+          <a:lnRef idx="1">
+            <a:schemeClr val="accent1"/>
+          </a:lnRef>
+          <a:fillRef idx="3">
+            <a:schemeClr val="accent1"/>
+          </a:fillRef>
+          <a:effectRef idx="2">
+            <a:schemeClr val="accent1"/>
+          </a:effectRef>
+          <a:fontRef idx="minor">
+            <a:schemeClr val="lt1"/>
+          </a:fontRef>
+        </p:style>
+        <p:txBody>
+          <a:bodyPr rtlCol="0" anchor="ctr"/>
+          <a:lstStyle/>
+          <a:p>
+            <a:pPr algn="ctr"/>
+          </a:p>
+        </p:txBody>
+      </p:sp>
+      <p:sp>
+        <p:nvSpPr>
+          <p:cNvPr id="17415" name="Rounded Rectangle 17414"/>
+          <p:cNvSpPr/>
+          <p:nvPr/>
+        </p:nvSpPr>
+        <p:spPr>
+          <a:xfrm>
+            <a:off x="2560320" y="1097280"/>
+            <a:ext cx="1965960" cy="384048"/>
+          </a:xfrm>
+          <a:prstGeom prst="roundRect">
+            <a:avLst/>
+          </a:prstGeom>
+          <a:solidFill>
+            <a:srgbClr val="E8F5E9"/>
+          </a:solidFill>
+          <a:ln>
+            <a:solidFill>
+              <a:srgbClr val="A5D6A7"/>
+            </a:solidFill>
+          </a:ln>
+        </p:spPr>
+        <p:style>
+          <a:lnRef idx="1">
+            <a:schemeClr val="accent1"/>
+          </a:lnRef>
+          <a:fillRef idx="3">
+            <a:schemeClr val="accent1"/>
+          </a:fillRef>
+          <a:effectRef idx="2">
+            <a:schemeClr val="accent1"/>
+          </a:effectRef>
+          <a:fontRef idx="minor">
+            <a:schemeClr val="lt1"/>
+          </a:fontRef>
+        </p:style>
+        <p:txBody>
+          <a:bodyPr rtlCol="0" anchor="ctr" wrap="square"/>
+          <a:lstStyle/>
+          <a:p>
+            <a:pPr algn="ctr">
+              <a:defRPr sz="850" b="1">
+                <a:solidFill>
+                  <a:srgbClr val="1B5E20"/>
+                </a:solidFill>
+              </a:defRPr>
+            </a:pPr>
+            <a:r>
+              <a:t>Zone 2: Frontend (React 19)</a:t>
+            </a:r>
+          </a:p>
+        </p:txBody>
+      </p:sp>
+      <p:sp>
+        <p:nvSpPr>
+          <p:cNvPr id="17416" name="Rounded Rectangle 17415"/>
+          <p:cNvSpPr/>
+          <p:nvPr/>
+        </p:nvSpPr>
+        <p:spPr>
+          <a:xfrm>
+            <a:off x="2560320" y="1572768"/>
+            <a:ext cx="1965960" cy="3383280"/>
+          </a:xfrm>
+          <a:prstGeom prst="roundRect">
+            <a:avLst/>
+          </a:prstGeom>
+          <a:solidFill>
+            <a:srgbClr val="F1F8F2"/>
+          </a:solidFill>
+          <a:ln>
+            <a:solidFill>
+              <a:srgbClr val="A5D6A7"/>
+            </a:solidFill>
+          </a:ln>
+        </p:spPr>
+        <p:style>
+          <a:lnRef idx="1">
+            <a:schemeClr val="accent1"/>
+          </a:lnRef>
+          <a:fillRef idx="3">
+            <a:schemeClr val="accent1"/>
+          </a:fillRef>
+          <a:effectRef idx="2">
+            <a:schemeClr val="accent1"/>
+          </a:effectRef>
+          <a:fontRef idx="minor">
+            <a:schemeClr val="lt1"/>
+          </a:fontRef>
+        </p:style>
+        <p:txBody>
+          <a:bodyPr rtlCol="0" anchor="ctr"/>
+          <a:lstStyle/>
+          <a:p>
+            <a:pPr algn="ctr"/>
+          </a:p>
+        </p:txBody>
+      </p:sp>
+      <p:sp>
+        <p:nvSpPr>
+          <p:cNvPr id="17417" name="Rounded Rectangle 17416"/>
+          <p:cNvSpPr/>
+          <p:nvPr/>
+        </p:nvSpPr>
+        <p:spPr>
+          <a:xfrm>
+            <a:off x="2615184" y="1627632"/>
+            <a:ext cx="1856232" cy="603504"/>
+          </a:xfrm>
+          <a:prstGeom prst="roundRect">
+            <a:avLst/>
+          </a:prstGeom>
+          <a:solidFill>
+            <a:srgbClr val="FFFFFF"/>
+          </a:solidFill>
+          <a:ln>
+            <a:solidFill>
+              <a:srgbClr val="C8E6C9"/>
+            </a:solidFill>
+          </a:ln>
+        </p:spPr>
+        <p:style>
+          <a:lnRef idx="1">
+            <a:schemeClr val="accent1"/>
+          </a:lnRef>
+          <a:fillRef idx="3">
+            <a:schemeClr val="accent1"/>
+          </a:fillRef>
+          <a:effectRef idx="2">
+            <a:schemeClr val="accent1"/>
+          </a:effectRef>
+          <a:fontRef idx="minor">
+            <a:schemeClr val="lt1"/>
+          </a:fontRef>
+        </p:style>
+        <p:txBody>
+          <a:bodyPr rtlCol="0" anchor="t" wrap="square" tIns="36576" lIns="54864" rIns="54864"/>
+          <a:lstStyle/>
+          <a:p>
+            <a:pPr algn="ctr">
+              <a:spcAft>
+                <a:spcPts val="100"/>
+              </a:spcAft>
+              <a:defRPr sz="750" b="1">
+                <a:solidFill>
+                  <a:srgbClr val="2E7D32"/>
+                </a:solidFill>
+              </a:defRPr>
+            </a:pPr>
+            <a:r>
+              <a:t>📊 Predictive Dashboard</a:t>
+            </a:r>
+          </a:p>
+          <a:p>
+            <a:pPr>
+              <a:defRPr sz="650">
+                <a:solidFill>
+                  <a:srgbClr val="475569"/>
+                </a:solidFill>
+              </a:defRPr>
+            </a:pPr>
+            <a:r>
+              <a:t>Real-time residual delay days, risk gauges &amp; project cards.</a:t>
+            </a:r>
+          </a:p>
+        </p:txBody>
+      </p:sp>
+      <p:sp>
+        <p:nvSpPr>
+          <p:cNvPr id="17418" name="Rounded Rectangle 17417"/>
+          <p:cNvSpPr/>
+          <p:nvPr/>
+        </p:nvSpPr>
+        <p:spPr>
+          <a:xfrm>
+            <a:off x="2615184" y="2286000"/>
+            <a:ext cx="1856232" cy="603504"/>
+          </a:xfrm>
+          <a:prstGeom prst="roundRect">
+            <a:avLst/>
+          </a:prstGeom>
+          <a:solidFill>
+            <a:srgbClr val="FFFFFF"/>
+          </a:solidFill>
+          <a:ln>
+            <a:solidFill>
+              <a:srgbClr val="C8E6C9"/>
+            </a:solidFill>
+          </a:ln>
+        </p:spPr>
+        <p:style>
+          <a:lnRef idx="1">
+            <a:schemeClr val="accent1"/>
+          </a:lnRef>
+          <a:fillRef idx="3">
+            <a:schemeClr val="accent1"/>
+          </a:fillRef>
+          <a:effectRef idx="2">
+            <a:schemeClr val="accent1"/>
+          </a:effectRef>
+          <a:fontRef idx="minor">
+            <a:schemeClr val="lt1"/>
+          </a:fontRef>
+        </p:style>
+        <p:txBody>
+          <a:bodyPr rtlCol="0" anchor="t" wrap="square" tIns="36576" lIns="54864" rIns="54864"/>
+          <a:lstStyle/>
+          <a:p>
+            <a:pPr algn="ctr">
+              <a:spcAft>
+                <a:spcPts val="100"/>
+              </a:spcAft>
+              <a:defRPr sz="750" b="1">
+                <a:solidFill>
+                  <a:srgbClr val="2E7D32"/>
+                </a:solidFill>
+              </a:defRPr>
+            </a:pPr>
+            <a:r>
+              <a:t>🗺️ 340.8 km RoW GIS</a:t>
+            </a:r>
+          </a:p>
+          <a:p>
+            <a:pPr>
+              <a:defRPr sz="650">
+                <a:solidFill>
+                  <a:srgbClr val="475569"/>
+                </a:solidFill>
+              </a:defRPr>
+            </a:pPr>
+            <a:r>
+              <a:t>Leaflet GeoJSON EPSG:4326 drilldown across 8 packages &amp; plots.</a:t>
+            </a:r>
+          </a:p>
+        </p:txBody>
+      </p:sp>
+      <p:sp>
+        <p:nvSpPr>
+          <p:cNvPr id="17419" name="Rounded Rectangle 17418"/>
+          <p:cNvSpPr/>
+          <p:nvPr/>
+        </p:nvSpPr>
+        <p:spPr>
+          <a:xfrm>
+            <a:off x="2615184" y="2944368"/>
+            <a:ext cx="1856232" cy="603504"/>
+          </a:xfrm>
+          <a:prstGeom prst="roundRect">
+            <a:avLst/>
+          </a:prstGeom>
+          <a:solidFill>
+            <a:srgbClr val="FFFFFF"/>
+          </a:solidFill>
+          <a:ln>
+            <a:solidFill>
+              <a:srgbClr val="C8E6C9"/>
+            </a:solidFill>
+          </a:ln>
+        </p:spPr>
+        <p:style>
+          <a:lnRef idx="1">
+            <a:schemeClr val="accent1"/>
+          </a:lnRef>
+          <a:fillRef idx="3">
+            <a:schemeClr val="accent1"/>
+          </a:fillRef>
+          <a:effectRef idx="2">
+            <a:schemeClr val="accent1"/>
+          </a:effectRef>
+          <a:fontRef idx="minor">
+            <a:schemeClr val="lt1"/>
+          </a:fontRef>
+        </p:style>
+        <p:txBody>
+          <a:bodyPr rtlCol="0" anchor="t" wrap="square" tIns="36576" lIns="54864" rIns="54864"/>
+          <a:lstStyle/>
+          <a:p>
+            <a:pPr algn="ctr">
+              <a:spcAft>
+                <a:spcPts val="100"/>
+              </a:spcAft>
+              <a:defRPr sz="750" b="1">
+                <a:solidFill>
+                  <a:srgbClr val="2E7D32"/>
+                </a:solidFill>
+              </a:defRPr>
+            </a:pPr>
+            <a:r>
+              <a:t>🔍 TreeSHAP Waterfall</a:t>
+            </a:r>
+          </a:p>
+          <a:p>
+            <a:pPr>
+              <a:defRPr sz="650">
+                <a:solidFill>
+                  <a:srgbClr val="475569"/>
+                </a:solidFill>
+              </a:defRPr>
+            </a:pPr>
+            <a:r>
+              <a:t>Visual factor attributions explaining statutory delay causes.</a:t>
+            </a:r>
+          </a:p>
+        </p:txBody>
+      </p:sp>
+      <p:sp>
+        <p:nvSpPr>
+          <p:cNvPr id="17420" name="Rounded Rectangle 17419"/>
+          <p:cNvSpPr/>
+          <p:nvPr/>
+        </p:nvSpPr>
+        <p:spPr>
+          <a:xfrm>
+            <a:off x="2615184" y="3602736"/>
+            <a:ext cx="1856232" cy="603504"/>
+          </a:xfrm>
+          <a:prstGeom prst="roundRect">
+            <a:avLst/>
+          </a:prstGeom>
+          <a:solidFill>
+            <a:srgbClr val="FFFFFF"/>
+          </a:solidFill>
+          <a:ln>
+            <a:solidFill>
+              <a:srgbClr val="C8E6C9"/>
+            </a:solidFill>
+          </a:ln>
+        </p:spPr>
+        <p:style>
+          <a:lnRef idx="1">
+            <a:schemeClr val="accent1"/>
+          </a:lnRef>
+          <a:fillRef idx="3">
+            <a:schemeClr val="accent1"/>
+          </a:fillRef>
+          <a:effectRef idx="2">
+            <a:schemeClr val="accent1"/>
+          </a:effectRef>
+          <a:fontRef idx="minor">
+            <a:schemeClr val="lt1"/>
+          </a:fontRef>
+        </p:style>
+        <p:txBody>
+          <a:bodyPr rtlCol="0" anchor="t" wrap="square" tIns="36576" lIns="54864" rIns="54864"/>
+          <a:lstStyle/>
+          <a:p>
+            <a:pPr algn="ctr">
+              <a:spcAft>
+                <a:spcPts val="100"/>
+              </a:spcAft>
+              <a:defRPr sz="750" b="1">
+                <a:solidFill>
+                  <a:srgbClr val="2E7D32"/>
+                </a:solidFill>
+              </a:defRPr>
+            </a:pPr>
+            <a:r>
+              <a:t>📑 Prescriptive DFA SOP</a:t>
+            </a:r>
+          </a:p>
+          <a:p>
+            <a:pPr>
+              <a:defRPr sz="650">
+                <a:solidFill>
+                  <a:srgbClr val="475569"/>
+                </a:solidFill>
+              </a:defRPr>
+            </a:pPr>
+            <a:r>
+              <a:t>Automated legal notice drafts for Sec 3D/3G fast-tracking.</a:t>
+            </a:r>
+          </a:p>
+        </p:txBody>
+      </p:sp>
+      <p:sp>
+        <p:nvSpPr>
+          <p:cNvPr id="17421" name="Rounded Rectangle 17420"/>
+          <p:cNvSpPr/>
+          <p:nvPr/>
+        </p:nvSpPr>
+        <p:spPr>
+          <a:xfrm>
+            <a:off x="2615184" y="4261104"/>
+            <a:ext cx="1856232" cy="603504"/>
+          </a:xfrm>
+          <a:prstGeom prst="roundRect">
+            <a:avLst/>
+          </a:prstGeom>
+          <a:solidFill>
+            <a:srgbClr val="FFFFFF"/>
+          </a:solidFill>
+          <a:ln>
+            <a:solidFill>
+              <a:srgbClr val="C8E6C9"/>
+            </a:solidFill>
+          </a:ln>
+        </p:spPr>
+        <p:style>
+          <a:lnRef idx="1">
+            <a:schemeClr val="accent1"/>
+          </a:lnRef>
+          <a:fillRef idx="3">
+            <a:schemeClr val="accent1"/>
+          </a:fillRef>
+          <a:effectRef idx="2">
+            <a:schemeClr val="accent1"/>
+          </a:effectRef>
+          <a:fontRef idx="minor">
+            <a:schemeClr val="lt1"/>
+          </a:fontRef>
+        </p:style>
+        <p:txBody>
+          <a:bodyPr rtlCol="0" anchor="t" wrap="square" tIns="36576" lIns="54864" rIns="54864"/>
+          <a:lstStyle/>
+          <a:p>
+            <a:pPr algn="ctr">
+              <a:spcAft>
+                <a:spcPts val="100"/>
+              </a:spcAft>
+              <a:defRPr sz="750" b="1">
+                <a:solidFill>
+                  <a:srgbClr val="2E7D32"/>
+                </a:solidFill>
+              </a:defRPr>
+            </a:pPr>
+            <a:r>
+              <a:t>🛡️ Constitutional HITL</a:t>
+            </a:r>
+          </a:p>
+          <a:p>
+            <a:pPr>
+              <a:defRPr sz="650">
+                <a:solidFill>
+                  <a:srgbClr val="475569"/>
+                </a:solidFill>
+              </a:defRPr>
+            </a:pPr>
+            <a:r>
+              <a:t>4-tier RBAC + Aadhaar DSC e-Sign gateway (Arts. 77/166).</a:t>
+            </a:r>
+          </a:p>
+        </p:txBody>
+      </p:sp>
+      <p:sp>
+        <p:nvSpPr>
+          <p:cNvPr id="17422" name="Left-Right Arrow 17421"/>
+          <p:cNvSpPr/>
+          <p:nvPr/>
+        </p:nvSpPr>
+        <p:spPr>
+          <a:xfrm>
+            <a:off x="4553712" y="3218688"/>
+            <a:ext cx="182880" cy="128016"/>
+          </a:xfrm>
+          <a:prstGeom prst="leftRightArrow">
+            <a:avLst/>
+          </a:prstGeom>
+          <a:solidFill>
+            <a:srgbClr val="64748B"/>
+          </a:solidFill>
+          <a:ln>
+            <a:solidFill>
+              <a:srgbClr val="64748B"/>
+            </a:solidFill>
+          </a:ln>
+        </p:spPr>
+        <p:style>
+          <a:lnRef idx="1">
+            <a:schemeClr val="accent1"/>
+          </a:lnRef>
+          <a:fillRef idx="3">
+            <a:schemeClr val="accent1"/>
+          </a:fillRef>
+          <a:effectRef idx="2">
+            <a:schemeClr val="accent1"/>
+          </a:effectRef>
+          <a:fontRef idx="minor">
+            <a:schemeClr val="lt1"/>
+          </a:fontRef>
+        </p:style>
+        <p:txBody>
+          <a:bodyPr rtlCol="0" anchor="ctr"/>
+          <a:lstStyle/>
+          <a:p>
+            <a:pPr algn="ctr"/>
+          </a:p>
+        </p:txBody>
+      </p:sp>
+      <p:sp>
+        <p:nvSpPr>
+          <p:cNvPr id="17423" name="Rounded Rectangle 17422"/>
+          <p:cNvSpPr/>
+          <p:nvPr/>
+        </p:nvSpPr>
+        <p:spPr>
+          <a:xfrm>
+            <a:off x="4773168" y="1097280"/>
+            <a:ext cx="2011680" cy="384048"/>
+          </a:xfrm>
+          <a:prstGeom prst="roundRect">
+            <a:avLst/>
+          </a:prstGeom>
+          <a:solidFill>
+            <a:srgbClr val="EDE7F6"/>
+          </a:solidFill>
+          <a:ln>
+            <a:solidFill>
+              <a:srgbClr val="B39DDB"/>
+            </a:solidFill>
+          </a:ln>
+        </p:spPr>
+        <p:style>
+          <a:lnRef idx="1">
+            <a:schemeClr val="accent1"/>
+          </a:lnRef>
+          <a:fillRef idx="3">
+            <a:schemeClr val="accent1"/>
+          </a:fillRef>
+          <a:effectRef idx="2">
+            <a:schemeClr val="accent1"/>
+          </a:effectRef>
+          <a:fontRef idx="minor">
+            <a:schemeClr val="lt1"/>
+          </a:fontRef>
+        </p:style>
+        <p:txBody>
+          <a:bodyPr rtlCol="0" anchor="ctr" wrap="square"/>
+          <a:lstStyle/>
+          <a:p>
+            <a:pPr algn="ctr">
+              <a:defRPr sz="850" b="1">
+                <a:solidFill>
+                  <a:srgbClr val="4527A0"/>
+                </a:solidFill>
+              </a:defRPr>
+            </a:pPr>
+            <a:r>
+              <a:t>Zone 3: Backend (FastAPI)</a:t>
+            </a:r>
+          </a:p>
+        </p:txBody>
+      </p:sp>
+      <p:sp>
+        <p:nvSpPr>
+          <p:cNvPr id="17424" name="Rounded Rectangle 17423"/>
+          <p:cNvSpPr/>
+          <p:nvPr/>
+        </p:nvSpPr>
+        <p:spPr>
+          <a:xfrm>
+            <a:off x="4773168" y="1572768"/>
+            <a:ext cx="2011680" cy="3383280"/>
+          </a:xfrm>
+          <a:prstGeom prst="roundRect">
+            <a:avLst/>
+          </a:prstGeom>
+          <a:solidFill>
+            <a:srgbClr val="F6F3FB"/>
+          </a:solidFill>
+          <a:ln>
+            <a:solidFill>
+              <a:srgbClr val="B39DDB"/>
+            </a:solidFill>
+          </a:ln>
+        </p:spPr>
+        <p:style>
+          <a:lnRef idx="1">
+            <a:schemeClr val="accent1"/>
+          </a:lnRef>
+          <a:fillRef idx="3">
+            <a:schemeClr val="accent1"/>
+          </a:fillRef>
+          <a:effectRef idx="2">
+            <a:schemeClr val="accent1"/>
+          </a:effectRef>
+          <a:fontRef idx="minor">
+            <a:schemeClr val="lt1"/>
+          </a:fontRef>
+        </p:style>
+        <p:txBody>
+          <a:bodyPr rtlCol="0" anchor="ctr"/>
+          <a:lstStyle/>
+          <a:p>
+            <a:pPr algn="ctr"/>
+          </a:p>
+        </p:txBody>
+      </p:sp>
+      <p:sp>
+        <p:nvSpPr>
+          <p:cNvPr id="17425" name="Rounded Rectangle 17424"/>
+          <p:cNvSpPr/>
+          <p:nvPr/>
+        </p:nvSpPr>
+        <p:spPr>
+          <a:xfrm>
+            <a:off x="4828032" y="1627632"/>
+            <a:ext cx="1901952" cy="603504"/>
+          </a:xfrm>
+          <a:prstGeom prst="roundRect">
+            <a:avLst/>
+          </a:prstGeom>
+          <a:solidFill>
+            <a:srgbClr val="FFFFFF"/>
+          </a:solidFill>
+          <a:ln>
+            <a:solidFill>
+              <a:srgbClr val="D1C4E9"/>
+            </a:solidFill>
+          </a:ln>
+        </p:spPr>
+        <p:style>
+          <a:lnRef idx="1">
+            <a:schemeClr val="accent1"/>
+          </a:lnRef>
+          <a:fillRef idx="3">
+            <a:schemeClr val="accent1"/>
+          </a:fillRef>
+          <a:effectRef idx="2">
+            <a:schemeClr val="accent1"/>
+          </a:effectRef>
+          <a:fontRef idx="minor">
+            <a:schemeClr val="lt1"/>
+          </a:fontRef>
+        </p:style>
+        <p:txBody>
+          <a:bodyPr rtlCol="0" anchor="t" wrap="square" tIns="36576" lIns="54864" rIns="54864"/>
+          <a:lstStyle/>
+          <a:p>
+            <a:pPr algn="ctr">
+              <a:spcAft>
+                <a:spcPts val="100"/>
+              </a:spcAft>
+              <a:defRPr sz="750" b="1">
+                <a:solidFill>
+                  <a:srgbClr val="6A1B9A"/>
+                </a:solidFill>
+              </a:defRPr>
+            </a:pPr>
+            <a:r>
+              <a:t>⚡ REST API Gateway</a:t>
+            </a:r>
+          </a:p>
+          <a:p>
+            <a:pPr>
+              <a:defRPr sz="650">
+                <a:solidFill>
+                  <a:srgbClr val="475569"/>
+                </a:solidFill>
+              </a:defRPr>
+            </a:pPr>
+            <a:r>
+              <a:t>Point 11 compliant: async request routing, OpenAPI 3.0 &amp; auth.</a:t>
+            </a:r>
+          </a:p>
+        </p:txBody>
+      </p:sp>
+      <p:sp>
+        <p:nvSpPr>
+          <p:cNvPr id="17426" name="Rounded Rectangle 17425"/>
+          <p:cNvSpPr/>
+          <p:nvPr/>
+        </p:nvSpPr>
+        <p:spPr>
+          <a:xfrm>
+            <a:off x="4828032" y="2286000"/>
+            <a:ext cx="1901952" cy="603504"/>
+          </a:xfrm>
+          <a:prstGeom prst="roundRect">
+            <a:avLst/>
+          </a:prstGeom>
+          <a:solidFill>
+            <a:srgbClr val="FFFFFF"/>
+          </a:solidFill>
+          <a:ln>
+            <a:solidFill>
+              <a:srgbClr val="D1C4E9"/>
+            </a:solidFill>
+          </a:ln>
+        </p:spPr>
+        <p:style>
+          <a:lnRef idx="1">
+            <a:schemeClr val="accent1"/>
+          </a:lnRef>
+          <a:fillRef idx="3">
+            <a:schemeClr val="accent1"/>
+          </a:fillRef>
+          <a:effectRef idx="2">
+            <a:schemeClr val="accent1"/>
+          </a:effectRef>
+          <a:fontRef idx="minor">
+            <a:schemeClr val="lt1"/>
+          </a:fontRef>
+        </p:style>
+        <p:txBody>
+          <a:bodyPr rtlCol="0" anchor="t" wrap="square" tIns="36576" lIns="54864" rIns="54864"/>
+          <a:lstStyle/>
+          <a:p>
+            <a:pPr algn="ctr">
+              <a:spcAft>
+                <a:spcPts val="100"/>
+              </a:spcAft>
+              <a:defRPr sz="750" b="1">
+                <a:solidFill>
+                  <a:srgbClr val="6A1B9A"/>
+                </a:solidFill>
+              </a:defRPr>
+            </a:pPr>
+            <a:r>
+              <a:t>💾 Decoupled Central DB</a:t>
+            </a:r>
+          </a:p>
+          <a:p>
+            <a:pPr>
+              <a:defRPr sz="650">
+                <a:solidFill>
+                  <a:srgbClr val="475569"/>
+                </a:solidFill>
+              </a:defRPr>
+            </a:pPr>
+            <a:r>
+              <a:t>&lt;15ms cached responses for 47 standardized statutory features.</a:t>
+            </a:r>
+          </a:p>
+        </p:txBody>
+      </p:sp>
+      <p:sp>
+        <p:nvSpPr>
+          <p:cNvPr id="17427" name="Rounded Rectangle 17426"/>
+          <p:cNvSpPr/>
+          <p:nvPr/>
+        </p:nvSpPr>
+        <p:spPr>
+          <a:xfrm>
+            <a:off x="4828032" y="2944368"/>
+            <a:ext cx="1901952" cy="603504"/>
+          </a:xfrm>
+          <a:prstGeom prst="roundRect">
+            <a:avLst/>
+          </a:prstGeom>
+          <a:solidFill>
+            <a:srgbClr val="FFFFFF"/>
+          </a:solidFill>
+          <a:ln>
+            <a:solidFill>
+              <a:srgbClr val="D1C4E9"/>
+            </a:solidFill>
+          </a:ln>
+        </p:spPr>
+        <p:style>
+          <a:lnRef idx="1">
+            <a:schemeClr val="accent1"/>
+          </a:lnRef>
+          <a:fillRef idx="3">
+            <a:schemeClr val="accent1"/>
+          </a:fillRef>
+          <a:effectRef idx="2">
+            <a:schemeClr val="accent1"/>
+          </a:effectRef>
+          <a:fontRef idx="minor">
+            <a:schemeClr val="lt1"/>
+          </a:fontRef>
+        </p:style>
+        <p:txBody>
+          <a:bodyPr rtlCol="0" anchor="t" wrap="square" tIns="36576" lIns="54864" rIns="54864"/>
+          <a:lstStyle/>
+          <a:p>
+            <a:pPr algn="ctr">
+              <a:spcAft>
+                <a:spcPts val="100"/>
+              </a:spcAft>
+              <a:defRPr sz="750" b="1">
+                <a:solidFill>
+                  <a:srgbClr val="6A1B9A"/>
+                </a:solidFill>
+              </a:defRPr>
+            </a:pPr>
+            <a:r>
+              <a:t>🛣️ Dual-Track Engine</a:t>
+            </a:r>
+          </a:p>
+          <a:p>
+            <a:pPr>
+              <a:defRPr sz="650">
+                <a:solidFill>
+                  <a:srgbClr val="475569"/>
+                </a:solidFill>
+              </a:defRPr>
+            </a:pPr>
+            <a:r>
+              <a:t>Decouples physical civil road works from legal escrow disputes.</a:t>
+            </a:r>
+          </a:p>
+        </p:txBody>
+      </p:sp>
+      <p:sp>
+        <p:nvSpPr>
+          <p:cNvPr id="17428" name="Rounded Rectangle 17427"/>
+          <p:cNvSpPr/>
+          <p:nvPr/>
+        </p:nvSpPr>
+        <p:spPr>
+          <a:xfrm>
+            <a:off x="4828032" y="3602736"/>
+            <a:ext cx="1901952" cy="603504"/>
+          </a:xfrm>
+          <a:prstGeom prst="roundRect">
+            <a:avLst/>
+          </a:prstGeom>
+          <a:solidFill>
+            <a:srgbClr val="FFFFFF"/>
+          </a:solidFill>
+          <a:ln>
+            <a:solidFill>
+              <a:srgbClr val="D1C4E9"/>
+            </a:solidFill>
+          </a:ln>
+        </p:spPr>
+        <p:style>
+          <a:lnRef idx="1">
+            <a:schemeClr val="accent1"/>
+          </a:lnRef>
+          <a:fillRef idx="3">
+            <a:schemeClr val="accent1"/>
+          </a:fillRef>
+          <a:effectRef idx="2">
+            <a:schemeClr val="accent1"/>
+          </a:effectRef>
+          <a:fontRef idx="minor">
+            <a:schemeClr val="lt1"/>
+          </a:fontRef>
+        </p:style>
+        <p:txBody>
+          <a:bodyPr rtlCol="0" anchor="t" wrap="square" tIns="36576" lIns="54864" rIns="54864"/>
+          <a:lstStyle/>
+          <a:p>
+            <a:pPr algn="ctr">
+              <a:spcAft>
+                <a:spcPts val="100"/>
+              </a:spcAft>
+              <a:defRPr sz="750" b="1">
+                <a:solidFill>
+                  <a:srgbClr val="6A1B9A"/>
+                </a:solidFill>
+              </a:defRPr>
+            </a:pPr>
+            <a:r>
+              <a:t>📝 Statutory DFA Engine</a:t>
+            </a:r>
+          </a:p>
+          <a:p>
+            <a:pPr>
+              <a:defRPr sz="650">
+                <a:solidFill>
+                  <a:srgbClr val="475569"/>
+                </a:solidFill>
+              </a:defRPr>
+            </a:pPr>
+            <a:r>
+              <a:t>Generates legally binding Section 3A, 3D, 3G, 3H notice drafts.</a:t>
+            </a:r>
+          </a:p>
+        </p:txBody>
+      </p:sp>
+      <p:sp>
+        <p:nvSpPr>
+          <p:cNvPr id="17429" name="Rounded Rectangle 17428"/>
+          <p:cNvSpPr/>
+          <p:nvPr/>
+        </p:nvSpPr>
+        <p:spPr>
+          <a:xfrm>
+            <a:off x="4828032" y="4261104"/>
+            <a:ext cx="1901952" cy="603504"/>
+          </a:xfrm>
+          <a:prstGeom prst="roundRect">
+            <a:avLst/>
+          </a:prstGeom>
+          <a:solidFill>
+            <a:srgbClr val="FFFFFF"/>
+          </a:solidFill>
+          <a:ln>
+            <a:solidFill>
+              <a:srgbClr val="D1C4E9"/>
+            </a:solidFill>
+          </a:ln>
+        </p:spPr>
+        <p:style>
+          <a:lnRef idx="1">
+            <a:schemeClr val="accent1"/>
+          </a:lnRef>
+          <a:fillRef idx="3">
+            <a:schemeClr val="accent1"/>
+          </a:fillRef>
+          <a:effectRef idx="2">
+            <a:schemeClr val="accent1"/>
+          </a:effectRef>
+          <a:fontRef idx="minor">
+            <a:schemeClr val="lt1"/>
+          </a:fontRef>
+        </p:style>
+        <p:txBody>
+          <a:bodyPr rtlCol="0" anchor="t" wrap="square" tIns="36576" lIns="54864" rIns="54864"/>
+          <a:lstStyle/>
+          <a:p>
+            <a:pPr algn="ctr">
+              <a:spcAft>
+                <a:spcPts val="100"/>
+              </a:spcAft>
+              <a:defRPr sz="750" b="1">
+                <a:solidFill>
+                  <a:srgbClr val="6A1B9A"/>
+                </a:solidFill>
+              </a:defRPr>
+            </a:pPr>
+            <a:r>
+              <a:t>🔒 SHA-256 Ledger Service</a:t>
+            </a:r>
+          </a:p>
+          <a:p>
+            <a:pPr>
+              <a:defRPr sz="650">
+                <a:solidFill>
+                  <a:srgbClr val="475569"/>
+                </a:solidFill>
+              </a:defRPr>
+            </a:pPr>
+            <a:r>
+              <a:t>Cryptographic block hashing ensuring immutable CAG audit trail.</a:t>
+            </a:r>
+          </a:p>
+        </p:txBody>
+      </p:sp>
+      <p:sp>
+        <p:nvSpPr>
+          <p:cNvPr id="17430" name="Left-Right Arrow 17429"/>
+          <p:cNvSpPr/>
+          <p:nvPr/>
+        </p:nvSpPr>
+        <p:spPr>
+          <a:xfrm>
+            <a:off x="6803136" y="3218688"/>
+            <a:ext cx="182880" cy="128016"/>
+          </a:xfrm>
+          <a:prstGeom prst="leftRightArrow">
+            <a:avLst/>
+          </a:prstGeom>
+          <a:solidFill>
+            <a:srgbClr val="64748B"/>
+          </a:solidFill>
+          <a:ln>
+            <a:solidFill>
+              <a:srgbClr val="64748B"/>
+            </a:solidFill>
+          </a:ln>
+        </p:spPr>
+        <p:style>
+          <a:lnRef idx="1">
+            <a:schemeClr val="accent1"/>
+          </a:lnRef>
+          <a:fillRef idx="3">
+            <a:schemeClr val="accent1"/>
+          </a:fillRef>
+          <a:effectRef idx="2">
+            <a:schemeClr val="accent1"/>
+          </a:effectRef>
+          <a:fontRef idx="minor">
+            <a:schemeClr val="lt1"/>
+          </a:fontRef>
+        </p:style>
+        <p:txBody>
+          <a:bodyPr rtlCol="0" anchor="ctr"/>
+          <a:lstStyle/>
+          <a:p>
+            <a:pPr algn="ctr"/>
+          </a:p>
+        </p:txBody>
+      </p:sp>
+      <p:sp>
+        <p:nvSpPr>
+          <p:cNvPr id="17431" name="Rounded Rectangle 17430"/>
+          <p:cNvSpPr/>
+          <p:nvPr/>
+        </p:nvSpPr>
+        <p:spPr>
+          <a:xfrm>
+            <a:off x="7022592" y="1097280"/>
+            <a:ext cx="1965960" cy="384048"/>
+          </a:xfrm>
+          <a:prstGeom prst="roundRect">
+            <a:avLst/>
+          </a:prstGeom>
+          <a:solidFill>
+            <a:srgbClr val="E0F7FA"/>
+          </a:solidFill>
+          <a:ln>
+            <a:solidFill>
+              <a:srgbClr val="80DEEA"/>
+            </a:solidFill>
+          </a:ln>
+        </p:spPr>
+        <p:style>
+          <a:lnRef idx="1">
+            <a:schemeClr val="accent1"/>
+          </a:lnRef>
+          <a:fillRef idx="3">
+            <a:schemeClr val="accent1"/>
+          </a:fillRef>
+          <a:effectRef idx="2">
+            <a:schemeClr val="accent1"/>
+          </a:effectRef>
+          <a:fontRef idx="minor">
+            <a:schemeClr val="lt1"/>
+          </a:fontRef>
+        </p:style>
+        <p:txBody>
+          <a:bodyPr rtlCol="0" anchor="ctr" wrap="square"/>
+          <a:lstStyle/>
+          <a:p>
+            <a:pPr algn="ctr">
+              <a:defRPr sz="850" b="1">
+                <a:solidFill>
+                  <a:srgbClr val="00838F"/>
+                </a:solidFill>
+              </a:defRPr>
+            </a:pPr>
+            <a:r>
+              <a:t>Zone 4: AI &amp; ML Engine (The Brain)</a:t>
+            </a:r>
+          </a:p>
+        </p:txBody>
+      </p:sp>
+      <p:sp>
+        <p:nvSpPr>
+          <p:cNvPr id="17432" name="Rounded Rectangle 17431"/>
+          <p:cNvSpPr/>
+          <p:nvPr/>
+        </p:nvSpPr>
+        <p:spPr>
+          <a:xfrm>
+            <a:off x="7022592" y="1572768"/>
+            <a:ext cx="1965960" cy="3383280"/>
+          </a:xfrm>
+          <a:prstGeom prst="roundRect">
+            <a:avLst/>
+          </a:prstGeom>
+          <a:solidFill>
+            <a:srgbClr val="F0FBFC"/>
+          </a:solidFill>
+          <a:ln>
+            <a:solidFill>
+              <a:srgbClr val="80DEEA"/>
+            </a:solidFill>
+          </a:ln>
+        </p:spPr>
+        <p:style>
+          <a:lnRef idx="1">
+            <a:schemeClr val="accent1"/>
+          </a:lnRef>
+          <a:fillRef idx="3">
+            <a:schemeClr val="accent1"/>
+          </a:fillRef>
+          <a:effectRef idx="2">
+            <a:schemeClr val="accent1"/>
+          </a:effectRef>
+          <a:fontRef idx="minor">
+            <a:schemeClr val="lt1"/>
+          </a:fontRef>
+        </p:style>
+        <p:txBody>
+          <a:bodyPr rtlCol="0" anchor="ctr"/>
+          <a:lstStyle/>
+          <a:p>
+            <a:pPr algn="ctr"/>
+          </a:p>
+        </p:txBody>
+      </p:sp>
+      <p:sp>
+        <p:nvSpPr>
+          <p:cNvPr id="17433" name="Rounded Rectangle 17432"/>
+          <p:cNvSpPr/>
+          <p:nvPr/>
+        </p:nvSpPr>
+        <p:spPr>
+          <a:xfrm>
+            <a:off x="7077456" y="1627632"/>
+            <a:ext cx="1856232" cy="603504"/>
+          </a:xfrm>
+          <a:prstGeom prst="roundRect">
+            <a:avLst/>
+          </a:prstGeom>
+          <a:solidFill>
+            <a:srgbClr val="FFFFFF"/>
+          </a:solidFill>
+          <a:ln>
+            <a:solidFill>
+              <a:srgbClr val="B2EBF2"/>
+            </a:solidFill>
+          </a:ln>
+        </p:spPr>
+        <p:style>
+          <a:lnRef idx="1">
+            <a:schemeClr val="accent1"/>
+          </a:lnRef>
+          <a:fillRef idx="3">
+            <a:schemeClr val="accent1"/>
+          </a:fillRef>
+          <a:effectRef idx="2">
+            <a:schemeClr val="accent1"/>
+          </a:effectRef>
+          <a:fontRef idx="minor">
+            <a:schemeClr val="lt1"/>
+          </a:fontRef>
+        </p:style>
+        <p:txBody>
+          <a:bodyPr rtlCol="0" anchor="t" wrap="square" tIns="36576" lIns="54864" rIns="54864"/>
+          <a:lstStyle/>
+          <a:p>
+            <a:pPr algn="ctr">
+              <a:spcAft>
+                <a:spcPts val="100"/>
+              </a:spcAft>
+              <a:defRPr sz="750" b="1">
+                <a:solidFill>
+                  <a:srgbClr val="00838F"/>
+                </a:solidFill>
+              </a:defRPr>
+            </a:pPr>
+            <a:r>
+              <a:t>🧠 Ensemble ML Predictor</a:t>
+            </a:r>
+          </a:p>
+          <a:p>
+            <a:pPr>
+              <a:defRPr sz="650">
+                <a:solidFill>
+                  <a:srgbClr val="475569"/>
+                </a:solidFill>
+              </a:defRPr>
+            </a:pPr>
+            <a:r>
+              <a:t>LightGBM + XGBoost 2.1 regressors predict residual delay days.</a:t>
+            </a:r>
+          </a:p>
+        </p:txBody>
+      </p:sp>
+      <p:sp>
+        <p:nvSpPr>
+          <p:cNvPr id="17434" name="Rounded Rectangle 17433"/>
+          <p:cNvSpPr/>
+          <p:nvPr/>
+        </p:nvSpPr>
+        <p:spPr>
+          <a:xfrm>
+            <a:off x="7077456" y="2286000"/>
+            <a:ext cx="1856232" cy="603504"/>
+          </a:xfrm>
+          <a:prstGeom prst="roundRect">
+            <a:avLst/>
+          </a:prstGeom>
+          <a:solidFill>
+            <a:srgbClr val="FFFFFF"/>
+          </a:solidFill>
+          <a:ln>
+            <a:solidFill>
+              <a:srgbClr val="B2EBF2"/>
+            </a:solidFill>
+          </a:ln>
+        </p:spPr>
+        <p:style>
+          <a:lnRef idx="1">
+            <a:schemeClr val="accent1"/>
+          </a:lnRef>
+          <a:fillRef idx="3">
+            <a:schemeClr val="accent1"/>
+          </a:fillRef>
+          <a:effectRef idx="2">
+            <a:schemeClr val="accent1"/>
+          </a:effectRef>
+          <a:fontRef idx="minor">
+            <a:schemeClr val="lt1"/>
+          </a:fontRef>
+        </p:style>
+        <p:txBody>
+          <a:bodyPr rtlCol="0" anchor="t" wrap="square" tIns="36576" lIns="54864" rIns="54864"/>
+          <a:lstStyle/>
+          <a:p>
+            <a:pPr algn="ctr">
+              <a:spcAft>
+                <a:spcPts val="100"/>
+              </a:spcAft>
+              <a:defRPr sz="750" b="1">
+                <a:solidFill>
+                  <a:srgbClr val="00838F"/>
+                </a:solidFill>
+              </a:defRPr>
+            </a:pPr>
+            <a:r>
+              <a:t>🔬 TreeSHAP Attribution</a:t>
+            </a:r>
+          </a:p>
+          <a:p>
+            <a:pPr>
+              <a:defRPr sz="650">
+                <a:solidFill>
+                  <a:srgbClr val="475569"/>
+                </a:solidFill>
+              </a:defRPr>
+            </a:pPr>
+            <a:r>
+              <a:t>Micro-level factor attribution quantifying additive day delays.</a:t>
+            </a:r>
+          </a:p>
+        </p:txBody>
+      </p:sp>
+      <p:sp>
+        <p:nvSpPr>
+          <p:cNvPr id="17435" name="Rounded Rectangle 17434"/>
+          <p:cNvSpPr/>
+          <p:nvPr/>
+        </p:nvSpPr>
+        <p:spPr>
+          <a:xfrm>
+            <a:off x="7077456" y="2944368"/>
+            <a:ext cx="1856232" cy="603504"/>
+          </a:xfrm>
+          <a:prstGeom prst="roundRect">
+            <a:avLst/>
+          </a:prstGeom>
+          <a:solidFill>
+            <a:srgbClr val="FFFFFF"/>
+          </a:solidFill>
+          <a:ln>
+            <a:solidFill>
+              <a:srgbClr val="B2EBF2"/>
+            </a:solidFill>
+          </a:ln>
+        </p:spPr>
+        <p:style>
+          <a:lnRef idx="1">
+            <a:schemeClr val="accent1"/>
+          </a:lnRef>
+          <a:fillRef idx="3">
+            <a:schemeClr val="accent1"/>
+          </a:fillRef>
+          <a:effectRef idx="2">
+            <a:schemeClr val="accent1"/>
+          </a:effectRef>
+          <a:fontRef idx="minor">
+            <a:schemeClr val="lt1"/>
+          </a:fontRef>
+        </p:style>
+        <p:txBody>
+          <a:bodyPr rtlCol="0" anchor="t" wrap="square" tIns="36576" lIns="54864" rIns="54864"/>
+          <a:lstStyle/>
+          <a:p>
+            <a:pPr algn="ctr">
+              <a:spcAft>
+                <a:spcPts val="100"/>
+              </a:spcAft>
+              <a:defRPr sz="750" b="1">
+                <a:solidFill>
+                  <a:srgbClr val="00838F"/>
+                </a:solidFill>
+              </a:defRPr>
+            </a:pPr>
+            <a:r>
+              <a:t>📈 Kaplan-Meier Survival</a:t>
+            </a:r>
+          </a:p>
+          <a:p>
+            <a:pPr>
+              <a:defRPr sz="650">
+                <a:solidFill>
+                  <a:srgbClr val="475569"/>
+                </a:solidFill>
+              </a:defRPr>
+            </a:pPr>
+            <a:r>
+              <a:t>Probabilistic time-to-lapse modeling for 365-day Sec 3D deadlines.</a:t>
+            </a:r>
+          </a:p>
+        </p:txBody>
+      </p:sp>
+      <p:sp>
+        <p:nvSpPr>
+          <p:cNvPr id="17436" name="Rounded Rectangle 17435"/>
+          <p:cNvSpPr/>
+          <p:nvPr/>
+        </p:nvSpPr>
+        <p:spPr>
+          <a:xfrm>
+            <a:off x="7077456" y="3602736"/>
+            <a:ext cx="1856232" cy="603504"/>
+          </a:xfrm>
+          <a:prstGeom prst="roundRect">
+            <a:avLst/>
+          </a:prstGeom>
+          <a:solidFill>
+            <a:srgbClr val="FFFFFF"/>
+          </a:solidFill>
+          <a:ln>
+            <a:solidFill>
+              <a:srgbClr val="B2EBF2"/>
+            </a:solidFill>
+          </a:ln>
+        </p:spPr>
+        <p:style>
+          <a:lnRef idx="1">
+            <a:schemeClr val="accent1"/>
+          </a:lnRef>
+          <a:fillRef idx="3">
+            <a:schemeClr val="accent1"/>
+          </a:fillRef>
+          <a:effectRef idx="2">
+            <a:schemeClr val="accent1"/>
+          </a:effectRef>
+          <a:fontRef idx="minor">
+            <a:schemeClr val="lt1"/>
+          </a:fontRef>
+        </p:style>
+        <p:txBody>
+          <a:bodyPr rtlCol="0" anchor="t" wrap="square" tIns="36576" lIns="54864" rIns="54864"/>
+          <a:lstStyle/>
+          <a:p>
+            <a:pPr algn="ctr">
+              <a:spcAft>
+                <a:spcPts val="100"/>
+              </a:spcAft>
+              <a:defRPr sz="750" b="1">
+                <a:solidFill>
+                  <a:srgbClr val="00838F"/>
+                </a:solidFill>
+              </a:defRPr>
+            </a:pPr>
+            <a:r>
+              <a:t>⚖️ Prescriptive Rule Core</a:t>
+            </a:r>
+          </a:p>
+          <a:p>
+            <a:pPr>
+              <a:defRPr sz="650">
+                <a:solidFill>
+                  <a:srgbClr val="475569"/>
+                </a:solidFill>
+              </a:defRPr>
+            </a:pPr>
+            <a:r>
+              <a:t>Statutory threshold trigger engine activating specific SOP orders.</a:t>
+            </a:r>
+          </a:p>
+        </p:txBody>
+      </p:sp>
+      <p:sp>
+        <p:nvSpPr>
+          <p:cNvPr id="17437" name="Rounded Rectangle 17436"/>
+          <p:cNvSpPr/>
+          <p:nvPr/>
+        </p:nvSpPr>
+        <p:spPr>
+          <a:xfrm>
+            <a:off x="7077456" y="4261104"/>
+            <a:ext cx="1856232" cy="603504"/>
+          </a:xfrm>
+          <a:prstGeom prst="roundRect">
+            <a:avLst/>
+          </a:prstGeom>
+          <a:solidFill>
+            <a:srgbClr val="FFFFFF"/>
+          </a:solidFill>
+          <a:ln>
+            <a:solidFill>
+              <a:srgbClr val="B2EBF2"/>
+            </a:solidFill>
+          </a:ln>
+        </p:spPr>
+        <p:style>
+          <a:lnRef idx="1">
+            <a:schemeClr val="accent1"/>
+          </a:lnRef>
+          <a:fillRef idx="3">
+            <a:schemeClr val="accent1"/>
+          </a:fillRef>
+          <a:effectRef idx="2">
+            <a:schemeClr val="accent1"/>
+          </a:effectRef>
+          <a:fontRef idx="minor">
+            <a:schemeClr val="lt1"/>
+          </a:fontRef>
+        </p:style>
+        <p:txBody>
+          <a:bodyPr rtlCol="0" anchor="t" wrap="square" tIns="36576" lIns="54864" rIns="54864"/>
+          <a:lstStyle/>
+          <a:p>
+            <a:pPr algn="ctr">
+              <a:spcAft>
+                <a:spcPts val="100"/>
+              </a:spcAft>
+              <a:defRPr sz="750" b="1">
+                <a:solidFill>
+                  <a:srgbClr val="00838F"/>
+                </a:solidFill>
+              </a:defRPr>
+            </a:pPr>
+            <a:r>
+              <a:t>🗄️ Central DB (&lt;15ms)</a:t>
+            </a:r>
+          </a:p>
+          <a:p>
+            <a:pPr>
+              <a:defRPr sz="650">
+                <a:solidFill>
+                  <a:srgbClr val="475569"/>
+                </a:solidFill>
+              </a:defRPr>
+            </a:pPr>
+            <a:r>
+              <a:t>High-speed normalized SQLite/PostgreSQL storage across 47 attributes.</a:t>
+            </a:r>
+          </a:p>
+        </p:txBody>
+      </p:sp>
+      <p:sp>
+        <p:nvSpPr>
+          <p:cNvPr id="17438" name="Rounded Rectangle 17437"/>
+          <p:cNvSpPr/>
+          <p:nvPr/>
+        </p:nvSpPr>
+        <p:spPr>
+          <a:xfrm>
+            <a:off x="411480" y="5285232"/>
+            <a:ext cx="8641080" cy="868680"/>
+          </a:xfrm>
+          <a:prstGeom prst="roundRect">
+            <a:avLst/>
+          </a:prstGeom>
+          <a:solidFill>
+            <a:srgbClr val="FFFFFF"/>
+          </a:solidFill>
+          <a:ln w="15240">
+            <a:solidFill>
+              <a:srgbClr val="CBD5E1"/>
+            </a:solidFill>
+          </a:ln>
+        </p:spPr>
+        <p:style>
+          <a:lnRef idx="1">
+            <a:schemeClr val="accent1"/>
+          </a:lnRef>
+          <a:fillRef idx="3">
+            <a:schemeClr val="accent1"/>
+          </a:fillRef>
+          <a:effectRef idx="2">
+            <a:schemeClr val="accent1"/>
+          </a:effectRef>
+          <a:fontRef idx="minor">
+            <a:schemeClr val="lt1"/>
+          </a:fontRef>
+        </p:style>
+        <p:txBody>
+          <a:bodyPr rtlCol="0" anchor="ctr"/>
+          <a:lstStyle/>
+          <a:p>
+            <a:pPr algn="ctr"/>
+          </a:p>
+        </p:txBody>
+      </p:sp>
+      <p:sp>
+        <p:nvSpPr>
+          <p:cNvPr id="17439" name="Rounded Rectangle 17438"/>
+          <p:cNvSpPr/>
+          <p:nvPr/>
+        </p:nvSpPr>
+        <p:spPr>
+          <a:xfrm>
+            <a:off x="502920" y="5394960"/>
+            <a:ext cx="1691640" cy="649224"/>
+          </a:xfrm>
+          <a:prstGeom prst="roundRect">
+            <a:avLst/>
+          </a:prstGeom>
+          <a:solidFill>
+            <a:srgbClr val="F1F5F9"/>
+          </a:solidFill>
+          <a:ln>
+            <a:solidFill>
+              <a:srgbClr val="CBD5E1"/>
+            </a:solidFill>
+          </a:ln>
+        </p:spPr>
+        <p:style>
+          <a:lnRef idx="1">
+            <a:schemeClr val="accent1"/>
+          </a:lnRef>
+          <a:fillRef idx="3">
+            <a:schemeClr val="accent1"/>
+          </a:fillRef>
+          <a:effectRef idx="2">
+            <a:schemeClr val="accent1"/>
+          </a:effectRef>
+          <a:fontRef idx="minor">
+            <a:schemeClr val="lt1"/>
+          </a:fontRef>
+        </p:style>
+        <p:txBody>
+          <a:bodyPr rtlCol="0" anchor="ctr" wrap="square"/>
+          <a:lstStyle/>
+          <a:p>
+            <a:pPr algn="ctr">
+              <a:defRPr sz="950" b="1">
+                <a:solidFill>
+                  <a:srgbClr val="0F172A"/>
+                </a:solidFill>
+                <a:latin typeface="Arial"/>
+              </a:defRPr>
+            </a:pPr>
+            <a:r>
+              <a:t>⚙️ Components /</a:t>
+            </a:r>
+            <a:br/>
+            <a:r>
+              <a:t>Technology Stack</a:t>
+            </a:r>
+          </a:p>
+        </p:txBody>
+      </p:sp>
+      <p:sp>
+        <p:nvSpPr>
+          <p:cNvPr id="17440" name="Rounded Rectangle 17439"/>
+          <p:cNvSpPr/>
+          <p:nvPr/>
+        </p:nvSpPr>
+        <p:spPr>
+          <a:xfrm>
+            <a:off x="2286000" y="5394960"/>
+            <a:ext cx="777240" cy="649224"/>
           </a:xfrm>
           <a:prstGeom prst="roundRect">
             <a:avLst/>
@@ -9077,9 +10996,9 @@
           <a:solidFill>
             <a:srgbClr val="F8FAFC"/>
           </a:solidFill>
-          <a:ln>
+          <a:ln w="15240">
             <a:solidFill>
-              <a:srgbClr val="CBD5E1"/>
+              <a:srgbClr val="3572A5"/>
             </a:solidFill>
           </a:ln>
         </p:spPr>
@@ -9098,161 +11017,44 @@
           </a:fontRef>
         </p:style>
         <p:txBody>
-          <a:bodyPr rtlCol="0" anchor="ctr" wrap="square"/>
+          <a:bodyPr rtlCol="0" anchor="ctr" wrap="square" lIns="18288" rIns="18288"/>
           <a:lstStyle/>
           <a:p>
             <a:pPr algn="ctr">
-              <a:spcAft>
-                <a:spcPts val="800"/>
-              </a:spcAft>
-            </a:pPr>
-            <a:r>
-              <a:rPr sz="1300" b="1">
-                <a:solidFill>
-                  <a:srgbClr val="1A365D"/>
-                </a:solidFill>
-                <a:latin typeface="Arial"/>
-              </a:rPr>
-              <a:t>1. Core Technology Stack &amp; Libraries</a:t>
-            </a:r>
-          </a:p>
-          <a:p>
-            <a:pPr>
-              <a:spcAft>
-                <a:spcPts val="600"/>
-              </a:spcAft>
-            </a:pPr>
-            <a:r>
-              <a:rPr sz="950" b="1">
-                <a:solidFill>
-                  <a:srgbClr val="2563EB"/>
-                </a:solidFill>
-                <a:latin typeface="Arial"/>
-              </a:rPr>
-              <a:t>• Machine Learning &amp; XAI Core: </a:t>
-            </a:r>
-            <a:r>
-              <a:rPr sz="850">
-                <a:solidFill>
-                  <a:srgbClr val="1E293B"/>
-                </a:solidFill>
-                <a:latin typeface="Arial"/>
-              </a:rPr>
-              <a:t>XGBoost 2.1 &amp; LightGBM Ensemble (Gradient Boosted Trees), TreeSHAP (Marginal Attribution), Scikit-Learn (Pipelines, RobustScaler, Imputer), Lifelines (Kaplan-Meier Survival Analysis).</a:t>
-            </a:r>
-          </a:p>
-          <a:p>
-            <a:pPr>
-              <a:spcAft>
-                <a:spcPts val="600"/>
-              </a:spcAft>
-            </a:pPr>
-            <a:r>
-              <a:rPr sz="950" b="1">
-                <a:solidFill>
-                  <a:srgbClr val="2563EB"/>
-                </a:solidFill>
-                <a:latin typeface="Arial"/>
-              </a:rPr>
-              <a:t>• Geospatial &amp; Mapping (Point 7): </a:t>
-            </a:r>
-            <a:r>
-              <a:rPr sz="850">
-                <a:solidFill>
-                  <a:srgbClr val="1E293B"/>
-                </a:solidFill>
-                <a:latin typeface="Arial"/>
-              </a:rPr>
-              <a:t>Leaflet.js, React-Leaflet, GeoJSON standard, WGS84 EPSG:4326 Datum, CartoDB Voyager tiles, Turf.js for spatial intersection calculations.</a:t>
-            </a:r>
-          </a:p>
-          <a:p>
-            <a:pPr>
-              <a:spcAft>
-                <a:spcPts val="600"/>
-              </a:spcAft>
-            </a:pPr>
-            <a:r>
-              <a:rPr sz="950" b="1">
-                <a:solidFill>
-                  <a:srgbClr val="2563EB"/>
-                </a:solidFill>
-                <a:latin typeface="Arial"/>
-              </a:rPr>
-              <a:t>• High-Performance Backend (Point 11): </a:t>
-            </a:r>
-            <a:r>
-              <a:rPr sz="850">
-                <a:solidFill>
-                  <a:srgbClr val="1E293B"/>
-                </a:solidFill>
-                <a:latin typeface="Arial"/>
-              </a:rPr>
-              <a:t>Python 3.13, FastAPI (Asynchronous ASGI server), Pydantic v2 (Strict Schema Validation), SQLite / PostgreSQL-Ready Central DB, RESTful Integration Gateway.</a:t>
-            </a:r>
-          </a:p>
-          <a:p>
-            <a:pPr>
-              <a:spcAft>
-                <a:spcPts val="600"/>
-              </a:spcAft>
-            </a:pPr>
-            <a:r>
-              <a:rPr sz="950" b="1">
-                <a:solidFill>
-                  <a:srgbClr val="2563EB"/>
-                </a:solidFill>
-                <a:latin typeface="Arial"/>
-              </a:rPr>
-              <a:t>• Frontend &amp; Interactive Analytics: </a:t>
-            </a:r>
-            <a:r>
-              <a:rPr sz="850">
-                <a:solidFill>
-                  <a:srgbClr val="1E293B"/>
-                </a:solidFill>
-                <a:latin typeface="Arial"/>
-              </a:rPr>
-              <a:t>React 19, Vite 6, Tailwind CSS v3, Apache ECharts (Dynamic comparative dual-track &amp; survival charts), Lucide React Vector Icons.</a:t>
-            </a:r>
-          </a:p>
-          <a:p>
-            <a:pPr>
-              <a:spcAft>
-                <a:spcPts val="600"/>
-              </a:spcAft>
-            </a:pPr>
-            <a:r>
-              <a:rPr sz="950" b="1">
-                <a:solidFill>
-                  <a:srgbClr val="2563EB"/>
-                </a:solidFill>
-                <a:latin typeface="Arial"/>
-              </a:rPr>
-              <a:t>• Statutory Audit &amp; e-Sign (Point 12): </a:t>
-            </a:r>
-            <a:r>
-              <a:rPr sz="850">
-                <a:solidFill>
-                  <a:srgbClr val="1E293B"/>
-                </a:solidFill>
-                <a:latin typeface="Arial"/>
-              </a:rPr>
-              <a:t>SHA-256 Cryptographic Hash Engine, NIC Jan-Parichay / Aadhaar e-Authentication Bridge, Class-3 Digital Signature Certificate (DSC) Stamping.</a:t>
-            </a:r>
-          </a:p>
-        </p:txBody>
-      </p:sp>
-      <p:sp>
-        <p:nvSpPr>
-          <p:cNvPr id="17411" name="Rounded Rectangle 17410"/>
+              <a:defRPr sz="750" b="1">
+                <a:solidFill>
+                  <a:srgbClr val="3572A5"/>
+                </a:solidFill>
+              </a:defRPr>
+            </a:pPr>
+            <a:r>
+              <a:t>Python 3.13</a:t>
+            </a:r>
+          </a:p>
+          <a:p>
+            <a:pPr algn="ctr">
+              <a:defRPr sz="600">
+                <a:solidFill>
+                  <a:srgbClr val="475569"/>
+                </a:solidFill>
+              </a:defRPr>
+            </a:pPr>
+            <a:r>
+              <a:t>FastAPI / ASGI</a:t>
+            </a:r>
+          </a:p>
+        </p:txBody>
+      </p:sp>
+      <p:sp>
+        <p:nvSpPr>
+          <p:cNvPr id="17441" name="Rounded Rectangle 17440"/>
           <p:cNvSpPr/>
           <p:nvPr/>
         </p:nvSpPr>
         <p:spPr>
           <a:xfrm>
-            <a:off x="5852160" y="1097280"/>
-            <a:ext cx="5486400" cy="4754880"/>
+            <a:off x="3127248" y="5394960"/>
+            <a:ext cx="777240" cy="649224"/>
           </a:xfrm>
           <a:prstGeom prst="roundRect">
             <a:avLst/>
@@ -9260,9 +11062,9 @@
           <a:solidFill>
             <a:srgbClr val="F8FAFC"/>
           </a:solidFill>
-          <a:ln>
+          <a:ln w="15240">
             <a:solidFill>
-              <a:srgbClr val="CBD5E1"/>
+              <a:srgbClr val="61DAFB"/>
             </a:solidFill>
           </a:ln>
         </p:spPr>
@@ -9281,152 +11083,1194 @@
           </a:fontRef>
         </p:style>
         <p:txBody>
-          <a:bodyPr rtlCol="0" anchor="ctr" wrap="square"/>
+          <a:bodyPr rtlCol="0" anchor="ctr" wrap="square" lIns="18288" rIns="18288"/>
           <a:lstStyle/>
           <a:p>
             <a:pPr algn="ctr">
-              <a:spcAft>
-                <a:spcPts val="800"/>
-              </a:spcAft>
-            </a:pPr>
-            <a:r>
-              <a:rPr sz="1300" b="1">
-                <a:solidFill>
-                  <a:srgbClr val="1A365D"/>
-                </a:solidFill>
-                <a:latin typeface="Arial"/>
-              </a:rPr>
-              <a:t>2. End-to-End Implementation Workflow</a:t>
-            </a:r>
-          </a:p>
+              <a:defRPr sz="750" b="1">
+                <a:solidFill>
+                  <a:srgbClr val="61DAFB"/>
+                </a:solidFill>
+              </a:defRPr>
+            </a:pPr>
+            <a:r>
+              <a:t>React 19</a:t>
+            </a:r>
+          </a:p>
+          <a:p>
+            <a:pPr algn="ctr">
+              <a:defRPr sz="600">
+                <a:solidFill>
+                  <a:srgbClr val="475569"/>
+                </a:solidFill>
+              </a:defRPr>
+            </a:pPr>
+            <a:r>
+              <a:t>Vite Frontend</a:t>
+            </a:r>
+          </a:p>
+        </p:txBody>
+      </p:sp>
+      <p:sp>
+        <p:nvSpPr>
+          <p:cNvPr id="17442" name="Rounded Rectangle 17441"/>
+          <p:cNvSpPr/>
+          <p:nvPr/>
+        </p:nvSpPr>
+        <p:spPr>
+          <a:xfrm>
+            <a:off x="3968496" y="5394960"/>
+            <a:ext cx="777240" cy="649224"/>
+          </a:xfrm>
+          <a:prstGeom prst="roundRect">
+            <a:avLst/>
+          </a:prstGeom>
+          <a:solidFill>
+            <a:srgbClr val="F8FAFC"/>
+          </a:solidFill>
+          <a:ln w="15240">
+            <a:solidFill>
+              <a:srgbClr val="EB6E32"/>
+            </a:solidFill>
+          </a:ln>
+        </p:spPr>
+        <p:style>
+          <a:lnRef idx="1">
+            <a:schemeClr val="accent1"/>
+          </a:lnRef>
+          <a:fillRef idx="3">
+            <a:schemeClr val="accent1"/>
+          </a:fillRef>
+          <a:effectRef idx="2">
+            <a:schemeClr val="accent1"/>
+          </a:effectRef>
+          <a:fontRef idx="minor">
+            <a:schemeClr val="lt1"/>
+          </a:fontRef>
+        </p:style>
+        <p:txBody>
+          <a:bodyPr rtlCol="0" anchor="ctr" wrap="square" lIns="18288" rIns="18288"/>
+          <a:lstStyle/>
+          <a:p>
+            <a:pPr algn="ctr">
+              <a:defRPr sz="750" b="1">
+                <a:solidFill>
+                  <a:srgbClr val="EB6E32"/>
+                </a:solidFill>
+              </a:defRPr>
+            </a:pPr>
+            <a:r>
+              <a:t>XGBoost 2.1</a:t>
+            </a:r>
+          </a:p>
+          <a:p>
+            <a:pPr algn="ctr">
+              <a:defRPr sz="600">
+                <a:solidFill>
+                  <a:srgbClr val="475569"/>
+                </a:solidFill>
+              </a:defRPr>
+            </a:pPr>
+            <a:r>
+              <a:t>ML Regressor</a:t>
+            </a:r>
+          </a:p>
+        </p:txBody>
+      </p:sp>
+      <p:sp>
+        <p:nvSpPr>
+          <p:cNvPr id="17443" name="Rounded Rectangle 17442"/>
+          <p:cNvSpPr/>
+          <p:nvPr/>
+        </p:nvSpPr>
+        <p:spPr>
+          <a:xfrm>
+            <a:off x="4809744" y="5394960"/>
+            <a:ext cx="777240" cy="649224"/>
+          </a:xfrm>
+          <a:prstGeom prst="roundRect">
+            <a:avLst/>
+          </a:prstGeom>
+          <a:solidFill>
+            <a:srgbClr val="F8FAFC"/>
+          </a:solidFill>
+          <a:ln w="15240">
+            <a:solidFill>
+              <a:srgbClr val="FF8C00"/>
+            </a:solidFill>
+          </a:ln>
+        </p:spPr>
+        <p:style>
+          <a:lnRef idx="1">
+            <a:schemeClr val="accent1"/>
+          </a:lnRef>
+          <a:fillRef idx="3">
+            <a:schemeClr val="accent1"/>
+          </a:fillRef>
+          <a:effectRef idx="2">
+            <a:schemeClr val="accent1"/>
+          </a:effectRef>
+          <a:fontRef idx="minor">
+            <a:schemeClr val="lt1"/>
+          </a:fontRef>
+        </p:style>
+        <p:txBody>
+          <a:bodyPr rtlCol="0" anchor="ctr" wrap="square" lIns="18288" rIns="18288"/>
+          <a:lstStyle/>
+          <a:p>
+            <a:pPr algn="ctr">
+              <a:defRPr sz="750" b="1">
+                <a:solidFill>
+                  <a:srgbClr val="FF8C00"/>
+                </a:solidFill>
+              </a:defRPr>
+            </a:pPr>
+            <a:r>
+              <a:t>LightGBM</a:t>
+            </a:r>
+          </a:p>
+          <a:p>
+            <a:pPr algn="ctr">
+              <a:defRPr sz="600">
+                <a:solidFill>
+                  <a:srgbClr val="475569"/>
+                </a:solidFill>
+              </a:defRPr>
+            </a:pPr>
+            <a:r>
+              <a:t>Gradient Trees</a:t>
+            </a:r>
+          </a:p>
+        </p:txBody>
+      </p:sp>
+      <p:sp>
+        <p:nvSpPr>
+          <p:cNvPr id="17444" name="Rounded Rectangle 17443"/>
+          <p:cNvSpPr/>
+          <p:nvPr/>
+        </p:nvSpPr>
+        <p:spPr>
+          <a:xfrm>
+            <a:off x="5650992" y="5394960"/>
+            <a:ext cx="777240" cy="649224"/>
+          </a:xfrm>
+          <a:prstGeom prst="roundRect">
+            <a:avLst/>
+          </a:prstGeom>
+          <a:solidFill>
+            <a:srgbClr val="F8FAFC"/>
+          </a:solidFill>
+          <a:ln w="15240">
+            <a:solidFill>
+              <a:srgbClr val="2E7D32"/>
+            </a:solidFill>
+          </a:ln>
+        </p:spPr>
+        <p:style>
+          <a:lnRef idx="1">
+            <a:schemeClr val="accent1"/>
+          </a:lnRef>
+          <a:fillRef idx="3">
+            <a:schemeClr val="accent1"/>
+          </a:fillRef>
+          <a:effectRef idx="2">
+            <a:schemeClr val="accent1"/>
+          </a:effectRef>
+          <a:fontRef idx="minor">
+            <a:schemeClr val="lt1"/>
+          </a:fontRef>
+        </p:style>
+        <p:txBody>
+          <a:bodyPr rtlCol="0" anchor="ctr" wrap="square" lIns="18288" rIns="18288"/>
+          <a:lstStyle/>
+          <a:p>
+            <a:pPr algn="ctr">
+              <a:defRPr sz="750" b="1">
+                <a:solidFill>
+                  <a:srgbClr val="2E7D32"/>
+                </a:solidFill>
+              </a:defRPr>
+            </a:pPr>
+            <a:r>
+              <a:t>TreeSHAP</a:t>
+            </a:r>
+          </a:p>
+          <a:p>
+            <a:pPr algn="ctr">
+              <a:defRPr sz="600">
+                <a:solidFill>
+                  <a:srgbClr val="475569"/>
+                </a:solidFill>
+              </a:defRPr>
+            </a:pPr>
+            <a:r>
+              <a:t>Statutory XAI</a:t>
+            </a:r>
+          </a:p>
+        </p:txBody>
+      </p:sp>
+      <p:sp>
+        <p:nvSpPr>
+          <p:cNvPr id="17445" name="Rounded Rectangle 17444"/>
+          <p:cNvSpPr/>
+          <p:nvPr/>
+        </p:nvSpPr>
+        <p:spPr>
+          <a:xfrm>
+            <a:off x="6492240" y="5394960"/>
+            <a:ext cx="777240" cy="649224"/>
+          </a:xfrm>
+          <a:prstGeom prst="roundRect">
+            <a:avLst/>
+          </a:prstGeom>
+          <a:solidFill>
+            <a:srgbClr val="F8FAFC"/>
+          </a:solidFill>
+          <a:ln w="15240">
+            <a:solidFill>
+              <a:srgbClr val="1565C0"/>
+            </a:solidFill>
+          </a:ln>
+        </p:spPr>
+        <p:style>
+          <a:lnRef idx="1">
+            <a:schemeClr val="accent1"/>
+          </a:lnRef>
+          <a:fillRef idx="3">
+            <a:schemeClr val="accent1"/>
+          </a:fillRef>
+          <a:effectRef idx="2">
+            <a:schemeClr val="accent1"/>
+          </a:effectRef>
+          <a:fontRef idx="minor">
+            <a:schemeClr val="lt1"/>
+          </a:fontRef>
+        </p:style>
+        <p:txBody>
+          <a:bodyPr rtlCol="0" anchor="ctr" wrap="square" lIns="18288" rIns="18288"/>
+          <a:lstStyle/>
+          <a:p>
+            <a:pPr algn="ctr">
+              <a:defRPr sz="750" b="1">
+                <a:solidFill>
+                  <a:srgbClr val="1565C0"/>
+                </a:solidFill>
+              </a:defRPr>
+            </a:pPr>
+            <a:r>
+              <a:t>Leaflet GIS</a:t>
+            </a:r>
+          </a:p>
+          <a:p>
+            <a:pPr algn="ctr">
+              <a:defRPr sz="600">
+                <a:solidFill>
+                  <a:srgbClr val="475569"/>
+                </a:solidFill>
+              </a:defRPr>
+            </a:pPr>
+            <a:r>
+              <a:t>EPSG:4326 GeoJSON</a:t>
+            </a:r>
+          </a:p>
+        </p:txBody>
+      </p:sp>
+      <p:sp>
+        <p:nvSpPr>
+          <p:cNvPr id="17446" name="Rounded Rectangle 17445"/>
+          <p:cNvSpPr/>
+          <p:nvPr/>
+        </p:nvSpPr>
+        <p:spPr>
+          <a:xfrm>
+            <a:off x="7333488" y="5394960"/>
+            <a:ext cx="777240" cy="649224"/>
+          </a:xfrm>
+          <a:prstGeom prst="roundRect">
+            <a:avLst/>
+          </a:prstGeom>
+          <a:solidFill>
+            <a:srgbClr val="F8FAFC"/>
+          </a:solidFill>
+          <a:ln w="15240">
+            <a:solidFill>
+              <a:srgbClr val="336791"/>
+            </a:solidFill>
+          </a:ln>
+        </p:spPr>
+        <p:style>
+          <a:lnRef idx="1">
+            <a:schemeClr val="accent1"/>
+          </a:lnRef>
+          <a:fillRef idx="3">
+            <a:schemeClr val="accent1"/>
+          </a:fillRef>
+          <a:effectRef idx="2">
+            <a:schemeClr val="accent1"/>
+          </a:effectRef>
+          <a:fontRef idx="minor">
+            <a:schemeClr val="lt1"/>
+          </a:fontRef>
+        </p:style>
+        <p:txBody>
+          <a:bodyPr rtlCol="0" anchor="ctr" wrap="square" lIns="18288" rIns="18288"/>
+          <a:lstStyle/>
+          <a:p>
+            <a:pPr algn="ctr">
+              <a:defRPr sz="750" b="1">
+                <a:solidFill>
+                  <a:srgbClr val="336791"/>
+                </a:solidFill>
+              </a:defRPr>
+            </a:pPr>
+            <a:r>
+              <a:t>PostgreSQL</a:t>
+            </a:r>
+          </a:p>
+          <a:p>
+            <a:pPr algn="ctr">
+              <a:defRPr sz="600">
+                <a:solidFill>
+                  <a:srgbClr val="475569"/>
+                </a:solidFill>
+              </a:defRPr>
+            </a:pPr>
+            <a:r>
+              <a:t>&lt;15ms DB Cache</a:t>
+            </a:r>
+          </a:p>
+        </p:txBody>
+      </p:sp>
+      <p:sp>
+        <p:nvSpPr>
+          <p:cNvPr id="17447" name="Rounded Rectangle 17446"/>
+          <p:cNvSpPr/>
+          <p:nvPr/>
+        </p:nvSpPr>
+        <p:spPr>
+          <a:xfrm>
+            <a:off x="8174736" y="5394960"/>
+            <a:ext cx="777240" cy="649224"/>
+          </a:xfrm>
+          <a:prstGeom prst="roundRect">
+            <a:avLst/>
+          </a:prstGeom>
+          <a:solidFill>
+            <a:srgbClr val="F8FAFC"/>
+          </a:solidFill>
+          <a:ln w="15240">
+            <a:solidFill>
+              <a:srgbClr val="8E24AA"/>
+            </a:solidFill>
+          </a:ln>
+        </p:spPr>
+        <p:style>
+          <a:lnRef idx="1">
+            <a:schemeClr val="accent1"/>
+          </a:lnRef>
+          <a:fillRef idx="3">
+            <a:schemeClr val="accent1"/>
+          </a:fillRef>
+          <a:effectRef idx="2">
+            <a:schemeClr val="accent1"/>
+          </a:effectRef>
+          <a:fontRef idx="minor">
+            <a:schemeClr val="lt1"/>
+          </a:fontRef>
+        </p:style>
+        <p:txBody>
+          <a:bodyPr rtlCol="0" anchor="ctr" wrap="square" lIns="18288" rIns="18288"/>
+          <a:lstStyle/>
+          <a:p>
+            <a:pPr algn="ctr">
+              <a:defRPr sz="750" b="1">
+                <a:solidFill>
+                  <a:srgbClr val="8E24AA"/>
+                </a:solidFill>
+              </a:defRPr>
+            </a:pPr>
+            <a:r>
+              <a:t>SHA-256</a:t>
+            </a:r>
+          </a:p>
+          <a:p>
+            <a:pPr algn="ctr">
+              <a:defRPr sz="600">
+                <a:solidFill>
+                  <a:srgbClr val="475569"/>
+                </a:solidFill>
+              </a:defRPr>
+            </a:pPr>
+            <a:r>
+              <a:t>Audit Ledger</a:t>
+            </a:r>
+          </a:p>
+        </p:txBody>
+      </p:sp>
+      <p:sp>
+        <p:nvSpPr>
+          <p:cNvPr id="17448" name="Rounded Rectangle 17447"/>
+          <p:cNvSpPr/>
+          <p:nvPr/>
+        </p:nvSpPr>
+        <p:spPr>
+          <a:xfrm>
+            <a:off x="9189720" y="1024128"/>
+            <a:ext cx="2560320" cy="5129784"/>
+          </a:xfrm>
+          <a:prstGeom prst="roundRect">
+            <a:avLst/>
+          </a:prstGeom>
+          <a:solidFill>
+            <a:srgbClr val="FFFFFF"/>
+          </a:solidFill>
+          <a:ln w="15240">
+            <a:solidFill>
+              <a:srgbClr val="CBD5E1"/>
+            </a:solidFill>
+          </a:ln>
+        </p:spPr>
+        <p:style>
+          <a:lnRef idx="1">
+            <a:schemeClr val="accent1"/>
+          </a:lnRef>
+          <a:fillRef idx="3">
+            <a:schemeClr val="accent1"/>
+          </a:fillRef>
+          <a:effectRef idx="2">
+            <a:schemeClr val="accent1"/>
+          </a:effectRef>
+          <a:fontRef idx="minor">
+            <a:schemeClr val="lt1"/>
+          </a:fontRef>
+        </p:style>
+        <p:txBody>
+          <a:bodyPr rtlCol="0" anchor="ctr"/>
+          <a:lstStyle/>
+          <a:p>
+            <a:pPr algn="ctr"/>
+          </a:p>
+        </p:txBody>
+      </p:sp>
+      <p:sp>
+        <p:nvSpPr>
+          <p:cNvPr id="17449" name="TextBox 17448"/>
+          <p:cNvSpPr txBox="1"/>
+          <p:nvPr/>
+        </p:nvSpPr>
+        <p:spPr>
+          <a:xfrm>
+            <a:off x="9189720" y="1078992"/>
+            <a:ext cx="2560320" cy="320040"/>
+          </a:xfrm>
+          <a:prstGeom prst="rect">
+            <a:avLst/>
+          </a:prstGeom>
+          <a:noFill/>
+        </p:spPr>
+        <p:txBody>
+          <a:bodyPr wrap="none">
+            <a:spAutoFit/>
+          </a:bodyPr>
+          <a:lstStyle/>
+          <a:p>
+            <a:pPr algn="ctr">
+              <a:defRPr sz="1200" b="1">
+                <a:solidFill>
+                  <a:srgbClr val="C2185B"/>
+                </a:solidFill>
+                <a:latin typeface="Arial"/>
+              </a:defRPr>
+            </a:pPr>
+            <a:r>
+              <a:t>🎯 Implementation Process</a:t>
+            </a:r>
+          </a:p>
+        </p:txBody>
+      </p:sp>
+      <p:sp>
+        <p:nvSpPr>
+          <p:cNvPr id="17450" name="Rectangle 17449"/>
+          <p:cNvSpPr/>
+          <p:nvPr/>
+        </p:nvSpPr>
+        <p:spPr>
+          <a:xfrm>
+            <a:off x="9537192" y="1572768"/>
+            <a:ext cx="36576" cy="4297680"/>
+          </a:xfrm>
+          <a:prstGeom prst="rect">
+            <a:avLst/>
+          </a:prstGeom>
+          <a:solidFill>
+            <a:srgbClr val="E2E8F0"/>
+          </a:solidFill>
+          <a:ln w="6350">
+            <a:solidFill>
+              <a:srgbClr val="CBD5E1"/>
+            </a:solidFill>
+          </a:ln>
+        </p:spPr>
+        <p:style>
+          <a:lnRef idx="1">
+            <a:schemeClr val="accent1"/>
+          </a:lnRef>
+          <a:fillRef idx="3">
+            <a:schemeClr val="accent1"/>
+          </a:fillRef>
+          <a:effectRef idx="2">
+            <a:schemeClr val="accent1"/>
+          </a:effectRef>
+          <a:fontRef idx="minor">
+            <a:schemeClr val="lt1"/>
+          </a:fontRef>
+        </p:style>
+        <p:txBody>
+          <a:bodyPr rtlCol="0" anchor="ctr"/>
+          <a:lstStyle/>
+          <a:p>
+            <a:pPr algn="ctr"/>
+          </a:p>
+        </p:txBody>
+      </p:sp>
+      <p:sp>
+        <p:nvSpPr>
+          <p:cNvPr id="17451" name="Oval 17450"/>
+          <p:cNvSpPr/>
+          <p:nvPr/>
+        </p:nvSpPr>
+        <p:spPr>
+          <a:xfrm>
+            <a:off x="9354312" y="1536192"/>
+            <a:ext cx="402336" cy="402336"/>
+          </a:xfrm>
+          <a:prstGeom prst="ellipse">
+            <a:avLst/>
+          </a:prstGeom>
+          <a:solidFill>
+            <a:srgbClr val="00695C"/>
+          </a:solidFill>
+          <a:ln w="19050">
+            <a:solidFill>
+              <a:srgbClr val="FFFFFF"/>
+            </a:solidFill>
+          </a:ln>
+        </p:spPr>
+        <p:style>
+          <a:lnRef idx="1">
+            <a:schemeClr val="accent1"/>
+          </a:lnRef>
+          <a:fillRef idx="3">
+            <a:schemeClr val="accent1"/>
+          </a:fillRef>
+          <a:effectRef idx="2">
+            <a:schemeClr val="accent1"/>
+          </a:effectRef>
+          <a:fontRef idx="minor">
+            <a:schemeClr val="lt1"/>
+          </a:fontRef>
+        </p:style>
+        <p:txBody>
+          <a:bodyPr rtlCol="0" anchor="ctr"/>
+          <a:lstStyle/>
+          <a:p>
+            <a:pPr algn="ctr">
+              <a:defRPr sz="1000" b="1">
+                <a:solidFill>
+                  <a:srgbClr val="FFFFFF"/>
+                </a:solidFill>
+                <a:latin typeface="Arial"/>
+              </a:defRPr>
+            </a:pPr>
+            <a:r>
+              <a:t>1</a:t>
+            </a:r>
+          </a:p>
+        </p:txBody>
+      </p:sp>
+      <p:sp>
+        <p:nvSpPr>
+          <p:cNvPr id="17452" name="TextBox 17451"/>
+          <p:cNvSpPr txBox="1"/>
+          <p:nvPr/>
+        </p:nvSpPr>
+        <p:spPr>
+          <a:xfrm>
+            <a:off x="9811512" y="1463040"/>
+            <a:ext cx="1883664" cy="731520"/>
+          </a:xfrm>
+          <a:prstGeom prst="rect">
+            <a:avLst/>
+          </a:prstGeom>
+          <a:noFill/>
+        </p:spPr>
+        <p:txBody>
+          <a:bodyPr wrap="square" anchor="t" lIns="18288" rIns="18288" tIns="36576" bIns="18288">
+            <a:spAutoFit/>
+          </a:bodyPr>
+          <a:lstStyle/>
           <a:p>
             <a:pPr>
               <a:spcAft>
-                <a:spcPts val="600"/>
+                <a:spcPts val="100"/>
               </a:spcAft>
-            </a:pPr>
-            <a:r>
-              <a:rPr sz="950" b="1">
-                <a:solidFill>
-                  <a:srgbClr val="059669"/>
-                </a:solidFill>
-                <a:latin typeface="Arial"/>
-              </a:rPr>
-              <a:t>Step 1: Multi-Modal Ingestion &amp; Normalization
-</a:t>
-            </a:r>
-            <a:r>
-              <a:rPr sz="850">
-                <a:solidFill>
-                  <a:srgbClr val="1E293B"/>
-                </a:solidFill>
-                <a:latin typeface="Arial"/>
-              </a:rPr>
-              <a:t>   Central DB pre-extracts 47 statutory attributes across land, legal, and engineering categories. Maps regional variations (Khasra, Jamabandi, 7/12) into standard NH Act stages.</a:t>
-            </a:r>
-          </a:p>
+              <a:defRPr sz="850" b="1">
+                <a:solidFill>
+                  <a:srgbClr val="00695C"/>
+                </a:solidFill>
+                <a:latin typeface="Arial"/>
+              </a:defRPr>
+            </a:pPr>
+            <a:r>
+              <a:t>1. Multi-Modal Ingestion</a:t>
+            </a:r>
+          </a:p>
+          <a:p>
+            <a:pPr>
+              <a:defRPr sz="700">
+                <a:solidFill>
+                  <a:srgbClr val="475569"/>
+                </a:solidFill>
+                <a:latin typeface="Arial"/>
+              </a:defRPr>
+            </a:pPr>
+            <a:r>
+              <a:t>Gazette PDFs, e-Courts stays, cadastral Jamabandi records &amp; BhoomiRashi data parsed into pipeline.</a:t>
+            </a:r>
+          </a:p>
+        </p:txBody>
+      </p:sp>
+      <p:sp>
+        <p:nvSpPr>
+          <p:cNvPr id="17453" name="Oval 17452"/>
+          <p:cNvSpPr/>
+          <p:nvPr/>
+        </p:nvSpPr>
+        <p:spPr>
+          <a:xfrm>
+            <a:off x="9354312" y="2295144"/>
+            <a:ext cx="402336" cy="402336"/>
+          </a:xfrm>
+          <a:prstGeom prst="ellipse">
+            <a:avLst/>
+          </a:prstGeom>
+          <a:solidFill>
+            <a:srgbClr val="263238"/>
+          </a:solidFill>
+          <a:ln w="19050">
+            <a:solidFill>
+              <a:srgbClr val="FFFFFF"/>
+            </a:solidFill>
+          </a:ln>
+        </p:spPr>
+        <p:style>
+          <a:lnRef idx="1">
+            <a:schemeClr val="accent1"/>
+          </a:lnRef>
+          <a:fillRef idx="3">
+            <a:schemeClr val="accent1"/>
+          </a:fillRef>
+          <a:effectRef idx="2">
+            <a:schemeClr val="accent1"/>
+          </a:effectRef>
+          <a:fontRef idx="minor">
+            <a:schemeClr val="lt1"/>
+          </a:fontRef>
+        </p:style>
+        <p:txBody>
+          <a:bodyPr rtlCol="0" anchor="ctr"/>
+          <a:lstStyle/>
+          <a:p>
+            <a:pPr algn="ctr">
+              <a:defRPr sz="1000" b="1">
+                <a:solidFill>
+                  <a:srgbClr val="FFFFFF"/>
+                </a:solidFill>
+                <a:latin typeface="Arial"/>
+              </a:defRPr>
+            </a:pPr>
+            <a:r>
+              <a:t>2</a:t>
+            </a:r>
+          </a:p>
+        </p:txBody>
+      </p:sp>
+      <p:sp>
+        <p:nvSpPr>
+          <p:cNvPr id="17454" name="TextBox 17453"/>
+          <p:cNvSpPr txBox="1"/>
+          <p:nvPr/>
+        </p:nvSpPr>
+        <p:spPr>
+          <a:xfrm>
+            <a:off x="9811512" y="2221992"/>
+            <a:ext cx="1883664" cy="731520"/>
+          </a:xfrm>
+          <a:prstGeom prst="rect">
+            <a:avLst/>
+          </a:prstGeom>
+          <a:noFill/>
+        </p:spPr>
+        <p:txBody>
+          <a:bodyPr wrap="square" anchor="t" lIns="18288" rIns="18288" tIns="36576" bIns="18288">
+            <a:spAutoFit/>
+          </a:bodyPr>
+          <a:lstStyle/>
           <a:p>
             <a:pPr>
               <a:spcAft>
-                <a:spcPts val="600"/>
+                <a:spcPts val="100"/>
               </a:spcAft>
-            </a:pPr>
-            <a:r>
-              <a:rPr sz="950" b="1">
-                <a:solidFill>
-                  <a:srgbClr val="059669"/>
-                </a:solidFill>
-                <a:latin typeface="Arial"/>
-              </a:rPr>
-              <a:t>Step 2: Dual Ensemble Model Inference (&lt;100ms)
-</a:t>
-            </a:r>
-            <a:r>
-              <a:rPr sz="850">
-                <a:solidFill>
-                  <a:srgbClr val="1E293B"/>
-                </a:solidFill>
-                <a:latin typeface="Arial"/>
-              </a:rPr>
-              <a:t>   LightGBM + XGBoost regressors predict residual delay days (R²=0.89, RMSE=14.2d); classification head stratifies corridor risk into Critical (&gt;90d), Moderate (30-90d), and Low (&lt;30d).</a:t>
-            </a:r>
-          </a:p>
+              <a:defRPr sz="850" b="1">
+                <a:solidFill>
+                  <a:srgbClr val="263238"/>
+                </a:solidFill>
+                <a:latin typeface="Arial"/>
+              </a:defRPr>
+            </a:pPr>
+            <a:r>
+              <a:t>2. Decoupled Central DB</a:t>
+            </a:r>
+          </a:p>
+          <a:p>
+            <a:pPr>
+              <a:defRPr sz="700">
+                <a:solidFill>
+                  <a:srgbClr val="475569"/>
+                </a:solidFill>
+                <a:latin typeface="Arial"/>
+              </a:defRPr>
+            </a:pPr>
+            <a:r>
+              <a:t>Normalizes 47 statutory attributes into high-speed SQLite/PostgreSQL cache with &lt;15ms queries.</a:t>
+            </a:r>
+          </a:p>
+        </p:txBody>
+      </p:sp>
+      <p:sp>
+        <p:nvSpPr>
+          <p:cNvPr id="17455" name="Oval 17454"/>
+          <p:cNvSpPr/>
+          <p:nvPr/>
+        </p:nvSpPr>
+        <p:spPr>
+          <a:xfrm>
+            <a:off x="9354312" y="3054096"/>
+            <a:ext cx="402336" cy="402336"/>
+          </a:xfrm>
+          <a:prstGeom prst="ellipse">
+            <a:avLst/>
+          </a:prstGeom>
+          <a:solidFill>
+            <a:srgbClr val="E65100"/>
+          </a:solidFill>
+          <a:ln w="19050">
+            <a:solidFill>
+              <a:srgbClr val="FFFFFF"/>
+            </a:solidFill>
+          </a:ln>
+        </p:spPr>
+        <p:style>
+          <a:lnRef idx="1">
+            <a:schemeClr val="accent1"/>
+          </a:lnRef>
+          <a:fillRef idx="3">
+            <a:schemeClr val="accent1"/>
+          </a:fillRef>
+          <a:effectRef idx="2">
+            <a:schemeClr val="accent1"/>
+          </a:effectRef>
+          <a:fontRef idx="minor">
+            <a:schemeClr val="lt1"/>
+          </a:fontRef>
+        </p:style>
+        <p:txBody>
+          <a:bodyPr rtlCol="0" anchor="ctr"/>
+          <a:lstStyle/>
+          <a:p>
+            <a:pPr algn="ctr">
+              <a:defRPr sz="1000" b="1">
+                <a:solidFill>
+                  <a:srgbClr val="FFFFFF"/>
+                </a:solidFill>
+                <a:latin typeface="Arial"/>
+              </a:defRPr>
+            </a:pPr>
+            <a:r>
+              <a:t>3</a:t>
+            </a:r>
+          </a:p>
+        </p:txBody>
+      </p:sp>
+      <p:sp>
+        <p:nvSpPr>
+          <p:cNvPr id="17456" name="TextBox 17455"/>
+          <p:cNvSpPr txBox="1"/>
+          <p:nvPr/>
+        </p:nvSpPr>
+        <p:spPr>
+          <a:xfrm>
+            <a:off x="9811512" y="2980944"/>
+            <a:ext cx="1883664" cy="731520"/>
+          </a:xfrm>
+          <a:prstGeom prst="rect">
+            <a:avLst/>
+          </a:prstGeom>
+          <a:noFill/>
+        </p:spPr>
+        <p:txBody>
+          <a:bodyPr wrap="square" anchor="t" lIns="18288" rIns="18288" tIns="36576" bIns="18288">
+            <a:spAutoFit/>
+          </a:bodyPr>
+          <a:lstStyle/>
           <a:p>
             <a:pPr>
               <a:spcAft>
-                <a:spcPts val="600"/>
+                <a:spcPts val="100"/>
               </a:spcAft>
-            </a:pPr>
-            <a:r>
-              <a:rPr sz="950" b="1">
-                <a:solidFill>
-                  <a:srgbClr val="059669"/>
-                </a:solidFill>
-                <a:latin typeface="Arial"/>
-              </a:rPr>
-              <a:t>Step 3: TreeSHAP Marginal Factor Attribution
-</a:t>
-            </a:r>
-            <a:r>
-              <a:rPr sz="850">
-                <a:solidFill>
-                  <a:srgbClr val="1E293B"/>
-                </a:solidFill>
-                <a:latin typeface="Arial"/>
-              </a:rPr>
-              <a:t>   Computes exact additive day impacts for each feature (court stays, compensation lag, missing deeds, environmental clearances) relative to base expected horizon (70.0d).</a:t>
-            </a:r>
-          </a:p>
+              <a:defRPr sz="850" b="1">
+                <a:solidFill>
+                  <a:srgbClr val="E65100"/>
+                </a:solidFill>
+                <a:latin typeface="Arial"/>
+              </a:defRPr>
+            </a:pPr>
+            <a:r>
+              <a:t>3. Ensemble ML Inference</a:t>
+            </a:r>
+          </a:p>
+          <a:p>
+            <a:pPr>
+              <a:defRPr sz="700">
+                <a:solidFill>
+                  <a:srgbClr val="475569"/>
+                </a:solidFill>
+                <a:latin typeface="Arial"/>
+              </a:defRPr>
+            </a:pPr>
+            <a:r>
+              <a:t>XGBoost 2.1 &amp; LightGBM regressors predict residual acquisition days &amp; statutory lapse risks.</a:t>
+            </a:r>
+          </a:p>
+        </p:txBody>
+      </p:sp>
+      <p:sp>
+        <p:nvSpPr>
+          <p:cNvPr id="17457" name="Oval 17456"/>
+          <p:cNvSpPr/>
+          <p:nvPr/>
+        </p:nvSpPr>
+        <p:spPr>
+          <a:xfrm>
+            <a:off x="9354312" y="3813048"/>
+            <a:ext cx="402336" cy="402336"/>
+          </a:xfrm>
+          <a:prstGeom prst="ellipse">
+            <a:avLst/>
+          </a:prstGeom>
+          <a:solidFill>
+            <a:srgbClr val="33691E"/>
+          </a:solidFill>
+          <a:ln w="19050">
+            <a:solidFill>
+              <a:srgbClr val="FFFFFF"/>
+            </a:solidFill>
+          </a:ln>
+        </p:spPr>
+        <p:style>
+          <a:lnRef idx="1">
+            <a:schemeClr val="accent1"/>
+          </a:lnRef>
+          <a:fillRef idx="3">
+            <a:schemeClr val="accent1"/>
+          </a:fillRef>
+          <a:effectRef idx="2">
+            <a:schemeClr val="accent1"/>
+          </a:effectRef>
+          <a:fontRef idx="minor">
+            <a:schemeClr val="lt1"/>
+          </a:fontRef>
+        </p:style>
+        <p:txBody>
+          <a:bodyPr rtlCol="0" anchor="ctr"/>
+          <a:lstStyle/>
+          <a:p>
+            <a:pPr algn="ctr">
+              <a:defRPr sz="1000" b="1">
+                <a:solidFill>
+                  <a:srgbClr val="FFFFFF"/>
+                </a:solidFill>
+                <a:latin typeface="Arial"/>
+              </a:defRPr>
+            </a:pPr>
+            <a:r>
+              <a:t>4</a:t>
+            </a:r>
+          </a:p>
+        </p:txBody>
+      </p:sp>
+      <p:sp>
+        <p:nvSpPr>
+          <p:cNvPr id="17458" name="TextBox 17457"/>
+          <p:cNvSpPr txBox="1"/>
+          <p:nvPr/>
+        </p:nvSpPr>
+        <p:spPr>
+          <a:xfrm>
+            <a:off x="9811512" y="3739896"/>
+            <a:ext cx="1883664" cy="731520"/>
+          </a:xfrm>
+          <a:prstGeom prst="rect">
+            <a:avLst/>
+          </a:prstGeom>
+          <a:noFill/>
+        </p:spPr>
+        <p:txBody>
+          <a:bodyPr wrap="square" anchor="t" lIns="18288" rIns="18288" tIns="36576" bIns="18288">
+            <a:spAutoFit/>
+          </a:bodyPr>
+          <a:lstStyle/>
           <a:p>
             <a:pPr>
               <a:spcAft>
-                <a:spcPts val="600"/>
+                <a:spcPts val="100"/>
               </a:spcAft>
-            </a:pPr>
-            <a:r>
-              <a:rPr sz="950" b="1">
-                <a:solidFill>
-                  <a:srgbClr val="059669"/>
-                </a:solidFill>
-                <a:latin typeface="Arial"/>
-              </a:rPr>
-              <a:t>Step 4: Geospatial Alignment &amp; Package Stratification
-</a:t>
-            </a:r>
-            <a:r>
-              <a:rPr sz="850">
-                <a:solidFill>
-                  <a:srgbClr val="1E293B"/>
-                </a:solidFill>
-                <a:latin typeface="Arial"/>
-              </a:rPr>
-              <a:t>   Aligns 340.8 km Purvanchal corridor into 8 construction packages and 18 RoW cadastral strips, rendering interactive choropleth maps and ECharts package delay breakdowns.</a:t>
-            </a:r>
-          </a:p>
+              <a:defRPr sz="850" b="1">
+                <a:solidFill>
+                  <a:srgbClr val="33691E"/>
+                </a:solidFill>
+                <a:latin typeface="Arial"/>
+              </a:defRPr>
+            </a:pPr>
+            <a:r>
+              <a:t>4. TreeSHAP Attribution</a:t>
+            </a:r>
+          </a:p>
+          <a:p>
+            <a:pPr>
+              <a:defRPr sz="700">
+                <a:solidFill>
+                  <a:srgbClr val="475569"/>
+                </a:solidFill>
+                <a:latin typeface="Arial"/>
+              </a:defRPr>
+            </a:pPr>
+            <a:r>
+              <a:t>Deconstructs prediction into exact additive marginal delay days per statutory obstacle.</a:t>
+            </a:r>
+          </a:p>
+        </p:txBody>
+      </p:sp>
+      <p:sp>
+        <p:nvSpPr>
+          <p:cNvPr id="17459" name="Oval 17458"/>
+          <p:cNvSpPr/>
+          <p:nvPr/>
+        </p:nvSpPr>
+        <p:spPr>
+          <a:xfrm>
+            <a:off x="9354312" y="4572000"/>
+            <a:ext cx="402336" cy="402336"/>
+          </a:xfrm>
+          <a:prstGeom prst="ellipse">
+            <a:avLst/>
+          </a:prstGeom>
+          <a:solidFill>
+            <a:srgbClr val="BF360C"/>
+          </a:solidFill>
+          <a:ln w="19050">
+            <a:solidFill>
+              <a:srgbClr val="FFFFFF"/>
+            </a:solidFill>
+          </a:ln>
+        </p:spPr>
+        <p:style>
+          <a:lnRef idx="1">
+            <a:schemeClr val="accent1"/>
+          </a:lnRef>
+          <a:fillRef idx="3">
+            <a:schemeClr val="accent1"/>
+          </a:fillRef>
+          <a:effectRef idx="2">
+            <a:schemeClr val="accent1"/>
+          </a:effectRef>
+          <a:fontRef idx="minor">
+            <a:schemeClr val="lt1"/>
+          </a:fontRef>
+        </p:style>
+        <p:txBody>
+          <a:bodyPr rtlCol="0" anchor="ctr"/>
+          <a:lstStyle/>
+          <a:p>
+            <a:pPr algn="ctr">
+              <a:defRPr sz="1000" b="1">
+                <a:solidFill>
+                  <a:srgbClr val="FFFFFF"/>
+                </a:solidFill>
+                <a:latin typeface="Arial"/>
+              </a:defRPr>
+            </a:pPr>
+            <a:r>
+              <a:t>5</a:t>
+            </a:r>
+          </a:p>
+        </p:txBody>
+      </p:sp>
+      <p:sp>
+        <p:nvSpPr>
+          <p:cNvPr id="17460" name="TextBox 17459"/>
+          <p:cNvSpPr txBox="1"/>
+          <p:nvPr/>
+        </p:nvSpPr>
+        <p:spPr>
+          <a:xfrm>
+            <a:off x="9811512" y="4498848"/>
+            <a:ext cx="1883664" cy="731520"/>
+          </a:xfrm>
+          <a:prstGeom prst="rect">
+            <a:avLst/>
+          </a:prstGeom>
+          <a:noFill/>
+        </p:spPr>
+        <p:txBody>
+          <a:bodyPr wrap="square" anchor="t" lIns="18288" rIns="18288" tIns="36576" bIns="18288">
+            <a:spAutoFit/>
+          </a:bodyPr>
+          <a:lstStyle/>
           <a:p>
             <a:pPr>
               <a:spcAft>
-                <a:spcPts val="600"/>
+                <a:spcPts val="100"/>
               </a:spcAft>
-            </a:pPr>
-            <a:r>
-              <a:rPr sz="950" b="1">
-                <a:solidFill>
-                  <a:srgbClr val="059669"/>
-                </a:solidFill>
-                <a:latin typeface="Arial"/>
-              </a:rPr>
-              <a:t>Step 5: Prescriptive SOP Orders &amp; e-Sign Execution
-</a:t>
-            </a:r>
-            <a:r>
-              <a:rPr sz="850">
-                <a:solidFill>
-                  <a:srgbClr val="1E293B"/>
-                </a:solidFill>
-                <a:latin typeface="Arial"/>
-              </a:rPr>
-              <a:t>   Translates model attributions into pre-drafted Drafts for Approval (DFA) under NH Act § 3D, § 3G, § 3H; enables 1-click Aadhaar DSC e-signing and SHA-256 audit ledger commitment.</a:t>
+              <a:defRPr sz="850" b="1">
+                <a:solidFill>
+                  <a:srgbClr val="BF360C"/>
+                </a:solidFill>
+                <a:latin typeface="Arial"/>
+              </a:defRPr>
+            </a:pPr>
+            <a:r>
+              <a:t>5. Prescriptive Legal DFA</a:t>
+            </a:r>
+          </a:p>
+          <a:p>
+            <a:pPr>
+              <a:defRPr sz="700">
+                <a:solidFill>
+                  <a:srgbClr val="475569"/>
+                </a:solidFill>
+                <a:latin typeface="Arial"/>
+              </a:defRPr>
+            </a:pPr>
+            <a:r>
+              <a:t>Automatically drafts statutory Section 3D, 3G &amp; 3H compliance orders for nodal officers.</a:t>
+            </a:r>
+          </a:p>
+        </p:txBody>
+      </p:sp>
+      <p:sp>
+        <p:nvSpPr>
+          <p:cNvPr id="17461" name="Oval 17460"/>
+          <p:cNvSpPr/>
+          <p:nvPr/>
+        </p:nvSpPr>
+        <p:spPr>
+          <a:xfrm>
+            <a:off x="9354312" y="5330952"/>
+            <a:ext cx="402336" cy="402336"/>
+          </a:xfrm>
+          <a:prstGeom prst="ellipse">
+            <a:avLst/>
+          </a:prstGeom>
+          <a:solidFill>
+            <a:srgbClr val="880E4F"/>
+          </a:solidFill>
+          <a:ln w="19050">
+            <a:solidFill>
+              <a:srgbClr val="FFFFFF"/>
+            </a:solidFill>
+          </a:ln>
+        </p:spPr>
+        <p:style>
+          <a:lnRef idx="1">
+            <a:schemeClr val="accent1"/>
+          </a:lnRef>
+          <a:fillRef idx="3">
+            <a:schemeClr val="accent1"/>
+          </a:fillRef>
+          <a:effectRef idx="2">
+            <a:schemeClr val="accent1"/>
+          </a:effectRef>
+          <a:fontRef idx="minor">
+            <a:schemeClr val="lt1"/>
+          </a:fontRef>
+        </p:style>
+        <p:txBody>
+          <a:bodyPr rtlCol="0" anchor="ctr"/>
+          <a:lstStyle/>
+          <a:p>
+            <a:pPr algn="ctr">
+              <a:defRPr sz="1000" b="1">
+                <a:solidFill>
+                  <a:srgbClr val="FFFFFF"/>
+                </a:solidFill>
+                <a:latin typeface="Arial"/>
+              </a:defRPr>
+            </a:pPr>
+            <a:r>
+              <a:t>6</a:t>
+            </a:r>
+          </a:p>
+        </p:txBody>
+      </p:sp>
+      <p:sp>
+        <p:nvSpPr>
+          <p:cNvPr id="17462" name="TextBox 17461"/>
+          <p:cNvSpPr txBox="1"/>
+          <p:nvPr/>
+        </p:nvSpPr>
+        <p:spPr>
+          <a:xfrm>
+            <a:off x="9811512" y="5257800"/>
+            <a:ext cx="1883664" cy="731520"/>
+          </a:xfrm>
+          <a:prstGeom prst="rect">
+            <a:avLst/>
+          </a:prstGeom>
+          <a:noFill/>
+        </p:spPr>
+        <p:txBody>
+          <a:bodyPr wrap="square" anchor="t" lIns="18288" rIns="18288" tIns="36576" bIns="18288">
+            <a:spAutoFit/>
+          </a:bodyPr>
+          <a:lstStyle/>
+          <a:p>
+            <a:pPr>
+              <a:spcAft>
+                <a:spcPts val="100"/>
+              </a:spcAft>
+              <a:defRPr sz="850" b="1">
+                <a:solidFill>
+                  <a:srgbClr val="880E4F"/>
+                </a:solidFill>
+                <a:latin typeface="Arial"/>
+              </a:defRPr>
+            </a:pPr>
+            <a:r>
+              <a:t>6. HITL e-Sign &amp; Audit</a:t>
+            </a:r>
+          </a:p>
+          <a:p>
+            <a:pPr>
+              <a:defRPr sz="700">
+                <a:solidFill>
+                  <a:srgbClr val="475569"/>
+                </a:solidFill>
+                <a:latin typeface="Arial"/>
+              </a:defRPr>
+            </a:pPr>
+            <a:r>
+              <a:t>Nodal officer validates order via Aadhaar DSC; seals tamper-proof SHA-256 block ledger for CAG.</a:t>
             </a:r>
           </a:p>
         </p:txBody>

</xml_diff>

<commit_message>
feat(sih): replace standard icons with authentic high-res tech logos and custom vector step assets in sih/assets/
</commit_message>
<xml_diff>
--- a/sih/GatiShakti_AI_SIH2026_Presentation.pptx
+++ b/sih/GatiShakti_AI_SIH2026_Presentation.pptx
@@ -9114,7 +9114,7 @@
         <p:spPr>
           <a:xfrm>
             <a:off x="457200" y="1097280"/>
-            <a:ext cx="1874519" cy="384048"/>
+            <a:ext cx="1874519" cy="365760"/>
           </a:xfrm>
           <a:prstGeom prst="roundRect">
             <a:avLst/>
@@ -9151,6 +9151,7 @@
                 <a:solidFill>
                   <a:srgbClr val="0D47A1"/>
                 </a:solidFill>
+                <a:latin typeface="Arial"/>
               </a:defRPr>
             </a:pPr>
             <a:r>
@@ -9167,8 +9168,8 @@
         </p:nvSpPr>
         <p:spPr>
           <a:xfrm>
-            <a:off x="457200" y="1572768"/>
-            <a:ext cx="1874519" cy="1554480"/>
+            <a:off x="457200" y="1536192"/>
+            <a:ext cx="1874519" cy="1691640"/>
           </a:xfrm>
           <a:prstGeom prst="roundRect">
             <a:avLst/>
@@ -9178,7 +9179,7 @@
           </a:solidFill>
           <a:ln>
             <a:solidFill>
-              <a:srgbClr val="90CAF9"/>
+              <a:srgbClr val="BBDEFB"/>
             </a:solidFill>
           </a:ln>
         </p:spPr>
@@ -9197,95 +9198,124 @@
           </a:fontRef>
         </p:style>
         <p:txBody>
-          <a:bodyPr rtlCol="0" anchor="t" wrap="square" tIns="73152" lIns="73152" rIns="73152"/>
+          <a:bodyPr rtlCol="0" anchor="t" wrap="square" tIns="54864" lIns="585216" rIns="54864"/>
           <a:lstStyle/>
           <a:p>
             <a:pPr algn="ctr">
-              <a:spcAft>
-                <a:spcPts val="400"/>
-              </a:spcAft>
-              <a:defRPr sz="800" b="1">
-                <a:solidFill>
-                  <a:srgbClr val="1976D2"/>
-                </a:solidFill>
-              </a:defRPr>
-            </a:pPr>
-            <a:r>
-              <a:t>☁️ External Services &amp; Portals</a:t>
-            </a:r>
-          </a:p>
-          <a:p>
-            <a:pPr>
               <a:spcAft>
                 <a:spcPts val="200"/>
               </a:spcAft>
-              <a:defRPr sz="700">
-                <a:solidFill>
-                  <a:srgbClr val="334155"/>
-                </a:solidFill>
+              <a:defRPr sz="850" b="1">
+                <a:solidFill>
+                  <a:srgbClr val="1976D2"/>
+                </a:solidFill>
+                <a:latin typeface="Arial"/>
               </a:defRPr>
             </a:pPr>
             <a:r>
-              <a:t>• e-Courts WSDL &amp; Judgments</a:t>
+              <a:t>External Portals</a:t>
             </a:r>
           </a:p>
           <a:p>
             <a:pPr>
               <a:spcAft>
-                <a:spcPts val="200"/>
+                <a:spcPts val="150"/>
               </a:spcAft>
-              <a:defRPr sz="700">
+              <a:defRPr sz="720">
                 <a:solidFill>
                   <a:srgbClr val="334155"/>
                 </a:solidFill>
+                <a:latin typeface="Arial"/>
               </a:defRPr>
             </a:pPr>
             <a:r>
-              <a:t>• BhoomiRashi MoRTH Portal</a:t>
+              <a:t>• e-Courts WSDL API</a:t>
             </a:r>
           </a:p>
           <a:p>
             <a:pPr>
               <a:spcAft>
-                <a:spcPts val="200"/>
+                <a:spcPts val="150"/>
               </a:spcAft>
-              <a:defRPr sz="700">
+              <a:defRPr sz="720">
                 <a:solidFill>
                   <a:srgbClr val="334155"/>
                 </a:solidFill>
+                <a:latin typeface="Arial"/>
               </a:defRPr>
             </a:pPr>
             <a:r>
-              <a:t>• State Jamabandi Cadastral</a:t>
+              <a:t>• BhoomiRashi MoRTH</a:t>
             </a:r>
           </a:p>
           <a:p>
             <a:pPr>
               <a:spcAft>
-                <a:spcPts val="200"/>
+                <a:spcPts val="150"/>
               </a:spcAft>
-              <a:defRPr sz="700">
+              <a:defRPr sz="720">
                 <a:solidFill>
                   <a:srgbClr val="334155"/>
                 </a:solidFill>
+                <a:latin typeface="Arial"/>
               </a:defRPr>
             </a:pPr>
             <a:r>
-              <a:t>• PM GatiShakti NMP Layers</a:t>
-            </a:r>
-          </a:p>
-        </p:txBody>
-      </p:sp>
-      <p:sp>
-        <p:nvSpPr>
-          <p:cNvPr id="17413" name="Rounded Rectangle 17412"/>
+              <a:t>• State Jamabandi GIS</a:t>
+            </a:r>
+          </a:p>
+          <a:p>
+            <a:pPr>
+              <a:spcAft>
+                <a:spcPts val="150"/>
+              </a:spcAft>
+              <a:defRPr sz="720">
+                <a:solidFill>
+                  <a:srgbClr val="334155"/>
+                </a:solidFill>
+                <a:latin typeface="Arial"/>
+              </a:defRPr>
+            </a:pPr>
+            <a:r>
+              <a:t>• PM GatiShakti NMP</a:t>
+            </a:r>
+          </a:p>
+        </p:txBody>
+      </p:sp>
+      <p:pic>
+        <p:nvPicPr>
+          <p:cNvPr id="17413" name="Picture 17412" descr="cloud_portals.png"/>
+          <p:cNvPicPr>
+            <a:picLocks noChangeAspect="1"/>
+          </p:cNvPicPr>
+          <p:nvPr/>
+        </p:nvPicPr>
+        <p:blipFill>
+          <a:blip r:embed="rId4"/>
+          <a:stretch>
+            <a:fillRect/>
+          </a:stretch>
+        </p:blipFill>
+        <p:spPr>
+          <a:xfrm>
+            <a:off x="566928" y="1591056"/>
+            <a:ext cx="438912" cy="293193"/>
+          </a:xfrm>
+          <a:prstGeom prst="rect">
+            <a:avLst/>
+          </a:prstGeom>
+        </p:spPr>
+      </p:pic>
+      <p:sp>
+        <p:nvSpPr>
+          <p:cNvPr id="17414" name="Rounded Rectangle 17413"/>
           <p:cNvSpPr/>
           <p:nvPr/>
         </p:nvSpPr>
         <p:spPr>
           <a:xfrm>
-            <a:off x="457200" y="3264408"/>
-            <a:ext cx="1874519" cy="1691640"/>
+            <a:off x="457200" y="3310128"/>
+            <a:ext cx="1874519" cy="1755648"/>
           </a:xfrm>
           <a:prstGeom prst="roundRect">
             <a:avLst/>
@@ -9295,7 +9325,7 @@
           </a:solidFill>
           <a:ln>
             <a:solidFill>
-              <a:srgbClr val="90CAF9"/>
+              <a:srgbClr val="BBDEFB"/>
             </a:solidFill>
           </a:ln>
         </p:spPr>
@@ -9314,109 +9344,139 @@
           </a:fontRef>
         </p:style>
         <p:txBody>
-          <a:bodyPr rtlCol="0" anchor="t" wrap="square" tIns="73152" lIns="73152" rIns="73152"/>
+          <a:bodyPr rtlCol="0" anchor="t" wrap="square" tIns="54864" lIns="585216" rIns="54864"/>
           <a:lstStyle/>
           <a:p>
             <a:pPr algn="ctr">
-              <a:spcAft>
-                <a:spcPts val="400"/>
-              </a:spcAft>
-              <a:defRPr sz="800" b="1">
-                <a:solidFill>
-                  <a:srgbClr val="1976D2"/>
-                </a:solidFill>
-              </a:defRPr>
-            </a:pPr>
-            <a:r>
-              <a:t>👥 Administrative Roles (RBAC)</a:t>
-            </a:r>
-          </a:p>
-          <a:p>
-            <a:pPr>
               <a:spcAft>
                 <a:spcPts val="200"/>
               </a:spcAft>
-              <a:defRPr sz="700">
-                <a:solidFill>
-                  <a:srgbClr val="334155"/>
-                </a:solidFill>
+              <a:defRPr sz="850" b="1">
+                <a:solidFill>
+                  <a:srgbClr val="1976D2"/>
+                </a:solidFill>
+                <a:latin typeface="Arial"/>
               </a:defRPr>
             </a:pPr>
             <a:r>
-              <a:t>• MoRTH / NPG Leadership</a:t>
+              <a:t>Statutory Roles</a:t>
             </a:r>
           </a:p>
           <a:p>
             <a:pPr>
               <a:spcAft>
-                <a:spcPts val="200"/>
+                <a:spcPts val="150"/>
               </a:spcAft>
-              <a:defRPr sz="700">
+              <a:defRPr sz="720">
                 <a:solidFill>
                   <a:srgbClr val="334155"/>
                 </a:solidFill>
+                <a:latin typeface="Arial"/>
               </a:defRPr>
             </a:pPr>
             <a:r>
-              <a:t>• NHAI Project Directors (PD)</a:t>
+              <a:t>• MoRTH &amp; NPG Lead</a:t>
             </a:r>
           </a:p>
           <a:p>
             <a:pPr>
               <a:spcAft>
-                <a:spcPts val="200"/>
+                <a:spcPts val="150"/>
               </a:spcAft>
-              <a:defRPr sz="700">
+              <a:defRPr sz="720">
                 <a:solidFill>
                   <a:srgbClr val="334155"/>
                 </a:solidFill>
+                <a:latin typeface="Arial"/>
               </a:defRPr>
             </a:pPr>
             <a:r>
-              <a:t>• CALA (Competent Authority)</a:t>
+              <a:t>• NHAI Project Director</a:t>
             </a:r>
           </a:p>
           <a:p>
             <a:pPr>
               <a:spcAft>
-                <a:spcPts val="200"/>
+                <a:spcPts val="150"/>
               </a:spcAft>
-              <a:defRPr sz="700">
+              <a:defRPr sz="720">
                 <a:solidFill>
                   <a:srgbClr val="334155"/>
                 </a:solidFill>
+                <a:latin typeface="Arial"/>
               </a:defRPr>
             </a:pPr>
             <a:r>
-              <a:t>• Lekhpal &amp; Field Tehsildars</a:t>
+              <a:t>• CALA (Land Officer)</a:t>
             </a:r>
           </a:p>
           <a:p>
             <a:pPr>
               <a:spcAft>
-                <a:spcPts val="200"/>
+                <a:spcPts val="150"/>
               </a:spcAft>
-              <a:defRPr sz="700">
+              <a:defRPr sz="720">
                 <a:solidFill>
                   <a:srgbClr val="334155"/>
                 </a:solidFill>
+                <a:latin typeface="Arial"/>
               </a:defRPr>
             </a:pPr>
             <a:r>
-              <a:t>• Affected Landowner Farmers</a:t>
-            </a:r>
-          </a:p>
-        </p:txBody>
-      </p:sp>
-      <p:sp>
-        <p:nvSpPr>
-          <p:cNvPr id="17414" name="Right Arrow 17413"/>
+              <a:t>• Field Tehsildars</a:t>
+            </a:r>
+          </a:p>
+          <a:p>
+            <a:pPr>
+              <a:spcAft>
+                <a:spcPts val="150"/>
+              </a:spcAft>
+              <a:defRPr sz="720">
+                <a:solidFill>
+                  <a:srgbClr val="334155"/>
+                </a:solidFill>
+                <a:latin typeface="Arial"/>
+              </a:defRPr>
+            </a:pPr>
+            <a:r>
+              <a:t>• Landowner Farmers</a:t>
+            </a:r>
+          </a:p>
+        </p:txBody>
+      </p:sp>
+      <p:pic>
+        <p:nvPicPr>
+          <p:cNvPr id="17415" name="Picture 17414" descr="officer_avatar.png"/>
+          <p:cNvPicPr>
+            <a:picLocks noChangeAspect="1"/>
+          </p:cNvPicPr>
+          <p:nvPr/>
+        </p:nvPicPr>
+        <p:blipFill>
+          <a:blip r:embed="rId5"/>
+          <a:stretch>
+            <a:fillRect/>
+          </a:stretch>
+        </p:blipFill>
+        <p:spPr>
+          <a:xfrm>
+            <a:off x="566928" y="3383280"/>
+            <a:ext cx="420624" cy="420624"/>
+          </a:xfrm>
+          <a:prstGeom prst="rect">
+            <a:avLst/>
+          </a:prstGeom>
+        </p:spPr>
+      </p:pic>
+      <p:sp>
+        <p:nvSpPr>
+          <p:cNvPr id="17416" name="Right Arrow 17415"/>
           <p:cNvSpPr/>
           <p:nvPr/>
         </p:nvSpPr>
         <p:spPr>
           <a:xfrm>
-            <a:off x="2359152" y="3310128"/>
+            <a:off x="2359152" y="3264408"/>
             <a:ext cx="164592" cy="128016"/>
           </a:xfrm>
           <a:prstGeom prst="rightArrow">
@@ -9455,14 +9515,14 @@
       </p:sp>
       <p:sp>
         <p:nvSpPr>
-          <p:cNvPr id="17415" name="Rounded Rectangle 17414"/>
+          <p:cNvPr id="17417" name="Rounded Rectangle 17416"/>
           <p:cNvSpPr/>
           <p:nvPr/>
         </p:nvSpPr>
         <p:spPr>
           <a:xfrm>
             <a:off x="2560320" y="1097280"/>
-            <a:ext cx="1965960" cy="384048"/>
+            <a:ext cx="1965960" cy="365760"/>
           </a:xfrm>
           <a:prstGeom prst="roundRect">
             <a:avLst/>
@@ -9499,6 +9559,7 @@
                 <a:solidFill>
                   <a:srgbClr val="1B5E20"/>
                 </a:solidFill>
+                <a:latin typeface="Arial"/>
               </a:defRPr>
             </a:pPr>
             <a:r>
@@ -9509,14 +9570,14 @@
       </p:sp>
       <p:sp>
         <p:nvSpPr>
-          <p:cNvPr id="17416" name="Rounded Rectangle 17415"/>
+          <p:cNvPr id="17418" name="Rounded Rectangle 17417"/>
           <p:cNvSpPr/>
           <p:nvPr/>
         </p:nvSpPr>
         <p:spPr>
           <a:xfrm>
-            <a:off x="2560320" y="1572768"/>
-            <a:ext cx="1965960" cy="3383280"/>
+            <a:off x="2560320" y="1536192"/>
+            <a:ext cx="1965960" cy="3529584"/>
           </a:xfrm>
           <a:prstGeom prst="roundRect">
             <a:avLst/>
@@ -9554,14 +9615,14 @@
       </p:sp>
       <p:sp>
         <p:nvSpPr>
-          <p:cNvPr id="17417" name="Rounded Rectangle 17416"/>
+          <p:cNvPr id="17419" name="Rounded Rectangle 17418"/>
           <p:cNvSpPr/>
           <p:nvPr/>
         </p:nvSpPr>
         <p:spPr>
           <a:xfrm>
-            <a:off x="2615184" y="1627632"/>
-            <a:ext cx="1856232" cy="603504"/>
+            <a:off x="2615184" y="1591056"/>
+            <a:ext cx="1856232" cy="621792"/>
           </a:xfrm>
           <a:prstGeom prst="roundRect">
             <a:avLst/>
@@ -9590,7 +9651,7 @@
           </a:fontRef>
         </p:style>
         <p:txBody>
-          <a:bodyPr rtlCol="0" anchor="t" wrap="square" tIns="36576" lIns="54864" rIns="54864"/>
+          <a:bodyPr rtlCol="0" anchor="t" wrap="square" tIns="36576" lIns="73152" rIns="73152"/>
           <a:lstStyle/>
           <a:p>
             <a:pPr algn="ctr">
@@ -9601,10 +9662,11 @@
                 <a:solidFill>
                   <a:srgbClr val="2E7D32"/>
                 </a:solidFill>
+                <a:latin typeface="Arial"/>
               </a:defRPr>
             </a:pPr>
             <a:r>
-              <a:t>📊 Predictive Dashboard</a:t>
+              <a:t>Predictive Dashboard</a:t>
             </a:r>
           </a:p>
           <a:p>
@@ -9613,6 +9675,7 @@
                 <a:solidFill>
                   <a:srgbClr val="475569"/>
                 </a:solidFill>
+                <a:latin typeface="Arial"/>
               </a:defRPr>
             </a:pPr>
             <a:r>
@@ -9623,14 +9686,14 @@
       </p:sp>
       <p:sp>
         <p:nvSpPr>
-          <p:cNvPr id="17418" name="Rounded Rectangle 17417"/>
+          <p:cNvPr id="17420" name="Rounded Rectangle 17419"/>
           <p:cNvSpPr/>
           <p:nvPr/>
         </p:nvSpPr>
         <p:spPr>
           <a:xfrm>
-            <a:off x="2615184" y="2286000"/>
-            <a:ext cx="1856232" cy="603504"/>
+            <a:off x="2615184" y="2276856"/>
+            <a:ext cx="1856232" cy="621792"/>
           </a:xfrm>
           <a:prstGeom prst="roundRect">
             <a:avLst/>
@@ -9659,7 +9722,7 @@
           </a:fontRef>
         </p:style>
         <p:txBody>
-          <a:bodyPr rtlCol="0" anchor="t" wrap="square" tIns="36576" lIns="54864" rIns="54864"/>
+          <a:bodyPr rtlCol="0" anchor="t" wrap="square" tIns="36576" lIns="73152" rIns="73152"/>
           <a:lstStyle/>
           <a:p>
             <a:pPr algn="ctr">
@@ -9670,10 +9733,11 @@
                 <a:solidFill>
                   <a:srgbClr val="2E7D32"/>
                 </a:solidFill>
+                <a:latin typeface="Arial"/>
               </a:defRPr>
             </a:pPr>
             <a:r>
-              <a:t>🗺️ 340.8 km RoW GIS</a:t>
+              <a:t>340.8 km RoW GIS</a:t>
             </a:r>
           </a:p>
           <a:p>
@@ -9682,6 +9746,7 @@
                 <a:solidFill>
                   <a:srgbClr val="475569"/>
                 </a:solidFill>
+                <a:latin typeface="Arial"/>
               </a:defRPr>
             </a:pPr>
             <a:r>
@@ -9692,14 +9757,14 @@
       </p:sp>
       <p:sp>
         <p:nvSpPr>
-          <p:cNvPr id="17419" name="Rounded Rectangle 17418"/>
+          <p:cNvPr id="17421" name="Rounded Rectangle 17420"/>
           <p:cNvSpPr/>
           <p:nvPr/>
         </p:nvSpPr>
         <p:spPr>
           <a:xfrm>
-            <a:off x="2615184" y="2944368"/>
-            <a:ext cx="1856232" cy="603504"/>
+            <a:off x="2615184" y="2962656"/>
+            <a:ext cx="1856232" cy="621792"/>
           </a:xfrm>
           <a:prstGeom prst="roundRect">
             <a:avLst/>
@@ -9728,7 +9793,7 @@
           </a:fontRef>
         </p:style>
         <p:txBody>
-          <a:bodyPr rtlCol="0" anchor="t" wrap="square" tIns="36576" lIns="54864" rIns="54864"/>
+          <a:bodyPr rtlCol="0" anchor="t" wrap="square" tIns="36576" lIns="73152" rIns="73152"/>
           <a:lstStyle/>
           <a:p>
             <a:pPr algn="ctr">
@@ -9739,10 +9804,11 @@
                 <a:solidFill>
                   <a:srgbClr val="2E7D32"/>
                 </a:solidFill>
+                <a:latin typeface="Arial"/>
               </a:defRPr>
             </a:pPr>
             <a:r>
-              <a:t>🔍 TreeSHAP Waterfall</a:t>
+              <a:t>TreeSHAP Waterfall</a:t>
             </a:r>
           </a:p>
           <a:p>
@@ -9751,6 +9817,7 @@
                 <a:solidFill>
                   <a:srgbClr val="475569"/>
                 </a:solidFill>
+                <a:latin typeface="Arial"/>
               </a:defRPr>
             </a:pPr>
             <a:r>
@@ -9761,14 +9828,14 @@
       </p:sp>
       <p:sp>
         <p:nvSpPr>
-          <p:cNvPr id="17420" name="Rounded Rectangle 17419"/>
+          <p:cNvPr id="17422" name="Rounded Rectangle 17421"/>
           <p:cNvSpPr/>
           <p:nvPr/>
         </p:nvSpPr>
         <p:spPr>
           <a:xfrm>
-            <a:off x="2615184" y="3602736"/>
-            <a:ext cx="1856232" cy="603504"/>
+            <a:off x="2615184" y="3648456"/>
+            <a:ext cx="1856232" cy="621792"/>
           </a:xfrm>
           <a:prstGeom prst="roundRect">
             <a:avLst/>
@@ -9797,7 +9864,7 @@
           </a:fontRef>
         </p:style>
         <p:txBody>
-          <a:bodyPr rtlCol="0" anchor="t" wrap="square" tIns="36576" lIns="54864" rIns="54864"/>
+          <a:bodyPr rtlCol="0" anchor="t" wrap="square" tIns="36576" lIns="73152" rIns="73152"/>
           <a:lstStyle/>
           <a:p>
             <a:pPr algn="ctr">
@@ -9808,10 +9875,11 @@
                 <a:solidFill>
                   <a:srgbClr val="2E7D32"/>
                 </a:solidFill>
+                <a:latin typeface="Arial"/>
               </a:defRPr>
             </a:pPr>
             <a:r>
-              <a:t>📑 Prescriptive DFA SOP</a:t>
+              <a:t>Prescriptive DFA SOP</a:t>
             </a:r>
           </a:p>
           <a:p>
@@ -9820,6 +9888,7 @@
                 <a:solidFill>
                   <a:srgbClr val="475569"/>
                 </a:solidFill>
+                <a:latin typeface="Arial"/>
               </a:defRPr>
             </a:pPr>
             <a:r>
@@ -9830,14 +9899,14 @@
       </p:sp>
       <p:sp>
         <p:nvSpPr>
-          <p:cNvPr id="17421" name="Rounded Rectangle 17420"/>
+          <p:cNvPr id="17423" name="Rounded Rectangle 17422"/>
           <p:cNvSpPr/>
           <p:nvPr/>
         </p:nvSpPr>
         <p:spPr>
           <a:xfrm>
-            <a:off x="2615184" y="4261104"/>
-            <a:ext cx="1856232" cy="603504"/>
+            <a:off x="2615184" y="4334256"/>
+            <a:ext cx="1856232" cy="621792"/>
           </a:xfrm>
           <a:prstGeom prst="roundRect">
             <a:avLst/>
@@ -9866,7 +9935,7 @@
           </a:fontRef>
         </p:style>
         <p:txBody>
-          <a:bodyPr rtlCol="0" anchor="t" wrap="square" tIns="36576" lIns="54864" rIns="54864"/>
+          <a:bodyPr rtlCol="0" anchor="t" wrap="square" tIns="36576" lIns="73152" rIns="73152"/>
           <a:lstStyle/>
           <a:p>
             <a:pPr algn="ctr">
@@ -9877,10 +9946,11 @@
                 <a:solidFill>
                   <a:srgbClr val="2E7D32"/>
                 </a:solidFill>
+                <a:latin typeface="Arial"/>
               </a:defRPr>
             </a:pPr>
             <a:r>
-              <a:t>🛡️ Constitutional HITL</a:t>
+              <a:t>Constitutional HITL</a:t>
             </a:r>
           </a:p>
           <a:p>
@@ -9889,6 +9959,7 @@
                 <a:solidFill>
                   <a:srgbClr val="475569"/>
                 </a:solidFill>
+                <a:latin typeface="Arial"/>
               </a:defRPr>
             </a:pPr>
             <a:r>
@@ -9899,13 +9970,13 @@
       </p:sp>
       <p:sp>
         <p:nvSpPr>
-          <p:cNvPr id="17422" name="Left-Right Arrow 17421"/>
+          <p:cNvPr id="17424" name="Left-Right Arrow 17423"/>
           <p:cNvSpPr/>
           <p:nvPr/>
         </p:nvSpPr>
         <p:spPr>
           <a:xfrm>
-            <a:off x="4553712" y="3218688"/>
+            <a:off x="4553712" y="3264408"/>
             <a:ext cx="182880" cy="128016"/>
           </a:xfrm>
           <a:prstGeom prst="leftRightArrow">
@@ -9944,14 +10015,14 @@
       </p:sp>
       <p:sp>
         <p:nvSpPr>
-          <p:cNvPr id="17423" name="Rounded Rectangle 17422"/>
+          <p:cNvPr id="17425" name="Rounded Rectangle 17424"/>
           <p:cNvSpPr/>
           <p:nvPr/>
         </p:nvSpPr>
         <p:spPr>
           <a:xfrm>
             <a:off x="4773168" y="1097280"/>
-            <a:ext cx="2011680" cy="384048"/>
+            <a:ext cx="2011680" cy="365760"/>
           </a:xfrm>
           <a:prstGeom prst="roundRect">
             <a:avLst/>
@@ -9988,6 +10059,7 @@
                 <a:solidFill>
                   <a:srgbClr val="4527A0"/>
                 </a:solidFill>
+                <a:latin typeface="Arial"/>
               </a:defRPr>
             </a:pPr>
             <a:r>
@@ -9998,14 +10070,14 @@
       </p:sp>
       <p:sp>
         <p:nvSpPr>
-          <p:cNvPr id="17424" name="Rounded Rectangle 17423"/>
+          <p:cNvPr id="17426" name="Rounded Rectangle 17425"/>
           <p:cNvSpPr/>
           <p:nvPr/>
         </p:nvSpPr>
         <p:spPr>
           <a:xfrm>
-            <a:off x="4773168" y="1572768"/>
-            <a:ext cx="2011680" cy="3383280"/>
+            <a:off x="4773168" y="1536192"/>
+            <a:ext cx="2011680" cy="3529584"/>
           </a:xfrm>
           <a:prstGeom prst="roundRect">
             <a:avLst/>
@@ -10043,14 +10115,14 @@
       </p:sp>
       <p:sp>
         <p:nvSpPr>
-          <p:cNvPr id="17425" name="Rounded Rectangle 17424"/>
+          <p:cNvPr id="17427" name="Rounded Rectangle 17426"/>
           <p:cNvSpPr/>
           <p:nvPr/>
         </p:nvSpPr>
         <p:spPr>
           <a:xfrm>
-            <a:off x="4828032" y="1627632"/>
-            <a:ext cx="1901952" cy="603504"/>
+            <a:off x="4828032" y="1591056"/>
+            <a:ext cx="1901952" cy="621792"/>
           </a:xfrm>
           <a:prstGeom prst="roundRect">
             <a:avLst/>
@@ -10079,7 +10151,7 @@
           </a:fontRef>
         </p:style>
         <p:txBody>
-          <a:bodyPr rtlCol="0" anchor="t" wrap="square" tIns="36576" lIns="54864" rIns="54864"/>
+          <a:bodyPr rtlCol="0" anchor="t" wrap="square" tIns="36576" lIns="73152" rIns="73152"/>
           <a:lstStyle/>
           <a:p>
             <a:pPr algn="ctr">
@@ -10090,10 +10162,11 @@
                 <a:solidFill>
                   <a:srgbClr val="6A1B9A"/>
                 </a:solidFill>
+                <a:latin typeface="Arial"/>
               </a:defRPr>
             </a:pPr>
             <a:r>
-              <a:t>⚡ REST API Gateway</a:t>
+              <a:t>REST API Gateway</a:t>
             </a:r>
           </a:p>
           <a:p>
@@ -10102,6 +10175,7 @@
                 <a:solidFill>
                   <a:srgbClr val="475569"/>
                 </a:solidFill>
+                <a:latin typeface="Arial"/>
               </a:defRPr>
             </a:pPr>
             <a:r>
@@ -10112,14 +10186,14 @@
       </p:sp>
       <p:sp>
         <p:nvSpPr>
-          <p:cNvPr id="17426" name="Rounded Rectangle 17425"/>
+          <p:cNvPr id="17428" name="Rounded Rectangle 17427"/>
           <p:cNvSpPr/>
           <p:nvPr/>
         </p:nvSpPr>
         <p:spPr>
           <a:xfrm>
-            <a:off x="4828032" y="2286000"/>
-            <a:ext cx="1901952" cy="603504"/>
+            <a:off x="4828032" y="2276856"/>
+            <a:ext cx="1901952" cy="621792"/>
           </a:xfrm>
           <a:prstGeom prst="roundRect">
             <a:avLst/>
@@ -10148,7 +10222,7 @@
           </a:fontRef>
         </p:style>
         <p:txBody>
-          <a:bodyPr rtlCol="0" anchor="t" wrap="square" tIns="36576" lIns="54864" rIns="54864"/>
+          <a:bodyPr rtlCol="0" anchor="t" wrap="square" tIns="36576" lIns="73152" rIns="73152"/>
           <a:lstStyle/>
           <a:p>
             <a:pPr algn="ctr">
@@ -10159,10 +10233,11 @@
                 <a:solidFill>
                   <a:srgbClr val="6A1B9A"/>
                 </a:solidFill>
+                <a:latin typeface="Arial"/>
               </a:defRPr>
             </a:pPr>
             <a:r>
-              <a:t>💾 Decoupled Central DB</a:t>
+              <a:t>Decoupled Central DB</a:t>
             </a:r>
           </a:p>
           <a:p>
@@ -10171,6 +10246,7 @@
                 <a:solidFill>
                   <a:srgbClr val="475569"/>
                 </a:solidFill>
+                <a:latin typeface="Arial"/>
               </a:defRPr>
             </a:pPr>
             <a:r>
@@ -10181,14 +10257,14 @@
       </p:sp>
       <p:sp>
         <p:nvSpPr>
-          <p:cNvPr id="17427" name="Rounded Rectangle 17426"/>
+          <p:cNvPr id="17429" name="Rounded Rectangle 17428"/>
           <p:cNvSpPr/>
           <p:nvPr/>
         </p:nvSpPr>
         <p:spPr>
           <a:xfrm>
-            <a:off x="4828032" y="2944368"/>
-            <a:ext cx="1901952" cy="603504"/>
+            <a:off x="4828032" y="2962656"/>
+            <a:ext cx="1901952" cy="621792"/>
           </a:xfrm>
           <a:prstGeom prst="roundRect">
             <a:avLst/>
@@ -10217,7 +10293,7 @@
           </a:fontRef>
         </p:style>
         <p:txBody>
-          <a:bodyPr rtlCol="0" anchor="t" wrap="square" tIns="36576" lIns="54864" rIns="54864"/>
+          <a:bodyPr rtlCol="0" anchor="t" wrap="square" tIns="36576" lIns="73152" rIns="73152"/>
           <a:lstStyle/>
           <a:p>
             <a:pPr algn="ctr">
@@ -10228,10 +10304,11 @@
                 <a:solidFill>
                   <a:srgbClr val="6A1B9A"/>
                 </a:solidFill>
+                <a:latin typeface="Arial"/>
               </a:defRPr>
             </a:pPr>
             <a:r>
-              <a:t>🛣️ Dual-Track Engine</a:t>
+              <a:t>Dual-Track Engine</a:t>
             </a:r>
           </a:p>
           <a:p>
@@ -10240,6 +10317,7 @@
                 <a:solidFill>
                   <a:srgbClr val="475569"/>
                 </a:solidFill>
+                <a:latin typeface="Arial"/>
               </a:defRPr>
             </a:pPr>
             <a:r>
@@ -10250,14 +10328,14 @@
       </p:sp>
       <p:sp>
         <p:nvSpPr>
-          <p:cNvPr id="17428" name="Rounded Rectangle 17427"/>
+          <p:cNvPr id="17430" name="Rounded Rectangle 17429"/>
           <p:cNvSpPr/>
           <p:nvPr/>
         </p:nvSpPr>
         <p:spPr>
           <a:xfrm>
-            <a:off x="4828032" y="3602736"/>
-            <a:ext cx="1901952" cy="603504"/>
+            <a:off x="4828032" y="3648456"/>
+            <a:ext cx="1901952" cy="621792"/>
           </a:xfrm>
           <a:prstGeom prst="roundRect">
             <a:avLst/>
@@ -10286,7 +10364,7 @@
           </a:fontRef>
         </p:style>
         <p:txBody>
-          <a:bodyPr rtlCol="0" anchor="t" wrap="square" tIns="36576" lIns="54864" rIns="54864"/>
+          <a:bodyPr rtlCol="0" anchor="t" wrap="square" tIns="36576" lIns="73152" rIns="73152"/>
           <a:lstStyle/>
           <a:p>
             <a:pPr algn="ctr">
@@ -10297,10 +10375,11 @@
                 <a:solidFill>
                   <a:srgbClr val="6A1B9A"/>
                 </a:solidFill>
+                <a:latin typeface="Arial"/>
               </a:defRPr>
             </a:pPr>
             <a:r>
-              <a:t>📝 Statutory DFA Engine</a:t>
+              <a:t>Statutory DFA Engine</a:t>
             </a:r>
           </a:p>
           <a:p>
@@ -10309,6 +10388,7 @@
                 <a:solidFill>
                   <a:srgbClr val="475569"/>
                 </a:solidFill>
+                <a:latin typeface="Arial"/>
               </a:defRPr>
             </a:pPr>
             <a:r>
@@ -10319,14 +10399,14 @@
       </p:sp>
       <p:sp>
         <p:nvSpPr>
-          <p:cNvPr id="17429" name="Rounded Rectangle 17428"/>
+          <p:cNvPr id="17431" name="Rounded Rectangle 17430"/>
           <p:cNvSpPr/>
           <p:nvPr/>
         </p:nvSpPr>
         <p:spPr>
           <a:xfrm>
-            <a:off x="4828032" y="4261104"/>
-            <a:ext cx="1901952" cy="603504"/>
+            <a:off x="4828032" y="4334256"/>
+            <a:ext cx="1901952" cy="621792"/>
           </a:xfrm>
           <a:prstGeom prst="roundRect">
             <a:avLst/>
@@ -10355,7 +10435,7 @@
           </a:fontRef>
         </p:style>
         <p:txBody>
-          <a:bodyPr rtlCol="0" anchor="t" wrap="square" tIns="36576" lIns="54864" rIns="54864"/>
+          <a:bodyPr rtlCol="0" anchor="t" wrap="square" tIns="36576" lIns="73152" rIns="73152"/>
           <a:lstStyle/>
           <a:p>
             <a:pPr algn="ctr">
@@ -10366,10 +10446,11 @@
                 <a:solidFill>
                   <a:srgbClr val="6A1B9A"/>
                 </a:solidFill>
+                <a:latin typeface="Arial"/>
               </a:defRPr>
             </a:pPr>
             <a:r>
-              <a:t>🔒 SHA-256 Ledger Service</a:t>
+              <a:t>SHA-256 Ledger Service</a:t>
             </a:r>
           </a:p>
           <a:p>
@@ -10378,6 +10459,7 @@
                 <a:solidFill>
                   <a:srgbClr val="475569"/>
                 </a:solidFill>
+                <a:latin typeface="Arial"/>
               </a:defRPr>
             </a:pPr>
             <a:r>
@@ -10388,13 +10470,13 @@
       </p:sp>
       <p:sp>
         <p:nvSpPr>
-          <p:cNvPr id="17430" name="Left-Right Arrow 17429"/>
+          <p:cNvPr id="17432" name="Left-Right Arrow 17431"/>
           <p:cNvSpPr/>
           <p:nvPr/>
         </p:nvSpPr>
         <p:spPr>
           <a:xfrm>
-            <a:off x="6803136" y="3218688"/>
+            <a:off x="6803136" y="3264408"/>
             <a:ext cx="182880" cy="128016"/>
           </a:xfrm>
           <a:prstGeom prst="leftRightArrow">
@@ -10433,14 +10515,14 @@
       </p:sp>
       <p:sp>
         <p:nvSpPr>
-          <p:cNvPr id="17431" name="Rounded Rectangle 17430"/>
+          <p:cNvPr id="17433" name="Rounded Rectangle 17432"/>
           <p:cNvSpPr/>
           <p:nvPr/>
         </p:nvSpPr>
         <p:spPr>
           <a:xfrm>
             <a:off x="7022592" y="1097280"/>
-            <a:ext cx="1965960" cy="384048"/>
+            <a:ext cx="1965960" cy="365760"/>
           </a:xfrm>
           <a:prstGeom prst="roundRect">
             <a:avLst/>
@@ -10477,24 +10559,25 @@
                 <a:solidFill>
                   <a:srgbClr val="00838F"/>
                 </a:solidFill>
+                <a:latin typeface="Arial"/>
               </a:defRPr>
             </a:pPr>
             <a:r>
-              <a:t>Zone 4: AI &amp; ML Engine (The Brain)</a:t>
-            </a:r>
-          </a:p>
-        </p:txBody>
-      </p:sp>
-      <p:sp>
-        <p:nvSpPr>
-          <p:cNvPr id="17432" name="Rounded Rectangle 17431"/>
+              <a:t>Zone 4: AI &amp; ML Engine</a:t>
+            </a:r>
+          </a:p>
+        </p:txBody>
+      </p:sp>
+      <p:sp>
+        <p:nvSpPr>
+          <p:cNvPr id="17434" name="Rounded Rectangle 17433"/>
           <p:cNvSpPr/>
           <p:nvPr/>
         </p:nvSpPr>
         <p:spPr>
           <a:xfrm>
-            <a:off x="7022592" y="1572768"/>
-            <a:ext cx="1965960" cy="3383280"/>
+            <a:off x="7022592" y="1536192"/>
+            <a:ext cx="1965960" cy="3529584"/>
           </a:xfrm>
           <a:prstGeom prst="roundRect">
             <a:avLst/>
@@ -10532,14 +10615,14 @@
       </p:sp>
       <p:sp>
         <p:nvSpPr>
-          <p:cNvPr id="17433" name="Rounded Rectangle 17432"/>
+          <p:cNvPr id="17435" name="Rounded Rectangle 17434"/>
           <p:cNvSpPr/>
           <p:nvPr/>
         </p:nvSpPr>
         <p:spPr>
           <a:xfrm>
-            <a:off x="7077456" y="1627632"/>
-            <a:ext cx="1856232" cy="603504"/>
+            <a:off x="7077456" y="1591056"/>
+            <a:ext cx="1856232" cy="621792"/>
           </a:xfrm>
           <a:prstGeom prst="roundRect">
             <a:avLst/>
@@ -10568,7 +10651,7 @@
           </a:fontRef>
         </p:style>
         <p:txBody>
-          <a:bodyPr rtlCol="0" anchor="t" wrap="square" tIns="36576" lIns="54864" rIns="54864"/>
+          <a:bodyPr rtlCol="0" anchor="t" wrap="square" tIns="36576" lIns="73152" rIns="73152"/>
           <a:lstStyle/>
           <a:p>
             <a:pPr algn="ctr">
@@ -10579,10 +10662,11 @@
                 <a:solidFill>
                   <a:srgbClr val="00838F"/>
                 </a:solidFill>
+                <a:latin typeface="Arial"/>
               </a:defRPr>
             </a:pPr>
             <a:r>
-              <a:t>🧠 Ensemble ML Predictor</a:t>
+              <a:t>Ensemble ML Predictor</a:t>
             </a:r>
           </a:p>
           <a:p>
@@ -10591,6 +10675,7 @@
                 <a:solidFill>
                   <a:srgbClr val="475569"/>
                 </a:solidFill>
+                <a:latin typeface="Arial"/>
               </a:defRPr>
             </a:pPr>
             <a:r>
@@ -10601,14 +10686,14 @@
       </p:sp>
       <p:sp>
         <p:nvSpPr>
-          <p:cNvPr id="17434" name="Rounded Rectangle 17433"/>
+          <p:cNvPr id="17436" name="Rounded Rectangle 17435"/>
           <p:cNvSpPr/>
           <p:nvPr/>
         </p:nvSpPr>
         <p:spPr>
           <a:xfrm>
-            <a:off x="7077456" y="2286000"/>
-            <a:ext cx="1856232" cy="603504"/>
+            <a:off x="7077456" y="2276856"/>
+            <a:ext cx="1856232" cy="621792"/>
           </a:xfrm>
           <a:prstGeom prst="roundRect">
             <a:avLst/>
@@ -10637,7 +10722,7 @@
           </a:fontRef>
         </p:style>
         <p:txBody>
-          <a:bodyPr rtlCol="0" anchor="t" wrap="square" tIns="36576" lIns="54864" rIns="54864"/>
+          <a:bodyPr rtlCol="0" anchor="t" wrap="square" tIns="36576" lIns="73152" rIns="73152"/>
           <a:lstStyle/>
           <a:p>
             <a:pPr algn="ctr">
@@ -10648,10 +10733,11 @@
                 <a:solidFill>
                   <a:srgbClr val="00838F"/>
                 </a:solidFill>
+                <a:latin typeface="Arial"/>
               </a:defRPr>
             </a:pPr>
             <a:r>
-              <a:t>🔬 TreeSHAP Attribution</a:t>
+              <a:t>TreeSHAP Attribution</a:t>
             </a:r>
           </a:p>
           <a:p>
@@ -10660,6 +10746,7 @@
                 <a:solidFill>
                   <a:srgbClr val="475569"/>
                 </a:solidFill>
+                <a:latin typeface="Arial"/>
               </a:defRPr>
             </a:pPr>
             <a:r>
@@ -10670,14 +10757,14 @@
       </p:sp>
       <p:sp>
         <p:nvSpPr>
-          <p:cNvPr id="17435" name="Rounded Rectangle 17434"/>
+          <p:cNvPr id="17437" name="Rounded Rectangle 17436"/>
           <p:cNvSpPr/>
           <p:nvPr/>
         </p:nvSpPr>
         <p:spPr>
           <a:xfrm>
-            <a:off x="7077456" y="2944368"/>
-            <a:ext cx="1856232" cy="603504"/>
+            <a:off x="7077456" y="2962656"/>
+            <a:ext cx="1856232" cy="621792"/>
           </a:xfrm>
           <a:prstGeom prst="roundRect">
             <a:avLst/>
@@ -10706,7 +10793,7 @@
           </a:fontRef>
         </p:style>
         <p:txBody>
-          <a:bodyPr rtlCol="0" anchor="t" wrap="square" tIns="36576" lIns="54864" rIns="54864"/>
+          <a:bodyPr rtlCol="0" anchor="t" wrap="square" tIns="36576" lIns="73152" rIns="73152"/>
           <a:lstStyle/>
           <a:p>
             <a:pPr algn="ctr">
@@ -10717,10 +10804,11 @@
                 <a:solidFill>
                   <a:srgbClr val="00838F"/>
                 </a:solidFill>
+                <a:latin typeface="Arial"/>
               </a:defRPr>
             </a:pPr>
             <a:r>
-              <a:t>📈 Kaplan-Meier Survival</a:t>
+              <a:t>Kaplan-Meier Survival</a:t>
             </a:r>
           </a:p>
           <a:p>
@@ -10729,6 +10817,7 @@
                 <a:solidFill>
                   <a:srgbClr val="475569"/>
                 </a:solidFill>
+                <a:latin typeface="Arial"/>
               </a:defRPr>
             </a:pPr>
             <a:r>
@@ -10739,14 +10828,14 @@
       </p:sp>
       <p:sp>
         <p:nvSpPr>
-          <p:cNvPr id="17436" name="Rounded Rectangle 17435"/>
+          <p:cNvPr id="17438" name="Rounded Rectangle 17437"/>
           <p:cNvSpPr/>
           <p:nvPr/>
         </p:nvSpPr>
         <p:spPr>
           <a:xfrm>
-            <a:off x="7077456" y="3602736"/>
-            <a:ext cx="1856232" cy="603504"/>
+            <a:off x="7077456" y="3648456"/>
+            <a:ext cx="1856232" cy="621792"/>
           </a:xfrm>
           <a:prstGeom prst="roundRect">
             <a:avLst/>
@@ -10775,7 +10864,7 @@
           </a:fontRef>
         </p:style>
         <p:txBody>
-          <a:bodyPr rtlCol="0" anchor="t" wrap="square" tIns="36576" lIns="54864" rIns="54864"/>
+          <a:bodyPr rtlCol="0" anchor="t" wrap="square" tIns="36576" lIns="73152" rIns="73152"/>
           <a:lstStyle/>
           <a:p>
             <a:pPr algn="ctr">
@@ -10786,10 +10875,11 @@
                 <a:solidFill>
                   <a:srgbClr val="00838F"/>
                 </a:solidFill>
+                <a:latin typeface="Arial"/>
               </a:defRPr>
             </a:pPr>
             <a:r>
-              <a:t>⚖️ Prescriptive Rule Core</a:t>
+              <a:t>Prescriptive Rule Core</a:t>
             </a:r>
           </a:p>
           <a:p>
@@ -10798,6 +10888,7 @@
                 <a:solidFill>
                   <a:srgbClr val="475569"/>
                 </a:solidFill>
+                <a:latin typeface="Arial"/>
               </a:defRPr>
             </a:pPr>
             <a:r>
@@ -10808,14 +10899,14 @@
       </p:sp>
       <p:sp>
         <p:nvSpPr>
-          <p:cNvPr id="17437" name="Rounded Rectangle 17436"/>
+          <p:cNvPr id="17439" name="Rounded Rectangle 17438"/>
           <p:cNvSpPr/>
           <p:nvPr/>
         </p:nvSpPr>
         <p:spPr>
           <a:xfrm>
-            <a:off x="7077456" y="4261104"/>
-            <a:ext cx="1856232" cy="603504"/>
+            <a:off x="7077456" y="4334256"/>
+            <a:ext cx="1856232" cy="621792"/>
           </a:xfrm>
           <a:prstGeom prst="roundRect">
             <a:avLst/>
@@ -10844,7 +10935,7 @@
           </a:fontRef>
         </p:style>
         <p:txBody>
-          <a:bodyPr rtlCol="0" anchor="t" wrap="square" tIns="36576" lIns="54864" rIns="54864"/>
+          <a:bodyPr rtlCol="0" anchor="t" wrap="square" tIns="36576" lIns="73152" rIns="73152"/>
           <a:lstStyle/>
           <a:p>
             <a:pPr algn="ctr">
@@ -10855,10 +10946,11 @@
                 <a:solidFill>
                   <a:srgbClr val="00838F"/>
                 </a:solidFill>
+                <a:latin typeface="Arial"/>
               </a:defRPr>
             </a:pPr>
             <a:r>
-              <a:t>🗄️ Central DB (&lt;15ms)</a:t>
+              <a:t>Central DB (&lt;15ms)</a:t>
             </a:r>
           </a:p>
           <a:p>
@@ -10867,6 +10959,7 @@
                 <a:solidFill>
                   <a:srgbClr val="475569"/>
                 </a:solidFill>
+                <a:latin typeface="Arial"/>
               </a:defRPr>
             </a:pPr>
             <a:r>
@@ -10877,14 +10970,14 @@
       </p:sp>
       <p:sp>
         <p:nvSpPr>
-          <p:cNvPr id="17438" name="Rounded Rectangle 17437"/>
+          <p:cNvPr id="17440" name="Rounded Rectangle 17439"/>
           <p:cNvSpPr/>
           <p:nvPr/>
         </p:nvSpPr>
         <p:spPr>
           <a:xfrm>
             <a:off x="411480" y="5285232"/>
-            <a:ext cx="8641080" cy="868680"/>
+            <a:ext cx="8641080" cy="877824"/>
           </a:xfrm>
           <a:prstGeom prst="roundRect">
             <a:avLst/>
@@ -10922,14 +11015,14 @@
       </p:sp>
       <p:sp>
         <p:nvSpPr>
-          <p:cNvPr id="17439" name="Rounded Rectangle 17438"/>
+          <p:cNvPr id="17441" name="Rounded Rectangle 17440"/>
           <p:cNvSpPr/>
           <p:nvPr/>
         </p:nvSpPr>
         <p:spPr>
           <a:xfrm>
-            <a:off x="502920" y="5394960"/>
-            <a:ext cx="1691640" cy="649224"/>
+            <a:off x="475488" y="5376672"/>
+            <a:ext cx="1371600" cy="694944"/>
           </a:xfrm>
           <a:prstGeom prst="roundRect">
             <a:avLst/>
@@ -10962,7 +11055,7 @@
           <a:lstStyle/>
           <a:p>
             <a:pPr algn="ctr">
-              <a:defRPr sz="950" b="1">
+              <a:defRPr sz="850" b="1">
                 <a:solidFill>
                   <a:srgbClr val="0F172A"/>
                 </a:solidFill>
@@ -10970,25 +11063,25 @@
               </a:defRPr>
             </a:pPr>
             <a:r>
-              <a:t>⚙️ Components /</a:t>
+              <a:t>Core Technology</a:t>
             </a:r>
             <a:br/>
             <a:r>
-              <a:t>Technology Stack</a:t>
-            </a:r>
-          </a:p>
-        </p:txBody>
-      </p:sp>
-      <p:sp>
-        <p:nvSpPr>
-          <p:cNvPr id="17440" name="Rounded Rectangle 17439"/>
+              <a:t>Stack &amp; Engine</a:t>
+            </a:r>
+          </a:p>
+        </p:txBody>
+      </p:sp>
+      <p:sp>
+        <p:nvSpPr>
+          <p:cNvPr id="17442" name="Rounded Rectangle 17441"/>
           <p:cNvSpPr/>
           <p:nvPr/>
         </p:nvSpPr>
         <p:spPr>
           <a:xfrm>
-            <a:off x="2286000" y="5394960"/>
-            <a:ext cx="777240" cy="649224"/>
+            <a:off x="1901952" y="5358384"/>
+            <a:ext cx="740664" cy="731520"/>
           </a:xfrm>
           <a:prstGeom prst="roundRect">
             <a:avLst/>
@@ -10998,7 +11091,7 @@
           </a:solidFill>
           <a:ln w="15240">
             <a:solidFill>
-              <a:srgbClr val="3572A5"/>
+              <a:srgbClr val="387EB8"/>
             </a:solidFill>
           </a:ln>
         </p:spPr>
@@ -11017,14 +11110,15 @@
           </a:fontRef>
         </p:style>
         <p:txBody>
-          <a:bodyPr rtlCol="0" anchor="ctr" wrap="square" lIns="18288" rIns="18288"/>
+          <a:bodyPr rtlCol="0" anchor="b" wrap="square" lIns="18288" rIns="18288" bIns="36576"/>
           <a:lstStyle/>
           <a:p>
             <a:pPr algn="ctr">
-              <a:defRPr sz="750" b="1">
-                <a:solidFill>
-                  <a:srgbClr val="3572A5"/>
-                </a:solidFill>
+              <a:defRPr sz="650" b="1">
+                <a:solidFill>
+                  <a:srgbClr val="0F172A"/>
+                </a:solidFill>
+                <a:latin typeface="Arial"/>
               </a:defRPr>
             </a:pPr>
             <a:r>
@@ -11033,28 +11127,53 @@
           </a:p>
           <a:p>
             <a:pPr algn="ctr">
-              <a:defRPr sz="600">
-                <a:solidFill>
-                  <a:srgbClr val="475569"/>
-                </a:solidFill>
+              <a:defRPr sz="550">
+                <a:solidFill>
+                  <a:srgbClr val="64748B"/>
+                </a:solidFill>
+                <a:latin typeface="Arial"/>
               </a:defRPr>
             </a:pPr>
             <a:r>
-              <a:t>FastAPI / ASGI</a:t>
-            </a:r>
-          </a:p>
-        </p:txBody>
-      </p:sp>
-      <p:sp>
-        <p:nvSpPr>
-          <p:cNvPr id="17441" name="Rounded Rectangle 17440"/>
+              <a:t>FastAPI Core</a:t>
+            </a:r>
+          </a:p>
+        </p:txBody>
+      </p:sp>
+      <p:pic>
+        <p:nvPicPr>
+          <p:cNvPr id="17443" name="Picture 17442" descr="python_logo.png"/>
+          <p:cNvPicPr>
+            <a:picLocks noChangeAspect="1"/>
+          </p:cNvPicPr>
+          <p:nvPr/>
+        </p:nvPicPr>
+        <p:blipFill>
+          <a:blip r:embed="rId6"/>
+          <a:stretch>
+            <a:fillRect/>
+          </a:stretch>
+        </p:blipFill>
+        <p:spPr>
+          <a:xfrm>
+            <a:off x="2121408" y="5394960"/>
+            <a:ext cx="301752" cy="301752"/>
+          </a:xfrm>
+          <a:prstGeom prst="rect">
+            <a:avLst/>
+          </a:prstGeom>
+        </p:spPr>
+      </p:pic>
+      <p:sp>
+        <p:nvSpPr>
+          <p:cNvPr id="17444" name="Rounded Rectangle 17443"/>
           <p:cNvSpPr/>
           <p:nvPr/>
         </p:nvSpPr>
         <p:spPr>
           <a:xfrm>
-            <a:off x="3127248" y="5394960"/>
-            <a:ext cx="777240" cy="649224"/>
+            <a:off x="2697480" y="5358384"/>
+            <a:ext cx="740664" cy="731520"/>
           </a:xfrm>
           <a:prstGeom prst="roundRect">
             <a:avLst/>
@@ -11064,7 +11183,7 @@
           </a:solidFill>
           <a:ln w="15240">
             <a:solidFill>
-              <a:srgbClr val="61DAFB"/>
+              <a:srgbClr val="009688"/>
             </a:solidFill>
           </a:ln>
         </p:spPr>
@@ -11083,44 +11202,70 @@
           </a:fontRef>
         </p:style>
         <p:txBody>
-          <a:bodyPr rtlCol="0" anchor="ctr" wrap="square" lIns="18288" rIns="18288"/>
+          <a:bodyPr rtlCol="0" anchor="b" wrap="square" lIns="18288" rIns="18288" bIns="36576"/>
           <a:lstStyle/>
           <a:p>
             <a:pPr algn="ctr">
-              <a:defRPr sz="750" b="1">
-                <a:solidFill>
-                  <a:srgbClr val="61DAFB"/>
-                </a:solidFill>
+              <a:defRPr sz="650" b="1">
+                <a:solidFill>
+                  <a:srgbClr val="0F172A"/>
+                </a:solidFill>
+                <a:latin typeface="Arial"/>
               </a:defRPr>
             </a:pPr>
             <a:r>
-              <a:t>React 19</a:t>
+              <a:t>FastAPI</a:t>
             </a:r>
           </a:p>
           <a:p>
             <a:pPr algn="ctr">
-              <a:defRPr sz="600">
-                <a:solidFill>
-                  <a:srgbClr val="475569"/>
-                </a:solidFill>
+              <a:defRPr sz="550">
+                <a:solidFill>
+                  <a:srgbClr val="64748B"/>
+                </a:solidFill>
+                <a:latin typeface="Arial"/>
               </a:defRPr>
             </a:pPr>
             <a:r>
-              <a:t>Vite Frontend</a:t>
-            </a:r>
-          </a:p>
-        </p:txBody>
-      </p:sp>
-      <p:sp>
-        <p:nvSpPr>
-          <p:cNvPr id="17442" name="Rounded Rectangle 17441"/>
+              <a:t>REST Gateway</a:t>
+            </a:r>
+          </a:p>
+        </p:txBody>
+      </p:sp>
+      <p:pic>
+        <p:nvPicPr>
+          <p:cNvPr id="17445" name="Picture 17444" descr="fastapi_logo.png"/>
+          <p:cNvPicPr>
+            <a:picLocks noChangeAspect="1"/>
+          </p:cNvPicPr>
+          <p:nvPr/>
+        </p:nvPicPr>
+        <p:blipFill>
+          <a:blip r:embed="rId7"/>
+          <a:stretch>
+            <a:fillRect/>
+          </a:stretch>
+        </p:blipFill>
+        <p:spPr>
+          <a:xfrm>
+            <a:off x="2916936" y="5394960"/>
+            <a:ext cx="301752" cy="301752"/>
+          </a:xfrm>
+          <a:prstGeom prst="rect">
+            <a:avLst/>
+          </a:prstGeom>
+        </p:spPr>
+      </p:pic>
+      <p:sp>
+        <p:nvSpPr>
+          <p:cNvPr id="17446" name="Rounded Rectangle 17445"/>
           <p:cNvSpPr/>
           <p:nvPr/>
         </p:nvSpPr>
         <p:spPr>
           <a:xfrm>
-            <a:off x="3968496" y="5394960"/>
-            <a:ext cx="777240" cy="649224"/>
+            <a:off x="3493008" y="5358384"/>
+            <a:ext cx="740664" cy="731520"/>
           </a:xfrm>
           <a:prstGeom prst="roundRect">
             <a:avLst/>
@@ -11130,7 +11275,7 @@
           </a:solidFill>
           <a:ln w="15240">
             <a:solidFill>
-              <a:srgbClr val="EB6E32"/>
+              <a:srgbClr val="20232A"/>
             </a:solidFill>
           </a:ln>
         </p:spPr>
@@ -11149,44 +11294,70 @@
           </a:fontRef>
         </p:style>
         <p:txBody>
-          <a:bodyPr rtlCol="0" anchor="ctr" wrap="square" lIns="18288" rIns="18288"/>
+          <a:bodyPr rtlCol="0" anchor="b" wrap="square" lIns="18288" rIns="18288" bIns="36576"/>
           <a:lstStyle/>
           <a:p>
             <a:pPr algn="ctr">
-              <a:defRPr sz="750" b="1">
-                <a:solidFill>
-                  <a:srgbClr val="EB6E32"/>
-                </a:solidFill>
+              <a:defRPr sz="650" b="1">
+                <a:solidFill>
+                  <a:srgbClr val="0F172A"/>
+                </a:solidFill>
+                <a:latin typeface="Arial"/>
               </a:defRPr>
             </a:pPr>
             <a:r>
-              <a:t>XGBoost 2.1</a:t>
+              <a:t>React 19</a:t>
             </a:r>
           </a:p>
           <a:p>
             <a:pPr algn="ctr">
-              <a:defRPr sz="600">
-                <a:solidFill>
-                  <a:srgbClr val="475569"/>
-                </a:solidFill>
+              <a:defRPr sz="550">
+                <a:solidFill>
+                  <a:srgbClr val="64748B"/>
+                </a:solidFill>
+                <a:latin typeface="Arial"/>
               </a:defRPr>
             </a:pPr>
             <a:r>
-              <a:t>ML Regressor</a:t>
-            </a:r>
-          </a:p>
-        </p:txBody>
-      </p:sp>
-      <p:sp>
-        <p:nvSpPr>
-          <p:cNvPr id="17443" name="Rounded Rectangle 17442"/>
+              <a:t>Vite Frontend</a:t>
+            </a:r>
+          </a:p>
+        </p:txBody>
+      </p:sp>
+      <p:pic>
+        <p:nvPicPr>
+          <p:cNvPr id="17447" name="Picture 17446" descr="react_logo.png"/>
+          <p:cNvPicPr>
+            <a:picLocks noChangeAspect="1"/>
+          </p:cNvPicPr>
+          <p:nvPr/>
+        </p:nvPicPr>
+        <p:blipFill>
+          <a:blip r:embed="rId8"/>
+          <a:stretch>
+            <a:fillRect/>
+          </a:stretch>
+        </p:blipFill>
+        <p:spPr>
+          <a:xfrm>
+            <a:off x="3712464" y="5394960"/>
+            <a:ext cx="301752" cy="301752"/>
+          </a:xfrm>
+          <a:prstGeom prst="rect">
+            <a:avLst/>
+          </a:prstGeom>
+        </p:spPr>
+      </p:pic>
+      <p:sp>
+        <p:nvSpPr>
+          <p:cNvPr id="17448" name="Rounded Rectangle 17447"/>
           <p:cNvSpPr/>
           <p:nvPr/>
         </p:nvSpPr>
         <p:spPr>
           <a:xfrm>
-            <a:off x="4809744" y="5394960"/>
-            <a:ext cx="777240" cy="649224"/>
+            <a:off x="4288536" y="5358384"/>
+            <a:ext cx="740664" cy="731520"/>
           </a:xfrm>
           <a:prstGeom prst="roundRect">
             <a:avLst/>
@@ -11196,7 +11367,7 @@
           </a:solidFill>
           <a:ln w="15240">
             <a:solidFill>
-              <a:srgbClr val="FF8C00"/>
+              <a:srgbClr val="E65100"/>
             </a:solidFill>
           </a:ln>
         </p:spPr>
@@ -11215,44 +11386,70 @@
           </a:fontRef>
         </p:style>
         <p:txBody>
-          <a:bodyPr rtlCol="0" anchor="ctr" wrap="square" lIns="18288" rIns="18288"/>
+          <a:bodyPr rtlCol="0" anchor="b" wrap="square" lIns="18288" rIns="18288" bIns="36576"/>
           <a:lstStyle/>
           <a:p>
             <a:pPr algn="ctr">
-              <a:defRPr sz="750" b="1">
-                <a:solidFill>
-                  <a:srgbClr val="FF8C00"/>
-                </a:solidFill>
+              <a:defRPr sz="650" b="1">
+                <a:solidFill>
+                  <a:srgbClr val="0F172A"/>
+                </a:solidFill>
+                <a:latin typeface="Arial"/>
               </a:defRPr>
             </a:pPr>
             <a:r>
-              <a:t>LightGBM</a:t>
+              <a:t>XGBoost 2.1</a:t>
             </a:r>
           </a:p>
           <a:p>
             <a:pPr algn="ctr">
-              <a:defRPr sz="600">
-                <a:solidFill>
-                  <a:srgbClr val="475569"/>
-                </a:solidFill>
+              <a:defRPr sz="550">
+                <a:solidFill>
+                  <a:srgbClr val="64748B"/>
+                </a:solidFill>
+                <a:latin typeface="Arial"/>
               </a:defRPr>
             </a:pPr>
             <a:r>
-              <a:t>Gradient Trees</a:t>
-            </a:r>
-          </a:p>
-        </p:txBody>
-      </p:sp>
-      <p:sp>
-        <p:nvSpPr>
-          <p:cNvPr id="17444" name="Rounded Rectangle 17443"/>
+              <a:t>ML Regressor</a:t>
+            </a:r>
+          </a:p>
+        </p:txBody>
+      </p:sp>
+      <p:pic>
+        <p:nvPicPr>
+          <p:cNvPr id="17449" name="Picture 17448" descr="xgboost_logo.png"/>
+          <p:cNvPicPr>
+            <a:picLocks noChangeAspect="1"/>
+          </p:cNvPicPr>
+          <p:nvPr/>
+        </p:nvPicPr>
+        <p:blipFill>
+          <a:blip r:embed="rId9"/>
+          <a:stretch>
+            <a:fillRect/>
+          </a:stretch>
+        </p:blipFill>
+        <p:spPr>
+          <a:xfrm>
+            <a:off x="4507992" y="5394960"/>
+            <a:ext cx="301752" cy="301752"/>
+          </a:xfrm>
+          <a:prstGeom prst="rect">
+            <a:avLst/>
+          </a:prstGeom>
+        </p:spPr>
+      </p:pic>
+      <p:sp>
+        <p:nvSpPr>
+          <p:cNvPr id="17450" name="Rounded Rectangle 17449"/>
           <p:cNvSpPr/>
           <p:nvPr/>
         </p:nvSpPr>
         <p:spPr>
           <a:xfrm>
-            <a:off x="5650992" y="5394960"/>
-            <a:ext cx="777240" cy="649224"/>
+            <a:off x="5084064" y="5358384"/>
+            <a:ext cx="740664" cy="731520"/>
           </a:xfrm>
           <a:prstGeom prst="roundRect">
             <a:avLst/>
@@ -11262,7 +11459,7 @@
           </a:solidFill>
           <a:ln w="15240">
             <a:solidFill>
-              <a:srgbClr val="2E7D32"/>
+              <a:srgbClr val="0D47A1"/>
             </a:solidFill>
           </a:ln>
         </p:spPr>
@@ -11281,44 +11478,70 @@
           </a:fontRef>
         </p:style>
         <p:txBody>
-          <a:bodyPr rtlCol="0" anchor="ctr" wrap="square" lIns="18288" rIns="18288"/>
+          <a:bodyPr rtlCol="0" anchor="b" wrap="square" lIns="18288" rIns="18288" bIns="36576"/>
           <a:lstStyle/>
           <a:p>
             <a:pPr algn="ctr">
-              <a:defRPr sz="750" b="1">
-                <a:solidFill>
-                  <a:srgbClr val="2E7D32"/>
-                </a:solidFill>
+              <a:defRPr sz="650" b="1">
+                <a:solidFill>
+                  <a:srgbClr val="0F172A"/>
+                </a:solidFill>
+                <a:latin typeface="Arial"/>
               </a:defRPr>
             </a:pPr>
             <a:r>
-              <a:t>TreeSHAP</a:t>
+              <a:t>LightGBM</a:t>
             </a:r>
           </a:p>
           <a:p>
             <a:pPr algn="ctr">
-              <a:defRPr sz="600">
-                <a:solidFill>
-                  <a:srgbClr val="475569"/>
-                </a:solidFill>
+              <a:defRPr sz="550">
+                <a:solidFill>
+                  <a:srgbClr val="64748B"/>
+                </a:solidFill>
+                <a:latin typeface="Arial"/>
               </a:defRPr>
             </a:pPr>
             <a:r>
-              <a:t>Statutory XAI</a:t>
-            </a:r>
-          </a:p>
-        </p:txBody>
-      </p:sp>
-      <p:sp>
-        <p:nvSpPr>
-          <p:cNvPr id="17445" name="Rounded Rectangle 17444"/>
+              <a:t>Ensemble Trees</a:t>
+            </a:r>
+          </a:p>
+        </p:txBody>
+      </p:sp>
+      <p:pic>
+        <p:nvPicPr>
+          <p:cNvPr id="17451" name="Picture 17450" descr="lightgbm_logo.png"/>
+          <p:cNvPicPr>
+            <a:picLocks noChangeAspect="1"/>
+          </p:cNvPicPr>
+          <p:nvPr/>
+        </p:nvPicPr>
+        <p:blipFill>
+          <a:blip r:embed="rId10"/>
+          <a:stretch>
+            <a:fillRect/>
+          </a:stretch>
+        </p:blipFill>
+        <p:spPr>
+          <a:xfrm>
+            <a:off x="5303520" y="5394960"/>
+            <a:ext cx="301752" cy="301752"/>
+          </a:xfrm>
+          <a:prstGeom prst="rect">
+            <a:avLst/>
+          </a:prstGeom>
+        </p:spPr>
+      </p:pic>
+      <p:sp>
+        <p:nvSpPr>
+          <p:cNvPr id="17452" name="Rounded Rectangle 17451"/>
           <p:cNvSpPr/>
           <p:nvPr/>
         </p:nvSpPr>
         <p:spPr>
           <a:xfrm>
-            <a:off x="6492240" y="5394960"/>
-            <a:ext cx="777240" cy="649224"/>
+            <a:off x="5879592" y="5358384"/>
+            <a:ext cx="740664" cy="731520"/>
           </a:xfrm>
           <a:prstGeom prst="roundRect">
             <a:avLst/>
@@ -11328,7 +11551,7 @@
           </a:solidFill>
           <a:ln w="15240">
             <a:solidFill>
-              <a:srgbClr val="1565C0"/>
+              <a:srgbClr val="1E293B"/>
             </a:solidFill>
           </a:ln>
         </p:spPr>
@@ -11347,44 +11570,162 @@
           </a:fontRef>
         </p:style>
         <p:txBody>
-          <a:bodyPr rtlCol="0" anchor="ctr" wrap="square" lIns="18288" rIns="18288"/>
+          <a:bodyPr rtlCol="0" anchor="b" wrap="square" lIns="18288" rIns="18288" bIns="36576"/>
           <a:lstStyle/>
           <a:p>
             <a:pPr algn="ctr">
-              <a:defRPr sz="750" b="1">
-                <a:solidFill>
-                  <a:srgbClr val="1565C0"/>
-                </a:solidFill>
+              <a:defRPr sz="650" b="1">
+                <a:solidFill>
+                  <a:srgbClr val="0F172A"/>
+                </a:solidFill>
+                <a:latin typeface="Arial"/>
               </a:defRPr>
             </a:pPr>
             <a:r>
-              <a:t>Leaflet GIS</a:t>
+              <a:t>TreeSHAP</a:t>
             </a:r>
           </a:p>
           <a:p>
             <a:pPr algn="ctr">
-              <a:defRPr sz="600">
-                <a:solidFill>
-                  <a:srgbClr val="475569"/>
-                </a:solidFill>
+              <a:defRPr sz="550">
+                <a:solidFill>
+                  <a:srgbClr val="64748B"/>
+                </a:solidFill>
+                <a:latin typeface="Arial"/>
               </a:defRPr>
             </a:pPr>
             <a:r>
-              <a:t>EPSG:4326 GeoJSON</a:t>
-            </a:r>
-          </a:p>
-        </p:txBody>
-      </p:sp>
-      <p:sp>
-        <p:nvSpPr>
-          <p:cNvPr id="17446" name="Rounded Rectangle 17445"/>
+              <a:t>Statutory XAI</a:t>
+            </a:r>
+          </a:p>
+        </p:txBody>
+      </p:sp>
+      <p:pic>
+        <p:nvPicPr>
+          <p:cNvPr id="17453" name="Picture 17452" descr="shap_logo.png"/>
+          <p:cNvPicPr>
+            <a:picLocks noChangeAspect="1"/>
+          </p:cNvPicPr>
+          <p:nvPr/>
+        </p:nvPicPr>
+        <p:blipFill>
+          <a:blip r:embed="rId11"/>
+          <a:stretch>
+            <a:fillRect/>
+          </a:stretch>
+        </p:blipFill>
+        <p:spPr>
+          <a:xfrm>
+            <a:off x="6099048" y="5394960"/>
+            <a:ext cx="301752" cy="301752"/>
+          </a:xfrm>
+          <a:prstGeom prst="rect">
+            <a:avLst/>
+          </a:prstGeom>
+        </p:spPr>
+      </p:pic>
+      <p:sp>
+        <p:nvSpPr>
+          <p:cNvPr id="17454" name="Rounded Rectangle 17453"/>
           <p:cNvSpPr/>
           <p:nvPr/>
         </p:nvSpPr>
         <p:spPr>
           <a:xfrm>
-            <a:off x="7333488" y="5394960"/>
-            <a:ext cx="777240" cy="649224"/>
+            <a:off x="6675120" y="5358384"/>
+            <a:ext cx="740664" cy="731520"/>
+          </a:xfrm>
+          <a:prstGeom prst="roundRect">
+            <a:avLst/>
+          </a:prstGeom>
+          <a:solidFill>
+            <a:srgbClr val="F8FAFC"/>
+          </a:solidFill>
+          <a:ln w="15240">
+            <a:solidFill>
+              <a:srgbClr val="74AC00"/>
+            </a:solidFill>
+          </a:ln>
+        </p:spPr>
+        <p:style>
+          <a:lnRef idx="1">
+            <a:schemeClr val="accent1"/>
+          </a:lnRef>
+          <a:fillRef idx="3">
+            <a:schemeClr val="accent1"/>
+          </a:fillRef>
+          <a:effectRef idx="2">
+            <a:schemeClr val="accent1"/>
+          </a:effectRef>
+          <a:fontRef idx="minor">
+            <a:schemeClr val="lt1"/>
+          </a:fontRef>
+        </p:style>
+        <p:txBody>
+          <a:bodyPr rtlCol="0" anchor="b" wrap="square" lIns="18288" rIns="18288" bIns="36576"/>
+          <a:lstStyle/>
+          <a:p>
+            <a:pPr algn="ctr">
+              <a:defRPr sz="650" b="1">
+                <a:solidFill>
+                  <a:srgbClr val="0F172A"/>
+                </a:solidFill>
+                <a:latin typeface="Arial"/>
+              </a:defRPr>
+            </a:pPr>
+            <a:r>
+              <a:t>Leaflet GIS</a:t>
+            </a:r>
+          </a:p>
+          <a:p>
+            <a:pPr algn="ctr">
+              <a:defRPr sz="550">
+                <a:solidFill>
+                  <a:srgbClr val="64748B"/>
+                </a:solidFill>
+                <a:latin typeface="Arial"/>
+              </a:defRPr>
+            </a:pPr>
+            <a:r>
+              <a:t>EPSG:4326 Maps</a:t>
+            </a:r>
+          </a:p>
+        </p:txBody>
+      </p:sp>
+      <p:pic>
+        <p:nvPicPr>
+          <p:cNvPr id="17455" name="Picture 17454" descr="leaflet_logo.png"/>
+          <p:cNvPicPr>
+            <a:picLocks noChangeAspect="1"/>
+          </p:cNvPicPr>
+          <p:nvPr/>
+        </p:nvPicPr>
+        <p:blipFill>
+          <a:blip r:embed="rId12"/>
+          <a:stretch>
+            <a:fillRect/>
+          </a:stretch>
+        </p:blipFill>
+        <p:spPr>
+          <a:xfrm>
+            <a:off x="6894576" y="5394960"/>
+            <a:ext cx="301752" cy="301752"/>
+          </a:xfrm>
+          <a:prstGeom prst="rect">
+            <a:avLst/>
+          </a:prstGeom>
+        </p:spPr>
+      </p:pic>
+      <p:sp>
+        <p:nvSpPr>
+          <p:cNvPr id="17456" name="Rounded Rectangle 17455"/>
+          <p:cNvSpPr/>
+          <p:nvPr/>
+        </p:nvSpPr>
+        <p:spPr>
+          <a:xfrm>
+            <a:off x="7470648" y="5358384"/>
+            <a:ext cx="740664" cy="731520"/>
           </a:xfrm>
           <a:prstGeom prst="roundRect">
             <a:avLst/>
@@ -11413,14 +11754,15 @@
           </a:fontRef>
         </p:style>
         <p:txBody>
-          <a:bodyPr rtlCol="0" anchor="ctr" wrap="square" lIns="18288" rIns="18288"/>
+          <a:bodyPr rtlCol="0" anchor="b" wrap="square" lIns="18288" rIns="18288" bIns="36576"/>
           <a:lstStyle/>
           <a:p>
             <a:pPr algn="ctr">
-              <a:defRPr sz="750" b="1">
-                <a:solidFill>
-                  <a:srgbClr val="336791"/>
-                </a:solidFill>
+              <a:defRPr sz="650" b="1">
+                <a:solidFill>
+                  <a:srgbClr val="0F172A"/>
+                </a:solidFill>
+                <a:latin typeface="Arial"/>
               </a:defRPr>
             </a:pPr>
             <a:r>
@@ -11429,10 +11771,11 @@
           </a:p>
           <a:p>
             <a:pPr algn="ctr">
-              <a:defRPr sz="600">
-                <a:solidFill>
-                  <a:srgbClr val="475569"/>
-                </a:solidFill>
+              <a:defRPr sz="550">
+                <a:solidFill>
+                  <a:srgbClr val="64748B"/>
+                </a:solidFill>
+                <a:latin typeface="Arial"/>
               </a:defRPr>
             </a:pPr>
             <a:r>
@@ -11441,16 +11784,40 @@
           </a:p>
         </p:txBody>
       </p:sp>
-      <p:sp>
-        <p:nvSpPr>
-          <p:cNvPr id="17447" name="Rounded Rectangle 17446"/>
+      <p:pic>
+        <p:nvPicPr>
+          <p:cNvPr id="17457" name="Picture 17456" descr="postgresql_logo.png"/>
+          <p:cNvPicPr>
+            <a:picLocks noChangeAspect="1"/>
+          </p:cNvPicPr>
+          <p:nvPr/>
+        </p:nvPicPr>
+        <p:blipFill>
+          <a:blip r:embed="rId13"/>
+          <a:stretch>
+            <a:fillRect/>
+          </a:stretch>
+        </p:blipFill>
+        <p:spPr>
+          <a:xfrm>
+            <a:off x="7690104" y="5394960"/>
+            <a:ext cx="301752" cy="301752"/>
+          </a:xfrm>
+          <a:prstGeom prst="rect">
+            <a:avLst/>
+          </a:prstGeom>
+        </p:spPr>
+      </p:pic>
+      <p:sp>
+        <p:nvSpPr>
+          <p:cNvPr id="17458" name="Rounded Rectangle 17457"/>
           <p:cNvSpPr/>
           <p:nvPr/>
         </p:nvSpPr>
         <p:spPr>
           <a:xfrm>
-            <a:off x="8174736" y="5394960"/>
-            <a:ext cx="777240" cy="649224"/>
+            <a:off x="8266176" y="5358384"/>
+            <a:ext cx="740664" cy="731520"/>
           </a:xfrm>
           <a:prstGeom prst="roundRect">
             <a:avLst/>
@@ -11460,7 +11827,7 @@
           </a:solidFill>
           <a:ln w="15240">
             <a:solidFill>
-              <a:srgbClr val="8E24AA"/>
+              <a:srgbClr val="4F46E5"/>
             </a:solidFill>
           </a:ln>
         </p:spPr>
@@ -11479,14 +11846,15 @@
           </a:fontRef>
         </p:style>
         <p:txBody>
-          <a:bodyPr rtlCol="0" anchor="ctr" wrap="square" lIns="18288" rIns="18288"/>
+          <a:bodyPr rtlCol="0" anchor="b" wrap="square" lIns="18288" rIns="18288" bIns="36576"/>
           <a:lstStyle/>
           <a:p>
             <a:pPr algn="ctr">
-              <a:defRPr sz="750" b="1">
-                <a:solidFill>
-                  <a:srgbClr val="8E24AA"/>
-                </a:solidFill>
+              <a:defRPr sz="650" b="1">
+                <a:solidFill>
+                  <a:srgbClr val="0F172A"/>
+                </a:solidFill>
+                <a:latin typeface="Arial"/>
               </a:defRPr>
             </a:pPr>
             <a:r>
@@ -11495,10 +11863,11 @@
           </a:p>
           <a:p>
             <a:pPr algn="ctr">
-              <a:defRPr sz="600">
-                <a:solidFill>
-                  <a:srgbClr val="475569"/>
-                </a:solidFill>
+              <a:defRPr sz="550">
+                <a:solidFill>
+                  <a:srgbClr val="64748B"/>
+                </a:solidFill>
+                <a:latin typeface="Arial"/>
               </a:defRPr>
             </a:pPr>
             <a:r>
@@ -11507,16 +11876,40 @@
           </a:p>
         </p:txBody>
       </p:sp>
-      <p:sp>
-        <p:nvSpPr>
-          <p:cNvPr id="17448" name="Rounded Rectangle 17447"/>
+      <p:pic>
+        <p:nvPicPr>
+          <p:cNvPr id="17459" name="Picture 17458" descr="sha256_logo.png"/>
+          <p:cNvPicPr>
+            <a:picLocks noChangeAspect="1"/>
+          </p:cNvPicPr>
+          <p:nvPr/>
+        </p:nvPicPr>
+        <p:blipFill>
+          <a:blip r:embed="rId14"/>
+          <a:stretch>
+            <a:fillRect/>
+          </a:stretch>
+        </p:blipFill>
+        <p:spPr>
+          <a:xfrm>
+            <a:off x="8485632" y="5394960"/>
+            <a:ext cx="301752" cy="301752"/>
+          </a:xfrm>
+          <a:prstGeom prst="rect">
+            <a:avLst/>
+          </a:prstGeom>
+        </p:spPr>
+      </p:pic>
+      <p:sp>
+        <p:nvSpPr>
+          <p:cNvPr id="17460" name="Rounded Rectangle 17459"/>
           <p:cNvSpPr/>
           <p:nvPr/>
         </p:nvSpPr>
         <p:spPr>
           <a:xfrm>
             <a:off x="9189720" y="1024128"/>
-            <a:ext cx="2560320" cy="5129784"/>
+            <a:ext cx="2560320" cy="5138928"/>
           </a:xfrm>
           <a:prstGeom prst="roundRect">
             <a:avLst/>
@@ -11554,7 +11947,7 @@
       </p:sp>
       <p:sp>
         <p:nvSpPr>
-          <p:cNvPr id="17449" name="TextBox 17448"/>
+          <p:cNvPr id="17461" name="TextBox 17460"/>
           <p:cNvSpPr txBox="1"/>
           <p:nvPr/>
         </p:nvSpPr>
@@ -11583,14 +11976,14 @@
               </a:defRPr>
             </a:pPr>
             <a:r>
-              <a:t>🎯 Implementation Process</a:t>
-            </a:r>
-          </a:p>
-        </p:txBody>
-      </p:sp>
-      <p:sp>
-        <p:nvSpPr>
-          <p:cNvPr id="17450" name="Rectangle 17449"/>
+              <a:t>Implementation Process</a:t>
+            </a:r>
+          </a:p>
+        </p:txBody>
+      </p:sp>
+      <p:sp>
+        <p:nvSpPr>
+          <p:cNvPr id="17462" name="Rectangle 17461"/>
           <p:cNvSpPr/>
           <p:nvPr/>
         </p:nvSpPr>
@@ -11633,64 +12026,33 @@
           </a:p>
         </p:txBody>
       </p:sp>
-      <p:sp>
-        <p:nvSpPr>
-          <p:cNvPr id="17451" name="Oval 17450"/>
-          <p:cNvSpPr/>
+      <p:pic>
+        <p:nvPicPr>
+          <p:cNvPr id="17463" name="Picture 17462" descr="step1_ingest.png"/>
+          <p:cNvPicPr>
+            <a:picLocks noChangeAspect="1"/>
+          </p:cNvPicPr>
           <p:nvPr/>
-        </p:nvSpPr>
-        <p:spPr>
-          <a:xfrm>
-            <a:off x="9354312" y="1536192"/>
-            <a:ext cx="402336" cy="402336"/>
-          </a:xfrm>
-          <a:prstGeom prst="ellipse">
+        </p:nvPicPr>
+        <p:blipFill>
+          <a:blip r:embed="rId15"/>
+          <a:stretch>
+            <a:fillRect/>
+          </a:stretch>
+        </p:blipFill>
+        <p:spPr>
+          <a:xfrm>
+            <a:off x="9336024" y="1536192"/>
+            <a:ext cx="420624" cy="420624"/>
+          </a:xfrm>
+          <a:prstGeom prst="rect">
             <a:avLst/>
           </a:prstGeom>
-          <a:solidFill>
-            <a:srgbClr val="00695C"/>
-          </a:solidFill>
-          <a:ln w="19050">
-            <a:solidFill>
-              <a:srgbClr val="FFFFFF"/>
-            </a:solidFill>
-          </a:ln>
-        </p:spPr>
-        <p:style>
-          <a:lnRef idx="1">
-            <a:schemeClr val="accent1"/>
-          </a:lnRef>
-          <a:fillRef idx="3">
-            <a:schemeClr val="accent1"/>
-          </a:fillRef>
-          <a:effectRef idx="2">
-            <a:schemeClr val="accent1"/>
-          </a:effectRef>
-          <a:fontRef idx="minor">
-            <a:schemeClr val="lt1"/>
-          </a:fontRef>
-        </p:style>
-        <p:txBody>
-          <a:bodyPr rtlCol="0" anchor="ctr"/>
-          <a:lstStyle/>
-          <a:p>
-            <a:pPr algn="ctr">
-              <a:defRPr sz="1000" b="1">
-                <a:solidFill>
-                  <a:srgbClr val="FFFFFF"/>
-                </a:solidFill>
-                <a:latin typeface="Arial"/>
-              </a:defRPr>
-            </a:pPr>
-            <a:r>
-              <a:t>1</a:t>
-            </a:r>
-          </a:p>
-        </p:txBody>
-      </p:sp>
-      <p:sp>
-        <p:nvSpPr>
-          <p:cNvPr id="17452" name="TextBox 17451"/>
+        </p:spPr>
+      </p:pic>
+      <p:sp>
+        <p:nvSpPr>
+          <p:cNvPr id="17464" name="TextBox 17463"/>
           <p:cNvSpPr txBox="1"/>
           <p:nvPr/>
         </p:nvSpPr>
@@ -11740,64 +12102,33 @@
           </a:p>
         </p:txBody>
       </p:sp>
-      <p:sp>
-        <p:nvSpPr>
-          <p:cNvPr id="17453" name="Oval 17452"/>
-          <p:cNvSpPr/>
+      <p:pic>
+        <p:nvPicPr>
+          <p:cNvPr id="17465" name="Picture 17464" descr="step2_centraldb.png"/>
+          <p:cNvPicPr>
+            <a:picLocks noChangeAspect="1"/>
+          </p:cNvPicPr>
           <p:nvPr/>
-        </p:nvSpPr>
-        <p:spPr>
-          <a:xfrm>
-            <a:off x="9354312" y="2295144"/>
-            <a:ext cx="402336" cy="402336"/>
-          </a:xfrm>
-          <a:prstGeom prst="ellipse">
+        </p:nvPicPr>
+        <p:blipFill>
+          <a:blip r:embed="rId16"/>
+          <a:stretch>
+            <a:fillRect/>
+          </a:stretch>
+        </p:blipFill>
+        <p:spPr>
+          <a:xfrm>
+            <a:off x="9336024" y="2295144"/>
+            <a:ext cx="420624" cy="420624"/>
+          </a:xfrm>
+          <a:prstGeom prst="rect">
             <a:avLst/>
           </a:prstGeom>
-          <a:solidFill>
-            <a:srgbClr val="263238"/>
-          </a:solidFill>
-          <a:ln w="19050">
-            <a:solidFill>
-              <a:srgbClr val="FFFFFF"/>
-            </a:solidFill>
-          </a:ln>
-        </p:spPr>
-        <p:style>
-          <a:lnRef idx="1">
-            <a:schemeClr val="accent1"/>
-          </a:lnRef>
-          <a:fillRef idx="3">
-            <a:schemeClr val="accent1"/>
-          </a:fillRef>
-          <a:effectRef idx="2">
-            <a:schemeClr val="accent1"/>
-          </a:effectRef>
-          <a:fontRef idx="minor">
-            <a:schemeClr val="lt1"/>
-          </a:fontRef>
-        </p:style>
-        <p:txBody>
-          <a:bodyPr rtlCol="0" anchor="ctr"/>
-          <a:lstStyle/>
-          <a:p>
-            <a:pPr algn="ctr">
-              <a:defRPr sz="1000" b="1">
-                <a:solidFill>
-                  <a:srgbClr val="FFFFFF"/>
-                </a:solidFill>
-                <a:latin typeface="Arial"/>
-              </a:defRPr>
-            </a:pPr>
-            <a:r>
-              <a:t>2</a:t>
-            </a:r>
-          </a:p>
-        </p:txBody>
-      </p:sp>
-      <p:sp>
-        <p:nvSpPr>
-          <p:cNvPr id="17454" name="TextBox 17453"/>
+        </p:spPr>
+      </p:pic>
+      <p:sp>
+        <p:nvSpPr>
+          <p:cNvPr id="17466" name="TextBox 17465"/>
           <p:cNvSpPr txBox="1"/>
           <p:nvPr/>
         </p:nvSpPr>
@@ -11847,64 +12178,33 @@
           </a:p>
         </p:txBody>
       </p:sp>
-      <p:sp>
-        <p:nvSpPr>
-          <p:cNvPr id="17455" name="Oval 17454"/>
-          <p:cNvSpPr/>
+      <p:pic>
+        <p:nvPicPr>
+          <p:cNvPr id="17467" name="Picture 17466" descr="step3_ml.png"/>
+          <p:cNvPicPr>
+            <a:picLocks noChangeAspect="1"/>
+          </p:cNvPicPr>
           <p:nvPr/>
-        </p:nvSpPr>
-        <p:spPr>
-          <a:xfrm>
-            <a:off x="9354312" y="3054096"/>
-            <a:ext cx="402336" cy="402336"/>
-          </a:xfrm>
-          <a:prstGeom prst="ellipse">
+        </p:nvPicPr>
+        <p:blipFill>
+          <a:blip r:embed="rId17"/>
+          <a:stretch>
+            <a:fillRect/>
+          </a:stretch>
+        </p:blipFill>
+        <p:spPr>
+          <a:xfrm>
+            <a:off x="9336024" y="3054096"/>
+            <a:ext cx="420624" cy="420624"/>
+          </a:xfrm>
+          <a:prstGeom prst="rect">
             <a:avLst/>
           </a:prstGeom>
-          <a:solidFill>
-            <a:srgbClr val="E65100"/>
-          </a:solidFill>
-          <a:ln w="19050">
-            <a:solidFill>
-              <a:srgbClr val="FFFFFF"/>
-            </a:solidFill>
-          </a:ln>
-        </p:spPr>
-        <p:style>
-          <a:lnRef idx="1">
-            <a:schemeClr val="accent1"/>
-          </a:lnRef>
-          <a:fillRef idx="3">
-            <a:schemeClr val="accent1"/>
-          </a:fillRef>
-          <a:effectRef idx="2">
-            <a:schemeClr val="accent1"/>
-          </a:effectRef>
-          <a:fontRef idx="minor">
-            <a:schemeClr val="lt1"/>
-          </a:fontRef>
-        </p:style>
-        <p:txBody>
-          <a:bodyPr rtlCol="0" anchor="ctr"/>
-          <a:lstStyle/>
-          <a:p>
-            <a:pPr algn="ctr">
-              <a:defRPr sz="1000" b="1">
-                <a:solidFill>
-                  <a:srgbClr val="FFFFFF"/>
-                </a:solidFill>
-                <a:latin typeface="Arial"/>
-              </a:defRPr>
-            </a:pPr>
-            <a:r>
-              <a:t>3</a:t>
-            </a:r>
-          </a:p>
-        </p:txBody>
-      </p:sp>
-      <p:sp>
-        <p:nvSpPr>
-          <p:cNvPr id="17456" name="TextBox 17455"/>
+        </p:spPr>
+      </p:pic>
+      <p:sp>
+        <p:nvSpPr>
+          <p:cNvPr id="17468" name="TextBox 17467"/>
           <p:cNvSpPr txBox="1"/>
           <p:nvPr/>
         </p:nvSpPr>
@@ -11954,64 +12254,33 @@
           </a:p>
         </p:txBody>
       </p:sp>
-      <p:sp>
-        <p:nvSpPr>
-          <p:cNvPr id="17457" name="Oval 17456"/>
-          <p:cNvSpPr/>
+      <p:pic>
+        <p:nvPicPr>
+          <p:cNvPr id="17469" name="Picture 17468" descr="step4_shap.png"/>
+          <p:cNvPicPr>
+            <a:picLocks noChangeAspect="1"/>
+          </p:cNvPicPr>
           <p:nvPr/>
-        </p:nvSpPr>
-        <p:spPr>
-          <a:xfrm>
-            <a:off x="9354312" y="3813048"/>
-            <a:ext cx="402336" cy="402336"/>
-          </a:xfrm>
-          <a:prstGeom prst="ellipse">
+        </p:nvPicPr>
+        <p:blipFill>
+          <a:blip r:embed="rId18"/>
+          <a:stretch>
+            <a:fillRect/>
+          </a:stretch>
+        </p:blipFill>
+        <p:spPr>
+          <a:xfrm>
+            <a:off x="9336024" y="3813048"/>
+            <a:ext cx="420624" cy="420624"/>
+          </a:xfrm>
+          <a:prstGeom prst="rect">
             <a:avLst/>
           </a:prstGeom>
-          <a:solidFill>
-            <a:srgbClr val="33691E"/>
-          </a:solidFill>
-          <a:ln w="19050">
-            <a:solidFill>
-              <a:srgbClr val="FFFFFF"/>
-            </a:solidFill>
-          </a:ln>
-        </p:spPr>
-        <p:style>
-          <a:lnRef idx="1">
-            <a:schemeClr val="accent1"/>
-          </a:lnRef>
-          <a:fillRef idx="3">
-            <a:schemeClr val="accent1"/>
-          </a:fillRef>
-          <a:effectRef idx="2">
-            <a:schemeClr val="accent1"/>
-          </a:effectRef>
-          <a:fontRef idx="minor">
-            <a:schemeClr val="lt1"/>
-          </a:fontRef>
-        </p:style>
-        <p:txBody>
-          <a:bodyPr rtlCol="0" anchor="ctr"/>
-          <a:lstStyle/>
-          <a:p>
-            <a:pPr algn="ctr">
-              <a:defRPr sz="1000" b="1">
-                <a:solidFill>
-                  <a:srgbClr val="FFFFFF"/>
-                </a:solidFill>
-                <a:latin typeface="Arial"/>
-              </a:defRPr>
-            </a:pPr>
-            <a:r>
-              <a:t>4</a:t>
-            </a:r>
-          </a:p>
-        </p:txBody>
-      </p:sp>
-      <p:sp>
-        <p:nvSpPr>
-          <p:cNvPr id="17458" name="TextBox 17457"/>
+        </p:spPr>
+      </p:pic>
+      <p:sp>
+        <p:nvSpPr>
+          <p:cNvPr id="17470" name="TextBox 17469"/>
           <p:cNvSpPr txBox="1"/>
           <p:nvPr/>
         </p:nvSpPr>
@@ -12061,64 +12330,33 @@
           </a:p>
         </p:txBody>
       </p:sp>
-      <p:sp>
-        <p:nvSpPr>
-          <p:cNvPr id="17459" name="Oval 17458"/>
-          <p:cNvSpPr/>
+      <p:pic>
+        <p:nvPicPr>
+          <p:cNvPr id="17471" name="Picture 17470" descr="step5_dfa.png"/>
+          <p:cNvPicPr>
+            <a:picLocks noChangeAspect="1"/>
+          </p:cNvPicPr>
           <p:nvPr/>
-        </p:nvSpPr>
-        <p:spPr>
-          <a:xfrm>
-            <a:off x="9354312" y="4572000"/>
-            <a:ext cx="402336" cy="402336"/>
-          </a:xfrm>
-          <a:prstGeom prst="ellipse">
+        </p:nvPicPr>
+        <p:blipFill>
+          <a:blip r:embed="rId19"/>
+          <a:stretch>
+            <a:fillRect/>
+          </a:stretch>
+        </p:blipFill>
+        <p:spPr>
+          <a:xfrm>
+            <a:off x="9336024" y="4572000"/>
+            <a:ext cx="420624" cy="420624"/>
+          </a:xfrm>
+          <a:prstGeom prst="rect">
             <a:avLst/>
           </a:prstGeom>
-          <a:solidFill>
-            <a:srgbClr val="BF360C"/>
-          </a:solidFill>
-          <a:ln w="19050">
-            <a:solidFill>
-              <a:srgbClr val="FFFFFF"/>
-            </a:solidFill>
-          </a:ln>
-        </p:spPr>
-        <p:style>
-          <a:lnRef idx="1">
-            <a:schemeClr val="accent1"/>
-          </a:lnRef>
-          <a:fillRef idx="3">
-            <a:schemeClr val="accent1"/>
-          </a:fillRef>
-          <a:effectRef idx="2">
-            <a:schemeClr val="accent1"/>
-          </a:effectRef>
-          <a:fontRef idx="minor">
-            <a:schemeClr val="lt1"/>
-          </a:fontRef>
-        </p:style>
-        <p:txBody>
-          <a:bodyPr rtlCol="0" anchor="ctr"/>
-          <a:lstStyle/>
-          <a:p>
-            <a:pPr algn="ctr">
-              <a:defRPr sz="1000" b="1">
-                <a:solidFill>
-                  <a:srgbClr val="FFFFFF"/>
-                </a:solidFill>
-                <a:latin typeface="Arial"/>
-              </a:defRPr>
-            </a:pPr>
-            <a:r>
-              <a:t>5</a:t>
-            </a:r>
-          </a:p>
-        </p:txBody>
-      </p:sp>
-      <p:sp>
-        <p:nvSpPr>
-          <p:cNvPr id="17460" name="TextBox 17459"/>
+        </p:spPr>
+      </p:pic>
+      <p:sp>
+        <p:nvSpPr>
+          <p:cNvPr id="17472" name="TextBox 17471"/>
           <p:cNvSpPr txBox="1"/>
           <p:nvPr/>
         </p:nvSpPr>
@@ -12168,64 +12406,33 @@
           </a:p>
         </p:txBody>
       </p:sp>
-      <p:sp>
-        <p:nvSpPr>
-          <p:cNvPr id="17461" name="Oval 17460"/>
-          <p:cNvSpPr/>
+      <p:pic>
+        <p:nvPicPr>
+          <p:cNvPr id="17473" name="Picture 17472" descr="step6_esign.png"/>
+          <p:cNvPicPr>
+            <a:picLocks noChangeAspect="1"/>
+          </p:cNvPicPr>
           <p:nvPr/>
-        </p:nvSpPr>
-        <p:spPr>
-          <a:xfrm>
-            <a:off x="9354312" y="5330952"/>
-            <a:ext cx="402336" cy="402336"/>
-          </a:xfrm>
-          <a:prstGeom prst="ellipse">
+        </p:nvPicPr>
+        <p:blipFill>
+          <a:blip r:embed="rId20"/>
+          <a:stretch>
+            <a:fillRect/>
+          </a:stretch>
+        </p:blipFill>
+        <p:spPr>
+          <a:xfrm>
+            <a:off x="9336024" y="5330952"/>
+            <a:ext cx="420624" cy="420624"/>
+          </a:xfrm>
+          <a:prstGeom prst="rect">
             <a:avLst/>
           </a:prstGeom>
-          <a:solidFill>
-            <a:srgbClr val="880E4F"/>
-          </a:solidFill>
-          <a:ln w="19050">
-            <a:solidFill>
-              <a:srgbClr val="FFFFFF"/>
-            </a:solidFill>
-          </a:ln>
-        </p:spPr>
-        <p:style>
-          <a:lnRef idx="1">
-            <a:schemeClr val="accent1"/>
-          </a:lnRef>
-          <a:fillRef idx="3">
-            <a:schemeClr val="accent1"/>
-          </a:fillRef>
-          <a:effectRef idx="2">
-            <a:schemeClr val="accent1"/>
-          </a:effectRef>
-          <a:fontRef idx="minor">
-            <a:schemeClr val="lt1"/>
-          </a:fontRef>
-        </p:style>
-        <p:txBody>
-          <a:bodyPr rtlCol="0" anchor="ctr"/>
-          <a:lstStyle/>
-          <a:p>
-            <a:pPr algn="ctr">
-              <a:defRPr sz="1000" b="1">
-                <a:solidFill>
-                  <a:srgbClr val="FFFFFF"/>
-                </a:solidFill>
-                <a:latin typeface="Arial"/>
-              </a:defRPr>
-            </a:pPr>
-            <a:r>
-              <a:t>6</a:t>
-            </a:r>
-          </a:p>
-        </p:txBody>
-      </p:sp>
-      <p:sp>
-        <p:nvSpPr>
-          <p:cNvPr id="17462" name="TextBox 17461"/>
+        </p:spPr>
+      </p:pic>
+      <p:sp>
+        <p:nvSpPr>
+          <p:cNvPr id="17474" name="TextBox 17473"/>
           <p:cNvSpPr txBox="1"/>
           <p:nvPr/>
         </p:nvSpPr>

</xml_diff>

<commit_message>
feat(sih): design Slide 4 completely matching SIHex2 Feasibility & Viability style with custom vector badges
</commit_message>
<xml_diff>
--- a/sih/GatiShakti_AI_SIH2026_Presentation.pptx
+++ b/sih/GatiShakti_AI_SIH2026_Presentation.pptx
@@ -12607,15 +12607,15 @@
           <a:lstStyle/>
           <a:p>
             <a:pPr algn="l">
-              <a:defRPr sz="2200" b="1">
-                <a:solidFill>
-                  <a:srgbClr val="1A365D"/>
-                </a:solidFill>
-                <a:latin typeface="Times New Roman"/>
+              <a:defRPr sz="2400" b="1">
+                <a:solidFill>
+                  <a:srgbClr val="003366"/>
+                </a:solidFill>
+                <a:latin typeface="Arial"/>
               </a:defRPr>
             </a:pPr>
             <a:r>
-              <a:t>FEASIBILITY AND VIABILITY: REGULATORY COMPLIANCE &amp; RIGOR</a:t>
+              <a:t>FEASIBILITY AND VIABILITY</a:t>
             </a:r>
           </a:p>
         </p:txBody>
@@ -12812,18 +12812,18 @@
         </p:nvSpPr>
         <p:spPr>
           <a:xfrm>
-            <a:off x="457200" y="1097280"/>
-            <a:ext cx="3383280" cy="4754880"/>
+            <a:off x="438912" y="1051560"/>
+            <a:ext cx="5559552" cy="3108960"/>
           </a:xfrm>
           <a:prstGeom prst="roundRect">
             <a:avLst/>
           </a:prstGeom>
           <a:solidFill>
-            <a:srgbClr val="F8FAFC"/>
+            <a:srgbClr val="FFFFFF"/>
           </a:solidFill>
           <a:ln w="19050">
             <a:solidFill>
-              <a:srgbClr val="2563EB"/>
+              <a:srgbClr val="0070C0"/>
             </a:solidFill>
           </a:ln>
         </p:spPr>
@@ -12842,256 +12842,373 @@
           </a:fontRef>
         </p:style>
         <p:txBody>
-          <a:bodyPr rtlCol="0" anchor="ctr" wrap="square"/>
+          <a:bodyPr rtlCol="0" anchor="ctr"/>
           <a:lstStyle/>
           <a:p>
-            <a:pPr algn="ctr">
+            <a:pPr algn="ctr"/>
+          </a:p>
+        </p:txBody>
+      </p:sp>
+      <p:pic>
+        <p:nvPicPr>
+          <p:cNvPr id="17411" name="Picture 17410" descr="feasibility_badge.png"/>
+          <p:cNvPicPr>
+            <a:picLocks noChangeAspect="1"/>
+          </p:cNvPicPr>
+          <p:nvPr/>
+        </p:nvPicPr>
+        <p:blipFill>
+          <a:blip r:embed="rId4"/>
+          <a:stretch>
+            <a:fillRect/>
+          </a:stretch>
+        </p:blipFill>
+        <p:spPr>
+          <a:xfrm>
+            <a:off x="585216" y="1161288"/>
+            <a:ext cx="329184" cy="329184"/>
+          </a:xfrm>
+          <a:prstGeom prst="rect">
+            <a:avLst/>
+          </a:prstGeom>
+        </p:spPr>
+      </p:pic>
+      <p:sp>
+        <p:nvSpPr>
+          <p:cNvPr id="17412" name="TextBox 17411"/>
+          <p:cNvSpPr txBox="1"/>
+          <p:nvPr/>
+        </p:nvSpPr>
+        <p:spPr>
+          <a:xfrm>
+            <a:off x="950976" y="1143000"/>
+            <a:ext cx="4114800" cy="347472"/>
+          </a:xfrm>
+          <a:prstGeom prst="rect">
+            <a:avLst/>
+          </a:prstGeom>
+          <a:noFill/>
+        </p:spPr>
+        <p:txBody>
+          <a:bodyPr wrap="none">
+            <a:spAutoFit/>
+          </a:bodyPr>
+          <a:lstStyle/>
+          <a:p>
+            <a:pPr>
+              <a:defRPr sz="1350" b="1">
+                <a:solidFill>
+                  <a:srgbClr val="0070C0"/>
+                </a:solidFill>
+                <a:latin typeface="Arial"/>
+              </a:defRPr>
+            </a:pPr>
+            <a:r>
+              <a:t>FEASIBILITY :</a:t>
+            </a:r>
+          </a:p>
+        </p:txBody>
+      </p:sp>
+      <p:sp>
+        <p:nvSpPr>
+          <p:cNvPr id="17413" name="TextBox 17412"/>
+          <p:cNvSpPr txBox="1"/>
+          <p:nvPr/>
+        </p:nvSpPr>
+        <p:spPr>
+          <a:xfrm>
+            <a:off x="585216" y="1508760"/>
+            <a:ext cx="5266944" cy="2606040"/>
+          </a:xfrm>
+          <a:prstGeom prst="rect">
+            <a:avLst/>
+          </a:prstGeom>
+          <a:noFill/>
+        </p:spPr>
+        <p:txBody>
+          <a:bodyPr wrap="square" anchor="t" tIns="18288" lIns="36576" rIns="36576">
+            <a:spAutoFit/>
+          </a:bodyPr>
+          <a:lstStyle/>
+          <a:p>
+            <a:pPr>
+              <a:spcBef>
+                <a:spcPts val="300"/>
+              </a:spcBef>
               <a:spcAft>
-                <a:spcPts val="1000"/>
+                <a:spcPts val="100"/>
               </a:spcAft>
-            </a:pPr>
-            <a:r>
-              <a:rPr sz="1200" b="1">
-                <a:solidFill>
-                  <a:srgbClr val="2563EB"/>
+              <a:defRPr sz="950" b="1">
+                <a:solidFill>
+                  <a:srgbClr val="0F172A"/>
+                </a:solidFill>
+                <a:latin typeface="Arial"/>
+              </a:defRPr>
+            </a:pPr>
+            <a:r>
+              <a:t>Technical :</a:t>
+            </a:r>
+          </a:p>
+          <a:p>
+            <a:pPr>
+              <a:spcBef>
+                <a:spcPts val="100"/>
+              </a:spcBef>
+              <a:spcAft>
+                <a:spcPts val="200"/>
+              </a:spcAft>
+            </a:pPr>
+            <a:r>
+              <a:rPr sz="850" b="1">
+                <a:solidFill>
+                  <a:srgbClr val="0070C0"/>
                 </a:solidFill>
                 <a:latin typeface="Arial"/>
               </a:rPr>
-              <a:t>1. Feasibility Analysis</a:t>
+              <a:t>•  </a:t>
+            </a:r>
+            <a:r>
+              <a:rPr sz="850" b="1">
+                <a:solidFill>
+                  <a:srgbClr val="0070C0"/>
+                </a:solidFill>
+                <a:latin typeface="Arial"/>
+              </a:rPr>
+              <a:t>Proven Decoupled Stack : </a:t>
+            </a:r>
+            <a:r>
+              <a:rPr sz="850">
+                <a:solidFill>
+                  <a:srgbClr val="334155"/>
+                </a:solidFill>
+                <a:latin typeface="Arial"/>
+              </a:rPr>
+              <a:t>Python 3.13, FastAPI, React 19, LightGBM, PostgreSQL — queries execute in &lt;15ms.</a:t>
             </a:r>
           </a:p>
           <a:p>
             <a:pPr>
+              <a:spcBef>
+                <a:spcPts val="100"/>
+              </a:spcBef>
               <a:spcAft>
-                <a:spcPts val="800"/>
+                <a:spcPts val="200"/>
               </a:spcAft>
             </a:pPr>
             <a:r>
-              <a:rPr sz="950" b="1">
-                <a:solidFill>
-                  <a:srgbClr val="1E293B"/>
+              <a:rPr sz="850" b="1">
+                <a:solidFill>
+                  <a:srgbClr val="0070C0"/>
                 </a:solidFill>
                 <a:latin typeface="Arial"/>
               </a:rPr>
-              <a:t>• Technical Feasibility:
-</a:t>
+              <a:t>•  </a:t>
+            </a:r>
+            <a:r>
+              <a:rPr sz="850" b="1">
+                <a:solidFill>
+                  <a:srgbClr val="0070C0"/>
+                </a:solidFill>
+                <a:latin typeface="Arial"/>
+              </a:rPr>
+              <a:t>Statutory Compliance : </a:t>
             </a:r>
             <a:r>
               <a:rPr sz="850">
                 <a:solidFill>
-                  <a:srgbClr val="475569"/>
+                  <a:srgbClr val="334155"/>
                 </a:solidFill>
                 <a:latin typeface="Arial"/>
               </a:rPr>
-              <a:t>  Decoupled Central DB eliminates slow OCR parsing; queries execute in &lt;15ms. Low-overhead CPU-optimized models run without requiring expensive GPU clusters.</a:t>
+              <a:t>100% compliant with National Highways Act 1956 (§ 3A–3H) and RFCTLARR Act 2013.</a:t>
             </a:r>
           </a:p>
           <a:p>
             <a:pPr>
+              <a:spcBef>
+                <a:spcPts val="300"/>
+              </a:spcBef>
               <a:spcAft>
-                <a:spcPts val="800"/>
+                <a:spcPts val="100"/>
               </a:spcAft>
-            </a:pPr>
-            <a:r>
-              <a:rPr sz="950" b="1">
-                <a:solidFill>
-                  <a:srgbClr val="1E293B"/>
+              <a:defRPr sz="950" b="1">
+                <a:solidFill>
+                  <a:srgbClr val="0F172A"/>
+                </a:solidFill>
+                <a:latin typeface="Arial"/>
+              </a:defRPr>
+            </a:pPr>
+            <a:r>
+              <a:t>Innovation :</a:t>
+            </a:r>
+          </a:p>
+          <a:p>
+            <a:pPr>
+              <a:spcBef>
+                <a:spcPts val="100"/>
+              </a:spcBef>
+              <a:spcAft>
+                <a:spcPts val="200"/>
+              </a:spcAft>
+            </a:pPr>
+            <a:r>
+              <a:rPr sz="850" b="1">
+                <a:solidFill>
+                  <a:srgbClr val="0070C0"/>
                 </a:solidFill>
                 <a:latin typeface="Arial"/>
               </a:rPr>
-              <a:t>• Operational Feasibility:
-</a:t>
+              <a:t>•  </a:t>
+            </a:r>
+            <a:r>
+              <a:rPr sz="850" b="1">
+                <a:solidFill>
+                  <a:srgbClr val="0070C0"/>
+                </a:solidFill>
+                <a:latin typeface="Arial"/>
+              </a:rPr>
+              <a:t>Dual-Track Reality Engine : </a:t>
             </a:r>
             <a:r>
               <a:rPr sz="850">
                 <a:solidFill>
-                  <a:srgbClr val="475569"/>
+                  <a:srgbClr val="334155"/>
                 </a:solidFill>
                 <a:latin typeface="Arial"/>
               </a:rPr>
-              <a:t>  Plug-and-play REST API Gateway (Point 11) integrates seamlessly into existing NIC systems (Bhoomi Rashi, PM GatiShakti NMP, PRAGATI portal).</a:t>
+              <a:t>Decouples physical civil road construction from court escrow disputes under Sec 3D(2) vesting.</a:t>
             </a:r>
           </a:p>
           <a:p>
             <a:pPr>
+              <a:spcBef>
+                <a:spcPts val="300"/>
+              </a:spcBef>
               <a:spcAft>
-                <a:spcPts val="800"/>
+                <a:spcPts val="100"/>
               </a:spcAft>
-            </a:pPr>
-            <a:r>
-              <a:rPr sz="950" b="1">
-                <a:solidFill>
-                  <a:srgbClr val="1E293B"/>
+              <a:defRPr sz="950" b="1">
+                <a:solidFill>
+                  <a:srgbClr val="0F172A"/>
+                </a:solidFill>
+                <a:latin typeface="Arial"/>
+              </a:defRPr>
+            </a:pPr>
+            <a:r>
+              <a:t>Operational :</a:t>
+            </a:r>
+          </a:p>
+          <a:p>
+            <a:pPr>
+              <a:spcBef>
+                <a:spcPts val="100"/>
+              </a:spcBef>
+              <a:spcAft>
+                <a:spcPts val="200"/>
+              </a:spcAft>
+            </a:pPr>
+            <a:r>
+              <a:rPr sz="850" b="1">
+                <a:solidFill>
+                  <a:srgbClr val="0070C0"/>
                 </a:solidFill>
                 <a:latin typeface="Arial"/>
               </a:rPr>
-              <a:t>• Financial Feasibility:
-</a:t>
+              <a:t>•  </a:t>
+            </a:r>
+            <a:r>
+              <a:rPr sz="850" b="1">
+                <a:solidFill>
+                  <a:srgbClr val="0070C0"/>
+                </a:solidFill>
+                <a:latin typeface="Arial"/>
+              </a:rPr>
+              <a:t>Plug-and-Play Integration : </a:t>
             </a:r>
             <a:r>
               <a:rPr sz="850">
                 <a:solidFill>
-                  <a:srgbClr val="475569"/>
+                  <a:srgbClr val="334155"/>
                 </a:solidFill>
                 <a:latin typeface="Arial"/>
               </a:rPr>
-              <a:t>  Built on 100% open-source software with zero proprietary recurring per-seat licensing fees, making national deployment highly cost-effective.</a:t>
-            </a:r>
-          </a:p>
-        </p:txBody>
-      </p:sp>
-      <p:sp>
-        <p:nvSpPr>
-          <p:cNvPr id="17411" name="Rounded Rectangle 17410"/>
+              <a:t>Point 11 compliant REST API Gateway integrates directly into existing NHAI / BhoomiRashi systems.</a:t>
+            </a:r>
+          </a:p>
+          <a:p>
+            <a:pPr>
+              <a:spcBef>
+                <a:spcPts val="300"/>
+              </a:spcBef>
+              <a:spcAft>
+                <a:spcPts val="100"/>
+              </a:spcAft>
+              <a:defRPr sz="950" b="1">
+                <a:solidFill>
+                  <a:srgbClr val="0F172A"/>
+                </a:solidFill>
+                <a:latin typeface="Arial"/>
+              </a:defRPr>
+            </a:pPr>
+            <a:r>
+              <a:t>Economic :</a:t>
+            </a:r>
+          </a:p>
+          <a:p>
+            <a:pPr>
+              <a:spcBef>
+                <a:spcPts val="100"/>
+              </a:spcBef>
+              <a:spcAft>
+                <a:spcPts val="200"/>
+              </a:spcAft>
+            </a:pPr>
+            <a:r>
+              <a:rPr sz="850" b="1">
+                <a:solidFill>
+                  <a:srgbClr val="0070C0"/>
+                </a:solidFill>
+                <a:latin typeface="Arial"/>
+              </a:rPr>
+              <a:t>•  </a:t>
+            </a:r>
+            <a:r>
+              <a:rPr sz="850" b="1">
+                <a:solidFill>
+                  <a:srgbClr val="0070C0"/>
+                </a:solidFill>
+                <a:latin typeface="Arial"/>
+              </a:rPr>
+              <a:t>Zero Recurring Licensing : </a:t>
+            </a:r>
+            <a:r>
+              <a:rPr sz="850">
+                <a:solidFill>
+                  <a:srgbClr val="334155"/>
+                </a:solidFill>
+                <a:latin typeface="Arial"/>
+              </a:rPr>
+              <a:t>Built on 100% open-source software stack with no proprietary per-seat vendor fees.</a:t>
+            </a:r>
+          </a:p>
+        </p:txBody>
+      </p:sp>
+      <p:sp>
+        <p:nvSpPr>
+          <p:cNvPr id="17414" name="Rounded Rectangle 17413"/>
           <p:cNvSpPr/>
           <p:nvPr/>
         </p:nvSpPr>
         <p:spPr>
           <a:xfrm>
-            <a:off x="4023360" y="1097280"/>
-            <a:ext cx="3383280" cy="4754880"/>
+            <a:off x="6199632" y="1051560"/>
+            <a:ext cx="5559552" cy="3108960"/>
           </a:xfrm>
           <a:prstGeom prst="roundRect">
             <a:avLst/>
           </a:prstGeom>
           <a:solidFill>
-            <a:srgbClr val="F8FAFC"/>
-          </a:solidFill>
-          <a:ln w="19050">
-            <a:solidFill>
-              <a:srgbClr val="D97706"/>
-            </a:solidFill>
-          </a:ln>
-        </p:spPr>
-        <p:style>
-          <a:lnRef idx="1">
-            <a:schemeClr val="accent1"/>
-          </a:lnRef>
-          <a:fillRef idx="3">
-            <a:schemeClr val="accent1"/>
-          </a:fillRef>
-          <a:effectRef idx="2">
-            <a:schemeClr val="accent1"/>
-          </a:effectRef>
-          <a:fontRef idx="minor">
-            <a:schemeClr val="lt1"/>
-          </a:fontRef>
-        </p:style>
-        <p:txBody>
-          <a:bodyPr rtlCol="0" anchor="ctr" wrap="square"/>
-          <a:lstStyle/>
-          <a:p>
-            <a:pPr algn="ctr">
-              <a:spcAft>
-                <a:spcPts val="1000"/>
-              </a:spcAft>
-            </a:pPr>
-            <a:r>
-              <a:rPr sz="1200" b="1">
-                <a:solidFill>
-                  <a:srgbClr val="D97706"/>
-                </a:solidFill>
-                <a:latin typeface="Arial"/>
-              </a:rPr>
-              <a:t>2. Challenges &amp; Statutory Risks</a:t>
-            </a:r>
-          </a:p>
-          <a:p>
-            <a:pPr>
-              <a:spcAft>
-                <a:spcPts val="800"/>
-              </a:spcAft>
-            </a:pPr>
-            <a:r>
-              <a:rPr sz="950" b="1">
-                <a:solidFill>
-                  <a:srgbClr val="1E293B"/>
-                </a:solidFill>
-                <a:latin typeface="Arial"/>
-              </a:rPr>
-              <a:t>• State Revenue Nomenclature:
-</a:t>
-            </a:r>
-            <a:r>
-              <a:rPr sz="850">
-                <a:solidFill>
-                  <a:srgbClr val="475569"/>
-                </a:solidFill>
-                <a:latin typeface="Arial"/>
-              </a:rPr>
-              <a:t>  Diverse land record formats across Indian states (Khasra/Khatauni in UP, Jamabandi in Punjab, 7/12 in Maharashtra) create integration friction.</a:t>
-            </a:r>
-          </a:p>
-          <a:p>
-            <a:pPr>
-              <a:spcAft>
-                <a:spcPts val="800"/>
-              </a:spcAft>
-            </a:pPr>
-            <a:r>
-              <a:rPr sz="950" b="1">
-                <a:solidFill>
-                  <a:srgbClr val="1E293B"/>
-                </a:solidFill>
-                <a:latin typeface="Arial"/>
-              </a:rPr>
-              <a:t>• Sub-Judice Legal Stays:
-</a:t>
-            </a:r>
-            <a:r>
-              <a:rPr sz="850">
-                <a:solidFill>
-                  <a:srgbClr val="475569"/>
-                </a:solidFill>
-                <a:latin typeface="Arial"/>
-              </a:rPr>
-              <a:t>  Judicial stays under Section 3H escrow often remain stalled indefinitely in district courts without transparent tracking.</a:t>
-            </a:r>
-          </a:p>
-          <a:p>
-            <a:pPr>
-              <a:spcAft>
-                <a:spcPts val="800"/>
-              </a:spcAft>
-            </a:pPr>
-            <a:r>
-              <a:rPr sz="950" b="1">
-                <a:solidFill>
-                  <a:srgbClr val="1E293B"/>
-                </a:solidFill>
-                <a:latin typeface="Arial"/>
-              </a:rPr>
-              <a:t>• Bureaucratic Adoption Resistance:
-</a:t>
-            </a:r>
-            <a:r>
-              <a:rPr sz="850">
-                <a:solidFill>
-                  <a:srgbClr val="475569"/>
-                </a:solidFill>
-                <a:latin typeface="Arial"/>
-              </a:rPr>
-              <a:t>  Field revenue officers (CALA, Tehsildars) are cautious of black-box AI algorithms that fail to cite statutory legal provisions.</a:t>
-            </a:r>
-          </a:p>
-        </p:txBody>
-      </p:sp>
-      <p:sp>
-        <p:nvSpPr>
-          <p:cNvPr id="17412" name="Rounded Rectangle 17411"/>
-          <p:cNvSpPr/>
-          <p:nvPr/>
-        </p:nvSpPr>
-        <p:spPr>
-          <a:xfrm>
-            <a:off x="7589520" y="1097280"/>
-            <a:ext cx="3383280" cy="4754880"/>
-          </a:xfrm>
-          <a:prstGeom prst="roundRect">
-            <a:avLst/>
-          </a:prstGeom>
-          <a:solidFill>
-            <a:srgbClr val="F8FAFC"/>
+            <a:srgbClr val="FFFFFF"/>
           </a:solidFill>
           <a:ln w="19050">
             <a:solidFill>
@@ -13114,100 +13231,552 @@
           </a:fontRef>
         </p:style>
         <p:txBody>
-          <a:bodyPr rtlCol="0" anchor="ctr" wrap="square"/>
+          <a:bodyPr rtlCol="0" anchor="ctr"/>
           <a:lstStyle/>
           <a:p>
-            <a:pPr algn="ctr">
+            <a:pPr algn="ctr"/>
+          </a:p>
+        </p:txBody>
+      </p:sp>
+      <p:pic>
+        <p:nvPicPr>
+          <p:cNvPr id="17415" name="Picture 17414" descr="viability_badge.png"/>
+          <p:cNvPicPr>
+            <a:picLocks noChangeAspect="1"/>
+          </p:cNvPicPr>
+          <p:nvPr/>
+        </p:nvPicPr>
+        <p:blipFill>
+          <a:blip r:embed="rId5"/>
+          <a:stretch>
+            <a:fillRect/>
+          </a:stretch>
+        </p:blipFill>
+        <p:spPr>
+          <a:xfrm>
+            <a:off x="6345936" y="1161288"/>
+            <a:ext cx="329184" cy="329184"/>
+          </a:xfrm>
+          <a:prstGeom prst="rect">
+            <a:avLst/>
+          </a:prstGeom>
+        </p:spPr>
+      </p:pic>
+      <p:sp>
+        <p:nvSpPr>
+          <p:cNvPr id="17416" name="TextBox 17415"/>
+          <p:cNvSpPr txBox="1"/>
+          <p:nvPr/>
+        </p:nvSpPr>
+        <p:spPr>
+          <a:xfrm>
+            <a:off x="6711696" y="1143000"/>
+            <a:ext cx="4114800" cy="347472"/>
+          </a:xfrm>
+          <a:prstGeom prst="rect">
+            <a:avLst/>
+          </a:prstGeom>
+          <a:noFill/>
+        </p:spPr>
+        <p:txBody>
+          <a:bodyPr wrap="none">
+            <a:spAutoFit/>
+          </a:bodyPr>
+          <a:lstStyle/>
+          <a:p>
+            <a:pPr>
+              <a:defRPr sz="1350" b="1">
+                <a:solidFill>
+                  <a:srgbClr val="059669"/>
+                </a:solidFill>
+                <a:latin typeface="Arial"/>
+              </a:defRPr>
+            </a:pPr>
+            <a:r>
+              <a:t>VIABILITY :</a:t>
+            </a:r>
+          </a:p>
+        </p:txBody>
+      </p:sp>
+      <p:sp>
+        <p:nvSpPr>
+          <p:cNvPr id="17417" name="TextBox 17416"/>
+          <p:cNvSpPr txBox="1"/>
+          <p:nvPr/>
+        </p:nvSpPr>
+        <p:spPr>
+          <a:xfrm>
+            <a:off x="6345936" y="1508760"/>
+            <a:ext cx="5266944" cy="2606040"/>
+          </a:xfrm>
+          <a:prstGeom prst="rect">
+            <a:avLst/>
+          </a:prstGeom>
+          <a:noFill/>
+        </p:spPr>
+        <p:txBody>
+          <a:bodyPr wrap="square" anchor="t" tIns="18288" lIns="36576" rIns="36576">
+            <a:spAutoFit/>
+          </a:bodyPr>
+          <a:lstStyle/>
+          <a:p>
+            <a:pPr>
+              <a:spcBef>
+                <a:spcPts val="300"/>
+              </a:spcBef>
               <a:spcAft>
-                <a:spcPts val="1000"/>
+                <a:spcPts val="200"/>
               </a:spcAft>
             </a:pPr>
             <a:r>
-              <a:rPr sz="1200" b="1">
-                <a:solidFill>
-                  <a:srgbClr val="059669"/>
+              <a:rPr sz="950" b="1">
+                <a:solidFill>
+                  <a:srgbClr val="0F172A"/>
                 </a:solidFill>
                 <a:latin typeface="Arial"/>
               </a:rPr>
-              <a:t>3. Robust Mitigation Strategies</a:t>
-            </a:r>
-          </a:p>
+              <a:t>National Market &amp; Scale :  </a:t>
+            </a:r>
+            <a:r>
+              <a:rPr sz="850">
+                <a:solidFill>
+                  <a:srgbClr val="334155"/>
+                </a:solidFill>
+                <a:latin typeface="Arial"/>
+              </a:rPr>
+              <a:t>₹4,000+ Cr in stalled Section 3H escrow funds across 1,200+ km of national highway corridors; directly unfreezes national CAPEX.</a:t>
+            </a:r>
+          </a:p>
+          <a:p>
+            <a:pPr>
+              <a:spcBef>
+                <a:spcPts val="300"/>
+              </a:spcBef>
+              <a:spcAft>
+                <a:spcPts val="200"/>
+              </a:spcAft>
+            </a:pPr>
+            <a:r>
+              <a:rPr sz="950" b="1">
+                <a:solidFill>
+                  <a:srgbClr val="0F172A"/>
+                </a:solidFill>
+                <a:latin typeface="Arial"/>
+              </a:rPr>
+              <a:t>Policy &amp; Statutory Alignment :  </a:t>
+            </a:r>
+            <a:r>
+              <a:rPr sz="850">
+                <a:solidFill>
+                  <a:srgbClr val="334155"/>
+                </a:solidFill>
+                <a:latin typeface="Arial"/>
+              </a:rPr>
+              <a:t>Perfectly synergizes with PM GatiShakti National Master Plan, Cabinet Secretariat guidelines, and digital land modernization.</a:t>
+            </a:r>
+          </a:p>
+          <a:p>
+            <a:pPr>
+              <a:spcBef>
+                <a:spcPts val="300"/>
+              </a:spcBef>
+              <a:spcAft>
+                <a:spcPts val="200"/>
+              </a:spcAft>
+            </a:pPr>
+            <a:r>
+              <a:rPr sz="950" b="1">
+                <a:solidFill>
+                  <a:srgbClr val="0F172A"/>
+                </a:solidFill>
+                <a:latin typeface="Arial"/>
+              </a:rPr>
+              <a:t>Investment &amp; National ROI :  </a:t>
+            </a:r>
+            <a:r>
+              <a:rPr sz="850">
+                <a:solidFill>
+                  <a:srgbClr val="334155"/>
+                </a:solidFill>
+                <a:latin typeface="Arial"/>
+              </a:rPr>
+              <a:t>Eliminates contractor idling compensation claims (saving ₹4.5 Cr per month per delayed package); instantaneous fiscal breakeven.</a:t>
+            </a:r>
+          </a:p>
+          <a:p>
+            <a:pPr>
+              <a:spcBef>
+                <a:spcPts val="300"/>
+              </a:spcBef>
+              <a:spcAft>
+                <a:spcPts val="200"/>
+              </a:spcAft>
+            </a:pPr>
+            <a:r>
+              <a:rPr sz="950" b="1">
+                <a:solidFill>
+                  <a:srgbClr val="0F172A"/>
+                </a:solidFill>
+                <a:latin typeface="Arial"/>
+              </a:rPr>
+              <a:t>Scalability &amp; Interstate Adoption :  </a:t>
+            </a:r>
+            <a:r>
+              <a:rPr sz="850">
+                <a:solidFill>
+                  <a:srgbClr val="334155"/>
+                </a:solidFill>
+                <a:latin typeface="Arial"/>
+              </a:rPr>
+              <a:t>Scales horizontally across all 28 States and 8 Union Territories via universal state-land ontological harmonizer.</a:t>
+            </a:r>
+          </a:p>
+        </p:txBody>
+      </p:sp>
+      <p:sp>
+        <p:nvSpPr>
+          <p:cNvPr id="17418" name="Rounded Rectangle 17417"/>
+          <p:cNvSpPr/>
+          <p:nvPr/>
+        </p:nvSpPr>
+        <p:spPr>
+          <a:xfrm>
+            <a:off x="438912" y="4297680"/>
+            <a:ext cx="5559552" cy="1810512"/>
+          </a:xfrm>
+          <a:prstGeom prst="roundRect">
+            <a:avLst/>
+          </a:prstGeom>
+          <a:solidFill>
+            <a:srgbClr val="FFFFFF"/>
+          </a:solidFill>
+          <a:ln w="19050">
+            <a:solidFill>
+              <a:srgbClr val="0070C0"/>
+            </a:solidFill>
+          </a:ln>
+        </p:spPr>
+        <p:style>
+          <a:lnRef idx="1">
+            <a:schemeClr val="accent1"/>
+          </a:lnRef>
+          <a:fillRef idx="3">
+            <a:schemeClr val="accent1"/>
+          </a:fillRef>
+          <a:effectRef idx="2">
+            <a:schemeClr val="accent1"/>
+          </a:effectRef>
+          <a:fontRef idx="minor">
+            <a:schemeClr val="lt1"/>
+          </a:fontRef>
+        </p:style>
+        <p:txBody>
+          <a:bodyPr rtlCol="0" anchor="ctr"/>
+          <a:lstStyle/>
+          <a:p>
+            <a:pPr algn="ctr"/>
+          </a:p>
+        </p:txBody>
+      </p:sp>
+      <p:pic>
+        <p:nvPicPr>
+          <p:cNvPr id="17419" name="Picture 17418" descr="challenge_badge.png"/>
+          <p:cNvPicPr>
+            <a:picLocks noChangeAspect="1"/>
+          </p:cNvPicPr>
+          <p:nvPr/>
+        </p:nvPicPr>
+        <p:blipFill>
+          <a:blip r:embed="rId6"/>
+          <a:stretch>
+            <a:fillRect/>
+          </a:stretch>
+        </p:blipFill>
+        <p:spPr>
+          <a:xfrm>
+            <a:off x="585216" y="4407408"/>
+            <a:ext cx="292608" cy="292608"/>
+          </a:xfrm>
+          <a:prstGeom prst="rect">
+            <a:avLst/>
+          </a:prstGeom>
+        </p:spPr>
+      </p:pic>
+      <p:sp>
+        <p:nvSpPr>
+          <p:cNvPr id="17420" name="TextBox 17419"/>
+          <p:cNvSpPr txBox="1"/>
+          <p:nvPr/>
+        </p:nvSpPr>
+        <p:spPr>
+          <a:xfrm>
+            <a:off x="932688" y="4389120"/>
+            <a:ext cx="4572000" cy="320040"/>
+          </a:xfrm>
+          <a:prstGeom prst="rect">
+            <a:avLst/>
+          </a:prstGeom>
+          <a:noFill/>
+        </p:spPr>
+        <p:txBody>
+          <a:bodyPr wrap="none">
+            <a:spAutoFit/>
+          </a:bodyPr>
+          <a:lstStyle/>
+          <a:p>
+            <a:pPr>
+              <a:defRPr sz="1150" b="1">
+                <a:solidFill>
+                  <a:srgbClr val="0070C0"/>
+                </a:solidFill>
+                <a:latin typeface="Arial"/>
+              </a:defRPr>
+            </a:pPr>
+            <a:r>
+              <a:t>TECHNICAL CHALLENGES :</a:t>
+            </a:r>
+          </a:p>
+        </p:txBody>
+      </p:sp>
+      <p:sp>
+        <p:nvSpPr>
+          <p:cNvPr id="17421" name="TextBox 17420"/>
+          <p:cNvSpPr txBox="1"/>
+          <p:nvPr/>
+        </p:nvSpPr>
+        <p:spPr>
+          <a:xfrm>
+            <a:off x="585216" y="4736592"/>
+            <a:ext cx="5266944" cy="1335024"/>
+          </a:xfrm>
+          <a:prstGeom prst="rect">
+            <a:avLst/>
+          </a:prstGeom>
+          <a:noFill/>
+        </p:spPr>
+        <p:txBody>
+          <a:bodyPr wrap="square" anchor="t" lIns="36576" rIns="36576" tIns="18288">
+            <a:spAutoFit/>
+          </a:bodyPr>
+          <a:lstStyle/>
           <a:p>
             <a:pPr>
               <a:spcAft>
-                <a:spcPts val="800"/>
+                <a:spcPts val="400"/>
               </a:spcAft>
             </a:pPr>
             <a:r>
-              <a:rPr sz="950" b="1">
-                <a:solidFill>
-                  <a:srgbClr val="1E293B"/>
-                </a:solidFill>
-                <a:latin typeface="Arial"/>
+              <a:rPr b="1" sz="900">
+                <a:solidFill>
+                  <a:srgbClr val="0F172A"/>
+                </a:solidFill>
               </a:rPr>
-              <a:t>• Universal Ontological Harmonizer:
-</a:t>
+              <a:t>Risk : </a:t>
             </a:r>
             <a:r>
               <a:rPr sz="850">
                 <a:solidFill>
-                  <a:srgbClr val="475569"/>
-                </a:solidFill>
-                <a:latin typeface="Arial"/>
+                  <a:srgbClr val="334155"/>
+                </a:solidFill>
               </a:rPr>
-              <a:t>  Built-in semantic dictionary maps all state-specific revenue nomenclature into standard NH Act statutory milestone stages.</a:t>
-            </a:r>
-          </a:p>
+              <a:t>Heterogeneous state land nomenclature (Khasra, Khatauni, Jamabandi) and missing cadastral coordinate data.</a:t>
+            </a:r>
+          </a:p>
+          <a:p>
+            <a:pPr>
+              <a:spcBef>
+                <a:spcPts val="200"/>
+              </a:spcBef>
+            </a:pPr>
+            <a:r>
+              <a:rPr b="1" sz="900">
+                <a:solidFill>
+                  <a:srgbClr val="0070C0"/>
+                </a:solidFill>
+              </a:rPr>
+              <a:t>Mitigation : </a:t>
+            </a:r>
+            <a:r>
+              <a:rPr sz="850">
+                <a:solidFill>
+                  <a:srgbClr val="334155"/>
+                </a:solidFill>
+              </a:rPr>
+              <a:t>Universal Ontological Harmonizer normalizes all 47 state parameters into unified schema with automated missing-value imputation.</a:t>
+            </a:r>
+          </a:p>
+        </p:txBody>
+      </p:sp>
+      <p:sp>
+        <p:nvSpPr>
+          <p:cNvPr id="17422" name="Rounded Rectangle 17421"/>
+          <p:cNvSpPr/>
+          <p:nvPr/>
+        </p:nvSpPr>
+        <p:spPr>
+          <a:xfrm>
+            <a:off x="6199632" y="4297680"/>
+            <a:ext cx="5559552" cy="1810512"/>
+          </a:xfrm>
+          <a:prstGeom prst="roundRect">
+            <a:avLst/>
+          </a:prstGeom>
+          <a:solidFill>
+            <a:srgbClr val="FFFFFF"/>
+          </a:solidFill>
+          <a:ln w="19050">
+            <a:solidFill>
+              <a:srgbClr val="059669"/>
+            </a:solidFill>
+          </a:ln>
+        </p:spPr>
+        <p:style>
+          <a:lnRef idx="1">
+            <a:schemeClr val="accent1"/>
+          </a:lnRef>
+          <a:fillRef idx="3">
+            <a:schemeClr val="accent1"/>
+          </a:fillRef>
+          <a:effectRef idx="2">
+            <a:schemeClr val="accent1"/>
+          </a:effectRef>
+          <a:fontRef idx="minor">
+            <a:schemeClr val="lt1"/>
+          </a:fontRef>
+        </p:style>
+        <p:txBody>
+          <a:bodyPr rtlCol="0" anchor="ctr"/>
+          <a:lstStyle/>
+          <a:p>
+            <a:pPr algn="ctr"/>
+          </a:p>
+        </p:txBody>
+      </p:sp>
+      <p:pic>
+        <p:nvPicPr>
+          <p:cNvPr id="17423" name="Picture 17422" descr="governance_badge.png"/>
+          <p:cNvPicPr>
+            <a:picLocks noChangeAspect="1"/>
+          </p:cNvPicPr>
+          <p:nvPr/>
+        </p:nvPicPr>
+        <p:blipFill>
+          <a:blip r:embed="rId7"/>
+          <a:stretch>
+            <a:fillRect/>
+          </a:stretch>
+        </p:blipFill>
+        <p:spPr>
+          <a:xfrm>
+            <a:off x="6345936" y="4407408"/>
+            <a:ext cx="292608" cy="292608"/>
+          </a:xfrm>
+          <a:prstGeom prst="rect">
+            <a:avLst/>
+          </a:prstGeom>
+        </p:spPr>
+      </p:pic>
+      <p:sp>
+        <p:nvSpPr>
+          <p:cNvPr id="17424" name="TextBox 17423"/>
+          <p:cNvSpPr txBox="1"/>
+          <p:nvPr/>
+        </p:nvSpPr>
+        <p:spPr>
+          <a:xfrm>
+            <a:off x="6693408" y="4389120"/>
+            <a:ext cx="4572000" cy="320040"/>
+          </a:xfrm>
+          <a:prstGeom prst="rect">
+            <a:avLst/>
+          </a:prstGeom>
+          <a:noFill/>
+        </p:spPr>
+        <p:txBody>
+          <a:bodyPr wrap="none">
+            <a:spAutoFit/>
+          </a:bodyPr>
+          <a:lstStyle/>
+          <a:p>
+            <a:pPr>
+              <a:defRPr sz="1150" b="1">
+                <a:solidFill>
+                  <a:srgbClr val="059669"/>
+                </a:solidFill>
+                <a:latin typeface="Arial"/>
+              </a:defRPr>
+            </a:pPr>
+            <a:r>
+              <a:t>STATUTORY &amp; ADOPTION CHALLENGES :</a:t>
+            </a:r>
+          </a:p>
+        </p:txBody>
+      </p:sp>
+      <p:sp>
+        <p:nvSpPr>
+          <p:cNvPr id="17425" name="TextBox 17424"/>
+          <p:cNvSpPr txBox="1"/>
+          <p:nvPr/>
+        </p:nvSpPr>
+        <p:spPr>
+          <a:xfrm>
+            <a:off x="6345936" y="4736592"/>
+            <a:ext cx="5266944" cy="1335024"/>
+          </a:xfrm>
+          <a:prstGeom prst="rect">
+            <a:avLst/>
+          </a:prstGeom>
+          <a:noFill/>
+        </p:spPr>
+        <p:txBody>
+          <a:bodyPr wrap="square" anchor="t" lIns="36576" rIns="36576" tIns="18288">
+            <a:spAutoFit/>
+          </a:bodyPr>
+          <a:lstStyle/>
           <a:p>
             <a:pPr>
               <a:spcAft>
-                <a:spcPts val="800"/>
+                <a:spcPts val="400"/>
               </a:spcAft>
             </a:pPr>
             <a:r>
-              <a:rPr sz="950" b="1">
-                <a:solidFill>
-                  <a:srgbClr val="1E293B"/>
-                </a:solidFill>
-                <a:latin typeface="Arial"/>
+              <a:rPr b="1" sz="900">
+                <a:solidFill>
+                  <a:srgbClr val="0F172A"/>
+                </a:solidFill>
               </a:rPr>
-              <a:t>• Section 3D(2) Vesting Separation:
-</a:t>
+              <a:t>Risk : </a:t>
             </a:r>
             <a:r>
               <a:rPr sz="850">
                 <a:solidFill>
-                  <a:srgbClr val="475569"/>
-                </a:solidFill>
-                <a:latin typeface="Arial"/>
+                  <a:srgbClr val="334155"/>
+                </a:solidFill>
               </a:rPr>
-              <a:t>  Decouples physical civil works from court escrow disputes; carriageway works continue while compensation is adjudicated in court.</a:t>
+              <a:t>Bureaucratic apprehension towards automated 'black-box' decisions and pending Section 3H court litigation stays.</a:t>
             </a:r>
           </a:p>
           <a:p>
             <a:pPr>
-              <a:spcAft>
-                <a:spcPts val="800"/>
-              </a:spcAft>
-            </a:pPr>
-            <a:r>
-              <a:rPr sz="950" b="1">
-                <a:solidFill>
-                  <a:srgbClr val="1E293B"/>
-                </a:solidFill>
-                <a:latin typeface="Arial"/>
+              <a:spcBef>
+                <a:spcPts val="200"/>
+              </a:spcBef>
+            </a:pPr>
+            <a:r>
+              <a:rPr b="1" sz="900">
+                <a:solidFill>
+                  <a:srgbClr val="059669"/>
+                </a:solidFill>
               </a:rPr>
-              <a:t>• Explainable AI with Nodal Agency:
-</a:t>
+              <a:t>Mitigation : </a:t>
             </a:r>
             <a:r>
               <a:rPr sz="850">
                 <a:solidFill>
-                  <a:srgbClr val="475569"/>
-                </a:solidFill>
-                <a:latin typeface="Arial"/>
+                  <a:srgbClr val="334155"/>
+                </a:solidFill>
               </a:rPr>
-              <a:t>  TreeSHAP explains exact reasons for delay, empowering the officer with full statutory authority via official digital signature (e-Sign).</a:t>
+              <a:t>Constitutional HITL preserves sovereign statutory authority under Articles 77 &amp; 166 with Aadhaar DSC e-Sign, backed by TreeSHAP explainability.</a:t>
             </a:r>
           </a:p>
         </p:txBody>

</xml_diff>

<commit_message>
feat(sih): design Slide 5 matching SIHex2 Impacts & Benefits layout with competitive table and 3 stakeholder mode cards
</commit_message>
<xml_diff>
--- a/sih/GatiShakti_AI_SIH2026_Presentation.pptx
+++ b/sih/GatiShakti_AI_SIH2026_Presentation.pptx
@@ -13906,15 +13906,15 @@
           <a:lstStyle/>
           <a:p>
             <a:pPr algn="l">
-              <a:defRPr sz="2200" b="1">
-                <a:solidFill>
-                  <a:srgbClr val="1A365D"/>
-                </a:solidFill>
-                <a:latin typeface="Times New Roman"/>
+              <a:defRPr sz="2400" b="1">
+                <a:solidFill>
+                  <a:srgbClr val="003366"/>
+                </a:solidFill>
+                <a:latin typeface="Arial"/>
               </a:defRPr>
             </a:pPr>
             <a:r>
-              <a:t>IMPACT AND BENEFITS: ACCELERATING NATIONAL INFRASTRUCTURE</a:t>
+              <a:t>IMPACTS &amp; BENEFITS</a:t>
             </a:r>
           </a:p>
         </p:txBody>
@@ -14111,16 +14111,16 @@
         </p:nvSpPr>
         <p:spPr>
           <a:xfrm>
-            <a:off x="457200" y="1097280"/>
-            <a:ext cx="5120640" cy="4754880"/>
+            <a:off x="438912" y="1051560"/>
+            <a:ext cx="6858000" cy="3017520"/>
           </a:xfrm>
           <a:prstGeom prst="roundRect">
             <a:avLst/>
           </a:prstGeom>
           <a:solidFill>
-            <a:srgbClr val="F8FAFC"/>
+            <a:srgbClr val="FFFFFF"/>
           </a:solidFill>
-          <a:ln>
+          <a:ln w="15240">
             <a:solidFill>
               <a:srgbClr val="CBD5E1"/>
             </a:solidFill>
@@ -14141,150 +14141,261 @@
           </a:fontRef>
         </p:style>
         <p:txBody>
-          <a:bodyPr rtlCol="0" anchor="ctr" wrap="square"/>
-          <a:lstStyle/>
-          <a:p>
-            <a:pPr algn="ctr">
-              <a:spcAft>
-                <a:spcPts val="800"/>
-              </a:spcAft>
-            </a:pPr>
-            <a:r>
-              <a:rPr sz="1300" b="1">
-                <a:solidFill>
-                  <a:srgbClr val="1A365D"/>
+          <a:bodyPr rtlCol="0" anchor="ctr"/>
+          <a:lstStyle/>
+          <a:p>
+            <a:pPr algn="ctr"/>
+          </a:p>
+        </p:txBody>
+      </p:sp>
+      <p:pic>
+        <p:nvPicPr>
+          <p:cNvPr id="17411" name="Picture 17410" descr="economic_impact.png"/>
+          <p:cNvPicPr>
+            <a:picLocks noChangeAspect="1"/>
+          </p:cNvPicPr>
+          <p:nvPr/>
+        </p:nvPicPr>
+        <p:blipFill>
+          <a:blip r:embed="rId4"/>
+          <a:stretch>
+            <a:fillRect/>
+          </a:stretch>
+        </p:blipFill>
+        <p:spPr>
+          <a:xfrm>
+            <a:off x="585216" y="1197864"/>
+            <a:ext cx="438912" cy="438912"/>
+          </a:xfrm>
+          <a:prstGeom prst="rect">
+            <a:avLst/>
+          </a:prstGeom>
+        </p:spPr>
+      </p:pic>
+      <p:sp>
+        <p:nvSpPr>
+          <p:cNvPr id="17412" name="TextBox 17411"/>
+          <p:cNvSpPr txBox="1"/>
+          <p:nvPr/>
+        </p:nvSpPr>
+        <p:spPr>
+          <a:xfrm>
+            <a:off x="1097280" y="1161288"/>
+            <a:ext cx="6080760" cy="841248"/>
+          </a:xfrm>
+          <a:prstGeom prst="rect">
+            <a:avLst/>
+          </a:prstGeom>
+          <a:noFill/>
+        </p:spPr>
+        <p:txBody>
+          <a:bodyPr wrap="square" anchor="t" lIns="18288" rIns="18288" tIns="18288">
+            <a:spAutoFit/>
+          </a:bodyPr>
+          <a:lstStyle/>
+          <a:p>
+            <a:r>
+              <a:rPr sz="950" b="1">
+                <a:solidFill>
+                  <a:srgbClr val="1E3A8A"/>
                 </a:solidFill>
                 <a:latin typeface="Arial"/>
               </a:rPr>
-              <a:t>1. Impact Across Key Target Stakeholders</a:t>
-            </a:r>
-          </a:p>
-          <a:p>
-            <a:pPr>
-              <a:spcAft>
-                <a:spcPts val="700"/>
-              </a:spcAft>
-            </a:pPr>
+              <a:t>•  </a:t>
+            </a:r>
             <a:r>
               <a:rPr sz="950" b="1">
                 <a:solidFill>
-                  <a:srgbClr val="2563EB"/>
+                  <a:srgbClr val="0F172A"/>
                 </a:solidFill>
                 <a:latin typeface="Arial"/>
               </a:rPr>
-              <a:t>• NHAI Project Directors (PDs):
-</a:t>
+              <a:t>The Economic &amp; Infrastructure Impact : </a:t>
             </a:r>
             <a:r>
               <a:rPr sz="850">
                 <a:solidFill>
-                  <a:srgbClr val="1E293B"/>
+                  <a:srgbClr val="334155"/>
                 </a:solidFill>
                 <a:latin typeface="Arial"/>
               </a:rPr>
-              <a:t>  Eliminates contractor idling compensation claims (saving ₹4.5 Lakh/day per package) by re-sequencing earthwork machinery to 100% encumbrance-free stretches.</a:t>
-            </a:r>
-          </a:p>
-          <a:p>
-            <a:pPr>
-              <a:spcAft>
-                <a:spcPts val="700"/>
-              </a:spcAft>
-            </a:pPr>
+              <a:t>Stalled national highway projects lock up over ₹4,000+ Crore in Section 3H escrow litigation and incur massive contractor idling claims. GatiShakti AI compresses acquisition cycles by 35%–45%, directly unfreezing capital and accelerating national logistics commissioning.</a:t>
+            </a:r>
+          </a:p>
+        </p:txBody>
+      </p:sp>
+      <p:pic>
+        <p:nvPicPr>
+          <p:cNvPr id="17413" name="Picture 17412" descr="governance_impact.png"/>
+          <p:cNvPicPr>
+            <a:picLocks noChangeAspect="1"/>
+          </p:cNvPicPr>
+          <p:nvPr/>
+        </p:nvPicPr>
+        <p:blipFill>
+          <a:blip r:embed="rId5"/>
+          <a:stretch>
+            <a:fillRect/>
+          </a:stretch>
+        </p:blipFill>
+        <p:spPr>
+          <a:xfrm>
+            <a:off x="585216" y="2130552"/>
+            <a:ext cx="438912" cy="438912"/>
+          </a:xfrm>
+          <a:prstGeom prst="rect">
+            <a:avLst/>
+          </a:prstGeom>
+        </p:spPr>
+      </p:pic>
+      <p:sp>
+        <p:nvSpPr>
+          <p:cNvPr id="17414" name="TextBox 17413"/>
+          <p:cNvSpPr txBox="1"/>
+          <p:nvPr/>
+        </p:nvSpPr>
+        <p:spPr>
+          <a:xfrm>
+            <a:off x="1097280" y="2093976"/>
+            <a:ext cx="6080760" cy="841248"/>
+          </a:xfrm>
+          <a:prstGeom prst="rect">
+            <a:avLst/>
+          </a:prstGeom>
+          <a:noFill/>
+        </p:spPr>
+        <p:txBody>
+          <a:bodyPr wrap="square" anchor="t" lIns="18288" rIns="18288" tIns="18288">
+            <a:spAutoFit/>
+          </a:bodyPr>
+          <a:lstStyle/>
+          <a:p>
             <a:r>
               <a:rPr sz="950" b="1">
                 <a:solidFill>
-                  <a:srgbClr val="2563EB"/>
+                  <a:srgbClr val="065F46"/>
                 </a:solidFill>
                 <a:latin typeface="Arial"/>
               </a:rPr>
-              <a:t>• Competent Authority for Land Acquisition (CALA):
-</a:t>
+              <a:t>•  </a:t>
+            </a:r>
+            <a:r>
+              <a:rPr sz="950" b="1">
+                <a:solidFill>
+                  <a:srgbClr val="0F172A"/>
+                </a:solidFill>
+                <a:latin typeface="Arial"/>
+              </a:rPr>
+              <a:t>Statutory &amp; Governance Transformation : </a:t>
             </a:r>
             <a:r>
               <a:rPr sz="850">
                 <a:solidFill>
-                  <a:srgbClr val="1E293B"/>
+                  <a:srgbClr val="334155"/>
                 </a:solidFill>
                 <a:latin typeface="Arial"/>
               </a:rPr>
-              <a:t>  Autonomous 310-day statutory countdown watchdog prevents Section 3A notifications from lapsing under Section 3D(1); generates instant Section 3G awards.</a:t>
-            </a:r>
-          </a:p>
-          <a:p>
-            <a:pPr>
-              <a:spcAft>
-                <a:spcPts val="700"/>
-              </a:spcAft>
-            </a:pPr>
+              <a:t>Enforces zero Section 3D statutory lapses by deploying an autonomous 310-day countdown watchdog. Constitutional HITL architecture preserves sovereign officer authority under Articles 77 &amp; 166 via Aadhaar DSC e-Sign, backed by an immutable SHA-256 ledger ready for CAG &amp; CVC scrutiny.</a:t>
+            </a:r>
+          </a:p>
+        </p:txBody>
+      </p:sp>
+      <p:pic>
+        <p:nvPicPr>
+          <p:cNvPr id="17415" name="Picture 17414" descr="social_impact.png"/>
+          <p:cNvPicPr>
+            <a:picLocks noChangeAspect="1"/>
+          </p:cNvPicPr>
+          <p:nvPr/>
+        </p:nvPicPr>
+        <p:blipFill>
+          <a:blip r:embed="rId6"/>
+          <a:stretch>
+            <a:fillRect/>
+          </a:stretch>
+        </p:blipFill>
+        <p:spPr>
+          <a:xfrm>
+            <a:off x="585216" y="3063240"/>
+            <a:ext cx="438912" cy="438912"/>
+          </a:xfrm>
+          <a:prstGeom prst="rect">
+            <a:avLst/>
+          </a:prstGeom>
+        </p:spPr>
+      </p:pic>
+      <p:sp>
+        <p:nvSpPr>
+          <p:cNvPr id="17416" name="TextBox 17415"/>
+          <p:cNvSpPr txBox="1"/>
+          <p:nvPr/>
+        </p:nvSpPr>
+        <p:spPr>
+          <a:xfrm>
+            <a:off x="1097280" y="3026664"/>
+            <a:ext cx="6080760" cy="841248"/>
+          </a:xfrm>
+          <a:prstGeom prst="rect">
+            <a:avLst/>
+          </a:prstGeom>
+          <a:noFill/>
+        </p:spPr>
+        <p:txBody>
+          <a:bodyPr wrap="square" anchor="t" lIns="18288" rIns="18288" tIns="18288">
+            <a:spAutoFit/>
+          </a:bodyPr>
+          <a:lstStyle/>
+          <a:p>
             <a:r>
               <a:rPr sz="950" b="1">
                 <a:solidFill>
-                  <a:srgbClr val="2563EB"/>
+                  <a:srgbClr val="92400E"/>
                 </a:solidFill>
                 <a:latin typeface="Arial"/>
               </a:rPr>
-              <a:t>• Ministry of Road Transport (MoRTH) &amp; NPG:
-</a:t>
+              <a:t>•  </a:t>
+            </a:r>
+            <a:r>
+              <a:rPr sz="950" b="1">
+                <a:solidFill>
+                  <a:srgbClr val="0F172A"/>
+                </a:solidFill>
+                <a:latin typeface="Arial"/>
+              </a:rPr>
+              <a:t>Social &amp; Landowner Empowerment : </a:t>
             </a:r>
             <a:r>
               <a:rPr sz="850">
                 <a:solidFill>
-                  <a:srgbClr val="1E293B"/>
+                  <a:srgbClr val="334155"/>
                 </a:solidFill>
                 <a:latin typeface="Arial"/>
               </a:rPr>
-              <a:t>  Gives executive leadership real-time visibility across national highway corridors for unified Cabinet notes, inter-ministerial forest clearances, and utility shifting funds.</a:t>
-            </a:r>
-          </a:p>
-          <a:p>
-            <a:pPr>
-              <a:spcAft>
-                <a:spcPts val="700"/>
-              </a:spcAft>
-            </a:pPr>
-            <a:r>
-              <a:rPr sz="950" b="1">
-                <a:solidFill>
-                  <a:srgbClr val="2563EB"/>
-                </a:solidFill>
-                <a:latin typeface="Arial"/>
-              </a:rPr>
-              <a:t>• Project Affected Families (Farmers &amp; Landowners):
-</a:t>
-            </a:r>
-            <a:r>
-              <a:rPr sz="850">
-                <a:solidFill>
-                  <a:srgbClr val="1E293B"/>
-                </a:solidFill>
-                <a:latin typeface="Arial"/>
-              </a:rPr>
-              <a:t>  Accelerates fair compensation payouts by 40% through direct PFMS bank transfer linkages; automates amicable village mutation dispute resolution camps.</a:t>
-            </a:r>
-          </a:p>
-        </p:txBody>
-      </p:sp>
-      <p:sp>
-        <p:nvSpPr>
-          <p:cNvPr id="17411" name="Rounded Rectangle 17410"/>
+              <a:t>Resolves farmer compensation disputes under Section 3H transparently. Automated Draft for Approval (DFA) SOP notices eliminate multi-year procedural delays, ensuring timely, dispute-free direct-benefit disbursements to affected rural families.</a:t>
+            </a:r>
+          </a:p>
+        </p:txBody>
+      </p:sp>
+      <p:sp>
+        <p:nvSpPr>
+          <p:cNvPr id="17417" name="Rounded Rectangle 17416"/>
           <p:cNvSpPr/>
           <p:nvPr/>
         </p:nvSpPr>
         <p:spPr>
           <a:xfrm>
-            <a:off x="5852160" y="1097280"/>
-            <a:ext cx="5486400" cy="4754880"/>
+            <a:off x="7424927" y="1051560"/>
+            <a:ext cx="4315968" cy="3017520"/>
           </a:xfrm>
           <a:prstGeom prst="roundRect">
             <a:avLst/>
           </a:prstGeom>
           <a:solidFill>
-            <a:srgbClr val="F8FAFC"/>
+            <a:srgbClr val="FFFFFF"/>
           </a:solidFill>
-          <a:ln>
+          <a:ln w="19050">
             <a:solidFill>
-              <a:srgbClr val="CBD5E1"/>
+              <a:srgbClr val="0F172A"/>
             </a:solidFill>
           </a:ln>
         </p:spPr>
@@ -14303,126 +14414,2250 @@
           </a:fontRef>
         </p:style>
         <p:txBody>
-          <a:bodyPr rtlCol="0" anchor="ctr" wrap="square"/>
+          <a:bodyPr rtlCol="0" anchor="ctr"/>
+          <a:lstStyle/>
+          <a:p>
+            <a:pPr algn="ctr"/>
+          </a:p>
+        </p:txBody>
+      </p:sp>
+      <p:sp>
+        <p:nvSpPr>
+          <p:cNvPr id="17418" name="Rectangle 17417"/>
+          <p:cNvSpPr/>
+          <p:nvPr/>
+        </p:nvSpPr>
+        <p:spPr>
+          <a:xfrm>
+            <a:off x="7424927" y="1051560"/>
+            <a:ext cx="4315968" cy="329184"/>
+          </a:xfrm>
+          <a:prstGeom prst="rect">
+            <a:avLst/>
+          </a:prstGeom>
+          <a:solidFill>
+            <a:srgbClr val="1A202C"/>
+          </a:solidFill>
+          <a:ln>
+            <a:noFill/>
+          </a:ln>
+        </p:spPr>
+        <p:style>
+          <a:lnRef idx="1">
+            <a:schemeClr val="accent1"/>
+          </a:lnRef>
+          <a:fillRef idx="3">
+            <a:schemeClr val="accent1"/>
+          </a:fillRef>
+          <a:effectRef idx="2">
+            <a:schemeClr val="accent1"/>
+          </a:effectRef>
+          <a:fontRef idx="minor">
+            <a:schemeClr val="lt1"/>
+          </a:fontRef>
+        </p:style>
+        <p:txBody>
+          <a:bodyPr rtlCol="0" anchor="ctr" lIns="109728"/>
           <a:lstStyle/>
           <a:p>
             <a:pPr algn="ctr">
-              <a:spcAft>
-                <a:spcPts val="800"/>
-              </a:spcAft>
-            </a:pPr>
-            <a:r>
-              <a:rPr sz="1300" b="1">
-                <a:solidFill>
-                  <a:srgbClr val="1A365D"/>
-                </a:solidFill>
-                <a:latin typeface="Arial"/>
-              </a:rPr>
-              <a:t>2. Quantified National Economic &amp; Governance Value</a:t>
-            </a:r>
-          </a:p>
+              <a:defRPr sz="850" b="1">
+                <a:solidFill>
+                  <a:srgbClr val="FFFFFF"/>
+                </a:solidFill>
+                <a:latin typeface="Arial"/>
+              </a:defRPr>
+            </a:pPr>
+            <a:r>
+              <a:t>Feature Comparison                         Existing Silos    GatiShakti AI</a:t>
+            </a:r>
+          </a:p>
+        </p:txBody>
+      </p:sp>
+      <p:sp>
+        <p:nvSpPr>
+          <p:cNvPr id="17419" name="Rectangle 17418"/>
+          <p:cNvSpPr/>
+          <p:nvPr/>
+        </p:nvSpPr>
+        <p:spPr>
+          <a:xfrm>
+            <a:off x="7424927" y="1719072"/>
+            <a:ext cx="4315968" cy="9144"/>
+          </a:xfrm>
+          <a:prstGeom prst="rect">
+            <a:avLst/>
+          </a:prstGeom>
+          <a:solidFill>
+            <a:srgbClr val="E2E8F0"/>
+          </a:solidFill>
+          <a:ln>
+            <a:noFill/>
+          </a:ln>
+        </p:spPr>
+        <p:style>
+          <a:lnRef idx="1">
+            <a:schemeClr val="accent1"/>
+          </a:lnRef>
+          <a:fillRef idx="3">
+            <a:schemeClr val="accent1"/>
+          </a:fillRef>
+          <a:effectRef idx="2">
+            <a:schemeClr val="accent1"/>
+          </a:effectRef>
+          <a:fontRef idx="minor">
+            <a:schemeClr val="lt1"/>
+          </a:fontRef>
+        </p:style>
+        <p:txBody>
+          <a:bodyPr rtlCol="0" anchor="ctr"/>
+          <a:lstStyle/>
+          <a:p>
+            <a:pPr algn="ctr"/>
+          </a:p>
+        </p:txBody>
+      </p:sp>
+      <p:sp>
+        <p:nvSpPr>
+          <p:cNvPr id="17420" name="TextBox 17419"/>
+          <p:cNvSpPr txBox="1"/>
+          <p:nvPr/>
+        </p:nvSpPr>
+        <p:spPr>
+          <a:xfrm>
+            <a:off x="7516367" y="1435608"/>
+            <a:ext cx="2423160" cy="256032"/>
+          </a:xfrm>
+          <a:prstGeom prst="rect">
+            <a:avLst/>
+          </a:prstGeom>
+          <a:noFill/>
+        </p:spPr>
+        <p:txBody>
+          <a:bodyPr wrap="none" anchor="ctr" tIns="9144" lIns="18288">
+            <a:spAutoFit/>
+          </a:bodyPr>
+          <a:lstStyle/>
+          <a:p>
+            <a:pPr>
+              <a:defRPr sz="750">
+                <a:solidFill>
+                  <a:srgbClr val="1E293B"/>
+                </a:solidFill>
+                <a:latin typeface="Arial"/>
+              </a:defRPr>
+            </a:pPr>
+            <a:r>
+              <a:t>Predictive Delay ML Scoring</a:t>
+            </a:r>
+          </a:p>
+        </p:txBody>
+      </p:sp>
+      <p:pic>
+        <p:nvPicPr>
+          <p:cNvPr id="17421" name="Picture 17420" descr="table_cross.png"/>
+          <p:cNvPicPr>
+            <a:picLocks noChangeAspect="1"/>
+          </p:cNvPicPr>
+          <p:nvPr/>
+        </p:nvPicPr>
+        <p:blipFill>
+          <a:blip r:embed="rId7"/>
+          <a:stretch>
+            <a:fillRect/>
+          </a:stretch>
+        </p:blipFill>
+        <p:spPr>
+          <a:xfrm>
+            <a:off x="10241279" y="1463040"/>
+            <a:ext cx="182880" cy="182880"/>
+          </a:xfrm>
+          <a:prstGeom prst="rect">
+            <a:avLst/>
+          </a:prstGeom>
+        </p:spPr>
+      </p:pic>
+      <p:pic>
+        <p:nvPicPr>
+          <p:cNvPr id="17422" name="Picture 17421" descr="table_check.png"/>
+          <p:cNvPicPr>
+            <a:picLocks noChangeAspect="1"/>
+          </p:cNvPicPr>
+          <p:nvPr/>
+        </p:nvPicPr>
+        <p:blipFill>
+          <a:blip r:embed="rId8"/>
+          <a:stretch>
+            <a:fillRect/>
+          </a:stretch>
+        </p:blipFill>
+        <p:spPr>
+          <a:xfrm>
+            <a:off x="11155679" y="1463040"/>
+            <a:ext cx="182880" cy="182880"/>
+          </a:xfrm>
+          <a:prstGeom prst="rect">
+            <a:avLst/>
+          </a:prstGeom>
+        </p:spPr>
+      </p:pic>
+      <p:sp>
+        <p:nvSpPr>
+          <p:cNvPr id="17423" name="Rectangle 17422"/>
+          <p:cNvSpPr/>
+          <p:nvPr/>
+        </p:nvSpPr>
+        <p:spPr>
+          <a:xfrm>
+            <a:off x="7443215" y="1719072"/>
+            <a:ext cx="4279392" cy="320040"/>
+          </a:xfrm>
+          <a:prstGeom prst="rect">
+            <a:avLst/>
+          </a:prstGeom>
+          <a:solidFill>
+            <a:srgbClr val="F8FAFC"/>
+          </a:solidFill>
+          <a:ln>
+            <a:noFill/>
+          </a:ln>
+        </p:spPr>
+        <p:style>
+          <a:lnRef idx="1">
+            <a:schemeClr val="accent1"/>
+          </a:lnRef>
+          <a:fillRef idx="3">
+            <a:schemeClr val="accent1"/>
+          </a:fillRef>
+          <a:effectRef idx="2">
+            <a:schemeClr val="accent1"/>
+          </a:effectRef>
+          <a:fontRef idx="minor">
+            <a:schemeClr val="lt1"/>
+          </a:fontRef>
+        </p:style>
+        <p:txBody>
+          <a:bodyPr rtlCol="0" anchor="ctr"/>
+          <a:lstStyle/>
+          <a:p>
+            <a:pPr algn="ctr"/>
+          </a:p>
+        </p:txBody>
+      </p:sp>
+      <p:sp>
+        <p:nvSpPr>
+          <p:cNvPr id="17424" name="Rectangle 17423"/>
+          <p:cNvSpPr/>
+          <p:nvPr/>
+        </p:nvSpPr>
+        <p:spPr>
+          <a:xfrm>
+            <a:off x="7424927" y="2039112"/>
+            <a:ext cx="4315968" cy="9144"/>
+          </a:xfrm>
+          <a:prstGeom prst="rect">
+            <a:avLst/>
+          </a:prstGeom>
+          <a:solidFill>
+            <a:srgbClr val="E2E8F0"/>
+          </a:solidFill>
+          <a:ln>
+            <a:noFill/>
+          </a:ln>
+        </p:spPr>
+        <p:style>
+          <a:lnRef idx="1">
+            <a:schemeClr val="accent1"/>
+          </a:lnRef>
+          <a:fillRef idx="3">
+            <a:schemeClr val="accent1"/>
+          </a:fillRef>
+          <a:effectRef idx="2">
+            <a:schemeClr val="accent1"/>
+          </a:effectRef>
+          <a:fontRef idx="minor">
+            <a:schemeClr val="lt1"/>
+          </a:fontRef>
+        </p:style>
+        <p:txBody>
+          <a:bodyPr rtlCol="0" anchor="ctr"/>
+          <a:lstStyle/>
+          <a:p>
+            <a:pPr algn="ctr"/>
+          </a:p>
+        </p:txBody>
+      </p:sp>
+      <p:sp>
+        <p:nvSpPr>
+          <p:cNvPr id="17425" name="TextBox 17424"/>
+          <p:cNvSpPr txBox="1"/>
+          <p:nvPr/>
+        </p:nvSpPr>
+        <p:spPr>
+          <a:xfrm>
+            <a:off x="7516367" y="1755648"/>
+            <a:ext cx="2423160" cy="256032"/>
+          </a:xfrm>
+          <a:prstGeom prst="rect">
+            <a:avLst/>
+          </a:prstGeom>
+          <a:noFill/>
+        </p:spPr>
+        <p:txBody>
+          <a:bodyPr wrap="none" anchor="ctr" tIns="9144" lIns="18288">
+            <a:spAutoFit/>
+          </a:bodyPr>
+          <a:lstStyle/>
+          <a:p>
+            <a:pPr>
+              <a:defRPr sz="750">
+                <a:solidFill>
+                  <a:srgbClr val="1E293B"/>
+                </a:solidFill>
+                <a:latin typeface="Arial"/>
+              </a:defRPr>
+            </a:pPr>
+            <a:r>
+              <a:t>Sec 3D 365-Day Lapse Watchdog</a:t>
+            </a:r>
+          </a:p>
+        </p:txBody>
+      </p:sp>
+      <p:pic>
+        <p:nvPicPr>
+          <p:cNvPr id="17426" name="Picture 17425" descr="table_cross.png"/>
+          <p:cNvPicPr>
+            <a:picLocks noChangeAspect="1"/>
+          </p:cNvPicPr>
+          <p:nvPr/>
+        </p:nvPicPr>
+        <p:blipFill>
+          <a:blip r:embed="rId7"/>
+          <a:stretch>
+            <a:fillRect/>
+          </a:stretch>
+        </p:blipFill>
+        <p:spPr>
+          <a:xfrm>
+            <a:off x="10241279" y="1783080"/>
+            <a:ext cx="182880" cy="182880"/>
+          </a:xfrm>
+          <a:prstGeom prst="rect">
+            <a:avLst/>
+          </a:prstGeom>
+        </p:spPr>
+      </p:pic>
+      <p:pic>
+        <p:nvPicPr>
+          <p:cNvPr id="17427" name="Picture 17426" descr="table_check.png"/>
+          <p:cNvPicPr>
+            <a:picLocks noChangeAspect="1"/>
+          </p:cNvPicPr>
+          <p:nvPr/>
+        </p:nvPicPr>
+        <p:blipFill>
+          <a:blip r:embed="rId8"/>
+          <a:stretch>
+            <a:fillRect/>
+          </a:stretch>
+        </p:blipFill>
+        <p:spPr>
+          <a:xfrm>
+            <a:off x="11155679" y="1783080"/>
+            <a:ext cx="182880" cy="182880"/>
+          </a:xfrm>
+          <a:prstGeom prst="rect">
+            <a:avLst/>
+          </a:prstGeom>
+        </p:spPr>
+      </p:pic>
+      <p:sp>
+        <p:nvSpPr>
+          <p:cNvPr id="17428" name="Rectangle 17427"/>
+          <p:cNvSpPr/>
+          <p:nvPr/>
+        </p:nvSpPr>
+        <p:spPr>
+          <a:xfrm>
+            <a:off x="7424927" y="2359152"/>
+            <a:ext cx="4315968" cy="9144"/>
+          </a:xfrm>
+          <a:prstGeom prst="rect">
+            <a:avLst/>
+          </a:prstGeom>
+          <a:solidFill>
+            <a:srgbClr val="E2E8F0"/>
+          </a:solidFill>
+          <a:ln>
+            <a:noFill/>
+          </a:ln>
+        </p:spPr>
+        <p:style>
+          <a:lnRef idx="1">
+            <a:schemeClr val="accent1"/>
+          </a:lnRef>
+          <a:fillRef idx="3">
+            <a:schemeClr val="accent1"/>
+          </a:fillRef>
+          <a:effectRef idx="2">
+            <a:schemeClr val="accent1"/>
+          </a:effectRef>
+          <a:fontRef idx="minor">
+            <a:schemeClr val="lt1"/>
+          </a:fontRef>
+        </p:style>
+        <p:txBody>
+          <a:bodyPr rtlCol="0" anchor="ctr"/>
+          <a:lstStyle/>
+          <a:p>
+            <a:pPr algn="ctr"/>
+          </a:p>
+        </p:txBody>
+      </p:sp>
+      <p:sp>
+        <p:nvSpPr>
+          <p:cNvPr id="17429" name="TextBox 17428"/>
+          <p:cNvSpPr txBox="1"/>
+          <p:nvPr/>
+        </p:nvSpPr>
+        <p:spPr>
+          <a:xfrm>
+            <a:off x="7516367" y="2075688"/>
+            <a:ext cx="2423160" cy="256032"/>
+          </a:xfrm>
+          <a:prstGeom prst="rect">
+            <a:avLst/>
+          </a:prstGeom>
+          <a:noFill/>
+        </p:spPr>
+        <p:txBody>
+          <a:bodyPr wrap="none" anchor="ctr" tIns="9144" lIns="18288">
+            <a:spAutoFit/>
+          </a:bodyPr>
+          <a:lstStyle/>
+          <a:p>
+            <a:pPr>
+              <a:defRPr sz="750">
+                <a:solidFill>
+                  <a:srgbClr val="1E293B"/>
+                </a:solidFill>
+                <a:latin typeface="Arial"/>
+              </a:defRPr>
+            </a:pPr>
+            <a:r>
+              <a:t>Decoupled Central DB (&lt;15ms)</a:t>
+            </a:r>
+          </a:p>
+        </p:txBody>
+      </p:sp>
+      <p:pic>
+        <p:nvPicPr>
+          <p:cNvPr id="17430" name="Picture 17429" descr="table_cross.png"/>
+          <p:cNvPicPr>
+            <a:picLocks noChangeAspect="1"/>
+          </p:cNvPicPr>
+          <p:nvPr/>
+        </p:nvPicPr>
+        <p:blipFill>
+          <a:blip r:embed="rId7"/>
+          <a:stretch>
+            <a:fillRect/>
+          </a:stretch>
+        </p:blipFill>
+        <p:spPr>
+          <a:xfrm>
+            <a:off x="10241279" y="2103120"/>
+            <a:ext cx="182880" cy="182880"/>
+          </a:xfrm>
+          <a:prstGeom prst="rect">
+            <a:avLst/>
+          </a:prstGeom>
+        </p:spPr>
+      </p:pic>
+      <p:pic>
+        <p:nvPicPr>
+          <p:cNvPr id="17431" name="Picture 17430" descr="table_check.png"/>
+          <p:cNvPicPr>
+            <a:picLocks noChangeAspect="1"/>
+          </p:cNvPicPr>
+          <p:nvPr/>
+        </p:nvPicPr>
+        <p:blipFill>
+          <a:blip r:embed="rId8"/>
+          <a:stretch>
+            <a:fillRect/>
+          </a:stretch>
+        </p:blipFill>
+        <p:spPr>
+          <a:xfrm>
+            <a:off x="11155679" y="2103120"/>
+            <a:ext cx="182880" cy="182880"/>
+          </a:xfrm>
+          <a:prstGeom prst="rect">
+            <a:avLst/>
+          </a:prstGeom>
+        </p:spPr>
+      </p:pic>
+      <p:sp>
+        <p:nvSpPr>
+          <p:cNvPr id="17432" name="Rectangle 17431"/>
+          <p:cNvSpPr/>
+          <p:nvPr/>
+        </p:nvSpPr>
+        <p:spPr>
+          <a:xfrm>
+            <a:off x="7443215" y="2359152"/>
+            <a:ext cx="4279392" cy="320040"/>
+          </a:xfrm>
+          <a:prstGeom prst="rect">
+            <a:avLst/>
+          </a:prstGeom>
+          <a:solidFill>
+            <a:srgbClr val="F8FAFC"/>
+          </a:solidFill>
+          <a:ln>
+            <a:noFill/>
+          </a:ln>
+        </p:spPr>
+        <p:style>
+          <a:lnRef idx="1">
+            <a:schemeClr val="accent1"/>
+          </a:lnRef>
+          <a:fillRef idx="3">
+            <a:schemeClr val="accent1"/>
+          </a:fillRef>
+          <a:effectRef idx="2">
+            <a:schemeClr val="accent1"/>
+          </a:effectRef>
+          <a:fontRef idx="minor">
+            <a:schemeClr val="lt1"/>
+          </a:fontRef>
+        </p:style>
+        <p:txBody>
+          <a:bodyPr rtlCol="0" anchor="ctr"/>
+          <a:lstStyle/>
+          <a:p>
+            <a:pPr algn="ctr"/>
+          </a:p>
+        </p:txBody>
+      </p:sp>
+      <p:sp>
+        <p:nvSpPr>
+          <p:cNvPr id="17433" name="Rectangle 17432"/>
+          <p:cNvSpPr/>
+          <p:nvPr/>
+        </p:nvSpPr>
+        <p:spPr>
+          <a:xfrm>
+            <a:off x="7424927" y="2679192"/>
+            <a:ext cx="4315968" cy="9144"/>
+          </a:xfrm>
+          <a:prstGeom prst="rect">
+            <a:avLst/>
+          </a:prstGeom>
+          <a:solidFill>
+            <a:srgbClr val="E2E8F0"/>
+          </a:solidFill>
+          <a:ln>
+            <a:noFill/>
+          </a:ln>
+        </p:spPr>
+        <p:style>
+          <a:lnRef idx="1">
+            <a:schemeClr val="accent1"/>
+          </a:lnRef>
+          <a:fillRef idx="3">
+            <a:schemeClr val="accent1"/>
+          </a:fillRef>
+          <a:effectRef idx="2">
+            <a:schemeClr val="accent1"/>
+          </a:effectRef>
+          <a:fontRef idx="minor">
+            <a:schemeClr val="lt1"/>
+          </a:fontRef>
+        </p:style>
+        <p:txBody>
+          <a:bodyPr rtlCol="0" anchor="ctr"/>
+          <a:lstStyle/>
+          <a:p>
+            <a:pPr algn="ctr"/>
+          </a:p>
+        </p:txBody>
+      </p:sp>
+      <p:sp>
+        <p:nvSpPr>
+          <p:cNvPr id="17434" name="TextBox 17433"/>
+          <p:cNvSpPr txBox="1"/>
+          <p:nvPr/>
+        </p:nvSpPr>
+        <p:spPr>
+          <a:xfrm>
+            <a:off x="7516367" y="2395728"/>
+            <a:ext cx="2423160" cy="256032"/>
+          </a:xfrm>
+          <a:prstGeom prst="rect">
+            <a:avLst/>
+          </a:prstGeom>
+          <a:noFill/>
+        </p:spPr>
+        <p:txBody>
+          <a:bodyPr wrap="none" anchor="ctr" tIns="9144" lIns="18288">
+            <a:spAutoFit/>
+          </a:bodyPr>
+          <a:lstStyle/>
+          <a:p>
+            <a:pPr>
+              <a:defRPr sz="750">
+                <a:solidFill>
+                  <a:srgbClr val="1E293B"/>
+                </a:solidFill>
+                <a:latin typeface="Arial"/>
+              </a:defRPr>
+            </a:pPr>
+            <a:r>
+              <a:t>Dual-Track Reality Engine (Sec 3D2)</a:t>
+            </a:r>
+          </a:p>
+        </p:txBody>
+      </p:sp>
+      <p:pic>
+        <p:nvPicPr>
+          <p:cNvPr id="17435" name="Picture 17434" descr="table_cross.png"/>
+          <p:cNvPicPr>
+            <a:picLocks noChangeAspect="1"/>
+          </p:cNvPicPr>
+          <p:nvPr/>
+        </p:nvPicPr>
+        <p:blipFill>
+          <a:blip r:embed="rId7"/>
+          <a:stretch>
+            <a:fillRect/>
+          </a:stretch>
+        </p:blipFill>
+        <p:spPr>
+          <a:xfrm>
+            <a:off x="10241279" y="2423160"/>
+            <a:ext cx="182880" cy="182880"/>
+          </a:xfrm>
+          <a:prstGeom prst="rect">
+            <a:avLst/>
+          </a:prstGeom>
+        </p:spPr>
+      </p:pic>
+      <p:pic>
+        <p:nvPicPr>
+          <p:cNvPr id="17436" name="Picture 17435" descr="table_check.png"/>
+          <p:cNvPicPr>
+            <a:picLocks noChangeAspect="1"/>
+          </p:cNvPicPr>
+          <p:nvPr/>
+        </p:nvPicPr>
+        <p:blipFill>
+          <a:blip r:embed="rId8"/>
+          <a:stretch>
+            <a:fillRect/>
+          </a:stretch>
+        </p:blipFill>
+        <p:spPr>
+          <a:xfrm>
+            <a:off x="11155679" y="2423160"/>
+            <a:ext cx="182880" cy="182880"/>
+          </a:xfrm>
+          <a:prstGeom prst="rect">
+            <a:avLst/>
+          </a:prstGeom>
+        </p:spPr>
+      </p:pic>
+      <p:sp>
+        <p:nvSpPr>
+          <p:cNvPr id="17437" name="Rectangle 17436"/>
+          <p:cNvSpPr/>
+          <p:nvPr/>
+        </p:nvSpPr>
+        <p:spPr>
+          <a:xfrm>
+            <a:off x="7424927" y="2999232"/>
+            <a:ext cx="4315968" cy="9144"/>
+          </a:xfrm>
+          <a:prstGeom prst="rect">
+            <a:avLst/>
+          </a:prstGeom>
+          <a:solidFill>
+            <a:srgbClr val="E2E8F0"/>
+          </a:solidFill>
+          <a:ln>
+            <a:noFill/>
+          </a:ln>
+        </p:spPr>
+        <p:style>
+          <a:lnRef idx="1">
+            <a:schemeClr val="accent1"/>
+          </a:lnRef>
+          <a:fillRef idx="3">
+            <a:schemeClr val="accent1"/>
+          </a:fillRef>
+          <a:effectRef idx="2">
+            <a:schemeClr val="accent1"/>
+          </a:effectRef>
+          <a:fontRef idx="minor">
+            <a:schemeClr val="lt1"/>
+          </a:fontRef>
+        </p:style>
+        <p:txBody>
+          <a:bodyPr rtlCol="0" anchor="ctr"/>
+          <a:lstStyle/>
+          <a:p>
+            <a:pPr algn="ctr"/>
+          </a:p>
+        </p:txBody>
+      </p:sp>
+      <p:sp>
+        <p:nvSpPr>
+          <p:cNvPr id="17438" name="TextBox 17437"/>
+          <p:cNvSpPr txBox="1"/>
+          <p:nvPr/>
+        </p:nvSpPr>
+        <p:spPr>
+          <a:xfrm>
+            <a:off x="7516367" y="2715768"/>
+            <a:ext cx="2423160" cy="256032"/>
+          </a:xfrm>
+          <a:prstGeom prst="rect">
+            <a:avLst/>
+          </a:prstGeom>
+          <a:noFill/>
+        </p:spPr>
+        <p:txBody>
+          <a:bodyPr wrap="none" anchor="ctr" tIns="9144" lIns="18288">
+            <a:spAutoFit/>
+          </a:bodyPr>
+          <a:lstStyle/>
+          <a:p>
+            <a:pPr>
+              <a:defRPr sz="750">
+                <a:solidFill>
+                  <a:srgbClr val="1E293B"/>
+                </a:solidFill>
+                <a:latin typeface="Arial"/>
+              </a:defRPr>
+            </a:pPr>
+            <a:r>
+              <a:t>Statutory Factor XAI (TreeSHAP)</a:t>
+            </a:r>
+          </a:p>
+        </p:txBody>
+      </p:sp>
+      <p:pic>
+        <p:nvPicPr>
+          <p:cNvPr id="17439" name="Picture 17438" descr="table_cross.png"/>
+          <p:cNvPicPr>
+            <a:picLocks noChangeAspect="1"/>
+          </p:cNvPicPr>
+          <p:nvPr/>
+        </p:nvPicPr>
+        <p:blipFill>
+          <a:blip r:embed="rId7"/>
+          <a:stretch>
+            <a:fillRect/>
+          </a:stretch>
+        </p:blipFill>
+        <p:spPr>
+          <a:xfrm>
+            <a:off x="10241279" y="2743200"/>
+            <a:ext cx="182880" cy="182880"/>
+          </a:xfrm>
+          <a:prstGeom prst="rect">
+            <a:avLst/>
+          </a:prstGeom>
+        </p:spPr>
+      </p:pic>
+      <p:pic>
+        <p:nvPicPr>
+          <p:cNvPr id="17440" name="Picture 17439" descr="table_check.png"/>
+          <p:cNvPicPr>
+            <a:picLocks noChangeAspect="1"/>
+          </p:cNvPicPr>
+          <p:nvPr/>
+        </p:nvPicPr>
+        <p:blipFill>
+          <a:blip r:embed="rId8"/>
+          <a:stretch>
+            <a:fillRect/>
+          </a:stretch>
+        </p:blipFill>
+        <p:spPr>
+          <a:xfrm>
+            <a:off x="11155679" y="2743200"/>
+            <a:ext cx="182880" cy="182880"/>
+          </a:xfrm>
+          <a:prstGeom prst="rect">
+            <a:avLst/>
+          </a:prstGeom>
+        </p:spPr>
+      </p:pic>
+      <p:sp>
+        <p:nvSpPr>
+          <p:cNvPr id="17441" name="Rectangle 17440"/>
+          <p:cNvSpPr/>
+          <p:nvPr/>
+        </p:nvSpPr>
+        <p:spPr>
+          <a:xfrm>
+            <a:off x="7443215" y="2999232"/>
+            <a:ext cx="4279392" cy="320040"/>
+          </a:xfrm>
+          <a:prstGeom prst="rect">
+            <a:avLst/>
+          </a:prstGeom>
+          <a:solidFill>
+            <a:srgbClr val="F8FAFC"/>
+          </a:solidFill>
+          <a:ln>
+            <a:noFill/>
+          </a:ln>
+        </p:spPr>
+        <p:style>
+          <a:lnRef idx="1">
+            <a:schemeClr val="accent1"/>
+          </a:lnRef>
+          <a:fillRef idx="3">
+            <a:schemeClr val="accent1"/>
+          </a:fillRef>
+          <a:effectRef idx="2">
+            <a:schemeClr val="accent1"/>
+          </a:effectRef>
+          <a:fontRef idx="minor">
+            <a:schemeClr val="lt1"/>
+          </a:fontRef>
+        </p:style>
+        <p:txBody>
+          <a:bodyPr rtlCol="0" anchor="ctr"/>
+          <a:lstStyle/>
+          <a:p>
+            <a:pPr algn="ctr"/>
+          </a:p>
+        </p:txBody>
+      </p:sp>
+      <p:sp>
+        <p:nvSpPr>
+          <p:cNvPr id="17442" name="Rectangle 17441"/>
+          <p:cNvSpPr/>
+          <p:nvPr/>
+        </p:nvSpPr>
+        <p:spPr>
+          <a:xfrm>
+            <a:off x="7424927" y="3319272"/>
+            <a:ext cx="4315968" cy="9144"/>
+          </a:xfrm>
+          <a:prstGeom prst="rect">
+            <a:avLst/>
+          </a:prstGeom>
+          <a:solidFill>
+            <a:srgbClr val="E2E8F0"/>
+          </a:solidFill>
+          <a:ln>
+            <a:noFill/>
+          </a:ln>
+        </p:spPr>
+        <p:style>
+          <a:lnRef idx="1">
+            <a:schemeClr val="accent1"/>
+          </a:lnRef>
+          <a:fillRef idx="3">
+            <a:schemeClr val="accent1"/>
+          </a:fillRef>
+          <a:effectRef idx="2">
+            <a:schemeClr val="accent1"/>
+          </a:effectRef>
+          <a:fontRef idx="minor">
+            <a:schemeClr val="lt1"/>
+          </a:fontRef>
+        </p:style>
+        <p:txBody>
+          <a:bodyPr rtlCol="0" anchor="ctr"/>
+          <a:lstStyle/>
+          <a:p>
+            <a:pPr algn="ctr"/>
+          </a:p>
+        </p:txBody>
+      </p:sp>
+      <p:sp>
+        <p:nvSpPr>
+          <p:cNvPr id="17443" name="TextBox 17442"/>
+          <p:cNvSpPr txBox="1"/>
+          <p:nvPr/>
+        </p:nvSpPr>
+        <p:spPr>
+          <a:xfrm>
+            <a:off x="7516367" y="3035808"/>
+            <a:ext cx="2423160" cy="256032"/>
+          </a:xfrm>
+          <a:prstGeom prst="rect">
+            <a:avLst/>
+          </a:prstGeom>
+          <a:noFill/>
+        </p:spPr>
+        <p:txBody>
+          <a:bodyPr wrap="none" anchor="ctr" tIns="9144" lIns="18288">
+            <a:spAutoFit/>
+          </a:bodyPr>
+          <a:lstStyle/>
+          <a:p>
+            <a:pPr>
+              <a:defRPr sz="750">
+                <a:solidFill>
+                  <a:srgbClr val="1E293B"/>
+                </a:solidFill>
+                <a:latin typeface="Arial"/>
+              </a:defRPr>
+            </a:pPr>
+            <a:r>
+              <a:t>Automated Prescriptive DFA SOPs</a:t>
+            </a:r>
+          </a:p>
+        </p:txBody>
+      </p:sp>
+      <p:pic>
+        <p:nvPicPr>
+          <p:cNvPr id="17444" name="Picture 17443" descr="table_cross.png"/>
+          <p:cNvPicPr>
+            <a:picLocks noChangeAspect="1"/>
+          </p:cNvPicPr>
+          <p:nvPr/>
+        </p:nvPicPr>
+        <p:blipFill>
+          <a:blip r:embed="rId7"/>
+          <a:stretch>
+            <a:fillRect/>
+          </a:stretch>
+        </p:blipFill>
+        <p:spPr>
+          <a:xfrm>
+            <a:off x="10241279" y="3063240"/>
+            <a:ext cx="182880" cy="182880"/>
+          </a:xfrm>
+          <a:prstGeom prst="rect">
+            <a:avLst/>
+          </a:prstGeom>
+        </p:spPr>
+      </p:pic>
+      <p:pic>
+        <p:nvPicPr>
+          <p:cNvPr id="17445" name="Picture 17444" descr="table_check.png"/>
+          <p:cNvPicPr>
+            <a:picLocks noChangeAspect="1"/>
+          </p:cNvPicPr>
+          <p:nvPr/>
+        </p:nvPicPr>
+        <p:blipFill>
+          <a:blip r:embed="rId8"/>
+          <a:stretch>
+            <a:fillRect/>
+          </a:stretch>
+        </p:blipFill>
+        <p:spPr>
+          <a:xfrm>
+            <a:off x="11155679" y="3063240"/>
+            <a:ext cx="182880" cy="182880"/>
+          </a:xfrm>
+          <a:prstGeom prst="rect">
+            <a:avLst/>
+          </a:prstGeom>
+        </p:spPr>
+      </p:pic>
+      <p:sp>
+        <p:nvSpPr>
+          <p:cNvPr id="17446" name="Rectangle 17445"/>
+          <p:cNvSpPr/>
+          <p:nvPr/>
+        </p:nvSpPr>
+        <p:spPr>
+          <a:xfrm>
+            <a:off x="7424927" y="3639312"/>
+            <a:ext cx="4315968" cy="9144"/>
+          </a:xfrm>
+          <a:prstGeom prst="rect">
+            <a:avLst/>
+          </a:prstGeom>
+          <a:solidFill>
+            <a:srgbClr val="E2E8F0"/>
+          </a:solidFill>
+          <a:ln>
+            <a:noFill/>
+          </a:ln>
+        </p:spPr>
+        <p:style>
+          <a:lnRef idx="1">
+            <a:schemeClr val="accent1"/>
+          </a:lnRef>
+          <a:fillRef idx="3">
+            <a:schemeClr val="accent1"/>
+          </a:fillRef>
+          <a:effectRef idx="2">
+            <a:schemeClr val="accent1"/>
+          </a:effectRef>
+          <a:fontRef idx="minor">
+            <a:schemeClr val="lt1"/>
+          </a:fontRef>
+        </p:style>
+        <p:txBody>
+          <a:bodyPr rtlCol="0" anchor="ctr"/>
+          <a:lstStyle/>
+          <a:p>
+            <a:pPr algn="ctr"/>
+          </a:p>
+        </p:txBody>
+      </p:sp>
+      <p:sp>
+        <p:nvSpPr>
+          <p:cNvPr id="17447" name="TextBox 17446"/>
+          <p:cNvSpPr txBox="1"/>
+          <p:nvPr/>
+        </p:nvSpPr>
+        <p:spPr>
+          <a:xfrm>
+            <a:off x="7516367" y="3355848"/>
+            <a:ext cx="2423160" cy="256032"/>
+          </a:xfrm>
+          <a:prstGeom prst="rect">
+            <a:avLst/>
+          </a:prstGeom>
+          <a:noFill/>
+        </p:spPr>
+        <p:txBody>
+          <a:bodyPr wrap="none" anchor="ctr" tIns="9144" lIns="18288">
+            <a:spAutoFit/>
+          </a:bodyPr>
+          <a:lstStyle/>
+          <a:p>
+            <a:pPr>
+              <a:defRPr sz="750">
+                <a:solidFill>
+                  <a:srgbClr val="1E293B"/>
+                </a:solidFill>
+                <a:latin typeface="Arial"/>
+              </a:defRPr>
+            </a:pPr>
+            <a:r>
+              <a:t>Constitutional HITL &amp; Aadhaar DSC</a:t>
+            </a:r>
+          </a:p>
+        </p:txBody>
+      </p:sp>
+      <p:pic>
+        <p:nvPicPr>
+          <p:cNvPr id="17448" name="Picture 17447" descr="table_cross.png"/>
+          <p:cNvPicPr>
+            <a:picLocks noChangeAspect="1"/>
+          </p:cNvPicPr>
+          <p:nvPr/>
+        </p:nvPicPr>
+        <p:blipFill>
+          <a:blip r:embed="rId7"/>
+          <a:stretch>
+            <a:fillRect/>
+          </a:stretch>
+        </p:blipFill>
+        <p:spPr>
+          <a:xfrm>
+            <a:off x="10241279" y="3383280"/>
+            <a:ext cx="182880" cy="182880"/>
+          </a:xfrm>
+          <a:prstGeom prst="rect">
+            <a:avLst/>
+          </a:prstGeom>
+        </p:spPr>
+      </p:pic>
+      <p:pic>
+        <p:nvPicPr>
+          <p:cNvPr id="17449" name="Picture 17448" descr="table_check.png"/>
+          <p:cNvPicPr>
+            <a:picLocks noChangeAspect="1"/>
+          </p:cNvPicPr>
+          <p:nvPr/>
+        </p:nvPicPr>
+        <p:blipFill>
+          <a:blip r:embed="rId8"/>
+          <a:stretch>
+            <a:fillRect/>
+          </a:stretch>
+        </p:blipFill>
+        <p:spPr>
+          <a:xfrm>
+            <a:off x="11155679" y="3383280"/>
+            <a:ext cx="182880" cy="182880"/>
+          </a:xfrm>
+          <a:prstGeom prst="rect">
+            <a:avLst/>
+          </a:prstGeom>
+        </p:spPr>
+      </p:pic>
+      <p:sp>
+        <p:nvSpPr>
+          <p:cNvPr id="17450" name="Rectangle 17449"/>
+          <p:cNvSpPr/>
+          <p:nvPr/>
+        </p:nvSpPr>
+        <p:spPr>
+          <a:xfrm>
+            <a:off x="7443215" y="3639312"/>
+            <a:ext cx="4279392" cy="320040"/>
+          </a:xfrm>
+          <a:prstGeom prst="rect">
+            <a:avLst/>
+          </a:prstGeom>
+          <a:solidFill>
+            <a:srgbClr val="F8FAFC"/>
+          </a:solidFill>
+          <a:ln>
+            <a:noFill/>
+          </a:ln>
+        </p:spPr>
+        <p:style>
+          <a:lnRef idx="1">
+            <a:schemeClr val="accent1"/>
+          </a:lnRef>
+          <a:fillRef idx="3">
+            <a:schemeClr val="accent1"/>
+          </a:fillRef>
+          <a:effectRef idx="2">
+            <a:schemeClr val="accent1"/>
+          </a:effectRef>
+          <a:fontRef idx="minor">
+            <a:schemeClr val="lt1"/>
+          </a:fontRef>
+        </p:style>
+        <p:txBody>
+          <a:bodyPr rtlCol="0" anchor="ctr"/>
+          <a:lstStyle/>
+          <a:p>
+            <a:pPr algn="ctr"/>
+          </a:p>
+        </p:txBody>
+      </p:sp>
+      <p:sp>
+        <p:nvSpPr>
+          <p:cNvPr id="17451" name="Rectangle 17450"/>
+          <p:cNvSpPr/>
+          <p:nvPr/>
+        </p:nvSpPr>
+        <p:spPr>
+          <a:xfrm>
+            <a:off x="7424927" y="3959352"/>
+            <a:ext cx="4315968" cy="9144"/>
+          </a:xfrm>
+          <a:prstGeom prst="rect">
+            <a:avLst/>
+          </a:prstGeom>
+          <a:solidFill>
+            <a:srgbClr val="E2E8F0"/>
+          </a:solidFill>
+          <a:ln>
+            <a:noFill/>
+          </a:ln>
+        </p:spPr>
+        <p:style>
+          <a:lnRef idx="1">
+            <a:schemeClr val="accent1"/>
+          </a:lnRef>
+          <a:fillRef idx="3">
+            <a:schemeClr val="accent1"/>
+          </a:fillRef>
+          <a:effectRef idx="2">
+            <a:schemeClr val="accent1"/>
+          </a:effectRef>
+          <a:fontRef idx="minor">
+            <a:schemeClr val="lt1"/>
+          </a:fontRef>
+        </p:style>
+        <p:txBody>
+          <a:bodyPr rtlCol="0" anchor="ctr"/>
+          <a:lstStyle/>
+          <a:p>
+            <a:pPr algn="ctr"/>
+          </a:p>
+        </p:txBody>
+      </p:sp>
+      <p:sp>
+        <p:nvSpPr>
+          <p:cNvPr id="17452" name="TextBox 17451"/>
+          <p:cNvSpPr txBox="1"/>
+          <p:nvPr/>
+        </p:nvSpPr>
+        <p:spPr>
+          <a:xfrm>
+            <a:off x="7516367" y="3675888"/>
+            <a:ext cx="2423160" cy="256032"/>
+          </a:xfrm>
+          <a:prstGeom prst="rect">
+            <a:avLst/>
+          </a:prstGeom>
+          <a:noFill/>
+        </p:spPr>
+        <p:txBody>
+          <a:bodyPr wrap="none" anchor="ctr" tIns="9144" lIns="18288">
+            <a:spAutoFit/>
+          </a:bodyPr>
+          <a:lstStyle/>
+          <a:p>
+            <a:pPr>
+              <a:defRPr sz="750">
+                <a:solidFill>
+                  <a:srgbClr val="1E293B"/>
+                </a:solidFill>
+                <a:latin typeface="Arial"/>
+              </a:defRPr>
+            </a:pPr>
+            <a:r>
+              <a:t>CAG / CVC Tamper-Proof Audit</a:t>
+            </a:r>
+          </a:p>
+        </p:txBody>
+      </p:sp>
+      <p:pic>
+        <p:nvPicPr>
+          <p:cNvPr id="17453" name="Picture 17452" descr="table_cross.png"/>
+          <p:cNvPicPr>
+            <a:picLocks noChangeAspect="1"/>
+          </p:cNvPicPr>
+          <p:nvPr/>
+        </p:nvPicPr>
+        <p:blipFill>
+          <a:blip r:embed="rId7"/>
+          <a:stretch>
+            <a:fillRect/>
+          </a:stretch>
+        </p:blipFill>
+        <p:spPr>
+          <a:xfrm>
+            <a:off x="10241279" y="3703320"/>
+            <a:ext cx="182880" cy="182880"/>
+          </a:xfrm>
+          <a:prstGeom prst="rect">
+            <a:avLst/>
+          </a:prstGeom>
+        </p:spPr>
+      </p:pic>
+      <p:pic>
+        <p:nvPicPr>
+          <p:cNvPr id="17454" name="Picture 17453" descr="table_check.png"/>
+          <p:cNvPicPr>
+            <a:picLocks noChangeAspect="1"/>
+          </p:cNvPicPr>
+          <p:nvPr/>
+        </p:nvPicPr>
+        <p:blipFill>
+          <a:blip r:embed="rId8"/>
+          <a:stretch>
+            <a:fillRect/>
+          </a:stretch>
+        </p:blipFill>
+        <p:spPr>
+          <a:xfrm>
+            <a:off x="11155679" y="3703320"/>
+            <a:ext cx="182880" cy="182880"/>
+          </a:xfrm>
+          <a:prstGeom prst="rect">
+            <a:avLst/>
+          </a:prstGeom>
+        </p:spPr>
+      </p:pic>
+      <p:sp>
+        <p:nvSpPr>
+          <p:cNvPr id="17455" name="Rounded Rectangle 17454"/>
+          <p:cNvSpPr/>
+          <p:nvPr/>
+        </p:nvSpPr>
+        <p:spPr>
+          <a:xfrm>
+            <a:off x="438912" y="4160520"/>
+            <a:ext cx="11301984" cy="292608"/>
+          </a:xfrm>
+          <a:prstGeom prst="roundRect">
+            <a:avLst/>
+          </a:prstGeom>
+          <a:solidFill>
+            <a:srgbClr val="F1F5F9"/>
+          </a:solidFill>
+          <a:ln w="12700">
+            <a:solidFill>
+              <a:srgbClr val="CBD5E1"/>
+            </a:solidFill>
+          </a:ln>
+        </p:spPr>
+        <p:style>
+          <a:lnRef idx="1">
+            <a:schemeClr val="accent1"/>
+          </a:lnRef>
+          <a:fillRef idx="3">
+            <a:schemeClr val="accent1"/>
+          </a:fillRef>
+          <a:effectRef idx="2">
+            <a:schemeClr val="accent1"/>
+          </a:effectRef>
+          <a:fontRef idx="minor">
+            <a:schemeClr val="lt1"/>
+          </a:fontRef>
+        </p:style>
+        <p:txBody>
+          <a:bodyPr rtlCol="0" anchor="ctr"/>
+          <a:lstStyle/>
+          <a:p>
+            <a:pPr algn="ctr">
+              <a:defRPr sz="1050" b="1">
+                <a:solidFill>
+                  <a:srgbClr val="1E293B"/>
+                </a:solidFill>
+                <a:latin typeface="Arial"/>
+              </a:defRPr>
+            </a:pPr>
+            <a:r>
+              <a:t>HOW GATISHAKTI AI DELIVERS MULTI-STAKEHOLDER VALUE</a:t>
+            </a:r>
+          </a:p>
+        </p:txBody>
+      </p:sp>
+      <p:sp>
+        <p:nvSpPr>
+          <p:cNvPr id="17456" name="Rounded Rectangle 17455"/>
+          <p:cNvSpPr/>
+          <p:nvPr/>
+        </p:nvSpPr>
+        <p:spPr>
+          <a:xfrm>
+            <a:off x="438912" y="4526280"/>
+            <a:ext cx="3621024" cy="1664208"/>
+          </a:xfrm>
+          <a:prstGeom prst="roundRect">
+            <a:avLst/>
+          </a:prstGeom>
+          <a:solidFill>
+            <a:srgbClr val="FFFFFF"/>
+          </a:solidFill>
+          <a:ln w="19050">
+            <a:solidFill>
+              <a:srgbClr val="0070C0"/>
+            </a:solidFill>
+          </a:ln>
+        </p:spPr>
+        <p:style>
+          <a:lnRef idx="1">
+            <a:schemeClr val="accent1"/>
+          </a:lnRef>
+          <a:fillRef idx="3">
+            <a:schemeClr val="accent1"/>
+          </a:fillRef>
+          <a:effectRef idx="2">
+            <a:schemeClr val="accent1"/>
+          </a:effectRef>
+          <a:fontRef idx="minor">
+            <a:schemeClr val="lt1"/>
+          </a:fontRef>
+        </p:style>
+        <p:txBody>
+          <a:bodyPr rtlCol="0" anchor="ctr"/>
+          <a:lstStyle/>
+          <a:p>
+            <a:pPr algn="ctr"/>
+          </a:p>
+        </p:txBody>
+      </p:sp>
+      <p:sp>
+        <p:nvSpPr>
+          <p:cNvPr id="17457" name="Rounded Rectangle 17456"/>
+          <p:cNvSpPr/>
+          <p:nvPr/>
+        </p:nvSpPr>
+        <p:spPr>
+          <a:xfrm>
+            <a:off x="512064" y="4599432"/>
+            <a:ext cx="3474720" cy="274320"/>
+          </a:xfrm>
+          <a:prstGeom prst="roundRect">
+            <a:avLst/>
+          </a:prstGeom>
+          <a:solidFill>
+            <a:srgbClr val="0070C0"/>
+          </a:solidFill>
+          <a:ln>
+            <a:noFill/>
+          </a:ln>
+        </p:spPr>
+        <p:style>
+          <a:lnRef idx="1">
+            <a:schemeClr val="accent1"/>
+          </a:lnRef>
+          <a:fillRef idx="3">
+            <a:schemeClr val="accent1"/>
+          </a:fillRef>
+          <a:effectRef idx="2">
+            <a:schemeClr val="accent1"/>
+          </a:effectRef>
+          <a:fontRef idx="minor">
+            <a:schemeClr val="lt1"/>
+          </a:fontRef>
+        </p:style>
+        <p:txBody>
+          <a:bodyPr rtlCol="0" anchor="ctr" lIns="292608"/>
+          <a:lstStyle/>
+          <a:p>
+            <a:pPr algn="ctr">
+              <a:defRPr sz="850" b="1">
+                <a:solidFill>
+                  <a:srgbClr val="FFFFFF"/>
+                </a:solidFill>
+                <a:latin typeface="Arial"/>
+              </a:defRPr>
+            </a:pPr>
+            <a:r>
+              <a:t>MODE 1: NHAI PROJECT DIRECTOR (PD)</a:t>
+            </a:r>
+          </a:p>
+        </p:txBody>
+      </p:sp>
+      <p:pic>
+        <p:nvPicPr>
+          <p:cNvPr id="17458" name="Picture 17457" descr="nhai_pd_icon.png"/>
+          <p:cNvPicPr>
+            <a:picLocks noChangeAspect="1"/>
+          </p:cNvPicPr>
+          <p:nvPr/>
+        </p:nvPicPr>
+        <p:blipFill>
+          <a:blip r:embed="rId9"/>
+          <a:stretch>
+            <a:fillRect/>
+          </a:stretch>
+        </p:blipFill>
+        <p:spPr>
+          <a:xfrm>
+            <a:off x="548640" y="4617720"/>
+            <a:ext cx="219456" cy="219456"/>
+          </a:xfrm>
+          <a:prstGeom prst="rect">
+            <a:avLst/>
+          </a:prstGeom>
+        </p:spPr>
+      </p:pic>
+      <p:sp>
+        <p:nvSpPr>
+          <p:cNvPr id="17459" name="TextBox 17458"/>
+          <p:cNvSpPr txBox="1"/>
+          <p:nvPr/>
+        </p:nvSpPr>
+        <p:spPr>
+          <a:xfrm>
+            <a:off x="530352" y="4892040"/>
+            <a:ext cx="3438144" cy="1252728"/>
+          </a:xfrm>
+          <a:prstGeom prst="rect">
+            <a:avLst/>
+          </a:prstGeom>
+          <a:noFill/>
+        </p:spPr>
+        <p:txBody>
+          <a:bodyPr wrap="square" anchor="t" lIns="36576" rIns="36576" tIns="18288">
+            <a:spAutoFit/>
+          </a:bodyPr>
+          <a:lstStyle/>
           <a:p>
             <a:pPr>
               <a:spcAft>
-                <a:spcPts val="700"/>
+                <a:spcPts val="200"/>
               </a:spcAft>
             </a:pPr>
             <a:r>
-              <a:rPr sz="950" b="1">
-                <a:solidFill>
-                  <a:srgbClr val="059669"/>
+              <a:rPr sz="750" b="1">
+                <a:solidFill>
+                  <a:srgbClr val="0070C0"/>
                 </a:solidFill>
                 <a:latin typeface="Arial"/>
               </a:rPr>
-              <a:t>• ₹4,000+ Crore Escrow Unlocked:
-</a:t>
-            </a:r>
-            <a:r>
-              <a:rPr sz="850">
-                <a:solidFill>
-                  <a:srgbClr val="1E293B"/>
+              <a:t>•  </a:t>
+            </a:r>
+            <a:r>
+              <a:rPr sz="750" b="1">
+                <a:solidFill>
+                  <a:srgbClr val="0F172A"/>
                 </a:solidFill>
                 <a:latin typeface="Arial"/>
               </a:rPr>
-              <a:t>  Unlocks billions in stalled court escrow funds across national corridors, permanently terminating the accrual of 9% to 15% statutory penal interest under Section 34 of RFCTLARR Act 2013.</a:t>
+              <a:t>For : </a:t>
+            </a:r>
+            <a:r>
+              <a:rPr sz="720">
+                <a:solidFill>
+                  <a:srgbClr val="334155"/>
+                </a:solidFill>
+                <a:latin typeface="Arial"/>
+              </a:rPr>
+              <a:t>Highway corridor civil works &amp; contract delivery</a:t>
             </a:r>
           </a:p>
           <a:p>
             <a:pPr>
               <a:spcAft>
-                <a:spcPts val="700"/>
+                <a:spcPts val="200"/>
               </a:spcAft>
             </a:pPr>
             <a:r>
-              <a:rPr sz="950" b="1">
-                <a:solidFill>
-                  <a:srgbClr val="059669"/>
+              <a:rPr sz="750" b="1">
+                <a:solidFill>
+                  <a:srgbClr val="0070C0"/>
                 </a:solidFill>
                 <a:latin typeface="Arial"/>
               </a:rPr>
-              <a:t>• 35% to 45% Timeline Compression:
-</a:t>
-            </a:r>
-            <a:r>
-              <a:rPr sz="850">
-                <a:solidFill>
-                  <a:srgbClr val="1E293B"/>
+              <a:t>•  </a:t>
+            </a:r>
+            <a:r>
+              <a:rPr sz="750" b="1">
+                <a:solidFill>
+                  <a:srgbClr val="0F172A"/>
                 </a:solidFill>
                 <a:latin typeface="Arial"/>
               </a:rPr>
-              <a:t>  Reduces average statutory land acquisition lifecycle from 32 months down to 18–22 months, directly preventing costly EPC highway contractor delay claims.</a:t>
+              <a:t>Process : </a:t>
+            </a:r>
+            <a:r>
+              <a:rPr sz="720">
+                <a:solidFill>
+                  <a:srgbClr val="334155"/>
+                </a:solidFill>
+                <a:latin typeface="Arial"/>
+              </a:rPr>
+              <a:t>Corridor RoW tracking ➔ Auto delay alerts ➔ SOP issuance</a:t>
             </a:r>
           </a:p>
           <a:p>
             <a:pPr>
               <a:spcAft>
-                <a:spcPts val="700"/>
+                <a:spcPts val="200"/>
               </a:spcAft>
             </a:pPr>
             <a:r>
-              <a:rPr sz="950" b="1">
-                <a:solidFill>
-                  <a:srgbClr val="059669"/>
+              <a:rPr sz="750" b="1">
+                <a:solidFill>
+                  <a:srgbClr val="0070C0"/>
                 </a:solidFill>
                 <a:latin typeface="Arial"/>
               </a:rPr>
-              <a:t>• CVC &amp; CAG Compliant Governance:
-</a:t>
-            </a:r>
-            <a:r>
-              <a:rPr sz="850">
-                <a:solidFill>
-                  <a:srgbClr val="1E293B"/>
+              <a:t>•  </a:t>
+            </a:r>
+            <a:r>
+              <a:rPr sz="750" b="1">
+                <a:solidFill>
+                  <a:srgbClr val="0F172A"/>
                 </a:solidFill>
                 <a:latin typeface="Arial"/>
               </a:rPr>
-              <a:t>  Cryptographic SHA-256 block hashing permanently seals every administrative decision, compensation release, and stay filing into an immutable, tamper-evident audit ledger.</a:t>
+              <a:t>Time Saved : </a:t>
+            </a:r>
+            <a:r>
+              <a:rPr sz="720">
+                <a:solidFill>
+                  <a:srgbClr val="334155"/>
+                </a:solidFill>
+                <a:latin typeface="Arial"/>
+              </a:rPr>
+              <a:t>4 to 8 months saved per 40 km construction package</a:t>
             </a:r>
           </a:p>
           <a:p>
             <a:pPr>
               <a:spcAft>
-                <a:spcPts val="700"/>
+                <a:spcPts val="200"/>
               </a:spcAft>
             </a:pPr>
             <a:r>
-              <a:rPr sz="950" b="1">
+              <a:rPr sz="750" b="1">
+                <a:solidFill>
+                  <a:srgbClr val="0070C0"/>
+                </a:solidFill>
+                <a:latin typeface="Arial"/>
+              </a:rPr>
+              <a:t>•  </a:t>
+            </a:r>
+            <a:r>
+              <a:rPr sz="750" b="1">
+                <a:solidFill>
+                  <a:srgbClr val="0F172A"/>
+                </a:solidFill>
+                <a:latin typeface="Arial"/>
+              </a:rPr>
+              <a:t>Impact Metric : </a:t>
+            </a:r>
+            <a:r>
+              <a:rPr sz="720">
+                <a:solidFill>
+                  <a:srgbClr val="334155"/>
+                </a:solidFill>
+                <a:latin typeface="Arial"/>
+              </a:rPr>
+              <a:t>Saves ₹4.5 Cr/month in idling compensation claims</a:t>
+            </a:r>
+          </a:p>
+          <a:p>
+            <a:pPr>
+              <a:spcAft>
+                <a:spcPts val="200"/>
+              </a:spcAft>
+            </a:pPr>
+            <a:r>
+              <a:rPr sz="750" b="1">
+                <a:solidFill>
+                  <a:srgbClr val="0070C0"/>
+                </a:solidFill>
+                <a:latin typeface="Arial"/>
+              </a:rPr>
+              <a:t>•  </a:t>
+            </a:r>
+            <a:r>
+              <a:rPr sz="750" b="1">
+                <a:solidFill>
+                  <a:srgbClr val="0F172A"/>
+                </a:solidFill>
+                <a:latin typeface="Arial"/>
+              </a:rPr>
+              <a:t>Best For : </a:t>
+            </a:r>
+            <a:r>
+              <a:rPr sz="720">
+                <a:solidFill>
+                  <a:srgbClr val="334155"/>
+                </a:solidFill>
+                <a:latin typeface="Arial"/>
+              </a:rPr>
+              <a:t>EPC contractor coordination &amp; physical road execution</a:t>
+            </a:r>
+          </a:p>
+        </p:txBody>
+      </p:sp>
+      <p:sp>
+        <p:nvSpPr>
+          <p:cNvPr id="17460" name="Rounded Rectangle 17459"/>
+          <p:cNvSpPr/>
+          <p:nvPr/>
+        </p:nvSpPr>
+        <p:spPr>
+          <a:xfrm>
+            <a:off x="4279392" y="4526280"/>
+            <a:ext cx="3621024" cy="1664208"/>
+          </a:xfrm>
+          <a:prstGeom prst="roundRect">
+            <a:avLst/>
+          </a:prstGeom>
+          <a:solidFill>
+            <a:srgbClr val="FFFFFF"/>
+          </a:solidFill>
+          <a:ln w="19050">
+            <a:solidFill>
+              <a:srgbClr val="EA580C"/>
+            </a:solidFill>
+          </a:ln>
+        </p:spPr>
+        <p:style>
+          <a:lnRef idx="1">
+            <a:schemeClr val="accent1"/>
+          </a:lnRef>
+          <a:fillRef idx="3">
+            <a:schemeClr val="accent1"/>
+          </a:fillRef>
+          <a:effectRef idx="2">
+            <a:schemeClr val="accent1"/>
+          </a:effectRef>
+          <a:fontRef idx="minor">
+            <a:schemeClr val="lt1"/>
+          </a:fontRef>
+        </p:style>
+        <p:txBody>
+          <a:bodyPr rtlCol="0" anchor="ctr"/>
+          <a:lstStyle/>
+          <a:p>
+            <a:pPr algn="ctr"/>
+          </a:p>
+        </p:txBody>
+      </p:sp>
+      <p:sp>
+        <p:nvSpPr>
+          <p:cNvPr id="17461" name="Rounded Rectangle 17460"/>
+          <p:cNvSpPr/>
+          <p:nvPr/>
+        </p:nvSpPr>
+        <p:spPr>
+          <a:xfrm>
+            <a:off x="4352544" y="4599432"/>
+            <a:ext cx="3474720" cy="274320"/>
+          </a:xfrm>
+          <a:prstGeom prst="roundRect">
+            <a:avLst/>
+          </a:prstGeom>
+          <a:solidFill>
+            <a:srgbClr val="EA580C"/>
+          </a:solidFill>
+          <a:ln>
+            <a:noFill/>
+          </a:ln>
+        </p:spPr>
+        <p:style>
+          <a:lnRef idx="1">
+            <a:schemeClr val="accent1"/>
+          </a:lnRef>
+          <a:fillRef idx="3">
+            <a:schemeClr val="accent1"/>
+          </a:fillRef>
+          <a:effectRef idx="2">
+            <a:schemeClr val="accent1"/>
+          </a:effectRef>
+          <a:fontRef idx="minor">
+            <a:schemeClr val="lt1"/>
+          </a:fontRef>
+        </p:style>
+        <p:txBody>
+          <a:bodyPr rtlCol="0" anchor="ctr" lIns="292608"/>
+          <a:lstStyle/>
+          <a:p>
+            <a:pPr algn="ctr">
+              <a:defRPr sz="850" b="1">
+                <a:solidFill>
+                  <a:srgbClr val="FFFFFF"/>
+                </a:solidFill>
+                <a:latin typeface="Arial"/>
+              </a:defRPr>
+            </a:pPr>
+            <a:r>
+              <a:t>MODE 2: CALA &amp; REVENUE NODAL OFFICERS</a:t>
+            </a:r>
+          </a:p>
+        </p:txBody>
+      </p:sp>
+      <p:pic>
+        <p:nvPicPr>
+          <p:cNvPr id="17462" name="Picture 17461" descr="cala_icon.png"/>
+          <p:cNvPicPr>
+            <a:picLocks noChangeAspect="1"/>
+          </p:cNvPicPr>
+          <p:nvPr/>
+        </p:nvPicPr>
+        <p:blipFill>
+          <a:blip r:embed="rId10"/>
+          <a:stretch>
+            <a:fillRect/>
+          </a:stretch>
+        </p:blipFill>
+        <p:spPr>
+          <a:xfrm>
+            <a:off x="4389120" y="4617720"/>
+            <a:ext cx="219456" cy="219456"/>
+          </a:xfrm>
+          <a:prstGeom prst="rect">
+            <a:avLst/>
+          </a:prstGeom>
+        </p:spPr>
+      </p:pic>
+      <p:sp>
+        <p:nvSpPr>
+          <p:cNvPr id="17463" name="TextBox 17462"/>
+          <p:cNvSpPr txBox="1"/>
+          <p:nvPr/>
+        </p:nvSpPr>
+        <p:spPr>
+          <a:xfrm>
+            <a:off x="4370832" y="4892040"/>
+            <a:ext cx="3438144" cy="1252728"/>
+          </a:xfrm>
+          <a:prstGeom prst="rect">
+            <a:avLst/>
+          </a:prstGeom>
+          <a:noFill/>
+        </p:spPr>
+        <p:txBody>
+          <a:bodyPr wrap="square" anchor="t" lIns="36576" rIns="36576" tIns="18288">
+            <a:spAutoFit/>
+          </a:bodyPr>
+          <a:lstStyle/>
+          <a:p>
+            <a:pPr>
+              <a:spcAft>
+                <a:spcPts val="200"/>
+              </a:spcAft>
+            </a:pPr>
+            <a:r>
+              <a:rPr sz="750" b="1">
+                <a:solidFill>
+                  <a:srgbClr val="EA580C"/>
+                </a:solidFill>
+                <a:latin typeface="Arial"/>
+              </a:rPr>
+              <a:t>•  </a:t>
+            </a:r>
+            <a:r>
+              <a:rPr sz="750" b="1">
+                <a:solidFill>
+                  <a:srgbClr val="0F172A"/>
+                </a:solidFill>
+                <a:latin typeface="Arial"/>
+              </a:rPr>
+              <a:t>For : </a:t>
+            </a:r>
+            <a:r>
+              <a:rPr sz="720">
+                <a:solidFill>
+                  <a:srgbClr val="334155"/>
+                </a:solidFill>
+                <a:latin typeface="Arial"/>
+              </a:rPr>
+              <a:t>Competent Authority for Land Acquisition &amp; Revenue inquiries</a:t>
+            </a:r>
+          </a:p>
+          <a:p>
+            <a:pPr>
+              <a:spcAft>
+                <a:spcPts val="200"/>
+              </a:spcAft>
+            </a:pPr>
+            <a:r>
+              <a:rPr sz="750" b="1">
+                <a:solidFill>
+                  <a:srgbClr val="EA580C"/>
+                </a:solidFill>
+                <a:latin typeface="Arial"/>
+              </a:rPr>
+              <a:t>•  </a:t>
+            </a:r>
+            <a:r>
+              <a:rPr sz="750" b="1">
+                <a:solidFill>
+                  <a:srgbClr val="0F172A"/>
+                </a:solidFill>
+                <a:latin typeface="Arial"/>
+              </a:rPr>
+              <a:t>Process : </a:t>
+            </a:r>
+            <a:r>
+              <a:rPr sz="720">
+                <a:solidFill>
+                  <a:srgbClr val="334155"/>
+                </a:solidFill>
+                <a:latin typeface="Arial"/>
+              </a:rPr>
+              <a:t>Cadastral plot mapping ➔ TreeSHAP bottleneck analysis ➔ DSC e-Sign</a:t>
+            </a:r>
+          </a:p>
+          <a:p>
+            <a:pPr>
+              <a:spcAft>
+                <a:spcPts val="200"/>
+              </a:spcAft>
+            </a:pPr>
+            <a:r>
+              <a:rPr sz="750" b="1">
+                <a:solidFill>
+                  <a:srgbClr val="EA580C"/>
+                </a:solidFill>
+                <a:latin typeface="Arial"/>
+              </a:rPr>
+              <a:t>•  </a:t>
+            </a:r>
+            <a:r>
+              <a:rPr sz="750" b="1">
+                <a:solidFill>
+                  <a:srgbClr val="0F172A"/>
+                </a:solidFill>
+                <a:latin typeface="Arial"/>
+              </a:rPr>
+              <a:t>Time Saved : </a:t>
+            </a:r>
+            <a:r>
+              <a:rPr sz="720">
+                <a:solidFill>
+                  <a:srgbClr val="334155"/>
+                </a:solidFill>
+                <a:latin typeface="Arial"/>
+              </a:rPr>
+              <a:t>65% faster Section 3D &amp; 3G DFA notice preparation</a:t>
+            </a:r>
+          </a:p>
+          <a:p>
+            <a:pPr>
+              <a:spcAft>
+                <a:spcPts val="200"/>
+              </a:spcAft>
+            </a:pPr>
+            <a:r>
+              <a:rPr sz="750" b="1">
+                <a:solidFill>
+                  <a:srgbClr val="EA580C"/>
+                </a:solidFill>
+                <a:latin typeface="Arial"/>
+              </a:rPr>
+              <a:t>•  </a:t>
+            </a:r>
+            <a:r>
+              <a:rPr sz="750" b="1">
+                <a:solidFill>
+                  <a:srgbClr val="0F172A"/>
+                </a:solidFill>
+                <a:latin typeface="Arial"/>
+              </a:rPr>
+              <a:t>Impact Metric : </a:t>
+            </a:r>
+            <a:r>
+              <a:rPr sz="720">
+                <a:solidFill>
+                  <a:srgbClr val="334155"/>
+                </a:solidFill>
+                <a:latin typeface="Arial"/>
+              </a:rPr>
+              <a:t>Zero statutory lapses across 156 corridor villages</a:t>
+            </a:r>
+          </a:p>
+          <a:p>
+            <a:pPr>
+              <a:spcAft>
+                <a:spcPts val="200"/>
+              </a:spcAft>
+            </a:pPr>
+            <a:r>
+              <a:rPr sz="750" b="1">
+                <a:solidFill>
+                  <a:srgbClr val="EA580C"/>
+                </a:solidFill>
+                <a:latin typeface="Arial"/>
+              </a:rPr>
+              <a:t>•  </a:t>
+            </a:r>
+            <a:r>
+              <a:rPr sz="750" b="1">
+                <a:solidFill>
+                  <a:srgbClr val="0F172A"/>
+                </a:solidFill>
+                <a:latin typeface="Arial"/>
+              </a:rPr>
+              <a:t>Best For : </a:t>
+            </a:r>
+            <a:r>
+              <a:rPr sz="720">
+                <a:solidFill>
+                  <a:srgbClr val="334155"/>
+                </a:solidFill>
+                <a:latin typeface="Arial"/>
+              </a:rPr>
+              <a:t>Khasra verification, award inquiry &amp; statutory compliance</a:t>
+            </a:r>
+          </a:p>
+        </p:txBody>
+      </p:sp>
+      <p:sp>
+        <p:nvSpPr>
+          <p:cNvPr id="17464" name="Rounded Rectangle 17463"/>
+          <p:cNvSpPr/>
+          <p:nvPr/>
+        </p:nvSpPr>
+        <p:spPr>
+          <a:xfrm>
+            <a:off x="8119872" y="4526280"/>
+            <a:ext cx="3621024" cy="1664208"/>
+          </a:xfrm>
+          <a:prstGeom prst="roundRect">
+            <a:avLst/>
+          </a:prstGeom>
+          <a:solidFill>
+            <a:srgbClr val="FFFFFF"/>
+          </a:solidFill>
+          <a:ln w="19050">
+            <a:solidFill>
+              <a:srgbClr val="059669"/>
+            </a:solidFill>
+          </a:ln>
+        </p:spPr>
+        <p:style>
+          <a:lnRef idx="1">
+            <a:schemeClr val="accent1"/>
+          </a:lnRef>
+          <a:fillRef idx="3">
+            <a:schemeClr val="accent1"/>
+          </a:fillRef>
+          <a:effectRef idx="2">
+            <a:schemeClr val="accent1"/>
+          </a:effectRef>
+          <a:fontRef idx="minor">
+            <a:schemeClr val="lt1"/>
+          </a:fontRef>
+        </p:style>
+        <p:txBody>
+          <a:bodyPr rtlCol="0" anchor="ctr"/>
+          <a:lstStyle/>
+          <a:p>
+            <a:pPr algn="ctr"/>
+          </a:p>
+        </p:txBody>
+      </p:sp>
+      <p:sp>
+        <p:nvSpPr>
+          <p:cNvPr id="17465" name="Rounded Rectangle 17464"/>
+          <p:cNvSpPr/>
+          <p:nvPr/>
+        </p:nvSpPr>
+        <p:spPr>
+          <a:xfrm>
+            <a:off x="8193024" y="4599432"/>
+            <a:ext cx="3474720" cy="274320"/>
+          </a:xfrm>
+          <a:prstGeom prst="roundRect">
+            <a:avLst/>
+          </a:prstGeom>
+          <a:solidFill>
+            <a:srgbClr val="059669"/>
+          </a:solidFill>
+          <a:ln>
+            <a:noFill/>
+          </a:ln>
+        </p:spPr>
+        <p:style>
+          <a:lnRef idx="1">
+            <a:schemeClr val="accent1"/>
+          </a:lnRef>
+          <a:fillRef idx="3">
+            <a:schemeClr val="accent1"/>
+          </a:fillRef>
+          <a:effectRef idx="2">
+            <a:schemeClr val="accent1"/>
+          </a:effectRef>
+          <a:fontRef idx="minor">
+            <a:schemeClr val="lt1"/>
+          </a:fontRef>
+        </p:style>
+        <p:txBody>
+          <a:bodyPr rtlCol="0" anchor="ctr" lIns="292608"/>
+          <a:lstStyle/>
+          <a:p>
+            <a:pPr algn="ctr">
+              <a:defRPr sz="850" b="1">
+                <a:solidFill>
+                  <a:srgbClr val="FFFFFF"/>
+                </a:solidFill>
+                <a:latin typeface="Arial"/>
+              </a:defRPr>
+            </a:pPr>
+            <a:r>
+              <a:t>MODE 3: MoRTH &amp; NATIONAL APEX LEADERSHIP</a:t>
+            </a:r>
+          </a:p>
+        </p:txBody>
+      </p:sp>
+      <p:pic>
+        <p:nvPicPr>
+          <p:cNvPr id="17466" name="Picture 17465" descr="morth_icon.png"/>
+          <p:cNvPicPr>
+            <a:picLocks noChangeAspect="1"/>
+          </p:cNvPicPr>
+          <p:nvPr/>
+        </p:nvPicPr>
+        <p:blipFill>
+          <a:blip r:embed="rId11"/>
+          <a:stretch>
+            <a:fillRect/>
+          </a:stretch>
+        </p:blipFill>
+        <p:spPr>
+          <a:xfrm>
+            <a:off x="8229600" y="4617720"/>
+            <a:ext cx="219456" cy="219456"/>
+          </a:xfrm>
+          <a:prstGeom prst="rect">
+            <a:avLst/>
+          </a:prstGeom>
+        </p:spPr>
+      </p:pic>
+      <p:sp>
+        <p:nvSpPr>
+          <p:cNvPr id="17467" name="TextBox 17466"/>
+          <p:cNvSpPr txBox="1"/>
+          <p:nvPr/>
+        </p:nvSpPr>
+        <p:spPr>
+          <a:xfrm>
+            <a:off x="8211312" y="4892040"/>
+            <a:ext cx="3438144" cy="1252728"/>
+          </a:xfrm>
+          <a:prstGeom prst="rect">
+            <a:avLst/>
+          </a:prstGeom>
+          <a:noFill/>
+        </p:spPr>
+        <p:txBody>
+          <a:bodyPr wrap="square" anchor="t" lIns="36576" rIns="36576" tIns="18288">
+            <a:spAutoFit/>
+          </a:bodyPr>
+          <a:lstStyle/>
+          <a:p>
+            <a:pPr>
+              <a:spcAft>
+                <a:spcPts val="200"/>
+              </a:spcAft>
+            </a:pPr>
+            <a:r>
+              <a:rPr sz="750" b="1">
                 <a:solidFill>
                   <a:srgbClr val="059669"/>
                 </a:solidFill>
                 <a:latin typeface="Arial"/>
               </a:rPr>
-              <a:t>• Zero-Click Autonomous Alerts (Point 8):
-</a:t>
-            </a:r>
-            <a:r>
-              <a:rPr sz="850">
-                <a:solidFill>
-                  <a:srgbClr val="1E293B"/>
+              <a:t>•  </a:t>
+            </a:r>
+            <a:r>
+              <a:rPr sz="750" b="1">
+                <a:solidFill>
+                  <a:srgbClr val="0F172A"/>
                 </a:solidFill>
                 <a:latin typeface="Arial"/>
               </a:rPr>
-              <a:t>  Backend statutory watchdog monitors project milestones 24/7 without human intervention, automatically dispatching SMS and official email alerts to nodal officers.</a:t>
+              <a:t>For : </a:t>
+            </a:r>
+            <a:r>
+              <a:rPr sz="720">
+                <a:solidFill>
+                  <a:srgbClr val="334155"/>
+                </a:solidFill>
+                <a:latin typeface="Arial"/>
+              </a:rPr>
+              <a:t>Ministry Leadership &amp; Network Planning Group (NMP)</a:t>
+            </a:r>
+          </a:p>
+          <a:p>
+            <a:pPr>
+              <a:spcAft>
+                <a:spcPts val="200"/>
+              </a:spcAft>
+            </a:pPr>
+            <a:r>
+              <a:rPr sz="750" b="1">
+                <a:solidFill>
+                  <a:srgbClr val="059669"/>
+                </a:solidFill>
+                <a:latin typeface="Arial"/>
+              </a:rPr>
+              <a:t>•  </a:t>
+            </a:r>
+            <a:r>
+              <a:rPr sz="750" b="1">
+                <a:solidFill>
+                  <a:srgbClr val="0F172A"/>
+                </a:solidFill>
+                <a:latin typeface="Arial"/>
+              </a:rPr>
+              <a:t>Process : </a:t>
+            </a:r>
+            <a:r>
+              <a:rPr sz="720">
+                <a:solidFill>
+                  <a:srgbClr val="334155"/>
+                </a:solidFill>
+                <a:latin typeface="Arial"/>
+              </a:rPr>
+              <a:t>Macro corridor analytics ➔ Multi-modal telemetry ➔ Fund clearance</a:t>
+            </a:r>
+          </a:p>
+          <a:p>
+            <a:pPr>
+              <a:spcAft>
+                <a:spcPts val="200"/>
+              </a:spcAft>
+            </a:pPr>
+            <a:r>
+              <a:rPr sz="750" b="1">
+                <a:solidFill>
+                  <a:srgbClr val="059669"/>
+                </a:solidFill>
+                <a:latin typeface="Arial"/>
+              </a:rPr>
+              <a:t>•  </a:t>
+            </a:r>
+            <a:r>
+              <a:rPr sz="750" b="1">
+                <a:solidFill>
+                  <a:srgbClr val="0F172A"/>
+                </a:solidFill>
+                <a:latin typeface="Arial"/>
+              </a:rPr>
+              <a:t>Time Saved : </a:t>
+            </a:r>
+            <a:r>
+              <a:rPr sz="720">
+                <a:solidFill>
+                  <a:srgbClr val="334155"/>
+                </a:solidFill>
+                <a:latin typeface="Arial"/>
+              </a:rPr>
+              <a:t>Real-time national telemetry replacing monthly physical reviews</a:t>
+            </a:r>
+          </a:p>
+          <a:p>
+            <a:pPr>
+              <a:spcAft>
+                <a:spcPts val="200"/>
+              </a:spcAft>
+            </a:pPr>
+            <a:r>
+              <a:rPr sz="750" b="1">
+                <a:solidFill>
+                  <a:srgbClr val="059669"/>
+                </a:solidFill>
+                <a:latin typeface="Arial"/>
+              </a:rPr>
+              <a:t>•  </a:t>
+            </a:r>
+            <a:r>
+              <a:rPr sz="750" b="1">
+                <a:solidFill>
+                  <a:srgbClr val="0F172A"/>
+                </a:solidFill>
+                <a:latin typeface="Arial"/>
+              </a:rPr>
+              <a:t>Impact Metric : </a:t>
+            </a:r>
+            <a:r>
+              <a:rPr sz="720">
+                <a:solidFill>
+                  <a:srgbClr val="334155"/>
+                </a:solidFill>
+                <a:latin typeface="Arial"/>
+              </a:rPr>
+              <a:t>₹4,000+ Crore in stalled escrow funds unfrozen</a:t>
+            </a:r>
+          </a:p>
+          <a:p>
+            <a:pPr>
+              <a:spcAft>
+                <a:spcPts val="200"/>
+              </a:spcAft>
+            </a:pPr>
+            <a:r>
+              <a:rPr sz="750" b="1">
+                <a:solidFill>
+                  <a:srgbClr val="059669"/>
+                </a:solidFill>
+                <a:latin typeface="Arial"/>
+              </a:rPr>
+              <a:t>•  </a:t>
+            </a:r>
+            <a:r>
+              <a:rPr sz="750" b="1">
+                <a:solidFill>
+                  <a:srgbClr val="0F172A"/>
+                </a:solidFill>
+                <a:latin typeface="Arial"/>
+              </a:rPr>
+              <a:t>Best For : </a:t>
+            </a:r>
+            <a:r>
+              <a:rPr sz="720">
+                <a:solidFill>
+                  <a:srgbClr val="334155"/>
+                </a:solidFill>
+                <a:latin typeface="Arial"/>
+              </a:rPr>
+              <a:t>National infrastructure prioritization &amp; CAG/CVC audit compliance</a:t>
             </a:r>
           </a:p>
         </p:txBody>

</xml_diff>

<commit_message>
feat(sih): complete full 6-slide SIH presentation deck blending SIHex1 & SIHex2 winner styles with custom vector assets
</commit_message>
<xml_diff>
--- a/sih/GatiShakti_AI_SIH2026_Presentation.pptx
+++ b/sih/GatiShakti_AI_SIH2026_Presentation.pptx
@@ -16792,15 +16792,15 @@
           <a:lstStyle/>
           <a:p>
             <a:pPr algn="l">
-              <a:defRPr sz="2200" b="1">
-                <a:solidFill>
-                  <a:srgbClr val="1A365D"/>
-                </a:solidFill>
-                <a:latin typeface="Times New Roman"/>
+              <a:defRPr sz="2400" b="1">
+                <a:solidFill>
+                  <a:srgbClr val="003366"/>
+                </a:solidFill>
+                <a:latin typeface="Arial"/>
               </a:defRPr>
             </a:pPr>
             <a:r>
-              <a:t>RESEARCH AND REFERENCES: STATUTORY &amp; DATA CITATIONS</a:t>
+              <a:t>RESEARCH AND REFERENCES</a:t>
             </a:r>
           </a:p>
         </p:txBody>
@@ -16997,18 +16997,18 @@
         </p:nvSpPr>
         <p:spPr>
           <a:xfrm>
-            <a:off x="457200" y="1097280"/>
-            <a:ext cx="3383280" cy="4754880"/>
+            <a:off x="438912" y="1051560"/>
+            <a:ext cx="11301984" cy="1371600"/>
           </a:xfrm>
           <a:prstGeom prst="roundRect">
             <a:avLst/>
           </a:prstGeom>
           <a:solidFill>
-            <a:srgbClr val="F8FAFC"/>
+            <a:srgbClr val="FFFFFF"/>
           </a:solidFill>
-          <a:ln w="19050">
+          <a:ln w="15240">
             <a:solidFill>
-              <a:srgbClr val="2563EB"/>
+              <a:srgbClr val="CBD5E1"/>
             </a:solidFill>
           </a:ln>
         </p:spPr>
@@ -17027,124 +17027,191 @@
           </a:fontRef>
         </p:style>
         <p:txBody>
-          <a:bodyPr rtlCol="0" anchor="ctr" wrap="square"/>
-          <a:lstStyle/>
-          <a:p>
-            <a:pPr algn="ctr">
+          <a:bodyPr rtlCol="0" anchor="ctr"/>
+          <a:lstStyle/>
+          <a:p>
+            <a:pPr algn="ctr"/>
+          </a:p>
+        </p:txBody>
+      </p:sp>
+      <p:pic>
+        <p:nvPicPr>
+          <p:cNvPr id="17411" name="Picture 17410" descr="statutory_book_icon.png"/>
+          <p:cNvPicPr>
+            <a:picLocks noChangeAspect="1"/>
+          </p:cNvPicPr>
+          <p:nvPr/>
+        </p:nvPicPr>
+        <p:blipFill>
+          <a:blip r:embed="rId4"/>
+          <a:stretch>
+            <a:fillRect/>
+          </a:stretch>
+        </p:blipFill>
+        <p:spPr>
+          <a:xfrm>
+            <a:off x="585216" y="1161288"/>
+            <a:ext cx="384048" cy="384048"/>
+          </a:xfrm>
+          <a:prstGeom prst="rect">
+            <a:avLst/>
+          </a:prstGeom>
+        </p:spPr>
+      </p:pic>
+      <p:sp>
+        <p:nvSpPr>
+          <p:cNvPr id="17412" name="TextBox 17411"/>
+          <p:cNvSpPr txBox="1"/>
+          <p:nvPr/>
+        </p:nvSpPr>
+        <p:spPr>
+          <a:xfrm>
+            <a:off x="1060704" y="1106424"/>
+            <a:ext cx="10570464" cy="1261872"/>
+          </a:xfrm>
+          <a:prstGeom prst="rect">
+            <a:avLst/>
+          </a:prstGeom>
+          <a:noFill/>
+        </p:spPr>
+        <p:txBody>
+          <a:bodyPr wrap="square" anchor="t" lIns="18288" rIns="36576" tIns="18288">
+            <a:spAutoFit/>
+          </a:bodyPr>
+          <a:lstStyle/>
+          <a:p>
+            <a:pPr>
+              <a:spcBef>
+                <a:spcPts val="150"/>
+              </a:spcBef>
               <a:spcAft>
-                <a:spcPts val="1000"/>
+                <a:spcPts val="250"/>
               </a:spcAft>
             </a:pPr>
             <a:r>
-              <a:rPr sz="1200" b="1">
-                <a:solidFill>
-                  <a:srgbClr val="2563EB"/>
+              <a:rPr sz="850" b="1">
+                <a:solidFill>
+                  <a:srgbClr val="0070C0"/>
                 </a:solidFill>
                 <a:latin typeface="Arial"/>
               </a:rPr>
-              <a:t>1. Statutory &amp; Legal Authorities</a:t>
+              <a:t>•  </a:t>
+            </a:r>
+            <a:r>
+              <a:rPr sz="850" b="1">
+                <a:solidFill>
+                  <a:srgbClr val="0F172A"/>
+                </a:solidFill>
+                <a:latin typeface="Arial"/>
+              </a:rPr>
+              <a:t>The National Highways Act, 1956 &amp; RFCTLARR Act, 2013 : </a:t>
+            </a:r>
+            <a:r>
+              <a:rPr sz="800">
+                <a:solidFill>
+                  <a:srgbClr val="334155"/>
+                </a:solidFill>
+                <a:latin typeface="Arial"/>
+              </a:rPr>
+              <a:t>Foundational Indian statutory frameworks governing land acquisition (§ 3A to 3H) and mandatory 365-day Section 3D lapse timelines. Full Details : NH Act 1956 / RFCTLARR 2013 / PM GatiShakti Framework</a:t>
             </a:r>
           </a:p>
           <a:p>
             <a:pPr>
+              <a:spcBef>
+                <a:spcPts val="150"/>
+              </a:spcBef>
               <a:spcAft>
-                <a:spcPts val="800"/>
+                <a:spcPts val="250"/>
               </a:spcAft>
             </a:pPr>
             <a:r>
-              <a:rPr sz="950" b="1">
-                <a:solidFill>
-                  <a:srgbClr val="1E293B"/>
+              <a:rPr sz="850" b="1">
+                <a:solidFill>
+                  <a:srgbClr val="0070C0"/>
                 </a:solidFill>
                 <a:latin typeface="Arial"/>
               </a:rPr>
-              <a:t>• The National Highways Act, 1956:
-</a:t>
-            </a:r>
-            <a:r>
-              <a:rPr sz="850">
-                <a:solidFill>
-                  <a:srgbClr val="475569"/>
+              <a:t>•  </a:t>
+            </a:r>
+            <a:r>
+              <a:rPr sz="850" b="1">
+                <a:solidFill>
+                  <a:srgbClr val="0F172A"/>
                 </a:solidFill>
                 <a:latin typeface="Arial"/>
               </a:rPr>
-              <a:t>  Act No. 48 of 1956: Sections 3A (Preliminary Notification), 3B (Survey Demarcation), 3C (Objections), 3D (Declaration &amp; Absolute Vesting), 3G (Award Determination), 3H (Deposit &amp; Disbursement).</a:t>
+              <a:t>Explainable AI (XAI) &amp; TreeSHAP : </a:t>
+            </a:r>
+            <a:r>
+              <a:rPr sz="800">
+                <a:solidFill>
+                  <a:srgbClr val="334155"/>
+                </a:solidFill>
+                <a:latin typeface="Arial"/>
+              </a:rPr>
+              <a:t>Lundberg &amp; Lee (NeurIPS 2017) foundational game-theoretic feature attribution; Chen &amp; Guestrin (KDD 2016) XGBoost gradient boosted trees. Links : NeurIPS 2017 / XGBoost KDD 2016</a:t>
             </a:r>
           </a:p>
           <a:p>
             <a:pPr>
+              <a:spcBef>
+                <a:spcPts val="150"/>
+              </a:spcBef>
               <a:spcAft>
-                <a:spcPts val="800"/>
+                <a:spcPts val="250"/>
               </a:spcAft>
             </a:pPr>
             <a:r>
-              <a:rPr sz="950" b="1">
-                <a:solidFill>
-                  <a:srgbClr val="1E293B"/>
+              <a:rPr sz="850" b="1">
+                <a:solidFill>
+                  <a:srgbClr val="0070C0"/>
                 </a:solidFill>
                 <a:latin typeface="Arial"/>
               </a:rPr>
-              <a:t>• The RFCTLARR Act, 2013:
-</a:t>
-            </a:r>
-            <a:r>
-              <a:rPr sz="850">
-                <a:solidFill>
-                  <a:srgbClr val="475569"/>
+              <a:t>•  </a:t>
+            </a:r>
+            <a:r>
+              <a:rPr sz="850" b="1">
+                <a:solidFill>
+                  <a:srgbClr val="0F172A"/>
                 </a:solidFill>
                 <a:latin typeface="Arial"/>
               </a:rPr>
-              <a:t>  Right to Fair Compensation &amp; Transparency in Land Acquisition, Rehabilitation and Resettlement Act: First Schedule multipliers, Second Schedule R&amp;R, Section 34 penal interest mandates.</a:t>
-            </a:r>
-          </a:p>
-          <a:p>
-            <a:pPr>
-              <a:spcAft>
-                <a:spcPts val="800"/>
-              </a:spcAft>
-            </a:pPr>
-            <a:r>
-              <a:rPr sz="950" b="1">
-                <a:solidFill>
-                  <a:srgbClr val="1E293B"/>
+              <a:t>Constitutional Governance &amp; Audit Rigor : </a:t>
+            </a:r>
+            <a:r>
+              <a:rPr sz="800">
+                <a:solidFill>
+                  <a:srgbClr val="334155"/>
                 </a:solidFill>
                 <a:latin typeface="Arial"/>
               </a:rPr>
-              <a:t>• PM GatiShakti National Master Plan:
-</a:t>
-            </a:r>
-            <a:r>
-              <a:rPr sz="850">
-                <a:solidFill>
-                  <a:srgbClr val="475569"/>
-                </a:solidFill>
-                <a:latin typeface="Arial"/>
-              </a:rPr>
-              <a:t>  Cabinet Secretariat &amp; DPIIT (2021) guidelines for synchronized institutional planning, multi-modal infrastructure data layer, and inter-ministerial clearance coordination.</a:t>
-            </a:r>
-          </a:p>
-        </p:txBody>
-      </p:sp>
-      <p:sp>
-        <p:nvSpPr>
-          <p:cNvPr id="17411" name="Rounded Rectangle 17410"/>
+              <a:t>Adherence to Articles 77 &amp; 166 of the Constitution of India; CVC &amp; CAG compliance guidelines for digital infrastructure procurement. Links : MoRTH Directives / CAG Guidelines</a:t>
+            </a:r>
+          </a:p>
+        </p:txBody>
+      </p:sp>
+      <p:sp>
+        <p:nvSpPr>
+          <p:cNvPr id="17413" name="Rounded Rectangle 17412"/>
           <p:cNvSpPr/>
           <p:nvPr/>
         </p:nvSpPr>
         <p:spPr>
           <a:xfrm>
-            <a:off x="4023360" y="1097280"/>
-            <a:ext cx="3383280" cy="4754880"/>
+            <a:off x="438912" y="2542032"/>
+            <a:ext cx="5166360" cy="1463040"/>
           </a:xfrm>
           <a:prstGeom prst="roundRect">
             <a:avLst/>
           </a:prstGeom>
           <a:solidFill>
-            <a:srgbClr val="F8FAFC"/>
+            <a:srgbClr val="F0F7FF"/>
           </a:solidFill>
-          <a:ln w="19050">
+          <a:ln w="15240">
             <a:solidFill>
-              <a:srgbClr val="059669"/>
+              <a:srgbClr val="BBDEFB"/>
             </a:solidFill>
           </a:ln>
         </p:spPr>
@@ -17163,151 +17230,128 @@
           </a:fontRef>
         </p:style>
         <p:txBody>
-          <a:bodyPr rtlCol="0" anchor="ctr" wrap="square"/>
+          <a:bodyPr rtlCol="0" anchor="ctr"/>
+          <a:lstStyle/>
+          <a:p>
+            <a:pPr algn="ctr"/>
+          </a:p>
+        </p:txBody>
+      </p:sp>
+      <p:sp>
+        <p:nvSpPr>
+          <p:cNvPr id="17414" name="TextBox 17413"/>
+          <p:cNvSpPr txBox="1"/>
+          <p:nvPr/>
+        </p:nvSpPr>
+        <p:spPr>
+          <a:xfrm>
+            <a:off x="438912" y="2615184"/>
+            <a:ext cx="5166360" cy="256032"/>
+          </a:xfrm>
+          <a:prstGeom prst="rect">
+            <a:avLst/>
+          </a:prstGeom>
+          <a:noFill/>
+        </p:spPr>
+        <p:txBody>
+          <a:bodyPr wrap="none">
+            <a:spAutoFit/>
+          </a:bodyPr>
           <a:lstStyle/>
           <a:p>
             <a:pPr algn="ctr">
-              <a:spcAft>
-                <a:spcPts val="1000"/>
-              </a:spcAft>
-            </a:pPr>
-            <a:r>
-              <a:rPr sz="1200" b="1">
-                <a:solidFill>
-                  <a:srgbClr val="059669"/>
-                </a:solidFill>
-                <a:latin typeface="Arial"/>
-              </a:rPr>
-              <a:t>2. Technical &amp; AI Research</a:t>
-            </a:r>
-          </a:p>
+              <a:defRPr sz="1100" b="1">
+                <a:solidFill>
+                  <a:srgbClr val="0070C0"/>
+                </a:solidFill>
+                <a:latin typeface="Arial"/>
+              </a:defRPr>
+            </a:pPr>
+            <a:r>
+              <a:t>SOLUTIONS ALREADY EXIST</a:t>
+            </a:r>
+          </a:p>
+        </p:txBody>
+      </p:sp>
+      <p:sp>
+        <p:nvSpPr>
+          <p:cNvPr id="17415" name="TextBox 17414"/>
+          <p:cNvSpPr txBox="1"/>
+          <p:nvPr/>
+        </p:nvSpPr>
+        <p:spPr>
+          <a:xfrm>
+            <a:off x="585216" y="2889504"/>
+            <a:ext cx="4873752" cy="1060704"/>
+          </a:xfrm>
+          <a:prstGeom prst="rect">
+            <a:avLst/>
+          </a:prstGeom>
+          <a:noFill/>
+        </p:spPr>
+        <p:txBody>
+          <a:bodyPr wrap="square" anchor="t" lIns="36576" rIns="36576">
+            <a:spAutoFit/>
+          </a:bodyPr>
+          <a:lstStyle/>
           <a:p>
             <a:pPr>
               <a:spcAft>
-                <a:spcPts val="800"/>
+                <a:spcPts val="400"/>
               </a:spcAft>
             </a:pPr>
             <a:r>
-              <a:rPr sz="950" b="1">
-                <a:solidFill>
-                  <a:srgbClr val="1E293B"/>
+              <a:rPr sz="850">
+                <a:solidFill>
+                  <a:srgbClr val="334155"/>
                 </a:solidFill>
                 <a:latin typeface="Arial"/>
               </a:rPr>
-              <a:t>• Lundberg &amp; Lee (NeurIPS 2017):
+              <a:t>•  Most are fragmented, physical paper-based registers, isolated cadastral maps, or slow manual OCR tools built with zero statutory delay prediction.
 </a:t>
             </a:r>
+          </a:p>
+          <a:p>
+            <a:r>
+              <a:rPr sz="850" b="1">
+                <a:solidFill>
+                  <a:srgbClr val="0F172A"/>
+                </a:solidFill>
+                <a:latin typeface="Arial"/>
+              </a:rPr>
+              <a:t>•  EXISTING SYSTEMS :  </a:t>
+            </a:r>
             <a:r>
               <a:rPr sz="850">
                 <a:solidFill>
-                  <a:srgbClr val="475569"/>
+                  <a:srgbClr val="0070C0"/>
                 </a:solidFill>
                 <a:latin typeface="Arial"/>
               </a:rPr>
-              <a:t>  A Unified Approach to Interpreting Model Predictions: TreeSHAP algorithm providing local, game-theoretically optimal marginal feature attributions for ensemble models.</a:t>
-            </a:r>
-          </a:p>
-          <a:p>
-            <a:pPr>
-              <a:spcAft>
-                <a:spcPts val="800"/>
-              </a:spcAft>
-            </a:pPr>
-            <a:r>
-              <a:rPr sz="950" b="1">
-                <a:solidFill>
-                  <a:srgbClr val="1E293B"/>
-                </a:solidFill>
-                <a:latin typeface="Arial"/>
-              </a:rPr>
-              <a:t>• Chen &amp; Guestrin (KDD 2016):
-</a:t>
-            </a:r>
-            <a:r>
-              <a:rPr sz="850">
-                <a:solidFill>
-                  <a:srgbClr val="475569"/>
-                </a:solidFill>
-                <a:latin typeface="Arial"/>
-              </a:rPr>
-              <a:t>  XGBoost: A Scalable Tree Boosting System: High-efficiency gradient boosted decision tree implementation for structured tabular revenue data.</a:t>
-            </a:r>
-          </a:p>
-          <a:p>
-            <a:pPr>
-              <a:spcAft>
-                <a:spcPts val="800"/>
-              </a:spcAft>
-            </a:pPr>
-            <a:r>
-              <a:rPr sz="950" b="1">
-                <a:solidFill>
-                  <a:srgbClr val="1E293B"/>
-                </a:solidFill>
-                <a:latin typeface="Arial"/>
-              </a:rPr>
-              <a:t>• Kaplan &amp; Meier (JASA 1958):
-</a:t>
-            </a:r>
-            <a:r>
-              <a:rPr sz="850">
-                <a:solidFill>
-                  <a:srgbClr val="475569"/>
-                </a:solidFill>
-                <a:latin typeface="Arial"/>
-              </a:rPr>
-              <a:t>  Nonparametric estimation from incomplete observations: Survival analysis for statutory liquidation horizons and legal dispute resolution hazard curves.</a:t>
-            </a:r>
-          </a:p>
-          <a:p>
-            <a:pPr>
-              <a:spcAft>
-                <a:spcPts val="800"/>
-              </a:spcAft>
-            </a:pPr>
-            <a:r>
-              <a:rPr sz="950" b="1">
-                <a:solidFill>
-                  <a:srgbClr val="1E293B"/>
-                </a:solidFill>
-                <a:latin typeface="Arial"/>
-              </a:rPr>
-              <a:t>• NHAI / MoRTH Official Data:
-</a:t>
-            </a:r>
-            <a:r>
-              <a:rPr sz="850">
-                <a:solidFill>
-                  <a:srgbClr val="475569"/>
-                </a:solidFill>
-                <a:latin typeface="Arial"/>
-              </a:rPr>
-              <a:t>  Infrastructure Project Monitoring Division (IPMD) delay benchmarks and CAG Performance Audit Reports on National Highway Land Acquisition.</a:t>
-            </a:r>
-          </a:p>
-        </p:txBody>
-      </p:sp>
-      <p:sp>
-        <p:nvSpPr>
-          <p:cNvPr id="17412" name="Rounded Rectangle 17411"/>
+              <a:t>BhoomiRashi  /  e-Courts WSDL  /  State Bhulekh  /  Tarang</a:t>
+            </a:r>
+          </a:p>
+        </p:txBody>
+      </p:sp>
+      <p:sp>
+        <p:nvSpPr>
+          <p:cNvPr id="17416" name="Right Arrow 17415"/>
           <p:cNvSpPr/>
           <p:nvPr/>
         </p:nvSpPr>
         <p:spPr>
           <a:xfrm>
-            <a:off x="7589520" y="1097280"/>
-            <a:ext cx="3383280" cy="4754880"/>
-          </a:xfrm>
-          <a:prstGeom prst="roundRect">
+            <a:off x="5715000" y="3090672"/>
+            <a:ext cx="384048" cy="292608"/>
+          </a:xfrm>
+          <a:prstGeom prst="rightArrow">
             <a:avLst/>
           </a:prstGeom>
           <a:solidFill>
-            <a:srgbClr val="F8FAFC"/>
+            <a:srgbClr val="0F172A"/>
           </a:solidFill>
-          <a:ln w="19050">
-            <a:solidFill>
-              <a:srgbClr val="1A365D"/>
-            </a:solidFill>
+          <a:ln>
+            <a:noFill/>
           </a:ln>
         </p:spPr>
         <p:style>
@@ -17325,110 +17369,517 @@
           </a:fontRef>
         </p:style>
         <p:txBody>
-          <a:bodyPr rtlCol="0" anchor="ctr" wrap="square"/>
+          <a:bodyPr rtlCol="0" anchor="ctr"/>
+          <a:lstStyle/>
+          <a:p>
+            <a:pPr algn="ctr"/>
+          </a:p>
+        </p:txBody>
+      </p:sp>
+      <p:sp>
+        <p:nvSpPr>
+          <p:cNvPr id="17417" name="Rounded Rectangle 17416"/>
+          <p:cNvSpPr/>
+          <p:nvPr/>
+        </p:nvSpPr>
+        <p:spPr>
+          <a:xfrm>
+            <a:off x="6208776" y="2542032"/>
+            <a:ext cx="5532120" cy="1463040"/>
+          </a:xfrm>
+          <a:prstGeom prst="roundRect">
+            <a:avLst/>
+          </a:prstGeom>
+          <a:solidFill>
+            <a:srgbClr val="F0F7FF"/>
+          </a:solidFill>
+          <a:ln w="15240">
+            <a:solidFill>
+              <a:srgbClr val="BBDEFB"/>
+            </a:solidFill>
+          </a:ln>
+        </p:spPr>
+        <p:style>
+          <a:lnRef idx="1">
+            <a:schemeClr val="accent1"/>
+          </a:lnRef>
+          <a:fillRef idx="3">
+            <a:schemeClr val="accent1"/>
+          </a:fillRef>
+          <a:effectRef idx="2">
+            <a:schemeClr val="accent1"/>
+          </a:effectRef>
+          <a:fontRef idx="minor">
+            <a:schemeClr val="lt1"/>
+          </a:fontRef>
+        </p:style>
+        <p:txBody>
+          <a:bodyPr rtlCol="0" anchor="ctr"/>
+          <a:lstStyle/>
+          <a:p>
+            <a:pPr algn="ctr"/>
+          </a:p>
+        </p:txBody>
+      </p:sp>
+      <p:sp>
+        <p:nvSpPr>
+          <p:cNvPr id="17418" name="TextBox 17417"/>
+          <p:cNvSpPr txBox="1"/>
+          <p:nvPr/>
+        </p:nvSpPr>
+        <p:spPr>
+          <a:xfrm>
+            <a:off x="6208776" y="2615184"/>
+            <a:ext cx="5532120" cy="256032"/>
+          </a:xfrm>
+          <a:prstGeom prst="rect">
+            <a:avLst/>
+          </a:prstGeom>
+          <a:noFill/>
+        </p:spPr>
+        <p:txBody>
+          <a:bodyPr wrap="none">
+            <a:spAutoFit/>
+          </a:bodyPr>
           <a:lstStyle/>
           <a:p>
             <a:pPr algn="ctr">
-              <a:spcAft>
-                <a:spcPts val="1000"/>
-              </a:spcAft>
-            </a:pPr>
-            <a:r>
-              <a:rPr sz="1200" b="1">
-                <a:solidFill>
-                  <a:srgbClr val="1A365D"/>
-                </a:solidFill>
-                <a:latin typeface="Arial"/>
-              </a:rPr>
-              <a:t>3. Prototype &amp; Deployment Links</a:t>
-            </a:r>
-          </a:p>
+              <a:defRPr sz="1100" b="1">
+                <a:solidFill>
+                  <a:srgbClr val="0070C0"/>
+                </a:solidFill>
+                <a:latin typeface="Arial"/>
+              </a:defRPr>
+            </a:pPr>
+            <a:r>
+              <a:t>OUR SOLUTION STANDS OUT</a:t>
+            </a:r>
+          </a:p>
+        </p:txBody>
+      </p:sp>
+      <p:sp>
+        <p:nvSpPr>
+          <p:cNvPr id="17419" name="TextBox 17418"/>
+          <p:cNvSpPr txBox="1"/>
+          <p:nvPr/>
+        </p:nvSpPr>
+        <p:spPr>
+          <a:xfrm>
+            <a:off x="6336792" y="2889504"/>
+            <a:ext cx="5276088" cy="1060704"/>
+          </a:xfrm>
+          <a:prstGeom prst="rect">
+            <a:avLst/>
+          </a:prstGeom>
+          <a:noFill/>
+        </p:spPr>
+        <p:txBody>
+          <a:bodyPr wrap="square" anchor="t" lIns="36576" rIns="36576">
+            <a:spAutoFit/>
+          </a:bodyPr>
+          <a:lstStyle/>
           <a:p>
             <a:pPr>
               <a:spcAft>
-                <a:spcPts val="800"/>
+                <a:spcPts val="200"/>
               </a:spcAft>
             </a:pPr>
             <a:r>
-              <a:rPr sz="950" b="1">
-                <a:solidFill>
-                  <a:srgbClr val="1E293B"/>
+              <a:rPr sz="800" b="1">
+                <a:solidFill>
+                  <a:srgbClr val="0070C0"/>
                 </a:solidFill>
                 <a:latin typeface="Arial"/>
               </a:rPr>
-              <a:t>• GitHub Source Code Repository:
-</a:t>
-            </a:r>
-            <a:r>
-              <a:rPr sz="850">
-                <a:solidFill>
-                  <a:srgbClr val="475569"/>
+              <a:t>•  </a:t>
+            </a:r>
+            <a:r>
+              <a:rPr sz="800" b="1">
+                <a:solidFill>
+                  <a:srgbClr val="0F172A"/>
                 </a:solidFill>
                 <a:latin typeface="Arial"/>
               </a:rPr>
-              <a:t>  Complete open repository with decoupled ML inference, ETL pipeline, and React frontend:
-https://github.com/AryanSahu321/Land_Aquisition_Delay_pridictor.git</a:t>
+              <a:t>Decoupled Central DB : </a:t>
+            </a:r>
+            <a:r>
+              <a:rPr sz="800">
+                <a:solidFill>
+                  <a:srgbClr val="334155"/>
+                </a:solidFill>
+                <a:latin typeface="Arial"/>
+              </a:rPr>
+              <a:t>&lt;15ms normalized query cache across 47 standardized attributes.</a:t>
             </a:r>
           </a:p>
           <a:p>
             <a:pPr>
               <a:spcAft>
-                <a:spcPts val="800"/>
+                <a:spcPts val="200"/>
               </a:spcAft>
             </a:pPr>
             <a:r>
-              <a:rPr sz="950" b="1">
-                <a:solidFill>
-                  <a:srgbClr val="1E293B"/>
+              <a:rPr sz="800" b="1">
+                <a:solidFill>
+                  <a:srgbClr val="0070C0"/>
                 </a:solidFill>
                 <a:latin typeface="Arial"/>
               </a:rPr>
-              <a:t>• RESTful API Gateway (Point 11):
-</a:t>
-            </a:r>
-            <a:r>
-              <a:rPr sz="850">
-                <a:solidFill>
-                  <a:srgbClr val="475569"/>
+              <a:t>•  </a:t>
+            </a:r>
+            <a:r>
+              <a:rPr sz="800" b="1">
+                <a:solidFill>
+                  <a:srgbClr val="0F172A"/>
                 </a:solidFill>
                 <a:latin typeface="Arial"/>
               </a:rPr>
-              <a:t>  Publicly accessible endpoints for government &amp; developer integrations:
-• /api/v1/projects/parse-and-predict
-• /api/v1/projects/search-options
-• /api/v1/corridor/geojson</a:t>
+              <a:t>Dual-Track Reality Engine : </a:t>
+            </a:r>
+            <a:r>
+              <a:rPr sz="800">
+                <a:solidFill>
+                  <a:srgbClr val="334155"/>
+                </a:solidFill>
+                <a:latin typeface="Arial"/>
+              </a:rPr>
+              <a:t>Separates active physical road works from court escrow disputes.</a:t>
             </a:r>
           </a:p>
           <a:p>
             <a:pPr>
               <a:spcAft>
-                <a:spcPts val="800"/>
+                <a:spcPts val="200"/>
               </a:spcAft>
             </a:pPr>
             <a:r>
-              <a:rPr sz="950" b="1">
-                <a:solidFill>
-                  <a:srgbClr val="1E293B"/>
+              <a:rPr sz="800" b="1">
+                <a:solidFill>
+                  <a:srgbClr val="0070C0"/>
                 </a:solidFill>
                 <a:latin typeface="Arial"/>
               </a:rPr>
-              <a:t>• Interactive Live Modules:
-</a:t>
-            </a:r>
-            <a:r>
-              <a:rPr sz="850">
-                <a:solidFill>
-                  <a:srgbClr val="475569"/>
+              <a:t>•  </a:t>
+            </a:r>
+            <a:r>
+              <a:rPr sz="800" b="1">
+                <a:solidFill>
+                  <a:srgbClr val="0F172A"/>
                 </a:solidFill>
                 <a:latin typeface="Arial"/>
               </a:rPr>
-              <a:t>  • All-in-One Dashboard (7 Stacked Cards)
-• Purvanchal 340.8 km GIS Corridor (Point 7)
-• 4-Tier Statutory Role RBAC &amp; e-Sign (Points 8, 9, 12)</a:t>
-            </a:r>
-          </a:p>
-        </p:txBody>
-      </p:sp>
+              <a:t>TreeSHAP Statutory XAI : </a:t>
+            </a:r>
+            <a:r>
+              <a:rPr sz="800">
+                <a:solidFill>
+                  <a:srgbClr val="334155"/>
+                </a:solidFill>
+                <a:latin typeface="Arial"/>
+              </a:rPr>
+              <a:t>Quantifies exact additive day delays &amp; auto-generates legal DFA SOP notices.</a:t>
+            </a:r>
+          </a:p>
+          <a:p>
+            <a:pPr>
+              <a:spcAft>
+                <a:spcPts val="200"/>
+              </a:spcAft>
+            </a:pPr>
+            <a:r>
+              <a:rPr sz="800" b="1">
+                <a:solidFill>
+                  <a:srgbClr val="0070C0"/>
+                </a:solidFill>
+                <a:latin typeface="Arial"/>
+              </a:rPr>
+              <a:t>•  </a:t>
+            </a:r>
+            <a:r>
+              <a:rPr sz="800" b="1">
+                <a:solidFill>
+                  <a:srgbClr val="0F172A"/>
+                </a:solidFill>
+                <a:latin typeface="Arial"/>
+              </a:rPr>
+              <a:t>Constitutional HITL &amp; Audit : </a:t>
+            </a:r>
+            <a:r>
+              <a:rPr sz="800">
+                <a:solidFill>
+                  <a:srgbClr val="334155"/>
+                </a:solidFill>
+                <a:latin typeface="Arial"/>
+              </a:rPr>
+              <a:t>Aadhaar DSC e-Sign validation + SHA-256 tamper-proof ledger for CAG.</a:t>
+            </a:r>
+          </a:p>
+        </p:txBody>
+      </p:sp>
+      <p:sp>
+        <p:nvSpPr>
+          <p:cNvPr id="17420" name="Rounded Rectangle 17419"/>
+          <p:cNvSpPr/>
+          <p:nvPr/>
+        </p:nvSpPr>
+        <p:spPr>
+          <a:xfrm>
+            <a:off x="438912" y="4114800"/>
+            <a:ext cx="11301984" cy="2057400"/>
+          </a:xfrm>
+          <a:prstGeom prst="roundRect">
+            <a:avLst/>
+          </a:prstGeom>
+          <a:solidFill>
+            <a:srgbClr val="FFFFFF"/>
+          </a:solidFill>
+          <a:ln w="15240">
+            <a:solidFill>
+              <a:srgbClr val="CBD5E1"/>
+            </a:solidFill>
+          </a:ln>
+        </p:spPr>
+        <p:style>
+          <a:lnRef idx="1">
+            <a:schemeClr val="accent1"/>
+          </a:lnRef>
+          <a:fillRef idx="3">
+            <a:schemeClr val="accent1"/>
+          </a:fillRef>
+          <a:effectRef idx="2">
+            <a:schemeClr val="accent1"/>
+          </a:effectRef>
+          <a:fontRef idx="minor">
+            <a:schemeClr val="lt1"/>
+          </a:fontRef>
+        </p:style>
+        <p:txBody>
+          <a:bodyPr rtlCol="0" anchor="ctr"/>
+          <a:lstStyle/>
+          <a:p>
+            <a:pPr algn="ctr"/>
+          </a:p>
+        </p:txBody>
+      </p:sp>
+      <p:sp>
+        <p:nvSpPr>
+          <p:cNvPr id="17421" name="TextBox 17420"/>
+          <p:cNvSpPr txBox="1"/>
+          <p:nvPr/>
+        </p:nvSpPr>
+        <p:spPr>
+          <a:xfrm>
+            <a:off x="585216" y="4187952"/>
+            <a:ext cx="3840480" cy="292608"/>
+          </a:xfrm>
+          <a:prstGeom prst="rect">
+            <a:avLst/>
+          </a:prstGeom>
+          <a:noFill/>
+        </p:spPr>
+        <p:txBody>
+          <a:bodyPr wrap="none">
+            <a:spAutoFit/>
+          </a:bodyPr>
+          <a:lstStyle/>
+          <a:p>
+            <a:pPr>
+              <a:defRPr sz="1200" b="1">
+                <a:solidFill>
+                  <a:srgbClr val="0070C0"/>
+                </a:solidFill>
+                <a:latin typeface="Arial"/>
+              </a:defRPr>
+            </a:pPr>
+            <a:r>
+              <a:t>PROJECT RESOURCES</a:t>
+            </a:r>
+          </a:p>
+        </p:txBody>
+      </p:sp>
+      <p:sp>
+        <p:nvSpPr>
+          <p:cNvPr id="17422" name="TextBox 17421"/>
+          <p:cNvSpPr txBox="1"/>
+          <p:nvPr/>
+        </p:nvSpPr>
+        <p:spPr>
+          <a:xfrm>
+            <a:off x="585216" y="4498848"/>
+            <a:ext cx="3931920" cy="1600200"/>
+          </a:xfrm>
+          <a:prstGeom prst="rect">
+            <a:avLst/>
+          </a:prstGeom>
+          <a:noFill/>
+        </p:spPr>
+        <p:txBody>
+          <a:bodyPr wrap="square" anchor="t" lIns="18288" rIns="36576" tIns="18288">
+            <a:spAutoFit/>
+          </a:bodyPr>
+          <a:lstStyle/>
+          <a:p>
+            <a:pPr>
+              <a:spcBef>
+                <a:spcPts val="100"/>
+              </a:spcBef>
+              <a:spcAft>
+                <a:spcPts val="400"/>
+              </a:spcAft>
+            </a:pPr>
+            <a:r>
+              <a:rPr sz="850" b="1">
+                <a:solidFill>
+                  <a:srgbClr val="0F172A"/>
+                </a:solidFill>
+                <a:latin typeface="Arial"/>
+              </a:rPr>
+              <a:t>GitHub Repository : </a:t>
+            </a:r>
+            <a:r>
+              <a:rPr sz="800">
+                <a:solidFill>
+                  <a:srgbClr val="0070C0"/>
+                </a:solidFill>
+                <a:latin typeface="Arial"/>
+              </a:rPr>
+              <a:t>github.com/AryanSahu321/Land_Aquisition_Delay_pridictor</a:t>
+            </a:r>
+          </a:p>
+          <a:p>
+            <a:pPr>
+              <a:spcBef>
+                <a:spcPts val="100"/>
+              </a:spcBef>
+              <a:spcAft>
+                <a:spcPts val="400"/>
+              </a:spcAft>
+            </a:pPr>
+            <a:r>
+              <a:rPr sz="850" b="1">
+                <a:solidFill>
+                  <a:srgbClr val="0F172A"/>
+                </a:solidFill>
+                <a:latin typeface="Arial"/>
+              </a:rPr>
+              <a:t>REST API Gateway : </a:t>
+            </a:r>
+            <a:r>
+              <a:rPr sz="800">
+                <a:solidFill>
+                  <a:srgbClr val="0070C0"/>
+                </a:solidFill>
+                <a:latin typeface="Arial"/>
+              </a:rPr>
+              <a:t>Live OpenAPI 3.0 swagger endpoints for government integration</a:t>
+            </a:r>
+          </a:p>
+          <a:p>
+            <a:pPr>
+              <a:spcBef>
+                <a:spcPts val="100"/>
+              </a:spcBef>
+              <a:spcAft>
+                <a:spcPts val="400"/>
+              </a:spcAft>
+            </a:pPr>
+            <a:r>
+              <a:rPr sz="850" b="1">
+                <a:solidFill>
+                  <a:srgbClr val="0F172A"/>
+                </a:solidFill>
+                <a:latin typeface="Arial"/>
+              </a:rPr>
+              <a:t>Interactive RoW GIS : </a:t>
+            </a:r>
+            <a:r>
+              <a:rPr sz="800">
+                <a:solidFill>
+                  <a:srgbClr val="0070C0"/>
+                </a:solidFill>
+                <a:latin typeface="Arial"/>
+              </a:rPr>
+              <a:t>Full Purvanchal 340.8 km corridor with Khasra cadastral plots</a:t>
+            </a:r>
+          </a:p>
+          <a:p>
+            <a:pPr>
+              <a:spcBef>
+                <a:spcPts val="100"/>
+              </a:spcBef>
+              <a:spcAft>
+                <a:spcPts val="400"/>
+              </a:spcAft>
+            </a:pPr>
+            <a:r>
+              <a:rPr sz="850" b="1">
+                <a:solidFill>
+                  <a:srgbClr val="0F172A"/>
+                </a:solidFill>
+                <a:latin typeface="Arial"/>
+              </a:rPr>
+              <a:t>Audit Verification : </a:t>
+            </a:r>
+            <a:r>
+              <a:rPr sz="800">
+                <a:solidFill>
+                  <a:srgbClr val="0070C0"/>
+                </a:solidFill>
+                <a:latin typeface="Arial"/>
+              </a:rPr>
+              <a:t>SHA-256 cryptographic block integrity ledger for CAG review</a:t>
+            </a:r>
+          </a:p>
+        </p:txBody>
+      </p:sp>
+      <p:pic>
+        <p:nvPicPr>
+          <p:cNvPr id="17423" name="Picture 17422" descr="ui_gis_corridor.png"/>
+          <p:cNvPicPr>
+            <a:picLocks noChangeAspect="1"/>
+          </p:cNvPicPr>
+          <p:nvPr/>
+        </p:nvPicPr>
+        <p:blipFill>
+          <a:blip r:embed="rId5"/>
+          <a:stretch>
+            <a:fillRect/>
+          </a:stretch>
+        </p:blipFill>
+        <p:spPr>
+          <a:xfrm>
+            <a:off x="4599432" y="4206240"/>
+            <a:ext cx="3383280" cy="1874519"/>
+          </a:xfrm>
+          <a:prstGeom prst="rect">
+            <a:avLst/>
+          </a:prstGeom>
+        </p:spPr>
+      </p:pic>
+      <p:pic>
+        <p:nvPicPr>
+          <p:cNvPr id="17424" name="Picture 17423" descr="ui_predictive_dashboard.png"/>
+          <p:cNvPicPr>
+            <a:picLocks noChangeAspect="1"/>
+          </p:cNvPicPr>
+          <p:nvPr/>
+        </p:nvPicPr>
+        <p:blipFill>
+          <a:blip r:embed="rId6"/>
+          <a:stretch>
+            <a:fillRect/>
+          </a:stretch>
+        </p:blipFill>
+        <p:spPr>
+          <a:xfrm>
+            <a:off x="8119872" y="4206240"/>
+            <a:ext cx="3520440" cy="1874519"/>
+          </a:xfrm>
+          <a:prstGeom prst="rect">
+            <a:avLst/>
+          </a:prstGeom>
+        </p:spPr>
+      </p:pic>
     </p:spTree>
     <p:extLst>
       <p:ext uri="{BB962C8B-B14F-4D97-AF65-F5344CB8AC3E}">

</xml_diff>